<commit_message>
docs: rebuild system architecture pptx as native editable shapes
이미지(PNG) 임베드가 아니라 PowerPoint 도형으로 재구성 — 모든 박스·텍스트·
화살표·배지를 직접 편집 가능. 3-Zone(내부망 Air-gap 심의코어 · DMZ 게이트웨이 ·
외부망 어댑터 F14-F16), 파이프라인 8모듈 그리드, Ollama, 존간 화살표. 16:9 1슬라이드.

Co-Authored-By: Claude Opus 4.8 (1M context) <noreply@anthropic.com>
</commit_message>
<xml_diff>
--- a/docs/submission/JB준법코파일럿_시스템아키텍처.pptx
+++ b/docs/submission/JB준법코파일럿_시스템아키텍처.pptx
@@ -6,7 +6,6 @@
   </p:sldMasterIdLst>
   <p:sldIdLst>
     <p:sldId id="256" r:id="rId7"/>
-    <p:sldId id="257" r:id="rId8"/>
   </p:sldIdLst>
   <p:sldSz cx="12191695" cy="6858000" type="screen4x3"/>
   <p:notesSz cx="6858000" cy="9144000"/>
@@ -3091,14 +3090,104 @@
       <p:grpSpPr/>
       <p:sp>
         <p:nvSpPr>
-          <p:cNvPr id="2" name="Rectangle 1"/>
+          <p:cNvPr id="2" name="TextBox 1"/>
+          <p:cNvSpPr txBox="1"/>
+          <p:nvPr/>
+        </p:nvSpPr>
+        <p:spPr>
+          <a:xfrm>
+            <a:off x="411480" y="237744"/>
+            <a:ext cx="10058400" cy="457200"/>
+          </a:xfrm>
+          <a:prstGeom prst="rect">
+            <a:avLst/>
+          </a:prstGeom>
+          <a:noFill/>
+        </p:spPr>
+        <p:txBody>
+          <a:bodyPr wrap="square" anchor="t" lIns="0" rIns="0" tIns="18288" bIns="18288">
+            <a:spAutoFit/>
+          </a:bodyPr>
+          <a:lstStyle/>
+          <a:p>
+            <a:pPr algn="l">
+              <a:lnSpc>
+                <a:spcPct val="100000"/>
+              </a:lnSpc>
+              <a:spcBef>
+                <a:spcPts val="0"/>
+              </a:spcBef>
+              <a:spcAft>
+                <a:spcPts val="100"/>
+              </a:spcAft>
+            </a:pPr>
+            <a:r>
+              <a:rPr sz="2200" b="1">
+                <a:solidFill>
+                  <a:srgbClr val="003A6E"/>
+                </a:solidFill>
+                <a:latin typeface="맑은 고딕"/>
+              </a:rPr>
+              <a:t>JB 준법 코파일럿 — 시스템 아키텍처</a:t>
+            </a:r>
+          </a:p>
+        </p:txBody>
+      </p:sp>
+      <p:sp>
+        <p:nvSpPr>
+          <p:cNvPr id="3" name="TextBox 2"/>
+          <p:cNvSpPr txBox="1"/>
+          <p:nvPr/>
+        </p:nvSpPr>
+        <p:spPr>
+          <a:xfrm>
+            <a:off x="429768" y="713232"/>
+            <a:ext cx="10972800" cy="320040"/>
+          </a:xfrm>
+          <a:prstGeom prst="rect">
+            <a:avLst/>
+          </a:prstGeom>
+          <a:noFill/>
+        </p:spPr>
+        <p:txBody>
+          <a:bodyPr wrap="square" anchor="t" lIns="0" rIns="0" tIns="18288" bIns="18288">
+            <a:spAutoFit/>
+          </a:bodyPr>
+          <a:lstStyle/>
+          <a:p>
+            <a:pPr algn="l">
+              <a:lnSpc>
+                <a:spcPct val="100000"/>
+              </a:lnSpc>
+              <a:spcBef>
+                <a:spcPts val="0"/>
+              </a:spcBef>
+              <a:spcAft>
+                <a:spcPts val="100"/>
+              </a:spcAft>
+            </a:pPr>
+            <a:r>
+              <a:rPr sz="1150" b="0">
+                <a:solidFill>
+                  <a:srgbClr val="5B6470"/>
+                </a:solidFill>
+                <a:latin typeface="맑은 고딕"/>
+              </a:rPr>
+              <a:t>온프레미스 · 오픈모델(Qwen2.5-7B) · 망분리 3-Zone · 전 과정 휴먼인더루프</a:t>
+            </a:r>
+          </a:p>
+        </p:txBody>
+      </p:sp>
+      <p:sp>
+        <p:nvSpPr>
+          <p:cNvPr id="4" name="Rectangle 3"/>
           <p:cNvSpPr/>
           <p:nvPr/>
         </p:nvSpPr>
         <p:spPr>
           <a:xfrm>
-            <a:off x="0" y="0"/>
-            <a:ext cx="12191695" cy="109728"/>
+            <a:off x="411480" y="1051560"/>
+            <a:ext cx="11365992" cy="31750"/>
           </a:xfrm>
           <a:prstGeom prst="rect">
             <a:avLst/>
@@ -3126,7 +3215,7 @@
           </a:fontRef>
         </p:style>
         <p:txBody>
-          <a:bodyPr rtlCol="0" anchor="ctr"/>
+          <a:bodyPr rtlCol="0" anchor="ctr" wrap="square" lIns="54864" rIns="54864" tIns="18288" bIns="18288"/>
           <a:lstStyle/>
           <a:p>
             <a:pPr algn="ctr"/>
@@ -3135,14 +3224,273 @@
       </p:sp>
       <p:sp>
         <p:nvSpPr>
-          <p:cNvPr id="3" name="TextBox 2"/>
+          <p:cNvPr id="5" name="Rounded Rectangle 4"/>
+          <p:cNvSpPr/>
+          <p:nvPr/>
+        </p:nvSpPr>
+        <p:spPr>
+          <a:xfrm>
+            <a:off x="411480" y="1325880"/>
+            <a:ext cx="5989320" cy="5074920"/>
+          </a:xfrm>
+          <a:prstGeom prst="roundRect">
+            <a:avLst/>
+          </a:prstGeom>
+          <a:solidFill>
+            <a:srgbClr val="FFFFFF"/>
+          </a:solidFill>
+          <a:ln w="12700">
+            <a:solidFill>
+              <a:srgbClr val="D8DEE6"/>
+            </a:solidFill>
+          </a:ln>
+          <a:effectLst/>
+        </p:spPr>
+        <p:style>
+          <a:lnRef idx="1">
+            <a:schemeClr val="accent1"/>
+          </a:lnRef>
+          <a:fillRef idx="3">
+            <a:schemeClr val="accent1"/>
+          </a:fillRef>
+          <a:effectRef idx="2">
+            <a:schemeClr val="accent1"/>
+          </a:effectRef>
+          <a:fontRef idx="minor">
+            <a:schemeClr val="lt1"/>
+          </a:fontRef>
+        </p:style>
+        <p:txBody>
+          <a:bodyPr rtlCol="0" anchor="ctr" wrap="square" lIns="54864" rIns="54864" tIns="18288" bIns="18288"/>
+          <a:lstStyle/>
+          <a:p>
+            <a:pPr algn="ctr"/>
+          </a:p>
+        </p:txBody>
+      </p:sp>
+      <p:sp>
+        <p:nvSpPr>
+          <p:cNvPr id="6" name="Rounded Rectangle 5"/>
+          <p:cNvSpPr/>
+          <p:nvPr/>
+        </p:nvSpPr>
+        <p:spPr>
+          <a:xfrm>
+            <a:off x="411480" y="1325880"/>
+            <a:ext cx="5989320" cy="475488"/>
+          </a:xfrm>
+          <a:prstGeom prst="roundRect">
+            <a:avLst/>
+          </a:prstGeom>
+          <a:solidFill>
+            <a:srgbClr val="EEF4FC"/>
+          </a:solidFill>
+          <a:ln>
+            <a:noFill/>
+          </a:ln>
+          <a:effectLst/>
+        </p:spPr>
+        <p:style>
+          <a:lnRef idx="1">
+            <a:schemeClr val="accent1"/>
+          </a:lnRef>
+          <a:fillRef idx="3">
+            <a:schemeClr val="accent1"/>
+          </a:fillRef>
+          <a:effectRef idx="2">
+            <a:schemeClr val="accent1"/>
+          </a:effectRef>
+          <a:fontRef idx="minor">
+            <a:schemeClr val="lt1"/>
+          </a:fontRef>
+        </p:style>
+        <p:txBody>
+          <a:bodyPr rtlCol="0" anchor="ctr" wrap="square" lIns="164592" rIns="164592" tIns="18288" bIns="18288"/>
+          <a:lstStyle/>
+          <a:p>
+            <a:pPr algn="l">
+              <a:lnSpc>
+                <a:spcPct val="100000"/>
+              </a:lnSpc>
+              <a:spcBef>
+                <a:spcPts val="0"/>
+              </a:spcBef>
+              <a:spcAft>
+                <a:spcPts val="100"/>
+              </a:spcAft>
+            </a:pPr>
+            <a:r>
+              <a:rPr sz="1350" b="1">
+                <a:solidFill>
+                  <a:srgbClr val="00529B"/>
+                </a:solidFill>
+                <a:latin typeface="맑은 고딕"/>
+              </a:rPr>
+              <a:t>🔒  내부망 (Air-gap) — 심의 코어</a:t>
+            </a:r>
+          </a:p>
+        </p:txBody>
+      </p:sp>
+      <p:sp>
+        <p:nvSpPr>
+          <p:cNvPr id="7" name="Rounded Rectangle 6"/>
+          <p:cNvSpPr/>
+          <p:nvPr/>
+        </p:nvSpPr>
+        <p:spPr>
+          <a:xfrm>
+            <a:off x="4709160" y="1426464"/>
+            <a:ext cx="1554480" cy="274320"/>
+          </a:xfrm>
+          <a:prstGeom prst="roundRect">
+            <a:avLst/>
+          </a:prstGeom>
+          <a:solidFill>
+            <a:srgbClr val="1F9D55"/>
+          </a:solidFill>
+          <a:ln>
+            <a:noFill/>
+          </a:ln>
+          <a:effectLst/>
+        </p:spPr>
+        <p:style>
+          <a:lnRef idx="1">
+            <a:schemeClr val="accent1"/>
+          </a:lnRef>
+          <a:fillRef idx="3">
+            <a:schemeClr val="accent1"/>
+          </a:fillRef>
+          <a:effectRef idx="2">
+            <a:schemeClr val="accent1"/>
+          </a:effectRef>
+          <a:fontRef idx="minor">
+            <a:schemeClr val="lt1"/>
+          </a:fontRef>
+        </p:style>
+        <p:txBody>
+          <a:bodyPr rtlCol="0" anchor="ctr" wrap="square" lIns="54864" rIns="54864" tIns="18288" bIns="18288"/>
+          <a:lstStyle/>
+          <a:p>
+            <a:pPr algn="ctr">
+              <a:lnSpc>
+                <a:spcPct val="100000"/>
+              </a:lnSpc>
+              <a:spcBef>
+                <a:spcPts val="0"/>
+              </a:spcBef>
+              <a:spcAft>
+                <a:spcPts val="100"/>
+              </a:spcAft>
+            </a:pPr>
+            <a:r>
+              <a:rPr sz="950" b="1">
+                <a:solidFill>
+                  <a:srgbClr val="FFFFFF"/>
+                </a:solidFill>
+                <a:latin typeface="맑은 고딕"/>
+              </a:rPr>
+              <a:t>데이터 외부 유출 0</a:t>
+            </a:r>
+          </a:p>
+        </p:txBody>
+      </p:sp>
+      <p:sp>
+        <p:nvSpPr>
+          <p:cNvPr id="8" name="Rounded Rectangle 7"/>
+          <p:cNvSpPr/>
+          <p:nvPr/>
+        </p:nvSpPr>
+        <p:spPr>
+          <a:xfrm>
+            <a:off x="594360" y="1920240"/>
+            <a:ext cx="5623560" cy="566928"/>
+          </a:xfrm>
+          <a:prstGeom prst="roundRect">
+            <a:avLst/>
+          </a:prstGeom>
+          <a:solidFill>
+            <a:srgbClr val="F7F9FC"/>
+          </a:solidFill>
+          <a:ln w="9525">
+            <a:solidFill>
+              <a:srgbClr val="BCD6F2"/>
+            </a:solidFill>
+          </a:ln>
+          <a:effectLst/>
+        </p:spPr>
+        <p:style>
+          <a:lnRef idx="1">
+            <a:schemeClr val="accent1"/>
+          </a:lnRef>
+          <a:fillRef idx="3">
+            <a:schemeClr val="accent1"/>
+          </a:fillRef>
+          <a:effectRef idx="2">
+            <a:schemeClr val="accent1"/>
+          </a:effectRef>
+          <a:fontRef idx="minor">
+            <a:schemeClr val="lt1"/>
+          </a:fontRef>
+        </p:style>
+        <p:txBody>
+          <a:bodyPr rtlCol="0" anchor="ctr" wrap="square" lIns="128016" rIns="128016" tIns="18288" bIns="18288"/>
+          <a:lstStyle/>
+          <a:p>
+            <a:pPr algn="l">
+              <a:lnSpc>
+                <a:spcPct val="100000"/>
+              </a:lnSpc>
+              <a:spcBef>
+                <a:spcPts val="0"/>
+              </a:spcBef>
+              <a:spcAft>
+                <a:spcPts val="100"/>
+              </a:spcAft>
+            </a:pPr>
+            <a:r>
+              <a:rPr sz="1100" b="1">
+                <a:solidFill>
+                  <a:srgbClr val="1A1D21"/>
+                </a:solidFill>
+                <a:latin typeface="맑은 고딕"/>
+              </a:rPr>
+              <a:t>Frontend · 정적 SPA</a:t>
+            </a:r>
+          </a:p>
+          <a:p>
+            <a:pPr algn="l">
+              <a:lnSpc>
+                <a:spcPct val="100000"/>
+              </a:lnSpc>
+              <a:spcBef>
+                <a:spcPts val="0"/>
+              </a:spcBef>
+              <a:spcAft>
+                <a:spcPts val="100"/>
+              </a:spcAft>
+            </a:pPr>
+            <a:r>
+              <a:rPr sz="900" b="0">
+                <a:solidFill>
+                  <a:srgbClr val="5B6470"/>
+                </a:solidFill>
+                <a:latin typeface="맑은 고딕"/>
+              </a:rPr>
+              <a:t>오인 시뮬레이터 · 실시간 에디터 · 준법관리자 승인 뷰 · 감사로그</a:t>
+            </a:r>
+          </a:p>
+        </p:txBody>
+      </p:sp>
+      <p:sp>
+        <p:nvSpPr>
+          <p:cNvPr id="9" name="TextBox 8"/>
           <p:cNvSpPr txBox="1"/>
           <p:nvPr/>
         </p:nvSpPr>
         <p:spPr>
           <a:xfrm>
-            <a:off x="502920" y="274320"/>
-            <a:ext cx="8686800" cy="548640"/>
+            <a:off x="612648" y="2606040"/>
+            <a:ext cx="5623560" cy="237744"/>
           </a:xfrm>
           <a:prstGeom prst="rect">
             <a:avLst/>
@@ -3150,67 +3498,1361 @@
           <a:noFill/>
         </p:spPr>
         <p:txBody>
-          <a:bodyPr wrap="square" anchor="t" lIns="0" rIns="0" tIns="0" bIns="0">
+          <a:bodyPr wrap="square" anchor="t" lIns="0" rIns="0" tIns="18288" bIns="18288">
             <a:spAutoFit/>
           </a:bodyPr>
           <a:lstStyle/>
           <a:p>
             <a:pPr algn="l">
+              <a:lnSpc>
+                <a:spcPct val="100000"/>
+              </a:lnSpc>
               <a:spcBef>
                 <a:spcPts val="0"/>
               </a:spcBef>
               <a:spcAft>
-                <a:spcPts val="200"/>
+                <a:spcPts val="100"/>
               </a:spcAft>
             </a:pPr>
             <a:r>
-              <a:rPr sz="2400" b="1">
+              <a:rPr sz="1050" b="1">
                 <a:solidFill>
                   <a:srgbClr val="003A6E"/>
                 </a:solidFill>
                 <a:latin typeface="맑은 고딕"/>
               </a:rPr>
-              <a:t>시스템 아키텍처 (System Architecture)</a:t>
-            </a:r>
-          </a:p>
-        </p:txBody>
-      </p:sp>
-      <p:pic>
-        <p:nvPicPr>
-          <p:cNvPr id="4" name="Picture 3" descr="image2.png"/>
-          <p:cNvPicPr>
-            <a:picLocks noChangeAspect="1"/>
-          </p:cNvPicPr>
+              <a:t>Backend · Orchestrator  (명시적 파이프라인)</a:t>
+            </a:r>
+          </a:p>
+        </p:txBody>
+      </p:sp>
+      <p:sp>
+        <p:nvSpPr>
+          <p:cNvPr id="10" name="Rounded Rectangle 9"/>
+          <p:cNvSpPr/>
           <p:nvPr/>
-        </p:nvPicPr>
-        <p:blipFill>
-          <a:blip r:embed="rId2"/>
-          <a:stretch>
-            <a:fillRect/>
-          </a:stretch>
-        </p:blipFill>
-        <p:spPr>
-          <a:xfrm>
-            <a:off x="9859975" y="274320"/>
-            <a:ext cx="1949782" cy="329184"/>
+        </p:nvSpPr>
+        <p:spPr>
+          <a:xfrm>
+            <a:off x="594360" y="2898648"/>
+            <a:ext cx="2729484" cy="420624"/>
+          </a:xfrm>
+          <a:prstGeom prst="roundRect">
+            <a:avLst/>
+          </a:prstGeom>
+          <a:solidFill>
+            <a:srgbClr val="EEF4FC"/>
+          </a:solidFill>
+          <a:ln w="9525">
+            <a:solidFill>
+              <a:srgbClr val="BCD6F2"/>
+            </a:solidFill>
+          </a:ln>
+          <a:effectLst/>
+        </p:spPr>
+        <p:style>
+          <a:lnRef idx="1">
+            <a:schemeClr val="accent1"/>
+          </a:lnRef>
+          <a:fillRef idx="3">
+            <a:schemeClr val="accent1"/>
+          </a:fillRef>
+          <a:effectRef idx="2">
+            <a:schemeClr val="accent1"/>
+          </a:effectRef>
+          <a:fontRef idx="minor">
+            <a:schemeClr val="lt1"/>
+          </a:fontRef>
+        </p:style>
+        <p:txBody>
+          <a:bodyPr rtlCol="0" anchor="ctr" wrap="square" lIns="109728" rIns="109728" tIns="18288" bIns="18288"/>
+          <a:lstStyle/>
+          <a:p>
+            <a:pPr algn="l">
+              <a:lnSpc>
+                <a:spcPct val="100000"/>
+              </a:lnSpc>
+              <a:spcBef>
+                <a:spcPts val="0"/>
+              </a:spcBef>
+              <a:spcAft>
+                <a:spcPts val="100"/>
+              </a:spcAft>
+            </a:pPr>
+            <a:r>
+              <a:rPr sz="950" b="0">
+                <a:solidFill>
+                  <a:srgbClr val="1A1D21"/>
+                </a:solidFill>
+                <a:latin typeface="맑은 고딕"/>
+              </a:rPr>
+              <a:t>① 유형분류 → 라우팅</a:t>
+            </a:r>
+          </a:p>
+        </p:txBody>
+      </p:sp>
+      <p:sp>
+        <p:nvSpPr>
+          <p:cNvPr id="11" name="Rounded Rectangle 10"/>
+          <p:cNvSpPr/>
+          <p:nvPr/>
+        </p:nvSpPr>
+        <p:spPr>
+          <a:xfrm>
+            <a:off x="3488436" y="2898648"/>
+            <a:ext cx="2729484" cy="420624"/>
+          </a:xfrm>
+          <a:prstGeom prst="roundRect">
+            <a:avLst/>
+          </a:prstGeom>
+          <a:solidFill>
+            <a:srgbClr val="EEF4FC"/>
+          </a:solidFill>
+          <a:ln w="9525">
+            <a:solidFill>
+              <a:srgbClr val="BCD6F2"/>
+            </a:solidFill>
+          </a:ln>
+          <a:effectLst/>
+        </p:spPr>
+        <p:style>
+          <a:lnRef idx="1">
+            <a:schemeClr val="accent1"/>
+          </a:lnRef>
+          <a:fillRef idx="3">
+            <a:schemeClr val="accent1"/>
+          </a:fillRef>
+          <a:effectRef idx="2">
+            <a:schemeClr val="accent1"/>
+          </a:effectRef>
+          <a:fontRef idx="minor">
+            <a:schemeClr val="lt1"/>
+          </a:fontRef>
+        </p:style>
+        <p:txBody>
+          <a:bodyPr rtlCol="0" anchor="ctr" wrap="square" lIns="109728" rIns="109728" tIns="18288" bIns="18288"/>
+          <a:lstStyle/>
+          <a:p>
+            <a:pPr algn="l">
+              <a:lnSpc>
+                <a:spcPct val="100000"/>
+              </a:lnSpc>
+              <a:spcBef>
+                <a:spcPts val="0"/>
+              </a:spcBef>
+              <a:spcAft>
+                <a:spcPts val="100"/>
+              </a:spcAft>
+            </a:pPr>
+            <a:r>
+              <a:rPr sz="950" b="0">
+                <a:solidFill>
+                  <a:srgbClr val="1A1D21"/>
+                </a:solidFill>
+                <a:latin typeface="맑은 고딕"/>
+              </a:rPr>
+              <a:t>② RAG 근거검색 (참조그래프)</a:t>
+            </a:r>
+          </a:p>
+        </p:txBody>
+      </p:sp>
+      <p:sp>
+        <p:nvSpPr>
+          <p:cNvPr id="12" name="Rounded Rectangle 11"/>
+          <p:cNvSpPr/>
+          <p:nvPr/>
+        </p:nvSpPr>
+        <p:spPr>
+          <a:xfrm>
+            <a:off x="594360" y="3429000"/>
+            <a:ext cx="2729484" cy="420624"/>
+          </a:xfrm>
+          <a:prstGeom prst="roundRect">
+            <a:avLst/>
+          </a:prstGeom>
+          <a:solidFill>
+            <a:srgbClr val="F0ECFF"/>
+          </a:solidFill>
+          <a:ln w="9525">
+            <a:solidFill>
+              <a:srgbClr val="CDBFF0"/>
+            </a:solidFill>
+          </a:ln>
+          <a:effectLst/>
+        </p:spPr>
+        <p:style>
+          <a:lnRef idx="1">
+            <a:schemeClr val="accent1"/>
+          </a:lnRef>
+          <a:fillRef idx="3">
+            <a:schemeClr val="accent1"/>
+          </a:fillRef>
+          <a:effectRef idx="2">
+            <a:schemeClr val="accent1"/>
+          </a:effectRef>
+          <a:fontRef idx="minor">
+            <a:schemeClr val="lt1"/>
+          </a:fontRef>
+        </p:style>
+        <p:txBody>
+          <a:bodyPr rtlCol="0" anchor="ctr" wrap="square" lIns="109728" rIns="109728" tIns="18288" bIns="18288"/>
+          <a:lstStyle/>
+          <a:p>
+            <a:pPr algn="l">
+              <a:lnSpc>
+                <a:spcPct val="100000"/>
+              </a:lnSpc>
+              <a:spcBef>
+                <a:spcPts val="0"/>
+              </a:spcBef>
+              <a:spcAft>
+                <a:spcPts val="100"/>
+              </a:spcAft>
+            </a:pPr>
+            <a:r>
+              <a:rPr sz="950" b="1">
+                <a:solidFill>
+                  <a:srgbClr val="003A6E"/>
+                </a:solidFill>
+                <a:latin typeface="맑은 고딕"/>
+              </a:rPr>
+              <a:t>③ 룰엔진 (결정적 권위)</a:t>
+            </a:r>
+          </a:p>
+        </p:txBody>
+      </p:sp>
+      <p:sp>
+        <p:nvSpPr>
+          <p:cNvPr id="13" name="Rounded Rectangle 12"/>
+          <p:cNvSpPr/>
+          <p:nvPr/>
+        </p:nvSpPr>
+        <p:spPr>
+          <a:xfrm>
+            <a:off x="3488436" y="3429000"/>
+            <a:ext cx="2729484" cy="420624"/>
+          </a:xfrm>
+          <a:prstGeom prst="roundRect">
+            <a:avLst/>
+          </a:prstGeom>
+          <a:solidFill>
+            <a:srgbClr val="EEF4FC"/>
+          </a:solidFill>
+          <a:ln w="9525">
+            <a:solidFill>
+              <a:srgbClr val="BCD6F2"/>
+            </a:solidFill>
+          </a:ln>
+          <a:effectLst/>
+        </p:spPr>
+        <p:style>
+          <a:lnRef idx="1">
+            <a:schemeClr val="accent1"/>
+          </a:lnRef>
+          <a:fillRef idx="3">
+            <a:schemeClr val="accent1"/>
+          </a:fillRef>
+          <a:effectRef idx="2">
+            <a:schemeClr val="accent1"/>
+          </a:effectRef>
+          <a:fontRef idx="minor">
+            <a:schemeClr val="lt1"/>
+          </a:fontRef>
+        </p:style>
+        <p:txBody>
+          <a:bodyPr rtlCol="0" anchor="ctr" wrap="square" lIns="109728" rIns="109728" tIns="18288" bIns="18288"/>
+          <a:lstStyle/>
+          <a:p>
+            <a:pPr algn="l">
+              <a:lnSpc>
+                <a:spcPct val="100000"/>
+              </a:lnSpc>
+              <a:spcBef>
+                <a:spcPts val="0"/>
+              </a:spcBef>
+              <a:spcAft>
+                <a:spcPts val="100"/>
+              </a:spcAft>
+            </a:pPr>
+            <a:r>
+              <a:rPr sz="950" b="0">
+                <a:solidFill>
+                  <a:srgbClr val="1A1D21"/>
+                </a:solidFill>
+                <a:latin typeface="맑은 고딕"/>
+              </a:rPr>
+              <a:t>④ LLM 뉘앙스 심의</a:t>
+            </a:r>
+          </a:p>
+        </p:txBody>
+      </p:sp>
+      <p:sp>
+        <p:nvSpPr>
+          <p:cNvPr id="14" name="Rounded Rectangle 13"/>
+          <p:cNvSpPr/>
+          <p:nvPr/>
+        </p:nvSpPr>
+        <p:spPr>
+          <a:xfrm>
+            <a:off x="594360" y="3959352"/>
+            <a:ext cx="2729484" cy="420624"/>
+          </a:xfrm>
+          <a:prstGeom prst="roundRect">
+            <a:avLst/>
+          </a:prstGeom>
+          <a:solidFill>
+            <a:srgbClr val="F0ECFF"/>
+          </a:solidFill>
+          <a:ln w="9525">
+            <a:solidFill>
+              <a:srgbClr val="CDBFF0"/>
+            </a:solidFill>
+          </a:ln>
+          <a:effectLst/>
+        </p:spPr>
+        <p:style>
+          <a:lnRef idx="1">
+            <a:schemeClr val="accent1"/>
+          </a:lnRef>
+          <a:fillRef idx="3">
+            <a:schemeClr val="accent1"/>
+          </a:fillRef>
+          <a:effectRef idx="2">
+            <a:schemeClr val="accent1"/>
+          </a:effectRef>
+          <a:fontRef idx="minor">
+            <a:schemeClr val="lt1"/>
+          </a:fontRef>
+        </p:style>
+        <p:txBody>
+          <a:bodyPr rtlCol="0" anchor="ctr" wrap="square" lIns="109728" rIns="109728" tIns="18288" bIns="18288"/>
+          <a:lstStyle/>
+          <a:p>
+            <a:pPr algn="l">
+              <a:lnSpc>
+                <a:spcPct val="100000"/>
+              </a:lnSpc>
+              <a:spcBef>
+                <a:spcPts val="0"/>
+              </a:spcBef>
+              <a:spcAft>
+                <a:spcPts val="100"/>
+              </a:spcAft>
+            </a:pPr>
+            <a:r>
+              <a:rPr sz="950" b="1">
+                <a:solidFill>
+                  <a:srgbClr val="003A6E"/>
+                </a:solidFill>
+                <a:latin typeface="맑은 고딕"/>
+              </a:rPr>
+              <a:t>⑤ ★오인 시뮬레이터</a:t>
+            </a:r>
+          </a:p>
+        </p:txBody>
+      </p:sp>
+      <p:sp>
+        <p:nvSpPr>
+          <p:cNvPr id="15" name="Rounded Rectangle 14"/>
+          <p:cNvSpPr/>
+          <p:nvPr/>
+        </p:nvSpPr>
+        <p:spPr>
+          <a:xfrm>
+            <a:off x="3488436" y="3959352"/>
+            <a:ext cx="2729484" cy="420624"/>
+          </a:xfrm>
+          <a:prstGeom prst="roundRect">
+            <a:avLst/>
+          </a:prstGeom>
+          <a:solidFill>
+            <a:srgbClr val="EEF4FC"/>
+          </a:solidFill>
+          <a:ln w="9525">
+            <a:solidFill>
+              <a:srgbClr val="BCD6F2"/>
+            </a:solidFill>
+          </a:ln>
+          <a:effectLst/>
+        </p:spPr>
+        <p:style>
+          <a:lnRef idx="1">
+            <a:schemeClr val="accent1"/>
+          </a:lnRef>
+          <a:fillRef idx="3">
+            <a:schemeClr val="accent1"/>
+          </a:fillRef>
+          <a:effectRef idx="2">
+            <a:schemeClr val="accent1"/>
+          </a:effectRef>
+          <a:fontRef idx="minor">
+            <a:schemeClr val="lt1"/>
+          </a:fontRef>
+        </p:style>
+        <p:txBody>
+          <a:bodyPr rtlCol="0" anchor="ctr" wrap="square" lIns="109728" rIns="109728" tIns="18288" bIns="18288"/>
+          <a:lstStyle/>
+          <a:p>
+            <a:pPr algn="l">
+              <a:lnSpc>
+                <a:spcPct val="100000"/>
+              </a:lnSpc>
+              <a:spcBef>
+                <a:spcPts val="0"/>
+              </a:spcBef>
+              <a:spcAft>
+                <a:spcPts val="100"/>
+              </a:spcAft>
+            </a:pPr>
+            <a:r>
+              <a:rPr sz="950" b="0">
+                <a:solidFill>
+                  <a:srgbClr val="1A1D21"/>
+                </a:solidFill>
+                <a:latin typeface="맑은 고딕"/>
+              </a:rPr>
+              <a:t>⑥ 리포트 · 점수 · 인용</a:t>
+            </a:r>
+          </a:p>
+        </p:txBody>
+      </p:sp>
+      <p:sp>
+        <p:nvSpPr>
+          <p:cNvPr id="16" name="Rounded Rectangle 15"/>
+          <p:cNvSpPr/>
+          <p:nvPr/>
+        </p:nvSpPr>
+        <p:spPr>
+          <a:xfrm>
+            <a:off x="594360" y="4489704"/>
+            <a:ext cx="2729484" cy="420624"/>
+          </a:xfrm>
+          <a:prstGeom prst="roundRect">
+            <a:avLst/>
+          </a:prstGeom>
+          <a:solidFill>
+            <a:srgbClr val="EEF4FC"/>
+          </a:solidFill>
+          <a:ln w="9525">
+            <a:solidFill>
+              <a:srgbClr val="BCD6F2"/>
+            </a:solidFill>
+          </a:ln>
+          <a:effectLst/>
+        </p:spPr>
+        <p:style>
+          <a:lnRef idx="1">
+            <a:schemeClr val="accent1"/>
+          </a:lnRef>
+          <a:fillRef idx="3">
+            <a:schemeClr val="accent1"/>
+          </a:fillRef>
+          <a:effectRef idx="2">
+            <a:schemeClr val="accent1"/>
+          </a:effectRef>
+          <a:fontRef idx="minor">
+            <a:schemeClr val="lt1"/>
+          </a:fontRef>
+        </p:style>
+        <p:txBody>
+          <a:bodyPr rtlCol="0" anchor="ctr" wrap="square" lIns="109728" rIns="109728" tIns="18288" bIns="18288"/>
+          <a:lstStyle/>
+          <a:p>
+            <a:pPr algn="l">
+              <a:lnSpc>
+                <a:spcPct val="100000"/>
+              </a:lnSpc>
+              <a:spcBef>
+                <a:spcPts val="0"/>
+              </a:spcBef>
+              <a:spcAft>
+                <a:spcPts val="100"/>
+              </a:spcAft>
+            </a:pPr>
+            <a:r>
+              <a:rPr sz="950" b="0">
+                <a:solidFill>
+                  <a:srgbClr val="1A1D21"/>
+                </a:solidFill>
+                <a:latin typeface="맑은 고딕"/>
+              </a:rPr>
+              <a:t>⑦⑧ 승인 · 감사로그</a:t>
+            </a:r>
+          </a:p>
+        </p:txBody>
+      </p:sp>
+      <p:sp>
+        <p:nvSpPr>
+          <p:cNvPr id="17" name="Rounded Rectangle 16"/>
+          <p:cNvSpPr/>
+          <p:nvPr/>
+        </p:nvSpPr>
+        <p:spPr>
+          <a:xfrm>
+            <a:off x="3488436" y="4489704"/>
+            <a:ext cx="2729484" cy="420624"/>
+          </a:xfrm>
+          <a:prstGeom prst="roundRect">
+            <a:avLst/>
+          </a:prstGeom>
+          <a:solidFill>
+            <a:srgbClr val="F0ECFF"/>
+          </a:solidFill>
+          <a:ln w="9525">
+            <a:solidFill>
+              <a:srgbClr val="CDBFF0"/>
+            </a:solidFill>
+          </a:ln>
+          <a:effectLst/>
+        </p:spPr>
+        <p:style>
+          <a:lnRef idx="1">
+            <a:schemeClr val="accent1"/>
+          </a:lnRef>
+          <a:fillRef idx="3">
+            <a:schemeClr val="accent1"/>
+          </a:fillRef>
+          <a:effectRef idx="2">
+            <a:schemeClr val="accent1"/>
+          </a:effectRef>
+          <a:fontRef idx="minor">
+            <a:schemeClr val="lt1"/>
+          </a:fontRef>
+        </p:style>
+        <p:txBody>
+          <a:bodyPr rtlCol="0" anchor="ctr" wrap="square" lIns="109728" rIns="109728" tIns="18288" bIns="18288"/>
+          <a:lstStyle/>
+          <a:p>
+            <a:pPr algn="l">
+              <a:lnSpc>
+                <a:spcPct val="100000"/>
+              </a:lnSpc>
+              <a:spcBef>
+                <a:spcPts val="0"/>
+              </a:spcBef>
+              <a:spcAft>
+                <a:spcPts val="100"/>
+              </a:spcAft>
+            </a:pPr>
+            <a:r>
+              <a:rPr sz="950" b="1">
+                <a:solidFill>
+                  <a:srgbClr val="003A6E"/>
+                </a:solidFill>
+                <a:latin typeface="맑은 고딕"/>
+              </a:rPr>
+              <a:t>★준법 오토파일럿 (자율 개선)</a:t>
+            </a:r>
+          </a:p>
+        </p:txBody>
+      </p:sp>
+      <p:sp>
+        <p:nvSpPr>
+          <p:cNvPr id="18" name="Rounded Rectangle 17"/>
+          <p:cNvSpPr/>
+          <p:nvPr/>
+        </p:nvSpPr>
+        <p:spPr>
+          <a:xfrm>
+            <a:off x="594360" y="5056632"/>
+            <a:ext cx="5623560" cy="548640"/>
+          </a:xfrm>
+          <a:prstGeom prst="roundRect">
+            <a:avLst/>
+          </a:prstGeom>
+          <a:solidFill>
+            <a:srgbClr val="1F2D44"/>
+          </a:solidFill>
+          <a:ln>
+            <a:noFill/>
+          </a:ln>
+          <a:effectLst/>
+        </p:spPr>
+        <p:style>
+          <a:lnRef idx="1">
+            <a:schemeClr val="accent1"/>
+          </a:lnRef>
+          <a:fillRef idx="3">
+            <a:schemeClr val="accent1"/>
+          </a:fillRef>
+          <a:effectRef idx="2">
+            <a:schemeClr val="accent1"/>
+          </a:effectRef>
+          <a:fontRef idx="minor">
+            <a:schemeClr val="lt1"/>
+          </a:fontRef>
+        </p:style>
+        <p:txBody>
+          <a:bodyPr rtlCol="0" anchor="ctr" wrap="square" lIns="146304" rIns="146304" tIns="18288" bIns="18288"/>
+          <a:lstStyle/>
+          <a:p>
+            <a:pPr algn="l">
+              <a:lnSpc>
+                <a:spcPct val="100000"/>
+              </a:lnSpc>
+              <a:spcBef>
+                <a:spcPts val="0"/>
+              </a:spcBef>
+              <a:spcAft>
+                <a:spcPts val="100"/>
+              </a:spcAft>
+            </a:pPr>
+            <a:r>
+              <a:rPr sz="1050" b="1">
+                <a:solidFill>
+                  <a:srgbClr val="FFFFFF"/>
+                </a:solidFill>
+                <a:latin typeface="맑은 고딕"/>
+              </a:rPr>
+              <a:t>LLM 서버 · Ollama  (Qwen2.5-7B-Instruct)</a:t>
+            </a:r>
+          </a:p>
+          <a:p>
+            <a:pPr algn="l">
+              <a:lnSpc>
+                <a:spcPct val="100000"/>
+              </a:lnSpc>
+              <a:spcBef>
+                <a:spcPts val="0"/>
+              </a:spcBef>
+              <a:spcAft>
+                <a:spcPts val="100"/>
+              </a:spcAft>
+            </a:pPr>
+            <a:r>
+              <a:rPr sz="900" b="0">
+                <a:solidFill>
+                  <a:srgbClr val="C7D2E0"/>
+                </a:solidFill>
+                <a:latin typeface="맑은 고딕"/>
+              </a:rPr>
+              <a:t>미연결 시 룰 기반 결정적 폴백</a:t>
+            </a:r>
+          </a:p>
+        </p:txBody>
+      </p:sp>
+      <p:sp>
+        <p:nvSpPr>
+          <p:cNvPr id="19" name="TextBox 18"/>
+          <p:cNvSpPr txBox="1"/>
+          <p:nvPr/>
+        </p:nvSpPr>
+        <p:spPr>
+          <a:xfrm>
+            <a:off x="612648" y="5660136"/>
+            <a:ext cx="5623560" cy="219456"/>
           </a:xfrm>
           <a:prstGeom prst="rect">
             <a:avLst/>
           </a:prstGeom>
-        </p:spPr>
-      </p:pic>
-      <p:sp>
-        <p:nvSpPr>
-          <p:cNvPr id="5" name="Rectangle 4"/>
+          <a:noFill/>
+        </p:spPr>
+        <p:txBody>
+          <a:bodyPr wrap="square" anchor="t" lIns="0" rIns="0" tIns="18288" bIns="18288">
+            <a:spAutoFit/>
+          </a:bodyPr>
+          <a:lstStyle/>
+          <a:p>
+            <a:pPr algn="l">
+              <a:lnSpc>
+                <a:spcPct val="100000"/>
+              </a:lnSpc>
+              <a:spcBef>
+                <a:spcPts val="0"/>
+              </a:spcBef>
+              <a:spcAft>
+                <a:spcPts val="100"/>
+              </a:spcAft>
+            </a:pPr>
+            <a:r>
+              <a:rPr sz="850" b="0">
+                <a:solidFill>
+                  <a:srgbClr val="5B6470"/>
+                </a:solidFill>
+                <a:latin typeface="맑은 고딕"/>
+              </a:rPr>
+              <a:t>✓ 결정적 룰엔진이 등급 관리 · LLM은 보조 · 합격 위장 불가</a:t>
+            </a:r>
+          </a:p>
+        </p:txBody>
+      </p:sp>
+      <p:sp>
+        <p:nvSpPr>
+          <p:cNvPr id="20" name="Rounded Rectangle 19"/>
           <p:cNvSpPr/>
           <p:nvPr/>
         </p:nvSpPr>
         <p:spPr>
           <a:xfrm>
-            <a:off x="502920" y="868680"/>
-            <a:ext cx="11183112" cy="25400"/>
+            <a:off x="6565392" y="1325880"/>
+            <a:ext cx="2057400" cy="5074920"/>
+          </a:xfrm>
+          <a:prstGeom prst="roundRect">
+            <a:avLst/>
+          </a:prstGeom>
+          <a:solidFill>
+            <a:srgbClr val="FEF7E6"/>
+          </a:solidFill>
+          <a:ln w="12700">
+            <a:solidFill>
+              <a:srgbClr val="F0D99A"/>
+            </a:solidFill>
+          </a:ln>
+          <a:effectLst/>
+        </p:spPr>
+        <p:style>
+          <a:lnRef idx="1">
+            <a:schemeClr val="accent1"/>
+          </a:lnRef>
+          <a:fillRef idx="3">
+            <a:schemeClr val="accent1"/>
+          </a:fillRef>
+          <a:effectRef idx="2">
+            <a:schemeClr val="accent1"/>
+          </a:effectRef>
+          <a:fontRef idx="minor">
+            <a:schemeClr val="lt1"/>
+          </a:fontRef>
+        </p:style>
+        <p:txBody>
+          <a:bodyPr rtlCol="0" anchor="ctr" wrap="square" lIns="54864" rIns="54864" tIns="18288" bIns="18288"/>
+          <a:lstStyle/>
+          <a:p>
+            <a:pPr algn="ctr"/>
+          </a:p>
+        </p:txBody>
+      </p:sp>
+      <p:sp>
+        <p:nvSpPr>
+          <p:cNvPr id="21" name="Rounded Rectangle 20"/>
+          <p:cNvSpPr/>
+          <p:nvPr/>
+        </p:nvSpPr>
+        <p:spPr>
+          <a:xfrm>
+            <a:off x="6565392" y="1325880"/>
+            <a:ext cx="2057400" cy="475488"/>
+          </a:xfrm>
+          <a:prstGeom prst="roundRect">
+            <a:avLst/>
+          </a:prstGeom>
+          <a:solidFill>
+            <a:srgbClr val="FBEECB"/>
+          </a:solidFill>
+          <a:ln>
+            <a:noFill/>
+          </a:ln>
+          <a:effectLst/>
+        </p:spPr>
+        <p:style>
+          <a:lnRef idx="1">
+            <a:schemeClr val="accent1"/>
+          </a:lnRef>
+          <a:fillRef idx="3">
+            <a:schemeClr val="accent1"/>
+          </a:fillRef>
+          <a:effectRef idx="2">
+            <a:schemeClr val="accent1"/>
+          </a:effectRef>
+          <a:fontRef idx="minor">
+            <a:schemeClr val="lt1"/>
+          </a:fontRef>
+        </p:style>
+        <p:txBody>
+          <a:bodyPr rtlCol="0" anchor="ctr" wrap="square" lIns="54864" rIns="54864" tIns="18288" bIns="18288"/>
+          <a:lstStyle/>
+          <a:p>
+            <a:pPr algn="ctr">
+              <a:lnSpc>
+                <a:spcPct val="100000"/>
+              </a:lnSpc>
+              <a:spcBef>
+                <a:spcPts val="0"/>
+              </a:spcBef>
+              <a:spcAft>
+                <a:spcPts val="100"/>
+              </a:spcAft>
+            </a:pPr>
+            <a:r>
+              <a:rPr sz="1300" b="1">
+                <a:solidFill>
+                  <a:srgbClr val="C78A06"/>
+                </a:solidFill>
+                <a:latin typeface="맑은 고딕"/>
+              </a:rPr>
+              <a:t>🔁 DMZ</a:t>
+            </a:r>
+          </a:p>
+          <a:p>
+            <a:pPr algn="ctr">
+              <a:lnSpc>
+                <a:spcPct val="100000"/>
+              </a:lnSpc>
+              <a:spcBef>
+                <a:spcPts val="0"/>
+              </a:spcBef>
+              <a:spcAft>
+                <a:spcPts val="100"/>
+              </a:spcAft>
+            </a:pPr>
+            <a:r>
+              <a:rPr sz="1050" b="1">
+                <a:solidFill>
+                  <a:srgbClr val="C78A06"/>
+                </a:solidFill>
+                <a:latin typeface="맑은 고딕"/>
+              </a:rPr>
+              <a:t>망연계 게이트웨이</a:t>
+            </a:r>
+          </a:p>
+        </p:txBody>
+      </p:sp>
+      <p:sp>
+        <p:nvSpPr>
+          <p:cNvPr id="22" name="TextBox 21"/>
+          <p:cNvSpPr txBox="1"/>
+          <p:nvPr/>
+        </p:nvSpPr>
+        <p:spPr>
+          <a:xfrm>
+            <a:off x="6675120" y="1892808"/>
+            <a:ext cx="1837944" cy="274320"/>
           </a:xfrm>
           <a:prstGeom prst="rect">
+            <a:avLst/>
+          </a:prstGeom>
+          <a:noFill/>
+        </p:spPr>
+        <p:txBody>
+          <a:bodyPr wrap="square" anchor="t" lIns="0" rIns="0" tIns="18288" bIns="18288">
+            <a:spAutoFit/>
+          </a:bodyPr>
+          <a:lstStyle/>
+          <a:p>
+            <a:pPr algn="ctr">
+              <a:lnSpc>
+                <a:spcPct val="100000"/>
+              </a:lnSpc>
+              <a:spcBef>
+                <a:spcPts val="0"/>
+              </a:spcBef>
+              <a:spcAft>
+                <a:spcPts val="100"/>
+              </a:spcAft>
+            </a:pPr>
+            <a:r>
+              <a:rPr sz="1000" b="1">
+                <a:solidFill>
+                  <a:srgbClr val="8A6200"/>
+                </a:solidFill>
+                <a:latin typeface="맑은 고딕"/>
+              </a:rPr>
+              <a:t>단방향 · 배치 · 검증</a:t>
+            </a:r>
+          </a:p>
+        </p:txBody>
+      </p:sp>
+      <p:sp>
+        <p:nvSpPr>
+          <p:cNvPr id="23" name="Rounded Rectangle 22"/>
+          <p:cNvSpPr/>
+          <p:nvPr/>
+        </p:nvSpPr>
+        <p:spPr>
+          <a:xfrm>
+            <a:off x="6885432" y="2697480"/>
+            <a:ext cx="1417320" cy="548640"/>
+          </a:xfrm>
+          <a:prstGeom prst="roundRect">
+            <a:avLst/>
+          </a:prstGeom>
+          <a:solidFill>
+            <a:srgbClr val="FFFFFF"/>
+          </a:solidFill>
+          <a:ln w="9525">
+            <a:solidFill>
+              <a:srgbClr val="F0D99A"/>
+            </a:solidFill>
+          </a:ln>
+          <a:effectLst/>
+        </p:spPr>
+        <p:style>
+          <a:lnRef idx="1">
+            <a:schemeClr val="accent1"/>
+          </a:lnRef>
+          <a:fillRef idx="3">
+            <a:schemeClr val="accent1"/>
+          </a:fillRef>
+          <a:effectRef idx="2">
+            <a:schemeClr val="accent1"/>
+          </a:effectRef>
+          <a:fontRef idx="minor">
+            <a:schemeClr val="lt1"/>
+          </a:fontRef>
+        </p:style>
+        <p:txBody>
+          <a:bodyPr rtlCol="0" anchor="ctr" wrap="square" lIns="54864" rIns="54864" tIns="18288" bIns="18288"/>
+          <a:lstStyle/>
+          <a:p>
+            <a:pPr algn="ctr">
+              <a:lnSpc>
+                <a:spcPct val="100000"/>
+              </a:lnSpc>
+              <a:spcBef>
+                <a:spcPts val="0"/>
+              </a:spcBef>
+              <a:spcAft>
+                <a:spcPts val="100"/>
+              </a:spcAft>
+            </a:pPr>
+            <a:r>
+              <a:rPr sz="2200" b="1">
+                <a:solidFill>
+                  <a:srgbClr val="C78A06"/>
+                </a:solidFill>
+                <a:latin typeface="맑은 고딕"/>
+              </a:rPr>
+              <a:t>⇄</a:t>
+            </a:r>
+          </a:p>
+        </p:txBody>
+      </p:sp>
+      <p:sp>
+        <p:nvSpPr>
+          <p:cNvPr id="24" name="Rounded Rectangle 23"/>
+          <p:cNvSpPr/>
+          <p:nvPr/>
+        </p:nvSpPr>
+        <p:spPr>
+          <a:xfrm>
+            <a:off x="6729984" y="3474720"/>
+            <a:ext cx="1728216" cy="548640"/>
+          </a:xfrm>
+          <a:prstGeom prst="roundRect">
+            <a:avLst/>
+          </a:prstGeom>
+          <a:solidFill>
+            <a:srgbClr val="FFFFFF"/>
+          </a:solidFill>
+          <a:ln w="9525">
+            <a:solidFill>
+              <a:srgbClr val="F0D99A"/>
+            </a:solidFill>
+          </a:ln>
+          <a:effectLst/>
+        </p:spPr>
+        <p:style>
+          <a:lnRef idx="1">
+            <a:schemeClr val="accent1"/>
+          </a:lnRef>
+          <a:fillRef idx="3">
+            <a:schemeClr val="accent1"/>
+          </a:fillRef>
+          <a:effectRef idx="2">
+            <a:schemeClr val="accent1"/>
+          </a:effectRef>
+          <a:fontRef idx="minor">
+            <a:schemeClr val="lt1"/>
+          </a:fontRef>
+        </p:style>
+        <p:txBody>
+          <a:bodyPr rtlCol="0" anchor="ctr" wrap="square" lIns="54864" rIns="54864" tIns="18288" bIns="18288"/>
+          <a:lstStyle/>
+          <a:p>
+            <a:pPr algn="ctr">
+              <a:lnSpc>
+                <a:spcPct val="100000"/>
+              </a:lnSpc>
+              <a:spcBef>
+                <a:spcPts val="0"/>
+              </a:spcBef>
+              <a:spcAft>
+                <a:spcPts val="100"/>
+              </a:spcAft>
+            </a:pPr>
+            <a:r>
+              <a:rPr sz="950" b="1">
+                <a:solidFill>
+                  <a:srgbClr val="1A1D21"/>
+                </a:solidFill>
+                <a:latin typeface="맑은 고딕"/>
+              </a:rPr>
+              <a:t>◀ 배치 수신</a:t>
+            </a:r>
+          </a:p>
+          <a:p>
+            <a:pPr algn="ctr">
+              <a:lnSpc>
+                <a:spcPct val="100000"/>
+              </a:lnSpc>
+              <a:spcBef>
+                <a:spcPts val="0"/>
+              </a:spcBef>
+              <a:spcAft>
+                <a:spcPts val="100"/>
+              </a:spcAft>
+            </a:pPr>
+            <a:r>
+              <a:rPr sz="850" b="0">
+                <a:solidFill>
+                  <a:srgbClr val="5B6470"/>
+                </a:solidFill>
+                <a:latin typeface="맑은 고딕"/>
+              </a:rPr>
+              <a:t>규제 피드</a:t>
+            </a:r>
+          </a:p>
+        </p:txBody>
+      </p:sp>
+      <p:sp>
+        <p:nvSpPr>
+          <p:cNvPr id="25" name="Rounded Rectangle 24"/>
+          <p:cNvSpPr/>
+          <p:nvPr/>
+        </p:nvSpPr>
+        <p:spPr>
+          <a:xfrm>
+            <a:off x="6729984" y="4114800"/>
+            <a:ext cx="1728216" cy="548640"/>
+          </a:xfrm>
+          <a:prstGeom prst="roundRect">
+            <a:avLst/>
+          </a:prstGeom>
+          <a:solidFill>
+            <a:srgbClr val="FFFFFF"/>
+          </a:solidFill>
+          <a:ln w="9525">
+            <a:solidFill>
+              <a:srgbClr val="F0D99A"/>
+            </a:solidFill>
+          </a:ln>
+          <a:effectLst/>
+        </p:spPr>
+        <p:style>
+          <a:lnRef idx="1">
+            <a:schemeClr val="accent1"/>
+          </a:lnRef>
+          <a:fillRef idx="3">
+            <a:schemeClr val="accent1"/>
+          </a:fillRef>
+          <a:effectRef idx="2">
+            <a:schemeClr val="accent1"/>
+          </a:effectRef>
+          <a:fontRef idx="minor">
+            <a:schemeClr val="lt1"/>
+          </a:fontRef>
+        </p:style>
+        <p:txBody>
+          <a:bodyPr rtlCol="0" anchor="ctr" wrap="square" lIns="54864" rIns="54864" tIns="18288" bIns="18288"/>
+          <a:lstStyle/>
+          <a:p>
+            <a:pPr algn="ctr">
+              <a:lnSpc>
+                <a:spcPct val="100000"/>
+              </a:lnSpc>
+              <a:spcBef>
+                <a:spcPts val="0"/>
+              </a:spcBef>
+              <a:spcAft>
+                <a:spcPts val="100"/>
+              </a:spcAft>
+            </a:pPr>
+            <a:r>
+              <a:rPr sz="950" b="1">
+                <a:solidFill>
+                  <a:srgbClr val="1A1D21"/>
+                </a:solidFill>
+                <a:latin typeface="맑은 고딕"/>
+              </a:rPr>
+              <a:t>승인본 발송 ▶</a:t>
+            </a:r>
+          </a:p>
+          <a:p>
+            <a:pPr algn="ctr">
+              <a:lnSpc>
+                <a:spcPct val="100000"/>
+              </a:lnSpc>
+              <a:spcBef>
+                <a:spcPts val="0"/>
+              </a:spcBef>
+              <a:spcAft>
+                <a:spcPts val="100"/>
+              </a:spcAft>
+            </a:pPr>
+            <a:r>
+              <a:rPr sz="850" b="0">
+                <a:solidFill>
+                  <a:srgbClr val="5B6470"/>
+                </a:solidFill>
+                <a:latin typeface="맑은 고딕"/>
+              </a:rPr>
+              <a:t>알림 요청</a:t>
+            </a:r>
+          </a:p>
+        </p:txBody>
+      </p:sp>
+      <p:sp>
+        <p:nvSpPr>
+          <p:cNvPr id="26" name="TextBox 25"/>
+          <p:cNvSpPr txBox="1"/>
+          <p:nvPr/>
+        </p:nvSpPr>
+        <p:spPr>
+          <a:xfrm>
+            <a:off x="6693408" y="4937760"/>
+            <a:ext cx="1801368" cy="1097280"/>
+          </a:xfrm>
+          <a:prstGeom prst="rect">
+            <a:avLst/>
+          </a:prstGeom>
+          <a:noFill/>
+        </p:spPr>
+        <p:txBody>
+          <a:bodyPr wrap="square" anchor="t" lIns="0" rIns="0" tIns="18288" bIns="18288">
+            <a:spAutoFit/>
+          </a:bodyPr>
+          <a:lstStyle/>
+          <a:p>
+            <a:pPr algn="ctr">
+              <a:lnSpc>
+                <a:spcPct val="100000"/>
+              </a:lnSpc>
+              <a:spcBef>
+                <a:spcPts val="0"/>
+              </a:spcBef>
+              <a:spcAft>
+                <a:spcPts val="100"/>
+              </a:spcAft>
+            </a:pPr>
+            <a:r>
+              <a:rPr sz="850" b="0">
+                <a:solidFill>
+                  <a:srgbClr val="8A6200"/>
+                </a:solidFill>
+                <a:latin typeface="맑은 고딕"/>
+              </a:rPr>
+              <a:t>실시간 그룹/직접 발송 아님 · 보안 검토 통과 트래픽만 허용</a:t>
+            </a:r>
+          </a:p>
+        </p:txBody>
+      </p:sp>
+      <p:sp>
+        <p:nvSpPr>
+          <p:cNvPr id="27" name="Rounded Rectangle 26"/>
+          <p:cNvSpPr/>
+          <p:nvPr/>
+        </p:nvSpPr>
+        <p:spPr>
+          <a:xfrm>
+            <a:off x="8778240" y="1325880"/>
+            <a:ext cx="2999232" cy="5074920"/>
+          </a:xfrm>
+          <a:prstGeom prst="roundRect">
+            <a:avLst/>
+          </a:prstGeom>
+          <a:solidFill>
+            <a:srgbClr val="FFFFFF"/>
+          </a:solidFill>
+          <a:ln w="12700">
+            <a:solidFill>
+              <a:srgbClr val="D8DEE6"/>
+            </a:solidFill>
+          </a:ln>
+          <a:effectLst/>
+        </p:spPr>
+        <p:style>
+          <a:lnRef idx="1">
+            <a:schemeClr val="accent1"/>
+          </a:lnRef>
+          <a:fillRef idx="3">
+            <a:schemeClr val="accent1"/>
+          </a:fillRef>
+          <a:effectRef idx="2">
+            <a:schemeClr val="accent1"/>
+          </a:effectRef>
+          <a:fontRef idx="minor">
+            <a:schemeClr val="lt1"/>
+          </a:fontRef>
+        </p:style>
+        <p:txBody>
+          <a:bodyPr rtlCol="0" anchor="ctr" wrap="square" lIns="54864" rIns="54864" tIns="18288" bIns="18288"/>
+          <a:lstStyle/>
+          <a:p>
+            <a:pPr algn="ctr"/>
+          </a:p>
+        </p:txBody>
+      </p:sp>
+      <p:sp>
+        <p:nvSpPr>
+          <p:cNvPr id="28" name="Rounded Rectangle 27"/>
+          <p:cNvSpPr/>
+          <p:nvPr/>
+        </p:nvSpPr>
+        <p:spPr>
+          <a:xfrm>
+            <a:off x="8778240" y="1325880"/>
+            <a:ext cx="2999232" cy="475488"/>
+          </a:xfrm>
+          <a:prstGeom prst="roundRect">
+            <a:avLst/>
+          </a:prstGeom>
+          <a:solidFill>
+            <a:srgbClr val="EEF1F5"/>
+          </a:solidFill>
+          <a:ln>
+            <a:noFill/>
+          </a:ln>
+          <a:effectLst/>
+        </p:spPr>
+        <p:style>
+          <a:lnRef idx="1">
+            <a:schemeClr val="accent1"/>
+          </a:lnRef>
+          <a:fillRef idx="3">
+            <a:schemeClr val="accent1"/>
+          </a:fillRef>
+          <a:effectRef idx="2">
+            <a:schemeClr val="accent1"/>
+          </a:effectRef>
+          <a:fontRef idx="minor">
+            <a:schemeClr val="lt1"/>
+          </a:fontRef>
+        </p:style>
+        <p:txBody>
+          <a:bodyPr rtlCol="0" anchor="ctr" wrap="square" lIns="164592" rIns="164592" tIns="18288" bIns="18288"/>
+          <a:lstStyle/>
+          <a:p>
+            <a:pPr algn="l">
+              <a:lnSpc>
+                <a:spcPct val="100000"/>
+              </a:lnSpc>
+              <a:spcBef>
+                <a:spcPts val="0"/>
+              </a:spcBef>
+              <a:spcAft>
+                <a:spcPts val="100"/>
+              </a:spcAft>
+            </a:pPr>
+            <a:r>
+              <a:rPr sz="1350" b="1">
+                <a:solidFill>
+                  <a:srgbClr val="003A6E"/>
+                </a:solidFill>
+                <a:latin typeface="맑은 고딕"/>
+              </a:rPr>
+              <a:t>🌐  외부망</a:t>
+            </a:r>
+            <a:r>
+              <a:rPr sz="1000" b="1">
+                <a:solidFill>
+                  <a:srgbClr val="5B6470"/>
+                </a:solidFill>
+                <a:latin typeface="맑은 고딕"/>
+              </a:rPr>
+              <a:t>   [어댑터 교체]</a:t>
+            </a:r>
+          </a:p>
+        </p:txBody>
+      </p:sp>
+      <p:sp>
+        <p:nvSpPr>
+          <p:cNvPr id="29" name="Rounded Rectangle 28"/>
+          <p:cNvSpPr/>
+          <p:nvPr/>
+        </p:nvSpPr>
+        <p:spPr>
+          <a:xfrm>
+            <a:off x="8961120" y="1965960"/>
+            <a:ext cx="2633472" cy="713232"/>
+          </a:xfrm>
+          <a:prstGeom prst="roundRect">
+            <a:avLst/>
+          </a:prstGeom>
+          <a:solidFill>
+            <a:srgbClr val="F7F9FC"/>
+          </a:solidFill>
+          <a:ln w="9525">
+            <a:solidFill>
+              <a:srgbClr val="D8DEE6"/>
+            </a:solidFill>
+          </a:ln>
+          <a:effectLst/>
+        </p:spPr>
+        <p:style>
+          <a:lnRef idx="1">
+            <a:schemeClr val="accent1"/>
+          </a:lnRef>
+          <a:fillRef idx="3">
+            <a:schemeClr val="accent1"/>
+          </a:fillRef>
+          <a:effectRef idx="2">
+            <a:schemeClr val="accent1"/>
+          </a:effectRef>
+          <a:fontRef idx="minor">
+            <a:schemeClr val="lt1"/>
+          </a:fontRef>
+        </p:style>
+        <p:txBody>
+          <a:bodyPr rtlCol="0" anchor="ctr" wrap="square" lIns="128016" rIns="128016" tIns="18288" bIns="18288"/>
+          <a:lstStyle/>
+          <a:p>
+            <a:pPr algn="l">
+              <a:lnSpc>
+                <a:spcPct val="100000"/>
+              </a:lnSpc>
+              <a:spcBef>
+                <a:spcPts val="0"/>
+              </a:spcBef>
+              <a:spcAft>
+                <a:spcPts val="100"/>
+              </a:spcAft>
+            </a:pPr>
+            <a:r>
+              <a:rPr sz="1100" b="1">
+                <a:solidFill>
+                  <a:srgbClr val="1A1D21"/>
+                </a:solidFill>
+                <a:latin typeface="맑은 고딕"/>
+              </a:rPr>
+              <a:t>법제처 OpenAPI</a:t>
+            </a:r>
+          </a:p>
+          <a:p>
+            <a:pPr algn="l">
+              <a:lnSpc>
+                <a:spcPct val="100000"/>
+              </a:lnSpc>
+              <a:spcBef>
+                <a:spcPts val="0"/>
+              </a:spcBef>
+              <a:spcAft>
+                <a:spcPts val="100"/>
+              </a:spcAft>
+            </a:pPr>
+            <a:r>
+              <a:rPr sz="900" b="0">
+                <a:solidFill>
+                  <a:srgbClr val="5B6470"/>
+                </a:solidFill>
+                <a:latin typeface="맑은 고딕"/>
+              </a:rPr>
+              <a:t>규제 변경 · 개정 피드</a:t>
+            </a:r>
+          </a:p>
+        </p:txBody>
+      </p:sp>
+      <p:sp>
+        <p:nvSpPr>
+          <p:cNvPr id="30" name="Rounded Rectangle 29"/>
+          <p:cNvSpPr/>
+          <p:nvPr/>
+        </p:nvSpPr>
+        <p:spPr>
+          <a:xfrm>
+            <a:off x="11064240" y="2185416"/>
+            <a:ext cx="457200" cy="274320"/>
+          </a:xfrm>
+          <a:prstGeom prst="roundRect">
             <a:avLst/>
           </a:prstGeom>
           <a:solidFill>
@@ -3236,184 +4878,131 @@
           </a:fontRef>
         </p:style>
         <p:txBody>
-          <a:bodyPr rtlCol="0" anchor="ctr"/>
-          <a:lstStyle/>
-          <a:p>
-            <a:pPr algn="ctr"/>
-          </a:p>
-        </p:txBody>
-      </p:sp>
-      <p:pic>
-        <p:nvPicPr>
-          <p:cNvPr id="6" name="Picture 5" descr="image3.png"/>
-          <p:cNvPicPr>
-            <a:picLocks noChangeAspect="1"/>
-          </p:cNvPicPr>
-          <p:nvPr/>
-        </p:nvPicPr>
-        <p:blipFill>
-          <a:blip r:embed="rId3"/>
-          <a:stretch>
-            <a:fillRect/>
-          </a:stretch>
-        </p:blipFill>
-        <p:spPr>
-          <a:xfrm>
-            <a:off x="518007" y="1417320"/>
-            <a:ext cx="11155680" cy="4202703"/>
-          </a:xfrm>
-          <a:prstGeom prst="rect">
-            <a:avLst/>
-          </a:prstGeom>
-        </p:spPr>
-      </p:pic>
-      <p:sp>
-        <p:nvSpPr>
-          <p:cNvPr id="7" name="TextBox 6"/>
-          <p:cNvSpPr txBox="1"/>
-          <p:nvPr/>
-        </p:nvSpPr>
-        <p:spPr>
-          <a:xfrm>
-            <a:off x="502920" y="5784615"/>
-            <a:ext cx="11183112" cy="822960"/>
-          </a:xfrm>
-          <a:prstGeom prst="rect">
-            <a:avLst/>
-          </a:prstGeom>
-          <a:noFill/>
-        </p:spPr>
-        <p:txBody>
-          <a:bodyPr wrap="square" anchor="t" lIns="0" rIns="0" tIns="0" bIns="0">
-            <a:spAutoFit/>
-          </a:bodyPr>
+          <a:bodyPr rtlCol="0" anchor="ctr" wrap="square" lIns="54864" rIns="54864" tIns="18288" bIns="18288"/>
           <a:lstStyle/>
           <a:p>
             <a:pPr algn="ctr">
+              <a:lnSpc>
+                <a:spcPct val="100000"/>
+              </a:lnSpc>
               <a:spcBef>
                 <a:spcPts val="0"/>
               </a:spcBef>
               <a:spcAft>
-                <a:spcPts val="200"/>
+                <a:spcPts val="100"/>
               </a:spcAft>
             </a:pPr>
             <a:r>
-              <a:rPr sz="1200" b="1">
-                <a:solidFill>
-                  <a:srgbClr val="1A1D21"/>
+              <a:rPr sz="900" b="1">
+                <a:solidFill>
+                  <a:srgbClr val="FFFFFF"/>
                 </a:solidFill>
                 <a:latin typeface="맑은 고딕"/>
               </a:rPr>
-              <a:t>온프레미스 · 오픈모델(Qwen2.5-7B) · 망분리 3-Zone · 전 과정 휴먼인더루프.  </a:t>
-            </a:r>
-            <a:r>
-              <a:rPr sz="1200" b="0">
-                <a:solidFill>
-                  <a:srgbClr val="5B6470"/>
-                </a:solidFill>
-                <a:latin typeface="맑은 고딕"/>
-              </a:rPr>
-              <a:t>데이터는 내부망(Air-gap)을 벗어나지 않으며, 외부 연동은 DMZ 게이트웨이를 통해 어댑터로 교체된다.</a:t>
-            </a:r>
-          </a:p>
-        </p:txBody>
-      </p:sp>
-      <p:pic>
-        <p:nvPicPr>
-          <p:cNvPr id="8" name="Picture 7" descr="image1.png"/>
-          <p:cNvPicPr>
-            <a:picLocks noChangeAspect="1"/>
-          </p:cNvPicPr>
+              <a:t>F14</a:t>
+            </a:r>
+          </a:p>
+        </p:txBody>
+      </p:sp>
+      <p:sp>
+        <p:nvSpPr>
+          <p:cNvPr id="31" name="Rounded Rectangle 30"/>
+          <p:cNvSpPr/>
           <p:nvPr/>
-        </p:nvPicPr>
-        <p:blipFill>
-          <a:blip r:embed="rId4"/>
-          <a:stretch>
-            <a:fillRect/>
-          </a:stretch>
-        </p:blipFill>
-        <p:spPr>
-          <a:xfrm>
-            <a:off x="10774375" y="6309360"/>
-            <a:ext cx="797242" cy="274320"/>
-          </a:xfrm>
-          <a:prstGeom prst="rect">
+        </p:nvSpPr>
+        <p:spPr>
+          <a:xfrm>
+            <a:off x="8961120" y="2834640"/>
+            <a:ext cx="2633472" cy="713232"/>
+          </a:xfrm>
+          <a:prstGeom prst="roundRect">
             <a:avLst/>
           </a:prstGeom>
-        </p:spPr>
-      </p:pic>
-      <p:sp>
-        <p:nvSpPr>
-          <p:cNvPr id="9" name="TextBox 8"/>
-          <p:cNvSpPr txBox="1"/>
-          <p:nvPr/>
-        </p:nvSpPr>
-        <p:spPr>
-          <a:xfrm>
-            <a:off x="502920" y="6309360"/>
-            <a:ext cx="8229600" cy="365760"/>
-          </a:xfrm>
-          <a:prstGeom prst="rect">
-            <a:avLst/>
-          </a:prstGeom>
-          <a:noFill/>
-        </p:spPr>
-        <p:txBody>
-          <a:bodyPr wrap="square" anchor="ctr" lIns="0" rIns="0" tIns="0" bIns="0">
-            <a:spAutoFit/>
-          </a:bodyPr>
+          <a:solidFill>
+            <a:srgbClr val="F7F9FC"/>
+          </a:solidFill>
+          <a:ln w="9525">
+            <a:solidFill>
+              <a:srgbClr val="D8DEE6"/>
+            </a:solidFill>
+          </a:ln>
+          <a:effectLst/>
+        </p:spPr>
+        <p:style>
+          <a:lnRef idx="1">
+            <a:schemeClr val="accent1"/>
+          </a:lnRef>
+          <a:fillRef idx="3">
+            <a:schemeClr val="accent1"/>
+          </a:fillRef>
+          <a:effectRef idx="2">
+            <a:schemeClr val="accent1"/>
+          </a:effectRef>
+          <a:fontRef idx="minor">
+            <a:schemeClr val="lt1"/>
+          </a:fontRef>
+        </p:style>
+        <p:txBody>
+          <a:bodyPr rtlCol="0" anchor="ctr" wrap="square" lIns="128016" rIns="128016" tIns="18288" bIns="18288"/>
           <a:lstStyle/>
           <a:p>
             <a:pPr algn="l">
+              <a:lnSpc>
+                <a:spcPct val="100000"/>
+              </a:lnSpc>
               <a:spcBef>
                 <a:spcPts val="0"/>
               </a:spcBef>
               <a:spcAft>
-                <a:spcPts val="200"/>
+                <a:spcPts val="100"/>
               </a:spcAft>
             </a:pPr>
             <a:r>
-              <a:rPr sz="1000" b="0">
-                <a:solidFill>
-                  <a:srgbClr val="5B6470"/>
+              <a:rPr sz="1100" b="1">
+                <a:solidFill>
+                  <a:srgbClr val="1A1D21"/>
                 </a:solidFill>
                 <a:latin typeface="맑은 고딕"/>
               </a:rPr>
-              <a:t>JB금융그룹 Fin:AI Challenge · 지정주제2 준법자문가 AI Agent · JB 준법 코파일럿</a:t>
-            </a:r>
-          </a:p>
-        </p:txBody>
-      </p:sp>
-    </p:spTree>
-  </p:cSld>
-  <p:clrMapOvr>
-    <a:masterClrMapping/>
-  </p:clrMapOvr>
-</p:sld>
-</file>
-
-<file path=ppt/slides/slide2.xml><?xml version="1.0" encoding="utf-8"?>
-<p:sld xmlns:a="http://schemas.openxmlformats.org/drawingml/2006/main" xmlns:p="http://schemas.openxmlformats.org/presentationml/2006/main" xmlns:r="http://schemas.openxmlformats.org/officeDocument/2006/relationships">
-  <p:cSld>
-    <p:spTree>
-      <p:nvGrpSpPr>
-        <p:cNvPr id="1" name=""/>
-        <p:cNvGrpSpPr/>
-        <p:nvPr/>
-      </p:nvGrpSpPr>
-      <p:grpSpPr/>
-      <p:sp>
-        <p:nvSpPr>
-          <p:cNvPr id="2" name="Rectangle 1"/>
+              <a:t>FCM · SNS · 알림톡</a:t>
+            </a:r>
+          </a:p>
+          <a:p>
+            <a:pPr algn="l">
+              <a:lnSpc>
+                <a:spcPct val="100000"/>
+              </a:lnSpc>
+              <a:spcBef>
+                <a:spcPts val="0"/>
+              </a:spcBef>
+              <a:spcAft>
+                <a:spcPts val="100"/>
+              </a:spcAft>
+            </a:pPr>
+            <a:r>
+              <a:rPr sz="900" b="0">
+                <a:solidFill>
+                  <a:srgbClr val="5B6470"/>
+                </a:solidFill>
+                <a:latin typeface="맑은 고딕"/>
+              </a:rPr>
+              <a:t>승인본 채널 발송</a:t>
+            </a:r>
+          </a:p>
+        </p:txBody>
+      </p:sp>
+      <p:sp>
+        <p:nvSpPr>
+          <p:cNvPr id="32" name="Rounded Rectangle 31"/>
           <p:cNvSpPr/>
           <p:nvPr/>
         </p:nvSpPr>
         <p:spPr>
           <a:xfrm>
-            <a:off x="0" y="0"/>
-            <a:ext cx="12191695" cy="109728"/>
-          </a:xfrm>
-          <a:prstGeom prst="rect">
+            <a:off x="11064240" y="3054096"/>
+            <a:ext cx="457200" cy="274320"/>
+          </a:xfrm>
+          <a:prstGeom prst="roundRect">
             <a:avLst/>
           </a:prstGeom>
           <a:solidFill>
@@ -3439,91 +5028,131 @@
           </a:fontRef>
         </p:style>
         <p:txBody>
-          <a:bodyPr rtlCol="0" anchor="ctr"/>
-          <a:lstStyle/>
-          <a:p>
-            <a:pPr algn="ctr"/>
-          </a:p>
-        </p:txBody>
-      </p:sp>
-      <p:sp>
-        <p:nvSpPr>
-          <p:cNvPr id="3" name="TextBox 2"/>
-          <p:cNvSpPr txBox="1"/>
-          <p:nvPr/>
-        </p:nvSpPr>
-        <p:spPr>
-          <a:xfrm>
-            <a:off x="502920" y="274320"/>
-            <a:ext cx="8686800" cy="548640"/>
-          </a:xfrm>
-          <a:prstGeom prst="rect">
-            <a:avLst/>
-          </a:prstGeom>
-          <a:noFill/>
-        </p:spPr>
-        <p:txBody>
-          <a:bodyPr wrap="square" anchor="t" lIns="0" rIns="0" tIns="0" bIns="0">
-            <a:spAutoFit/>
-          </a:bodyPr>
-          <a:lstStyle/>
-          <a:p>
-            <a:pPr algn="l">
+          <a:bodyPr rtlCol="0" anchor="ctr" wrap="square" lIns="54864" rIns="54864" tIns="18288" bIns="18288"/>
+          <a:lstStyle/>
+          <a:p>
+            <a:pPr algn="ctr">
+              <a:lnSpc>
+                <a:spcPct val="100000"/>
+              </a:lnSpc>
               <a:spcBef>
                 <a:spcPts val="0"/>
               </a:spcBef>
               <a:spcAft>
-                <a:spcPts val="200"/>
+                <a:spcPts val="100"/>
               </a:spcAft>
             </a:pPr>
             <a:r>
-              <a:rPr sz="2400" b="1">
-                <a:solidFill>
-                  <a:srgbClr val="003A6E"/>
+              <a:rPr sz="900" b="1">
+                <a:solidFill>
+                  <a:srgbClr val="FFFFFF"/>
                 </a:solidFill>
                 <a:latin typeface="맑은 고딕"/>
               </a:rPr>
-              <a:t>구성요소 역할 (Components)</a:t>
-            </a:r>
-          </a:p>
-        </p:txBody>
-      </p:sp>
-      <p:pic>
-        <p:nvPicPr>
-          <p:cNvPr id="4" name="Picture 3" descr="image2.png"/>
-          <p:cNvPicPr>
-            <a:picLocks noChangeAspect="1"/>
-          </p:cNvPicPr>
+              <a:t>F15</a:t>
+            </a:r>
+          </a:p>
+        </p:txBody>
+      </p:sp>
+      <p:sp>
+        <p:nvSpPr>
+          <p:cNvPr id="33" name="Rounded Rectangle 32"/>
+          <p:cNvSpPr/>
           <p:nvPr/>
-        </p:nvPicPr>
-        <p:blipFill>
-          <a:blip r:embed="rId2"/>
-          <a:stretch>
-            <a:fillRect/>
-          </a:stretch>
-        </p:blipFill>
-        <p:spPr>
-          <a:xfrm>
-            <a:off x="9859975" y="274320"/>
-            <a:ext cx="1949782" cy="329184"/>
-          </a:xfrm>
-          <a:prstGeom prst="rect">
+        </p:nvSpPr>
+        <p:spPr>
+          <a:xfrm>
+            <a:off x="8961120" y="3703320"/>
+            <a:ext cx="2633472" cy="713232"/>
+          </a:xfrm>
+          <a:prstGeom prst="roundRect">
             <a:avLst/>
           </a:prstGeom>
-        </p:spPr>
-      </p:pic>
-      <p:sp>
-        <p:nvSpPr>
-          <p:cNvPr id="5" name="Rectangle 4"/>
+          <a:solidFill>
+            <a:srgbClr val="F7F9FC"/>
+          </a:solidFill>
+          <a:ln w="9525">
+            <a:solidFill>
+              <a:srgbClr val="D8DEE6"/>
+            </a:solidFill>
+          </a:ln>
+          <a:effectLst/>
+        </p:spPr>
+        <p:style>
+          <a:lnRef idx="1">
+            <a:schemeClr val="accent1"/>
+          </a:lnRef>
+          <a:fillRef idx="3">
+            <a:schemeClr val="accent1"/>
+          </a:fillRef>
+          <a:effectRef idx="2">
+            <a:schemeClr val="accent1"/>
+          </a:effectRef>
+          <a:fontRef idx="minor">
+            <a:schemeClr val="lt1"/>
+          </a:fontRef>
+        </p:style>
+        <p:txBody>
+          <a:bodyPr rtlCol="0" anchor="ctr" wrap="square" lIns="128016" rIns="128016" tIns="18288" bIns="18288"/>
+          <a:lstStyle/>
+          <a:p>
+            <a:pPr algn="l">
+              <a:lnSpc>
+                <a:spcPct val="100000"/>
+              </a:lnSpc>
+              <a:spcBef>
+                <a:spcPts val="0"/>
+              </a:spcBef>
+              <a:spcAft>
+                <a:spcPts val="100"/>
+              </a:spcAft>
+            </a:pPr>
+            <a:r>
+              <a:rPr sz="1100" b="1">
+                <a:solidFill>
+                  <a:srgbClr val="1A1D21"/>
+                </a:solidFill>
+                <a:latin typeface="맑은 고딕"/>
+              </a:rPr>
+              <a:t>코어뱅킹 상품 DB</a:t>
+            </a:r>
+          </a:p>
+          <a:p>
+            <a:pPr algn="l">
+              <a:lnSpc>
+                <a:spcPct val="100000"/>
+              </a:lnSpc>
+              <a:spcBef>
+                <a:spcPts val="0"/>
+              </a:spcBef>
+              <a:spcAft>
+                <a:spcPts val="100"/>
+              </a:spcAft>
+            </a:pPr>
+            <a:r>
+              <a:rPr sz="900" b="0">
+                <a:solidFill>
+                  <a:srgbClr val="5B6470"/>
+                </a:solidFill>
+                <a:latin typeface="맑은 고딕"/>
+              </a:rPr>
+              <a:t>상품조건 자동 주입</a:t>
+            </a:r>
+          </a:p>
+        </p:txBody>
+      </p:sp>
+      <p:sp>
+        <p:nvSpPr>
+          <p:cNvPr id="34" name="Rounded Rectangle 33"/>
           <p:cNvSpPr/>
           <p:nvPr/>
         </p:nvSpPr>
         <p:spPr>
           <a:xfrm>
-            <a:off x="502920" y="868680"/>
-            <a:ext cx="11183112" cy="25400"/>
-          </a:xfrm>
-          <a:prstGeom prst="rect">
+            <a:off x="11064240" y="3922776"/>
+            <a:ext cx="457200" cy="274320"/>
+          </a:xfrm>
+          <a:prstGeom prst="roundRect">
             <a:avLst/>
           </a:prstGeom>
           <a:solidFill>
@@ -3549,34 +5178,96 @@
           </a:fontRef>
         </p:style>
         <p:txBody>
-          <a:bodyPr rtlCol="0" anchor="ctr"/>
-          <a:lstStyle/>
-          <a:p>
-            <a:pPr algn="ctr"/>
-          </a:p>
-        </p:txBody>
-      </p:sp>
-      <p:sp>
-        <p:nvSpPr>
-          <p:cNvPr id="6" name="Rectangle 5"/>
-          <p:cNvSpPr/>
+          <a:bodyPr rtlCol="0" anchor="ctr" wrap="square" lIns="54864" rIns="54864" tIns="18288" bIns="18288"/>
+          <a:lstStyle/>
+          <a:p>
+            <a:pPr algn="ctr">
+              <a:lnSpc>
+                <a:spcPct val="100000"/>
+              </a:lnSpc>
+              <a:spcBef>
+                <a:spcPts val="0"/>
+              </a:spcBef>
+              <a:spcAft>
+                <a:spcPts val="100"/>
+              </a:spcAft>
+            </a:pPr>
+            <a:r>
+              <a:rPr sz="900" b="1">
+                <a:solidFill>
+                  <a:srgbClr val="FFFFFF"/>
+                </a:solidFill>
+                <a:latin typeface="맑은 고딕"/>
+              </a:rPr>
+              <a:t>F16</a:t>
+            </a:r>
+          </a:p>
+        </p:txBody>
+      </p:sp>
+      <p:sp>
+        <p:nvSpPr>
+          <p:cNvPr id="35" name="TextBox 34"/>
+          <p:cNvSpPr txBox="1"/>
           <p:nvPr/>
         </p:nvSpPr>
         <p:spPr>
           <a:xfrm>
-            <a:off x="502920" y="1234440"/>
-            <a:ext cx="3611880" cy="4800600"/>
+            <a:off x="8961120" y="4617720"/>
+            <a:ext cx="2633472" cy="914400"/>
           </a:xfrm>
           <a:prstGeom prst="rect">
             <a:avLst/>
           </a:prstGeom>
+          <a:noFill/>
+        </p:spPr>
+        <p:txBody>
+          <a:bodyPr wrap="square" anchor="t" lIns="0" rIns="0" tIns="18288" bIns="18288">
+            <a:spAutoFit/>
+          </a:bodyPr>
+          <a:lstStyle/>
+          <a:p>
+            <a:pPr algn="l">
+              <a:lnSpc>
+                <a:spcPct val="100000"/>
+              </a:lnSpc>
+              <a:spcBef>
+                <a:spcPts val="0"/>
+              </a:spcBef>
+              <a:spcAft>
+                <a:spcPts val="100"/>
+              </a:spcAft>
+            </a:pPr>
+            <a:r>
+              <a:rPr sz="850" b="0">
+                <a:solidFill>
+                  <a:srgbClr val="5B6470"/>
+                </a:solidFill>
+                <a:latin typeface="맑은 고딕"/>
+              </a:rPr>
+              <a:t>운영 변동성(규제·발송·상품)을 외부망으로 분리 — 금융권 내부망/외부망 분리 원칙 준수</a:t>
+            </a:r>
+          </a:p>
+        </p:txBody>
+      </p:sp>
+      <p:sp>
+        <p:nvSpPr>
+          <p:cNvPr id="36" name="Left-Right Arrow 35"/>
+          <p:cNvSpPr/>
+          <p:nvPr/>
+        </p:nvSpPr>
+        <p:spPr>
+          <a:xfrm>
+            <a:off x="6364224" y="3520440"/>
+            <a:ext cx="237744" cy="457200"/>
+          </a:xfrm>
+          <a:prstGeom prst="leftRightArrow">
+            <a:avLst/>
+          </a:prstGeom>
           <a:solidFill>
-            <a:srgbClr val="FFFFFF"/>
+            <a:srgbClr val="9AA7B4"/>
           </a:solidFill>
-          <a:ln w="12700">
-            <a:solidFill>
-              <a:srgbClr val="E1E5EA"/>
-            </a:solidFill>
+          <a:ln>
+            <a:noFill/>
           </a:ln>
           <a:effectLst/>
         </p:spPr>
@@ -3604,20 +5295,20 @@
       </p:sp>
       <p:sp>
         <p:nvSpPr>
-          <p:cNvPr id="7" name="Rectangle 6"/>
+          <p:cNvPr id="37" name="Left-Right Arrow 36"/>
           <p:cNvSpPr/>
           <p:nvPr/>
         </p:nvSpPr>
         <p:spPr>
           <a:xfrm>
-            <a:off x="502920" y="1234440"/>
-            <a:ext cx="3611880" cy="91440"/>
-          </a:xfrm>
-          <a:prstGeom prst="rect">
+            <a:off x="8558784" y="3520440"/>
+            <a:ext cx="256032" cy="457200"/>
+          </a:xfrm>
+          <a:prstGeom prst="leftRightArrow">
             <a:avLst/>
           </a:prstGeom>
           <a:solidFill>
-            <a:srgbClr val="00529B"/>
+            <a:srgbClr val="9AA7B4"/>
           </a:solidFill>
           <a:ln>
             <a:noFill/>
@@ -3648,14 +5339,14 @@
       </p:sp>
       <p:sp>
         <p:nvSpPr>
-          <p:cNvPr id="8" name="TextBox 7"/>
+          <p:cNvPr id="38" name="TextBox 37"/>
           <p:cNvSpPr txBox="1"/>
           <p:nvPr/>
         </p:nvSpPr>
         <p:spPr>
           <a:xfrm>
-            <a:off x="704088" y="1508760"/>
-            <a:ext cx="3209544" cy="822960"/>
+            <a:off x="411480" y="6400800"/>
+            <a:ext cx="11338560" cy="320040"/>
           </a:xfrm>
           <a:prstGeom prst="rect">
             <a:avLst/>
@@ -3663,705 +5354,24 @@
           <a:noFill/>
         </p:spPr>
         <p:txBody>
-          <a:bodyPr wrap="square" anchor="t" lIns="0" rIns="0" tIns="0" bIns="0">
+          <a:bodyPr wrap="square" anchor="t" lIns="0" rIns="0" tIns="18288" bIns="18288">
             <a:spAutoFit/>
           </a:bodyPr>
           <a:lstStyle/>
           <a:p>
             <a:pPr algn="l">
+              <a:lnSpc>
+                <a:spcPct val="100000"/>
+              </a:lnSpc>
               <a:spcBef>
                 <a:spcPts val="0"/>
               </a:spcBef>
               <a:spcAft>
-                <a:spcPts val="300"/>
+                <a:spcPts val="100"/>
               </a:spcAft>
             </a:pPr>
             <a:r>
-              <a:rPr sz="1400" b="1">
-                <a:solidFill>
-                  <a:srgbClr val="00529B"/>
-                </a:solidFill>
-                <a:latin typeface="맑은 고딕"/>
-              </a:rPr>
-              <a:t>🔒 내부망 (Air-gap) — 심의 코어</a:t>
-            </a:r>
-          </a:p>
-          <a:p>
-            <a:pPr algn="l">
-              <a:spcBef>
-                <a:spcPts val="0"/>
-              </a:spcBef>
-              <a:spcAft>
-                <a:spcPts val="300"/>
-              </a:spcAft>
-            </a:pPr>
-            <a:r>
-              <a:rPr sz="1100" b="1">
-                <a:solidFill>
-                  <a:srgbClr val="5B6470"/>
-                </a:solidFill>
-                <a:latin typeface="맑은 고딕"/>
-              </a:rPr>
-              <a:t>데이터 외부 유출 0</a:t>
-            </a:r>
-          </a:p>
-        </p:txBody>
-      </p:sp>
-      <p:sp>
-        <p:nvSpPr>
-          <p:cNvPr id="9" name="TextBox 8"/>
-          <p:cNvSpPr txBox="1"/>
-          <p:nvPr/>
-        </p:nvSpPr>
-        <p:spPr>
-          <a:xfrm>
-            <a:off x="704088" y="2423160"/>
-            <a:ext cx="3209544" cy="3474720"/>
-          </a:xfrm>
-          <a:prstGeom prst="rect">
-            <a:avLst/>
-          </a:prstGeom>
-          <a:noFill/>
-        </p:spPr>
-        <p:txBody>
-          <a:bodyPr wrap="square" anchor="t" lIns="0" rIns="0" tIns="0" bIns="0">
-            <a:spAutoFit/>
-          </a:bodyPr>
-          <a:lstStyle/>
-          <a:p>
-            <a:pPr algn="l">
-              <a:spcBef>
-                <a:spcPts val="0"/>
-              </a:spcBef>
-              <a:spcAft>
-                <a:spcPts val="800"/>
-              </a:spcAft>
-            </a:pPr>
-            <a:r>
-              <a:rPr sz="1150" b="0">
-                <a:solidFill>
-                  <a:srgbClr val="1A1D21"/>
-                </a:solidFill>
-                <a:latin typeface="맑은 고딕"/>
-              </a:rPr>
-              <a:t>• 정적 SPA(작성·시뮬레이터·승인·감사로그) + FastAPI Orchestrator</a:t>
-            </a:r>
-          </a:p>
-          <a:p>
-            <a:pPr algn="l">
-              <a:spcBef>
-                <a:spcPts val="0"/>
-              </a:spcBef>
-              <a:spcAft>
-                <a:spcPts val="800"/>
-              </a:spcAft>
-            </a:pPr>
-            <a:r>
-              <a:rPr sz="1150" b="0">
-                <a:solidFill>
-                  <a:srgbClr val="1A1D21"/>
-                </a:solidFill>
-                <a:latin typeface="맑은 고딕"/>
-              </a:rPr>
-              <a:t>• 명시적 파이프라인: 유형분류 → RAG 근거검색 ∥ 룰엔진(결정적 권위)</a:t>
-            </a:r>
-          </a:p>
-          <a:p>
-            <a:pPr algn="l">
-              <a:spcBef>
-                <a:spcPts val="0"/>
-              </a:spcBef>
-              <a:spcAft>
-                <a:spcPts val="800"/>
-              </a:spcAft>
-            </a:pPr>
-            <a:r>
-              <a:rPr sz="1150" b="0">
-                <a:solidFill>
-                  <a:srgbClr val="1A1D21"/>
-                </a:solidFill>
-                <a:latin typeface="맑은 고딕"/>
-              </a:rPr>
-              <a:t>• → LLM 뉘앙스 심의 ∥ 오인 시뮬레이터 → 리포트·점수·인용</a:t>
-            </a:r>
-          </a:p>
-          <a:p>
-            <a:pPr algn="l">
-              <a:spcBef>
-                <a:spcPts val="0"/>
-              </a:spcBef>
-              <a:spcAft>
-                <a:spcPts val="800"/>
-              </a:spcAft>
-            </a:pPr>
-            <a:r>
-              <a:rPr sz="1150" b="0">
-                <a:solidFill>
-                  <a:srgbClr val="1A1D21"/>
-                </a:solidFill>
-                <a:latin typeface="맑은 고딕"/>
-              </a:rPr>
-              <a:t>• → 준법관리자 승인 · 감사로그</a:t>
-            </a:r>
-          </a:p>
-          <a:p>
-            <a:pPr algn="l">
-              <a:spcBef>
-                <a:spcPts val="0"/>
-              </a:spcBef>
-              <a:spcAft>
-                <a:spcPts val="800"/>
-              </a:spcAft>
-            </a:pPr>
-            <a:r>
-              <a:rPr sz="1150" b="0">
-                <a:solidFill>
-                  <a:srgbClr val="1A1D21"/>
-                </a:solidFill>
-                <a:latin typeface="맑은 고딕"/>
-              </a:rPr>
-              <a:t>• ★준법 오토파일럿 — 통과까지 자율 개선(미수렴 시 사람 에스컬레이션)</a:t>
-            </a:r>
-          </a:p>
-          <a:p>
-            <a:pPr algn="l">
-              <a:spcBef>
-                <a:spcPts val="0"/>
-              </a:spcBef>
-              <a:spcAft>
-                <a:spcPts val="800"/>
-              </a:spcAft>
-            </a:pPr>
-            <a:r>
-              <a:rPr sz="1150" b="0">
-                <a:solidFill>
-                  <a:srgbClr val="1A1D21"/>
-                </a:solidFill>
-                <a:latin typeface="맑은 고딕"/>
-              </a:rPr>
-              <a:t>• LLM 서버: Ollama(Qwen2.5-7B) — 미연결 시 룰 기반 폴백</a:t>
-            </a:r>
-          </a:p>
-        </p:txBody>
-      </p:sp>
-      <p:sp>
-        <p:nvSpPr>
-          <p:cNvPr id="10" name="Rectangle 9"/>
-          <p:cNvSpPr/>
-          <p:nvPr/>
-        </p:nvSpPr>
-        <p:spPr>
-          <a:xfrm>
-            <a:off x="4315968" y="1234440"/>
-            <a:ext cx="3611880" cy="4800600"/>
-          </a:xfrm>
-          <a:prstGeom prst="rect">
-            <a:avLst/>
-          </a:prstGeom>
-          <a:solidFill>
-            <a:srgbClr val="FFFFFF"/>
-          </a:solidFill>
-          <a:ln w="12700">
-            <a:solidFill>
-              <a:srgbClr val="E1E5EA"/>
-            </a:solidFill>
-          </a:ln>
-          <a:effectLst/>
-        </p:spPr>
-        <p:style>
-          <a:lnRef idx="1">
-            <a:schemeClr val="accent1"/>
-          </a:lnRef>
-          <a:fillRef idx="3">
-            <a:schemeClr val="accent1"/>
-          </a:fillRef>
-          <a:effectRef idx="2">
-            <a:schemeClr val="accent1"/>
-          </a:effectRef>
-          <a:fontRef idx="minor">
-            <a:schemeClr val="lt1"/>
-          </a:fontRef>
-        </p:style>
-        <p:txBody>
-          <a:bodyPr rtlCol="0" anchor="ctr"/>
-          <a:lstStyle/>
-          <a:p>
-            <a:pPr algn="ctr"/>
-          </a:p>
-        </p:txBody>
-      </p:sp>
-      <p:sp>
-        <p:nvSpPr>
-          <p:cNvPr id="11" name="Rectangle 10"/>
-          <p:cNvSpPr/>
-          <p:nvPr/>
-        </p:nvSpPr>
-        <p:spPr>
-          <a:xfrm>
-            <a:off x="4315968" y="1234440"/>
-            <a:ext cx="3611880" cy="91440"/>
-          </a:xfrm>
-          <a:prstGeom prst="rect">
-            <a:avLst/>
-          </a:prstGeom>
-          <a:solidFill>
-            <a:srgbClr val="C78A06"/>
-          </a:solidFill>
-          <a:ln>
-            <a:noFill/>
-          </a:ln>
-          <a:effectLst/>
-        </p:spPr>
-        <p:style>
-          <a:lnRef idx="1">
-            <a:schemeClr val="accent1"/>
-          </a:lnRef>
-          <a:fillRef idx="3">
-            <a:schemeClr val="accent1"/>
-          </a:fillRef>
-          <a:effectRef idx="2">
-            <a:schemeClr val="accent1"/>
-          </a:effectRef>
-          <a:fontRef idx="minor">
-            <a:schemeClr val="lt1"/>
-          </a:fontRef>
-        </p:style>
-        <p:txBody>
-          <a:bodyPr rtlCol="0" anchor="ctr"/>
-          <a:lstStyle/>
-          <a:p>
-            <a:pPr algn="ctr"/>
-          </a:p>
-        </p:txBody>
-      </p:sp>
-      <p:sp>
-        <p:nvSpPr>
-          <p:cNvPr id="12" name="TextBox 11"/>
-          <p:cNvSpPr txBox="1"/>
-          <p:nvPr/>
-        </p:nvSpPr>
-        <p:spPr>
-          <a:xfrm>
-            <a:off x="4517136" y="1508760"/>
-            <a:ext cx="3209544" cy="822960"/>
-          </a:xfrm>
-          <a:prstGeom prst="rect">
-            <a:avLst/>
-          </a:prstGeom>
-          <a:noFill/>
-        </p:spPr>
-        <p:txBody>
-          <a:bodyPr wrap="square" anchor="t" lIns="0" rIns="0" tIns="0" bIns="0">
-            <a:spAutoFit/>
-          </a:bodyPr>
-          <a:lstStyle/>
-          <a:p>
-            <a:pPr algn="l">
-              <a:spcBef>
-                <a:spcPts val="0"/>
-              </a:spcBef>
-              <a:spcAft>
-                <a:spcPts val="300"/>
-              </a:spcAft>
-            </a:pPr>
-            <a:r>
-              <a:rPr sz="1400" b="1">
-                <a:solidFill>
-                  <a:srgbClr val="C78A06"/>
-                </a:solidFill>
-                <a:latin typeface="맑은 고딕"/>
-              </a:rPr>
-              <a:t>🔁 DMZ — 망연계 게이트웨이</a:t>
-            </a:r>
-          </a:p>
-          <a:p>
-            <a:pPr algn="l">
-              <a:spcBef>
-                <a:spcPts val="0"/>
-              </a:spcBef>
-              <a:spcAft>
-                <a:spcPts val="300"/>
-              </a:spcAft>
-            </a:pPr>
-            <a:r>
-              <a:rPr sz="1100" b="1">
-                <a:solidFill>
-                  <a:srgbClr val="5B6470"/>
-                </a:solidFill>
-                <a:latin typeface="맑은 고딕"/>
-              </a:rPr>
-              <a:t>단방향·배치 연계</a:t>
-            </a:r>
-          </a:p>
-        </p:txBody>
-      </p:sp>
-      <p:sp>
-        <p:nvSpPr>
-          <p:cNvPr id="13" name="TextBox 12"/>
-          <p:cNvSpPr txBox="1"/>
-          <p:nvPr/>
-        </p:nvSpPr>
-        <p:spPr>
-          <a:xfrm>
-            <a:off x="4517136" y="2423160"/>
-            <a:ext cx="3209544" cy="3474720"/>
-          </a:xfrm>
-          <a:prstGeom prst="rect">
-            <a:avLst/>
-          </a:prstGeom>
-          <a:noFill/>
-        </p:spPr>
-        <p:txBody>
-          <a:bodyPr wrap="square" anchor="t" lIns="0" rIns="0" tIns="0" bIns="0">
-            <a:spAutoFit/>
-          </a:bodyPr>
-          <a:lstStyle/>
-          <a:p>
-            <a:pPr algn="l">
-              <a:spcBef>
-                <a:spcPts val="0"/>
-              </a:spcBef>
-              <a:spcAft>
-                <a:spcPts val="800"/>
-              </a:spcAft>
-            </a:pPr>
-            <a:r>
-              <a:rPr sz="1150" b="0">
-                <a:solidFill>
-                  <a:srgbClr val="1A1D21"/>
-                </a:solidFill>
-                <a:latin typeface="맑은 고딕"/>
-              </a:rPr>
-              <a:t>• 내부망 ↔ 외부망을 직접 연결하지 않고 게이트웨이로 중계</a:t>
-            </a:r>
-          </a:p>
-          <a:p>
-            <a:pPr algn="l">
-              <a:spcBef>
-                <a:spcPts val="0"/>
-              </a:spcBef>
-              <a:spcAft>
-                <a:spcPts val="800"/>
-              </a:spcAft>
-            </a:pPr>
-            <a:r>
-              <a:rPr sz="1150" b="0">
-                <a:solidFill>
-                  <a:srgbClr val="1A1D21"/>
-                </a:solidFill>
-                <a:latin typeface="맑은 고딕"/>
-              </a:rPr>
-              <a:t>• 배치 수신(규제 피드) · 승인본 발송(알림 요청)만 통과</a:t>
-            </a:r>
-          </a:p>
-          <a:p>
-            <a:pPr algn="l">
-              <a:spcBef>
-                <a:spcPts val="0"/>
-              </a:spcBef>
-              <a:spcAft>
-                <a:spcPts val="800"/>
-              </a:spcAft>
-            </a:pPr>
-            <a:r>
-              <a:rPr sz="1150" b="0">
-                <a:solidFill>
-                  <a:srgbClr val="1A1D21"/>
-                </a:solidFill>
-                <a:latin typeface="맑은 고딕"/>
-              </a:rPr>
-              <a:t>• 실시간 그룹발송 아님 · 보안 검토 통과 트래픽만 허용</a:t>
-            </a:r>
-          </a:p>
-        </p:txBody>
-      </p:sp>
-      <p:sp>
-        <p:nvSpPr>
-          <p:cNvPr id="14" name="Rectangle 13"/>
-          <p:cNvSpPr/>
-          <p:nvPr/>
-        </p:nvSpPr>
-        <p:spPr>
-          <a:xfrm>
-            <a:off x="8129016" y="1234440"/>
-            <a:ext cx="3611880" cy="4800600"/>
-          </a:xfrm>
-          <a:prstGeom prst="rect">
-            <a:avLst/>
-          </a:prstGeom>
-          <a:solidFill>
-            <a:srgbClr val="FFFFFF"/>
-          </a:solidFill>
-          <a:ln w="12700">
-            <a:solidFill>
-              <a:srgbClr val="E1E5EA"/>
-            </a:solidFill>
-          </a:ln>
-          <a:effectLst/>
-        </p:spPr>
-        <p:style>
-          <a:lnRef idx="1">
-            <a:schemeClr val="accent1"/>
-          </a:lnRef>
-          <a:fillRef idx="3">
-            <a:schemeClr val="accent1"/>
-          </a:fillRef>
-          <a:effectRef idx="2">
-            <a:schemeClr val="accent1"/>
-          </a:effectRef>
-          <a:fontRef idx="minor">
-            <a:schemeClr val="lt1"/>
-          </a:fontRef>
-        </p:style>
-        <p:txBody>
-          <a:bodyPr rtlCol="0" anchor="ctr"/>
-          <a:lstStyle/>
-          <a:p>
-            <a:pPr algn="ctr"/>
-          </a:p>
-        </p:txBody>
-      </p:sp>
-      <p:sp>
-        <p:nvSpPr>
-          <p:cNvPr id="15" name="Rectangle 14"/>
-          <p:cNvSpPr/>
-          <p:nvPr/>
-        </p:nvSpPr>
-        <p:spPr>
-          <a:xfrm>
-            <a:off x="8129016" y="1234440"/>
-            <a:ext cx="3611880" cy="91440"/>
-          </a:xfrm>
-          <a:prstGeom prst="rect">
-            <a:avLst/>
-          </a:prstGeom>
-          <a:solidFill>
-            <a:srgbClr val="003A6E"/>
-          </a:solidFill>
-          <a:ln>
-            <a:noFill/>
-          </a:ln>
-          <a:effectLst/>
-        </p:spPr>
-        <p:style>
-          <a:lnRef idx="1">
-            <a:schemeClr val="accent1"/>
-          </a:lnRef>
-          <a:fillRef idx="3">
-            <a:schemeClr val="accent1"/>
-          </a:fillRef>
-          <a:effectRef idx="2">
-            <a:schemeClr val="accent1"/>
-          </a:effectRef>
-          <a:fontRef idx="minor">
-            <a:schemeClr val="lt1"/>
-          </a:fontRef>
-        </p:style>
-        <p:txBody>
-          <a:bodyPr rtlCol="0" anchor="ctr"/>
-          <a:lstStyle/>
-          <a:p>
-            <a:pPr algn="ctr"/>
-          </a:p>
-        </p:txBody>
-      </p:sp>
-      <p:sp>
-        <p:nvSpPr>
-          <p:cNvPr id="16" name="TextBox 15"/>
-          <p:cNvSpPr txBox="1"/>
-          <p:nvPr/>
-        </p:nvSpPr>
-        <p:spPr>
-          <a:xfrm>
-            <a:off x="8330184" y="1508760"/>
-            <a:ext cx="3209544" cy="822960"/>
-          </a:xfrm>
-          <a:prstGeom prst="rect">
-            <a:avLst/>
-          </a:prstGeom>
-          <a:noFill/>
-        </p:spPr>
-        <p:txBody>
-          <a:bodyPr wrap="square" anchor="t" lIns="0" rIns="0" tIns="0" bIns="0">
-            <a:spAutoFit/>
-          </a:bodyPr>
-          <a:lstStyle/>
-          <a:p>
-            <a:pPr algn="l">
-              <a:spcBef>
-                <a:spcPts val="0"/>
-              </a:spcBef>
-              <a:spcAft>
-                <a:spcPts val="300"/>
-              </a:spcAft>
-            </a:pPr>
-            <a:r>
-              <a:rPr sz="1400" b="1">
-                <a:solidFill>
-                  <a:srgbClr val="003A6E"/>
-                </a:solidFill>
-                <a:latin typeface="맑은 고딕"/>
-              </a:rPr>
-              <a:t>🌐 외부망 — 어댑터 교체</a:t>
-            </a:r>
-          </a:p>
-          <a:p>
-            <a:pPr algn="l">
-              <a:spcBef>
-                <a:spcPts val="0"/>
-              </a:spcBef>
-              <a:spcAft>
-                <a:spcPts val="300"/>
-              </a:spcAft>
-            </a:pPr>
-            <a:r>
-              <a:rPr sz="1100" b="1">
-                <a:solidFill>
-                  <a:srgbClr val="5B6470"/>
-                </a:solidFill>
-                <a:latin typeface="맑은 고딕"/>
-              </a:rPr>
-              <a:t>운영 시 실제 API로 교체</a:t>
-            </a:r>
-          </a:p>
-        </p:txBody>
-      </p:sp>
-      <p:sp>
-        <p:nvSpPr>
-          <p:cNvPr id="17" name="TextBox 16"/>
-          <p:cNvSpPr txBox="1"/>
-          <p:nvPr/>
-        </p:nvSpPr>
-        <p:spPr>
-          <a:xfrm>
-            <a:off x="8330184" y="2423160"/>
-            <a:ext cx="3209544" cy="3474720"/>
-          </a:xfrm>
-          <a:prstGeom prst="rect">
-            <a:avLst/>
-          </a:prstGeom>
-          <a:noFill/>
-        </p:spPr>
-        <p:txBody>
-          <a:bodyPr wrap="square" anchor="t" lIns="0" rIns="0" tIns="0" bIns="0">
-            <a:spAutoFit/>
-          </a:bodyPr>
-          <a:lstStyle/>
-          <a:p>
-            <a:pPr algn="l">
-              <a:spcBef>
-                <a:spcPts val="0"/>
-              </a:spcBef>
-              <a:spcAft>
-                <a:spcPts val="800"/>
-              </a:spcAft>
-            </a:pPr>
-            <a:r>
-              <a:rPr sz="1150" b="0">
-                <a:solidFill>
-                  <a:srgbClr val="1A1D21"/>
-                </a:solidFill>
-                <a:latin typeface="맑은 고딕"/>
-              </a:rPr>
-              <a:t>• 법제처 OpenAPI — 규제 변경·개정 피드 (F14 규제 자동추적)</a:t>
-            </a:r>
-          </a:p>
-          <a:p>
-            <a:pPr algn="l">
-              <a:spcBef>
-                <a:spcPts val="0"/>
-              </a:spcBef>
-              <a:spcAft>
-                <a:spcPts val="800"/>
-              </a:spcAft>
-            </a:pPr>
-            <a:r>
-              <a:rPr sz="1150" b="0">
-                <a:solidFill>
-                  <a:srgbClr val="1A1D21"/>
-                </a:solidFill>
-                <a:latin typeface="맑은 고딕"/>
-              </a:rPr>
-              <a:t>• FCM · SNS · 알림톡 — 승인본 채널 발송 (F15 배포 Last-Mile)</a:t>
-            </a:r>
-          </a:p>
-          <a:p>
-            <a:pPr algn="l">
-              <a:spcBef>
-                <a:spcPts val="0"/>
-              </a:spcBef>
-              <a:spcAft>
-                <a:spcPts val="800"/>
-              </a:spcAft>
-            </a:pPr>
-            <a:r>
-              <a:rPr sz="1150" b="0">
-                <a:solidFill>
-                  <a:srgbClr val="1A1D21"/>
-                </a:solidFill>
-                <a:latin typeface="맑은 고딕"/>
-              </a:rPr>
-              <a:t>• 코어뱅킹 상품 DB — 상품조건 자동 주입 (F16 상품 연동)</a:t>
-            </a:r>
-          </a:p>
-        </p:txBody>
-      </p:sp>
-      <p:pic>
-        <p:nvPicPr>
-          <p:cNvPr id="18" name="Picture 17" descr="image1.png"/>
-          <p:cNvPicPr>
-            <a:picLocks noChangeAspect="1"/>
-          </p:cNvPicPr>
-          <p:nvPr/>
-        </p:nvPicPr>
-        <p:blipFill>
-          <a:blip r:embed="rId3"/>
-          <a:stretch>
-            <a:fillRect/>
-          </a:stretch>
-        </p:blipFill>
-        <p:spPr>
-          <a:xfrm>
-            <a:off x="10774375" y="6309360"/>
-            <a:ext cx="797242" cy="274320"/>
-          </a:xfrm>
-          <a:prstGeom prst="rect">
-            <a:avLst/>
-          </a:prstGeom>
-        </p:spPr>
-      </p:pic>
-      <p:sp>
-        <p:nvSpPr>
-          <p:cNvPr id="19" name="TextBox 18"/>
-          <p:cNvSpPr txBox="1"/>
-          <p:nvPr/>
-        </p:nvSpPr>
-        <p:spPr>
-          <a:xfrm>
-            <a:off x="502920" y="6309360"/>
-            <a:ext cx="8229600" cy="365760"/>
-          </a:xfrm>
-          <a:prstGeom prst="rect">
-            <a:avLst/>
-          </a:prstGeom>
-          <a:noFill/>
-        </p:spPr>
-        <p:txBody>
-          <a:bodyPr wrap="square" anchor="ctr" lIns="0" rIns="0" tIns="0" bIns="0">
-            <a:spAutoFit/>
-          </a:bodyPr>
-          <a:lstStyle/>
-          <a:p>
-            <a:pPr algn="l">
-              <a:spcBef>
-                <a:spcPts val="0"/>
-              </a:spcBef>
-              <a:spcAft>
-                <a:spcPts val="200"/>
-              </a:spcAft>
-            </a:pPr>
-            <a:r>
-              <a:rPr sz="1000" b="0">
+              <a:rPr sz="950" b="0">
                 <a:solidFill>
                   <a:srgbClr val="5B6470"/>
                 </a:solidFill>

</xml_diff>

<commit_message>
docs: redraw architecture as technical layered data-flow (not 망분리 view)
양식 가이드(사용자 입력→AI Agent/모델→백엔드/API→DB/외부연동→프론트엔드/UI)에 맞춰
기술 계층 흐름으로 재구성. 5계층(사용자·프론트UI·백엔드API·AI Agent모델·DB외부연동),
계층간 화살표(REST·추론·조회), AI 코어에 파이프라인 8단계+오토파일럿+Ollama+BGE-m3.
전부 편집 가능한 PowerPoint 도형.

Co-Authored-By: Claude Opus 4.8 (1M context) <noreply@anthropic.com>
</commit_message>
<xml_diff>
--- a/docs/submission/JB준법코파일럿_시스템아키텍처.pptx
+++ b/docs/submission/JB준법코파일럿_시스템아키텍처.pptx
@@ -3096,7 +3096,7 @@
         </p:nvSpPr>
         <p:spPr>
           <a:xfrm>
-            <a:off x="411480" y="237744"/>
+            <a:off x="411480" y="219456"/>
             <a:ext cx="10058400" cy="457200"/>
           </a:xfrm>
           <a:prstGeom prst="rect">
@@ -3105,7 +3105,7 @@
           <a:noFill/>
         </p:spPr>
         <p:txBody>
-          <a:bodyPr wrap="square" anchor="t" lIns="0" rIns="0" tIns="18288" bIns="18288">
+          <a:bodyPr wrap="square" anchor="t" lIns="0" rIns="0" tIns="9144" bIns="9144">
             <a:spAutoFit/>
           </a:bodyPr>
           <a:lstStyle/>
@@ -3118,7 +3118,7 @@
                 <a:spcPts val="0"/>
               </a:spcBef>
               <a:spcAft>
-                <a:spcPts val="100"/>
+                <a:spcPts val="0"/>
               </a:spcAft>
             </a:pPr>
             <a:r>
@@ -3141,8 +3141,8 @@
         </p:nvSpPr>
         <p:spPr>
           <a:xfrm>
-            <a:off x="429768" y="713232"/>
-            <a:ext cx="10972800" cy="320040"/>
+            <a:off x="429768" y="694944"/>
+            <a:ext cx="10972800" cy="292608"/>
           </a:xfrm>
           <a:prstGeom prst="rect">
             <a:avLst/>
@@ -3150,7 +3150,7 @@
           <a:noFill/>
         </p:spPr>
         <p:txBody>
-          <a:bodyPr wrap="square" anchor="t" lIns="0" rIns="0" tIns="18288" bIns="18288">
+          <a:bodyPr wrap="square" anchor="t" lIns="0" rIns="0" tIns="9144" bIns="9144">
             <a:spAutoFit/>
           </a:bodyPr>
           <a:lstStyle/>
@@ -3163,7 +3163,7 @@
                 <a:spcPts val="0"/>
               </a:spcBef>
               <a:spcAft>
-                <a:spcPts val="100"/>
+                <a:spcPts val="0"/>
               </a:spcAft>
             </a:pPr>
             <a:r>
@@ -3173,7 +3173,7 @@
                 </a:solidFill>
                 <a:latin typeface="맑은 고딕"/>
               </a:rPr>
-              <a:t>온프레미스 · 오픈모델(Qwen2.5-7B) · 망분리 3-Zone · 전 과정 휴먼인더루프</a:t>
+              <a:t>사용자 → 프론트엔드/UI → 백엔드/API → AI Agent·모델 → DB·외부연동 (전 과정 온프레미스 · 휴먼인더루프)</a:t>
             </a:r>
           </a:p>
         </p:txBody>
@@ -3186,7 +3186,7 @@
         </p:nvSpPr>
         <p:spPr>
           <a:xfrm>
-            <a:off x="411480" y="1051560"/>
+            <a:off x="411480" y="1033271"/>
             <a:ext cx="11365992" cy="31750"/>
           </a:xfrm>
           <a:prstGeom prst="rect">
@@ -3215,7 +3215,7 @@
           </a:fontRef>
         </p:style>
         <p:txBody>
-          <a:bodyPr rtlCol="0" anchor="ctr" wrap="square" lIns="54864" rIns="54864" tIns="18288" bIns="18288"/>
+          <a:bodyPr rtlCol="0" anchor="ctr" wrap="square" lIns="64008" rIns="64008" tIns="9144" bIns="9144"/>
           <a:lstStyle/>
           <a:p>
             <a:pPr algn="ctr"/>
@@ -3230,16 +3230,79 @@
         </p:nvSpPr>
         <p:spPr>
           <a:xfrm>
-            <a:off x="411480" y="1325880"/>
-            <a:ext cx="5989320" cy="5074920"/>
+            <a:off x="457200" y="1207008"/>
+            <a:ext cx="1965960" cy="658368"/>
           </a:xfrm>
           <a:prstGeom prst="roundRect">
             <a:avLst/>
           </a:prstGeom>
           <a:solidFill>
-            <a:srgbClr val="FFFFFF"/>
+            <a:srgbClr val="5B6470"/>
           </a:solidFill>
-          <a:ln w="12700">
+          <a:ln>
+            <a:noFill/>
+          </a:ln>
+          <a:effectLst/>
+        </p:spPr>
+        <p:style>
+          <a:lnRef idx="1">
+            <a:schemeClr val="accent1"/>
+          </a:lnRef>
+          <a:fillRef idx="3">
+            <a:schemeClr val="accent1"/>
+          </a:fillRef>
+          <a:effectRef idx="2">
+            <a:schemeClr val="accent1"/>
+          </a:effectRef>
+          <a:fontRef idx="minor">
+            <a:schemeClr val="lt1"/>
+          </a:fontRef>
+        </p:style>
+        <p:txBody>
+          <a:bodyPr rtlCol="0" anchor="ctr" wrap="square" lIns="64008" rIns="64008" tIns="9144" bIns="9144"/>
+          <a:lstStyle/>
+          <a:p>
+            <a:pPr algn="ctr">
+              <a:lnSpc>
+                <a:spcPct val="100000"/>
+              </a:lnSpc>
+              <a:spcBef>
+                <a:spcPts val="0"/>
+              </a:spcBef>
+              <a:spcAft>
+                <a:spcPts val="0"/>
+              </a:spcAft>
+            </a:pPr>
+            <a:r>
+              <a:rPr sz="1250" b="1">
+                <a:solidFill>
+                  <a:srgbClr val="FFFFFF"/>
+                </a:solidFill>
+                <a:latin typeface="맑은 고딕"/>
+              </a:rPr>
+              <a:t>👤 사용자</a:t>
+            </a:r>
+          </a:p>
+        </p:txBody>
+      </p:sp>
+      <p:sp>
+        <p:nvSpPr>
+          <p:cNvPr id="6" name="Rounded Rectangle 5"/>
+          <p:cNvSpPr/>
+          <p:nvPr/>
+        </p:nvSpPr>
+        <p:spPr>
+          <a:xfrm>
+            <a:off x="2560320" y="1207008"/>
+            <a:ext cx="4512564" cy="658368"/>
+          </a:xfrm>
+          <a:prstGeom prst="roundRect">
+            <a:avLst/>
+          </a:prstGeom>
+          <a:solidFill>
+            <a:srgbClr val="EEF1F5"/>
+          </a:solidFill>
+          <a:ln w="9525">
             <a:solidFill>
               <a:srgbClr val="D8DEE6"/>
             </a:solidFill>
@@ -3261,29 +3324,157 @@
           </a:fontRef>
         </p:style>
         <p:txBody>
-          <a:bodyPr rtlCol="0" anchor="ctr" wrap="square" lIns="54864" rIns="54864" tIns="18288" bIns="18288"/>
-          <a:lstStyle/>
-          <a:p>
-            <a:pPr algn="ctr"/>
-          </a:p>
-        </p:txBody>
-      </p:sp>
-      <p:sp>
-        <p:nvSpPr>
-          <p:cNvPr id="6" name="Rounded Rectangle 5"/>
+          <a:bodyPr rtlCol="0" anchor="ctr" wrap="square" lIns="64008" rIns="64008" tIns="9144" bIns="9144"/>
+          <a:lstStyle/>
+          <a:p>
+            <a:pPr algn="l">
+              <a:lnSpc>
+                <a:spcPct val="100000"/>
+              </a:lnSpc>
+              <a:spcBef>
+                <a:spcPts val="0"/>
+              </a:spcBef>
+              <a:spcAft>
+                <a:spcPts val="0"/>
+              </a:spcAft>
+            </a:pPr>
+            <a:r>
+              <a:rPr sz="1050" b="1">
+                <a:solidFill>
+                  <a:srgbClr val="1A1D21"/>
+                </a:solidFill>
+                <a:latin typeface="맑은 고딕"/>
+              </a:rPr>
+              <a:t>마케팅 · 지점 담당자</a:t>
+            </a:r>
+          </a:p>
+          <a:p>
+            <a:pPr algn="l">
+              <a:lnSpc>
+                <a:spcPct val="100000"/>
+              </a:lnSpc>
+              <a:spcBef>
+                <a:spcPts val="0"/>
+              </a:spcBef>
+              <a:spcAft>
+                <a:spcPts val="0"/>
+              </a:spcAft>
+            </a:pPr>
+            <a:r>
+              <a:rPr sz="900" b="0">
+                <a:solidFill>
+                  <a:srgbClr val="5B6470"/>
+                </a:solidFill>
+                <a:latin typeface="맑은 고딕"/>
+              </a:rPr>
+              <a:t>금융 콘텐츠 초안 작성 (작성 시점 실시간)</a:t>
+            </a:r>
+          </a:p>
+        </p:txBody>
+      </p:sp>
+      <p:sp>
+        <p:nvSpPr>
+          <p:cNvPr id="7" name="Rounded Rectangle 6"/>
           <p:cNvSpPr/>
           <p:nvPr/>
         </p:nvSpPr>
         <p:spPr>
           <a:xfrm>
-            <a:off x="411480" y="1325880"/>
-            <a:ext cx="5989320" cy="475488"/>
+            <a:off x="7219188" y="1207008"/>
+            <a:ext cx="4512564" cy="658368"/>
           </a:xfrm>
           <a:prstGeom prst="roundRect">
             <a:avLst/>
           </a:prstGeom>
           <a:solidFill>
-            <a:srgbClr val="EEF4FC"/>
+            <a:srgbClr val="EEF1F5"/>
+          </a:solidFill>
+          <a:ln w="9525">
+            <a:solidFill>
+              <a:srgbClr val="D8DEE6"/>
+            </a:solidFill>
+          </a:ln>
+          <a:effectLst/>
+        </p:spPr>
+        <p:style>
+          <a:lnRef idx="1">
+            <a:schemeClr val="accent1"/>
+          </a:lnRef>
+          <a:fillRef idx="3">
+            <a:schemeClr val="accent1"/>
+          </a:fillRef>
+          <a:effectRef idx="2">
+            <a:schemeClr val="accent1"/>
+          </a:effectRef>
+          <a:fontRef idx="minor">
+            <a:schemeClr val="lt1"/>
+          </a:fontRef>
+        </p:style>
+        <p:txBody>
+          <a:bodyPr rtlCol="0" anchor="ctr" wrap="square" lIns="64008" rIns="64008" tIns="9144" bIns="9144"/>
+          <a:lstStyle/>
+          <a:p>
+            <a:pPr algn="l">
+              <a:lnSpc>
+                <a:spcPct val="100000"/>
+              </a:lnSpc>
+              <a:spcBef>
+                <a:spcPts val="0"/>
+              </a:spcBef>
+              <a:spcAft>
+                <a:spcPts val="0"/>
+              </a:spcAft>
+            </a:pPr>
+            <a:r>
+              <a:rPr sz="1050" b="1">
+                <a:solidFill>
+                  <a:srgbClr val="1A1D21"/>
+                </a:solidFill>
+                <a:latin typeface="맑은 고딕"/>
+              </a:rPr>
+              <a:t>준법관리자 (준법감시부)</a:t>
+            </a:r>
+          </a:p>
+          <a:p>
+            <a:pPr algn="l">
+              <a:lnSpc>
+                <a:spcPct val="100000"/>
+              </a:lnSpc>
+              <a:spcBef>
+                <a:spcPts val="0"/>
+              </a:spcBef>
+              <a:spcAft>
+                <a:spcPts val="0"/>
+              </a:spcAft>
+            </a:pPr>
+            <a:r>
+              <a:rPr sz="900" b="0">
+                <a:solidFill>
+                  <a:srgbClr val="5B6470"/>
+                </a:solidFill>
+                <a:latin typeface="맑은 고딕"/>
+              </a:rPr>
+              <a:t>검토 · 승인 (Human-in-the-loop)</a:t>
+            </a:r>
+          </a:p>
+        </p:txBody>
+      </p:sp>
+      <p:sp>
+        <p:nvSpPr>
+          <p:cNvPr id="8" name="Down Arrow 7"/>
+          <p:cNvSpPr/>
+          <p:nvPr/>
+        </p:nvSpPr>
+        <p:spPr>
+          <a:xfrm>
+            <a:off x="7022592" y="1883664"/>
+            <a:ext cx="219456" cy="146304"/>
+          </a:xfrm>
+          <a:prstGeom prst="downArrow">
+            <a:avLst/>
+          </a:prstGeom>
+          <a:solidFill>
+            <a:srgbClr val="AAB4C0"/>
           </a:solidFill>
           <a:ln>
             <a:noFill/>
@@ -3305,42 +3496,23 @@
           </a:fontRef>
         </p:style>
         <p:txBody>
-          <a:bodyPr rtlCol="0" anchor="ctr" wrap="square" lIns="164592" rIns="164592" tIns="18288" bIns="18288"/>
-          <a:lstStyle/>
-          <a:p>
-            <a:pPr algn="l">
-              <a:lnSpc>
-                <a:spcPct val="100000"/>
-              </a:lnSpc>
-              <a:spcBef>
-                <a:spcPts val="0"/>
-              </a:spcBef>
-              <a:spcAft>
-                <a:spcPts val="100"/>
-              </a:spcAft>
-            </a:pPr>
-            <a:r>
-              <a:rPr sz="1350" b="1">
-                <a:solidFill>
-                  <a:srgbClr val="00529B"/>
-                </a:solidFill>
-                <a:latin typeface="맑은 고딕"/>
-              </a:rPr>
-              <a:t>🔒  내부망 (Air-gap) — 심의 코어</a:t>
-            </a:r>
-          </a:p>
-        </p:txBody>
-      </p:sp>
-      <p:sp>
-        <p:nvSpPr>
-          <p:cNvPr id="7" name="Rounded Rectangle 6"/>
+          <a:bodyPr rtlCol="0" anchor="ctr"/>
+          <a:lstStyle/>
+          <a:p>
+            <a:pPr algn="ctr"/>
+          </a:p>
+        </p:txBody>
+      </p:sp>
+      <p:sp>
+        <p:nvSpPr>
+          <p:cNvPr id="9" name="Rounded Rectangle 8"/>
           <p:cNvSpPr/>
           <p:nvPr/>
         </p:nvSpPr>
         <p:spPr>
           <a:xfrm>
-            <a:off x="4709160" y="1426464"/>
-            <a:ext cx="1554480" cy="274320"/>
+            <a:off x="457200" y="2048256"/>
+            <a:ext cx="1965960" cy="786384"/>
           </a:xfrm>
           <a:prstGeom prst="roundRect">
             <a:avLst/>
@@ -3368,7 +3540,7 @@
           </a:fontRef>
         </p:style>
         <p:txBody>
-          <a:bodyPr rtlCol="0" anchor="ctr" wrap="square" lIns="54864" rIns="54864" tIns="18288" bIns="18288"/>
+          <a:bodyPr rtlCol="0" anchor="ctr" wrap="square" lIns="64008" rIns="64008" tIns="9144" bIns="9144"/>
           <a:lstStyle/>
           <a:p>
             <a:pPr algn="ctr">
@@ -3379,41 +3551,86 @@
                 <a:spcPts val="0"/>
               </a:spcBef>
               <a:spcAft>
-                <a:spcPts val="100"/>
+                <a:spcPts val="0"/>
               </a:spcAft>
             </a:pPr>
             <a:r>
-              <a:rPr sz="950" b="1">
+              <a:rPr sz="1250" b="1">
                 <a:solidFill>
                   <a:srgbClr val="FFFFFF"/>
                 </a:solidFill>
                 <a:latin typeface="맑은 고딕"/>
               </a:rPr>
-              <a:t>데이터 외부 유출 0</a:t>
-            </a:r>
-          </a:p>
-        </p:txBody>
-      </p:sp>
-      <p:sp>
-        <p:nvSpPr>
-          <p:cNvPr id="8" name="Rounded Rectangle 7"/>
+              <a:t>🖥 프론트엔드/UI</a:t>
+            </a:r>
+          </a:p>
+        </p:txBody>
+      </p:sp>
+      <p:sp>
+        <p:nvSpPr>
+          <p:cNvPr id="10" name="TextBox 9"/>
+          <p:cNvSpPr txBox="1"/>
+          <p:nvPr/>
+        </p:nvSpPr>
+        <p:spPr>
+          <a:xfrm>
+            <a:off x="2606040" y="2084832"/>
+            <a:ext cx="9171432" cy="219456"/>
+          </a:xfrm>
+          <a:prstGeom prst="rect">
+            <a:avLst/>
+          </a:prstGeom>
+          <a:noFill/>
+        </p:spPr>
+        <p:txBody>
+          <a:bodyPr wrap="square" anchor="t" lIns="0" rIns="0" tIns="9144" bIns="9144">
+            <a:spAutoFit/>
+          </a:bodyPr>
+          <a:lstStyle/>
+          <a:p>
+            <a:pPr algn="l">
+              <a:lnSpc>
+                <a:spcPct val="100000"/>
+              </a:lnSpc>
+              <a:spcBef>
+                <a:spcPts val="0"/>
+              </a:spcBef>
+              <a:spcAft>
+                <a:spcPts val="0"/>
+              </a:spcAft>
+            </a:pPr>
+            <a:r>
+              <a:rPr sz="950" b="1">
+                <a:solidFill>
+                  <a:srgbClr val="1F9D55"/>
+                </a:solidFill>
+                <a:latin typeface="맑은 고딕"/>
+              </a:rPr>
+              <a:t>정적 SPA · 바닐라 JS (빌드리스, FastAPI가 서빙)</a:t>
+            </a:r>
+          </a:p>
+        </p:txBody>
+      </p:sp>
+      <p:sp>
+        <p:nvSpPr>
+          <p:cNvPr id="11" name="Rounded Rectangle 10"/>
           <p:cNvSpPr/>
           <p:nvPr/>
         </p:nvSpPr>
         <p:spPr>
           <a:xfrm>
-            <a:off x="594360" y="1920240"/>
-            <a:ext cx="5623560" cy="566928"/>
+            <a:off x="2560320" y="2359152"/>
+            <a:ext cx="2210562" cy="402336"/>
           </a:xfrm>
           <a:prstGeom prst="roundRect">
             <a:avLst/>
           </a:prstGeom>
           <a:solidFill>
-            <a:srgbClr val="F7F9FC"/>
+            <a:srgbClr val="E9F7EF"/>
           </a:solidFill>
           <a:ln w="9525">
             <a:solidFill>
-              <a:srgbClr val="BCD6F2"/>
+              <a:srgbClr val="BFE6CF"/>
             </a:solidFill>
           </a:ln>
           <a:effectLst/>
@@ -3433,7 +3650,291 @@
           </a:fontRef>
         </p:style>
         <p:txBody>
-          <a:bodyPr rtlCol="0" anchor="ctr" wrap="square" lIns="128016" rIns="128016" tIns="18288" bIns="18288"/>
+          <a:bodyPr rtlCol="0" anchor="ctr" wrap="square" lIns="45720" rIns="45720" tIns="9144" bIns="9144"/>
+          <a:lstStyle/>
+          <a:p>
+            <a:pPr algn="ctr">
+              <a:lnSpc>
+                <a:spcPct val="100000"/>
+              </a:lnSpc>
+              <a:spcBef>
+                <a:spcPts val="0"/>
+              </a:spcBef>
+              <a:spcAft>
+                <a:spcPts val="0"/>
+              </a:spcAft>
+            </a:pPr>
+            <a:r>
+              <a:rPr sz="950" b="0">
+                <a:solidFill>
+                  <a:srgbClr val="1A1D21"/>
+                </a:solidFill>
+                <a:latin typeface="맑은 고딕"/>
+              </a:rPr>
+              <a:t>심의 워크스페이스</a:t>
+            </a:r>
+          </a:p>
+        </p:txBody>
+      </p:sp>
+      <p:sp>
+        <p:nvSpPr>
+          <p:cNvPr id="12" name="Rounded Rectangle 11"/>
+          <p:cNvSpPr/>
+          <p:nvPr/>
+        </p:nvSpPr>
+        <p:spPr>
+          <a:xfrm>
+            <a:off x="4880610" y="2359152"/>
+            <a:ext cx="2210562" cy="402336"/>
+          </a:xfrm>
+          <a:prstGeom prst="roundRect">
+            <a:avLst/>
+          </a:prstGeom>
+          <a:solidFill>
+            <a:srgbClr val="E9F7EF"/>
+          </a:solidFill>
+          <a:ln w="9525">
+            <a:solidFill>
+              <a:srgbClr val="BFE6CF"/>
+            </a:solidFill>
+          </a:ln>
+          <a:effectLst/>
+        </p:spPr>
+        <p:style>
+          <a:lnRef idx="1">
+            <a:schemeClr val="accent1"/>
+          </a:lnRef>
+          <a:fillRef idx="3">
+            <a:schemeClr val="accent1"/>
+          </a:fillRef>
+          <a:effectRef idx="2">
+            <a:schemeClr val="accent1"/>
+          </a:effectRef>
+          <a:fontRef idx="minor">
+            <a:schemeClr val="lt1"/>
+          </a:fontRef>
+        </p:style>
+        <p:txBody>
+          <a:bodyPr rtlCol="0" anchor="ctr" wrap="square" lIns="45720" rIns="45720" tIns="9144" bIns="9144"/>
+          <a:lstStyle/>
+          <a:p>
+            <a:pPr algn="ctr">
+              <a:lnSpc>
+                <a:spcPct val="100000"/>
+              </a:lnSpc>
+              <a:spcBef>
+                <a:spcPts val="0"/>
+              </a:spcBef>
+              <a:spcAft>
+                <a:spcPts val="0"/>
+              </a:spcAft>
+            </a:pPr>
+            <a:r>
+              <a:rPr sz="950" b="0">
+                <a:solidFill>
+                  <a:srgbClr val="1A1D21"/>
+                </a:solidFill>
+                <a:latin typeface="맑은 고딕"/>
+              </a:rPr>
+              <a:t>오인 시뮬레이터 ★</a:t>
+            </a:r>
+          </a:p>
+        </p:txBody>
+      </p:sp>
+      <p:sp>
+        <p:nvSpPr>
+          <p:cNvPr id="13" name="Rounded Rectangle 12"/>
+          <p:cNvSpPr/>
+          <p:nvPr/>
+        </p:nvSpPr>
+        <p:spPr>
+          <a:xfrm>
+            <a:off x="7200900" y="2359152"/>
+            <a:ext cx="2210562" cy="402336"/>
+          </a:xfrm>
+          <a:prstGeom prst="roundRect">
+            <a:avLst/>
+          </a:prstGeom>
+          <a:solidFill>
+            <a:srgbClr val="E9F7EF"/>
+          </a:solidFill>
+          <a:ln w="9525">
+            <a:solidFill>
+              <a:srgbClr val="BFE6CF"/>
+            </a:solidFill>
+          </a:ln>
+          <a:effectLst/>
+        </p:spPr>
+        <p:style>
+          <a:lnRef idx="1">
+            <a:schemeClr val="accent1"/>
+          </a:lnRef>
+          <a:fillRef idx="3">
+            <a:schemeClr val="accent1"/>
+          </a:fillRef>
+          <a:effectRef idx="2">
+            <a:schemeClr val="accent1"/>
+          </a:effectRef>
+          <a:fontRef idx="minor">
+            <a:schemeClr val="lt1"/>
+          </a:fontRef>
+        </p:style>
+        <p:txBody>
+          <a:bodyPr rtlCol="0" anchor="ctr" wrap="square" lIns="45720" rIns="45720" tIns="9144" bIns="9144"/>
+          <a:lstStyle/>
+          <a:p>
+            <a:pPr algn="ctr">
+              <a:lnSpc>
+                <a:spcPct val="100000"/>
+              </a:lnSpc>
+              <a:spcBef>
+                <a:spcPts val="0"/>
+              </a:spcBef>
+              <a:spcAft>
+                <a:spcPts val="0"/>
+              </a:spcAft>
+            </a:pPr>
+            <a:r>
+              <a:rPr sz="950" b="0">
+                <a:solidFill>
+                  <a:srgbClr val="1A1D21"/>
+                </a:solidFill>
+                <a:latin typeface="맑은 고딕"/>
+              </a:rPr>
+              <a:t>준법관리자 승인 뷰</a:t>
+            </a:r>
+          </a:p>
+        </p:txBody>
+      </p:sp>
+      <p:sp>
+        <p:nvSpPr>
+          <p:cNvPr id="14" name="Rounded Rectangle 13"/>
+          <p:cNvSpPr/>
+          <p:nvPr/>
+        </p:nvSpPr>
+        <p:spPr>
+          <a:xfrm>
+            <a:off x="9521190" y="2359152"/>
+            <a:ext cx="2210562" cy="402336"/>
+          </a:xfrm>
+          <a:prstGeom prst="roundRect">
+            <a:avLst/>
+          </a:prstGeom>
+          <a:solidFill>
+            <a:srgbClr val="E9F7EF"/>
+          </a:solidFill>
+          <a:ln w="9525">
+            <a:solidFill>
+              <a:srgbClr val="BFE6CF"/>
+            </a:solidFill>
+          </a:ln>
+          <a:effectLst/>
+        </p:spPr>
+        <p:style>
+          <a:lnRef idx="1">
+            <a:schemeClr val="accent1"/>
+          </a:lnRef>
+          <a:fillRef idx="3">
+            <a:schemeClr val="accent1"/>
+          </a:fillRef>
+          <a:effectRef idx="2">
+            <a:schemeClr val="accent1"/>
+          </a:effectRef>
+          <a:fontRef idx="minor">
+            <a:schemeClr val="lt1"/>
+          </a:fontRef>
+        </p:style>
+        <p:txBody>
+          <a:bodyPr rtlCol="0" anchor="ctr" wrap="square" lIns="45720" rIns="45720" tIns="9144" bIns="9144"/>
+          <a:lstStyle/>
+          <a:p>
+            <a:pPr algn="ctr">
+              <a:lnSpc>
+                <a:spcPct val="100000"/>
+              </a:lnSpc>
+              <a:spcBef>
+                <a:spcPts val="0"/>
+              </a:spcBef>
+              <a:spcAft>
+                <a:spcPts val="0"/>
+              </a:spcAft>
+            </a:pPr>
+            <a:r>
+              <a:rPr sz="950" b="0">
+                <a:solidFill>
+                  <a:srgbClr val="1A1D21"/>
+                </a:solidFill>
+                <a:latin typeface="맑은 고딕"/>
+              </a:rPr>
+              <a:t>감사로그 뷰</a:t>
+            </a:r>
+          </a:p>
+        </p:txBody>
+      </p:sp>
+      <p:sp>
+        <p:nvSpPr>
+          <p:cNvPr id="15" name="Down Arrow 14"/>
+          <p:cNvSpPr/>
+          <p:nvPr/>
+        </p:nvSpPr>
+        <p:spPr>
+          <a:xfrm>
+            <a:off x="7022592" y="2852928"/>
+            <a:ext cx="219456" cy="146304"/>
+          </a:xfrm>
+          <a:prstGeom prst="downArrow">
+            <a:avLst/>
+          </a:prstGeom>
+          <a:solidFill>
+            <a:srgbClr val="AAB4C0"/>
+          </a:solidFill>
+          <a:ln>
+            <a:noFill/>
+          </a:ln>
+          <a:effectLst/>
+        </p:spPr>
+        <p:style>
+          <a:lnRef idx="1">
+            <a:schemeClr val="accent1"/>
+          </a:lnRef>
+          <a:fillRef idx="3">
+            <a:schemeClr val="accent1"/>
+          </a:fillRef>
+          <a:effectRef idx="2">
+            <a:schemeClr val="accent1"/>
+          </a:effectRef>
+          <a:fontRef idx="minor">
+            <a:schemeClr val="lt1"/>
+          </a:fontRef>
+        </p:style>
+        <p:txBody>
+          <a:bodyPr rtlCol="0" anchor="ctr"/>
+          <a:lstStyle/>
+          <a:p>
+            <a:pPr algn="ctr"/>
+          </a:p>
+        </p:txBody>
+      </p:sp>
+      <p:sp>
+        <p:nvSpPr>
+          <p:cNvPr id="16" name="TextBox 15"/>
+          <p:cNvSpPr txBox="1"/>
+          <p:nvPr/>
+        </p:nvSpPr>
+        <p:spPr>
+          <a:xfrm>
+            <a:off x="7315200" y="2834640"/>
+            <a:ext cx="2743200" cy="146304"/>
+          </a:xfrm>
+          <a:prstGeom prst="rect">
+            <a:avLst/>
+          </a:prstGeom>
+          <a:noFill/>
+        </p:spPr>
+        <p:txBody>
+          <a:bodyPr wrap="square" anchor="ctr" lIns="0" rIns="0" tIns="9144" bIns="9144">
+            <a:spAutoFit/>
+          </a:bodyPr>
           <a:lstStyle/>
           <a:p>
             <a:pPr algn="l">
@@ -3444,19 +3945,105 @@
                 <a:spcPts val="0"/>
               </a:spcBef>
               <a:spcAft>
-                <a:spcPts val="100"/>
+                <a:spcPts val="0"/>
               </a:spcAft>
             </a:pPr>
             <a:r>
-              <a:rPr sz="1100" b="1">
-                <a:solidFill>
-                  <a:srgbClr val="1A1D21"/>
+              <a:rPr sz="850" b="0">
+                <a:solidFill>
+                  <a:srgbClr val="5B6470"/>
                 </a:solidFill>
                 <a:latin typeface="맑은 고딕"/>
               </a:rPr>
-              <a:t>Frontend · 정적 SPA</a:t>
-            </a:r>
-          </a:p>
+              <a:t>REST (JSON)</a:t>
+            </a:r>
+          </a:p>
+        </p:txBody>
+      </p:sp>
+      <p:sp>
+        <p:nvSpPr>
+          <p:cNvPr id="17" name="Rounded Rectangle 16"/>
+          <p:cNvSpPr/>
+          <p:nvPr/>
+        </p:nvSpPr>
+        <p:spPr>
+          <a:xfrm>
+            <a:off x="457200" y="3017520"/>
+            <a:ext cx="1965960" cy="731520"/>
+          </a:xfrm>
+          <a:prstGeom prst="roundRect">
+            <a:avLst/>
+          </a:prstGeom>
+          <a:solidFill>
+            <a:srgbClr val="00529B"/>
+          </a:solidFill>
+          <a:ln>
+            <a:noFill/>
+          </a:ln>
+          <a:effectLst/>
+        </p:spPr>
+        <p:style>
+          <a:lnRef idx="1">
+            <a:schemeClr val="accent1"/>
+          </a:lnRef>
+          <a:fillRef idx="3">
+            <a:schemeClr val="accent1"/>
+          </a:fillRef>
+          <a:effectRef idx="2">
+            <a:schemeClr val="accent1"/>
+          </a:effectRef>
+          <a:fontRef idx="minor">
+            <a:schemeClr val="lt1"/>
+          </a:fontRef>
+        </p:style>
+        <p:txBody>
+          <a:bodyPr rtlCol="0" anchor="ctr" wrap="square" lIns="64008" rIns="64008" tIns="9144" bIns="9144"/>
+          <a:lstStyle/>
+          <a:p>
+            <a:pPr algn="ctr">
+              <a:lnSpc>
+                <a:spcPct val="100000"/>
+              </a:lnSpc>
+              <a:spcBef>
+                <a:spcPts val="0"/>
+              </a:spcBef>
+              <a:spcAft>
+                <a:spcPts val="0"/>
+              </a:spcAft>
+            </a:pPr>
+            <a:r>
+              <a:rPr sz="1250" b="1">
+                <a:solidFill>
+                  <a:srgbClr val="FFFFFF"/>
+                </a:solidFill>
+                <a:latin typeface="맑은 고딕"/>
+              </a:rPr>
+              <a:t>⚙ 백엔드/API</a:t>
+            </a:r>
+          </a:p>
+        </p:txBody>
+      </p:sp>
+      <p:sp>
+        <p:nvSpPr>
+          <p:cNvPr id="18" name="TextBox 17"/>
+          <p:cNvSpPr txBox="1"/>
+          <p:nvPr/>
+        </p:nvSpPr>
+        <p:spPr>
+          <a:xfrm>
+            <a:off x="2606040" y="3054096"/>
+            <a:ext cx="9171432" cy="219456"/>
+          </a:xfrm>
+          <a:prstGeom prst="rect">
+            <a:avLst/>
+          </a:prstGeom>
+          <a:noFill/>
+        </p:spPr>
+        <p:txBody>
+          <a:bodyPr wrap="square" anchor="t" lIns="0" rIns="0" tIns="9144" bIns="9144">
+            <a:spAutoFit/>
+          </a:bodyPr>
+          <a:lstStyle/>
           <a:p>
             <a:pPr algn="l">
               <a:lnSpc>
@@ -3466,76 +4053,31 @@
                 <a:spcPts val="0"/>
               </a:spcBef>
               <a:spcAft>
-                <a:spcPts val="100"/>
+                <a:spcPts val="0"/>
               </a:spcAft>
             </a:pPr>
             <a:r>
-              <a:rPr sz="900" b="0">
-                <a:solidFill>
-                  <a:srgbClr val="5B6470"/>
+              <a:rPr sz="950" b="1">
+                <a:solidFill>
+                  <a:srgbClr val="00529B"/>
                 </a:solidFill>
                 <a:latin typeface="맑은 고딕"/>
               </a:rPr>
-              <a:t>오인 시뮬레이터 · 실시간 에디터 · 준법관리자 승인 뷰 · 감사로그</a:t>
-            </a:r>
-          </a:p>
-        </p:txBody>
-      </p:sp>
-      <p:sp>
-        <p:nvSpPr>
-          <p:cNvPr id="9" name="TextBox 8"/>
-          <p:cNvSpPr txBox="1"/>
-          <p:nvPr/>
-        </p:nvSpPr>
-        <p:spPr>
-          <a:xfrm>
-            <a:off x="612648" y="2606040"/>
-            <a:ext cx="5623560" cy="237744"/>
-          </a:xfrm>
-          <a:prstGeom prst="rect">
-            <a:avLst/>
-          </a:prstGeom>
-          <a:noFill/>
-        </p:spPr>
-        <p:txBody>
-          <a:bodyPr wrap="square" anchor="t" lIns="0" rIns="0" tIns="18288" bIns="18288">
-            <a:spAutoFit/>
-          </a:bodyPr>
-          <a:lstStyle/>
-          <a:p>
-            <a:pPr algn="l">
-              <a:lnSpc>
-                <a:spcPct val="100000"/>
-              </a:lnSpc>
-              <a:spcBef>
-                <a:spcPts val="0"/>
-              </a:spcBef>
-              <a:spcAft>
-                <a:spcPts val="100"/>
-              </a:spcAft>
-            </a:pPr>
-            <a:r>
-              <a:rPr sz="1050" b="1">
-                <a:solidFill>
-                  <a:srgbClr val="003A6E"/>
-                </a:solidFill>
-                <a:latin typeface="맑은 고딕"/>
-              </a:rPr>
-              <a:t>Backend · Orchestrator  (명시적 파이프라인)</a:t>
-            </a:r>
-          </a:p>
-        </p:txBody>
-      </p:sp>
-      <p:sp>
-        <p:nvSpPr>
-          <p:cNvPr id="10" name="Rounded Rectangle 9"/>
+              <a:t>FastAPI · app/main.py — REST 엔드포인트</a:t>
+            </a:r>
+          </a:p>
+        </p:txBody>
+      </p:sp>
+      <p:sp>
+        <p:nvSpPr>
+          <p:cNvPr id="19" name="Rounded Rectangle 18"/>
           <p:cNvSpPr/>
           <p:nvPr/>
         </p:nvSpPr>
         <p:spPr>
           <a:xfrm>
-            <a:off x="594360" y="2898648"/>
-            <a:ext cx="2729484" cy="420624"/>
+            <a:off x="2560320" y="3310128"/>
+            <a:ext cx="1247502" cy="365760"/>
           </a:xfrm>
           <a:prstGeom prst="roundRect">
             <a:avLst/>
@@ -3565,10 +4107,10 @@
           </a:fontRef>
         </p:style>
         <p:txBody>
-          <a:bodyPr rtlCol="0" anchor="ctr" wrap="square" lIns="109728" rIns="109728" tIns="18288" bIns="18288"/>
-          <a:lstStyle/>
-          <a:p>
-            <a:pPr algn="l">
+          <a:bodyPr rtlCol="0" anchor="ctr" wrap="square" lIns="45720" rIns="45720" tIns="9144" bIns="9144"/>
+          <a:lstStyle/>
+          <a:p>
+            <a:pPr algn="ctr">
               <a:lnSpc>
                 <a:spcPct val="100000"/>
               </a:lnSpc>
@@ -3576,31 +4118,31 @@
                 <a:spcPts val="0"/>
               </a:spcBef>
               <a:spcAft>
-                <a:spcPts val="100"/>
+                <a:spcPts val="0"/>
               </a:spcAft>
             </a:pPr>
             <a:r>
-              <a:rPr sz="950" b="0">
+              <a:rPr sz="850" b="0">
                 <a:solidFill>
                   <a:srgbClr val="1A1D21"/>
                 </a:solidFill>
                 <a:latin typeface="맑은 고딕"/>
               </a:rPr>
-              <a:t>① 유형분류 → 라우팅</a:t>
-            </a:r>
-          </a:p>
-        </p:txBody>
-      </p:sp>
-      <p:sp>
-        <p:nvSpPr>
-          <p:cNvPr id="11" name="Rounded Rectangle 10"/>
+              <a:t>/review</a:t>
+            </a:r>
+          </a:p>
+        </p:txBody>
+      </p:sp>
+      <p:sp>
+        <p:nvSpPr>
+          <p:cNvPr id="20" name="Rounded Rectangle 19"/>
           <p:cNvSpPr/>
           <p:nvPr/>
         </p:nvSpPr>
         <p:spPr>
           <a:xfrm>
-            <a:off x="3488436" y="2898648"/>
-            <a:ext cx="2729484" cy="420624"/>
+            <a:off x="3880974" y="3310128"/>
+            <a:ext cx="1247502" cy="365760"/>
           </a:xfrm>
           <a:prstGeom prst="roundRect">
             <a:avLst/>
@@ -3630,10 +4172,10 @@
           </a:fontRef>
         </p:style>
         <p:txBody>
-          <a:bodyPr rtlCol="0" anchor="ctr" wrap="square" lIns="109728" rIns="109728" tIns="18288" bIns="18288"/>
-          <a:lstStyle/>
-          <a:p>
-            <a:pPr algn="l">
+          <a:bodyPr rtlCol="0" anchor="ctr" wrap="square" lIns="45720" rIns="45720" tIns="9144" bIns="9144"/>
+          <a:lstStyle/>
+          <a:p>
+            <a:pPr algn="ctr">
               <a:lnSpc>
                 <a:spcPct val="100000"/>
               </a:lnSpc>
@@ -3641,96 +4183,31 @@
                 <a:spcPts val="0"/>
               </a:spcBef>
               <a:spcAft>
-                <a:spcPts val="100"/>
+                <a:spcPts val="0"/>
               </a:spcAft>
             </a:pPr>
             <a:r>
-              <a:rPr sz="950" b="0">
+              <a:rPr sz="850" b="0">
                 <a:solidFill>
                   <a:srgbClr val="1A1D21"/>
                 </a:solidFill>
                 <a:latin typeface="맑은 고딕"/>
               </a:rPr>
-              <a:t>② RAG 근거검색 (참조그래프)</a:t>
-            </a:r>
-          </a:p>
-        </p:txBody>
-      </p:sp>
-      <p:sp>
-        <p:nvSpPr>
-          <p:cNvPr id="12" name="Rounded Rectangle 11"/>
+              <a:t>/autopilot</a:t>
+            </a:r>
+          </a:p>
+        </p:txBody>
+      </p:sp>
+      <p:sp>
+        <p:nvSpPr>
+          <p:cNvPr id="21" name="Rounded Rectangle 20"/>
           <p:cNvSpPr/>
           <p:nvPr/>
         </p:nvSpPr>
         <p:spPr>
           <a:xfrm>
-            <a:off x="594360" y="3429000"/>
-            <a:ext cx="2729484" cy="420624"/>
-          </a:xfrm>
-          <a:prstGeom prst="roundRect">
-            <a:avLst/>
-          </a:prstGeom>
-          <a:solidFill>
-            <a:srgbClr val="F0ECFF"/>
-          </a:solidFill>
-          <a:ln w="9525">
-            <a:solidFill>
-              <a:srgbClr val="CDBFF0"/>
-            </a:solidFill>
-          </a:ln>
-          <a:effectLst/>
-        </p:spPr>
-        <p:style>
-          <a:lnRef idx="1">
-            <a:schemeClr val="accent1"/>
-          </a:lnRef>
-          <a:fillRef idx="3">
-            <a:schemeClr val="accent1"/>
-          </a:fillRef>
-          <a:effectRef idx="2">
-            <a:schemeClr val="accent1"/>
-          </a:effectRef>
-          <a:fontRef idx="minor">
-            <a:schemeClr val="lt1"/>
-          </a:fontRef>
-        </p:style>
-        <p:txBody>
-          <a:bodyPr rtlCol="0" anchor="ctr" wrap="square" lIns="109728" rIns="109728" tIns="18288" bIns="18288"/>
-          <a:lstStyle/>
-          <a:p>
-            <a:pPr algn="l">
-              <a:lnSpc>
-                <a:spcPct val="100000"/>
-              </a:lnSpc>
-              <a:spcBef>
-                <a:spcPts val="0"/>
-              </a:spcBef>
-              <a:spcAft>
-                <a:spcPts val="100"/>
-              </a:spcAft>
-            </a:pPr>
-            <a:r>
-              <a:rPr sz="950" b="1">
-                <a:solidFill>
-                  <a:srgbClr val="003A6E"/>
-                </a:solidFill>
-                <a:latin typeface="맑은 고딕"/>
-              </a:rPr>
-              <a:t>③ 룰엔진 (결정적 권위)</a:t>
-            </a:r>
-          </a:p>
-        </p:txBody>
-      </p:sp>
-      <p:sp>
-        <p:nvSpPr>
-          <p:cNvPr id="13" name="Rounded Rectangle 12"/>
-          <p:cNvSpPr/>
-          <p:nvPr/>
-        </p:nvSpPr>
-        <p:spPr>
-          <a:xfrm>
-            <a:off x="3488436" y="3429000"/>
-            <a:ext cx="2729484" cy="420624"/>
+            <a:off x="5201628" y="3310128"/>
+            <a:ext cx="1247502" cy="365760"/>
           </a:xfrm>
           <a:prstGeom prst="roundRect">
             <a:avLst/>
@@ -3760,10 +4237,10 @@
           </a:fontRef>
         </p:style>
         <p:txBody>
-          <a:bodyPr rtlCol="0" anchor="ctr" wrap="square" lIns="109728" rIns="109728" tIns="18288" bIns="18288"/>
-          <a:lstStyle/>
-          <a:p>
-            <a:pPr algn="l">
+          <a:bodyPr rtlCol="0" anchor="ctr" wrap="square" lIns="45720" rIns="45720" tIns="9144" bIns="9144"/>
+          <a:lstStyle/>
+          <a:p>
+            <a:pPr algn="ctr">
               <a:lnSpc>
                 <a:spcPct val="100000"/>
               </a:lnSpc>
@@ -3771,96 +4248,31 @@
                 <a:spcPts val="0"/>
               </a:spcBef>
               <a:spcAft>
-                <a:spcPts val="100"/>
+                <a:spcPts val="0"/>
               </a:spcAft>
             </a:pPr>
             <a:r>
-              <a:rPr sz="950" b="0">
+              <a:rPr sz="850" b="0">
                 <a:solidFill>
                   <a:srgbClr val="1A1D21"/>
                 </a:solidFill>
                 <a:latin typeface="맑은 고딕"/>
               </a:rPr>
-              <a:t>④ LLM 뉘앙스 심의</a:t>
-            </a:r>
-          </a:p>
-        </p:txBody>
-      </p:sp>
-      <p:sp>
-        <p:nvSpPr>
-          <p:cNvPr id="14" name="Rounded Rectangle 13"/>
+              <a:t>/submissions</a:t>
+            </a:r>
+          </a:p>
+        </p:txBody>
+      </p:sp>
+      <p:sp>
+        <p:nvSpPr>
+          <p:cNvPr id="22" name="Rounded Rectangle 21"/>
           <p:cNvSpPr/>
           <p:nvPr/>
         </p:nvSpPr>
         <p:spPr>
           <a:xfrm>
-            <a:off x="594360" y="3959352"/>
-            <a:ext cx="2729484" cy="420624"/>
-          </a:xfrm>
-          <a:prstGeom prst="roundRect">
-            <a:avLst/>
-          </a:prstGeom>
-          <a:solidFill>
-            <a:srgbClr val="F0ECFF"/>
-          </a:solidFill>
-          <a:ln w="9525">
-            <a:solidFill>
-              <a:srgbClr val="CDBFF0"/>
-            </a:solidFill>
-          </a:ln>
-          <a:effectLst/>
-        </p:spPr>
-        <p:style>
-          <a:lnRef idx="1">
-            <a:schemeClr val="accent1"/>
-          </a:lnRef>
-          <a:fillRef idx="3">
-            <a:schemeClr val="accent1"/>
-          </a:fillRef>
-          <a:effectRef idx="2">
-            <a:schemeClr val="accent1"/>
-          </a:effectRef>
-          <a:fontRef idx="minor">
-            <a:schemeClr val="lt1"/>
-          </a:fontRef>
-        </p:style>
-        <p:txBody>
-          <a:bodyPr rtlCol="0" anchor="ctr" wrap="square" lIns="109728" rIns="109728" tIns="18288" bIns="18288"/>
-          <a:lstStyle/>
-          <a:p>
-            <a:pPr algn="l">
-              <a:lnSpc>
-                <a:spcPct val="100000"/>
-              </a:lnSpc>
-              <a:spcBef>
-                <a:spcPts val="0"/>
-              </a:spcBef>
-              <a:spcAft>
-                <a:spcPts val="100"/>
-              </a:spcAft>
-            </a:pPr>
-            <a:r>
-              <a:rPr sz="950" b="1">
-                <a:solidFill>
-                  <a:srgbClr val="003A6E"/>
-                </a:solidFill>
-                <a:latin typeface="맑은 고딕"/>
-              </a:rPr>
-              <a:t>⑤ ★오인 시뮬레이터</a:t>
-            </a:r>
-          </a:p>
-        </p:txBody>
-      </p:sp>
-      <p:sp>
-        <p:nvSpPr>
-          <p:cNvPr id="15" name="Rounded Rectangle 14"/>
-          <p:cNvSpPr/>
-          <p:nvPr/>
-        </p:nvSpPr>
-        <p:spPr>
-          <a:xfrm>
-            <a:off x="3488436" y="3959352"/>
-            <a:ext cx="2729484" cy="420624"/>
+            <a:off x="6522282" y="3310128"/>
+            <a:ext cx="1247502" cy="365760"/>
           </a:xfrm>
           <a:prstGeom prst="roundRect">
             <a:avLst/>
@@ -3890,10 +4302,10 @@
           </a:fontRef>
         </p:style>
         <p:txBody>
-          <a:bodyPr rtlCol="0" anchor="ctr" wrap="square" lIns="109728" rIns="109728" tIns="18288" bIns="18288"/>
-          <a:lstStyle/>
-          <a:p>
-            <a:pPr algn="l">
+          <a:bodyPr rtlCol="0" anchor="ctr" wrap="square" lIns="45720" rIns="45720" tIns="9144" bIns="9144"/>
+          <a:lstStyle/>
+          <a:p>
+            <a:pPr algn="ctr">
               <a:lnSpc>
                 <a:spcPct val="100000"/>
               </a:lnSpc>
@@ -3901,31 +4313,31 @@
                 <a:spcPts val="0"/>
               </a:spcBef>
               <a:spcAft>
-                <a:spcPts val="100"/>
+                <a:spcPts val="0"/>
               </a:spcAft>
             </a:pPr>
             <a:r>
-              <a:rPr sz="950" b="0">
+              <a:rPr sz="850" b="0">
                 <a:solidFill>
                   <a:srgbClr val="1A1D21"/>
                 </a:solidFill>
                 <a:latin typeface="맑은 고딕"/>
               </a:rPr>
-              <a:t>⑥ 리포트 · 점수 · 인용</a:t>
-            </a:r>
-          </a:p>
-        </p:txBody>
-      </p:sp>
-      <p:sp>
-        <p:nvSpPr>
-          <p:cNvPr id="16" name="Rounded Rectangle 15"/>
+              <a:t>/internal-rules</a:t>
+            </a:r>
+          </a:p>
+        </p:txBody>
+      </p:sp>
+      <p:sp>
+        <p:nvSpPr>
+          <p:cNvPr id="23" name="Rounded Rectangle 22"/>
           <p:cNvSpPr/>
           <p:nvPr/>
         </p:nvSpPr>
         <p:spPr>
           <a:xfrm>
-            <a:off x="594360" y="4489704"/>
-            <a:ext cx="2729484" cy="420624"/>
+            <a:off x="7842936" y="3310128"/>
+            <a:ext cx="1247502" cy="365760"/>
           </a:xfrm>
           <a:prstGeom prst="roundRect">
             <a:avLst/>
@@ -3955,7 +4367,226 @@
           </a:fontRef>
         </p:style>
         <p:txBody>
-          <a:bodyPr rtlCol="0" anchor="ctr" wrap="square" lIns="109728" rIns="109728" tIns="18288" bIns="18288"/>
+          <a:bodyPr rtlCol="0" anchor="ctr" wrap="square" lIns="45720" rIns="45720" tIns="9144" bIns="9144"/>
+          <a:lstStyle/>
+          <a:p>
+            <a:pPr algn="ctr">
+              <a:lnSpc>
+                <a:spcPct val="100000"/>
+              </a:lnSpc>
+              <a:spcBef>
+                <a:spcPts val="0"/>
+              </a:spcBef>
+              <a:spcAft>
+                <a:spcPts val="0"/>
+              </a:spcAft>
+            </a:pPr>
+            <a:r>
+              <a:rPr sz="850" b="0">
+                <a:solidFill>
+                  <a:srgbClr val="1A1D21"/>
+                </a:solidFill>
+                <a:latin typeface="맑은 고딕"/>
+              </a:rPr>
+              <a:t>/regwatch</a:t>
+            </a:r>
+          </a:p>
+        </p:txBody>
+      </p:sp>
+      <p:sp>
+        <p:nvSpPr>
+          <p:cNvPr id="24" name="Rounded Rectangle 23"/>
+          <p:cNvSpPr/>
+          <p:nvPr/>
+        </p:nvSpPr>
+        <p:spPr>
+          <a:xfrm>
+            <a:off x="9163590" y="3310128"/>
+            <a:ext cx="1247502" cy="365760"/>
+          </a:xfrm>
+          <a:prstGeom prst="roundRect">
+            <a:avLst/>
+          </a:prstGeom>
+          <a:solidFill>
+            <a:srgbClr val="EEF4FC"/>
+          </a:solidFill>
+          <a:ln w="9525">
+            <a:solidFill>
+              <a:srgbClr val="BCD6F2"/>
+            </a:solidFill>
+          </a:ln>
+          <a:effectLst/>
+        </p:spPr>
+        <p:style>
+          <a:lnRef idx="1">
+            <a:schemeClr val="accent1"/>
+          </a:lnRef>
+          <a:fillRef idx="3">
+            <a:schemeClr val="accent1"/>
+          </a:fillRef>
+          <a:effectRef idx="2">
+            <a:schemeClr val="accent1"/>
+          </a:effectRef>
+          <a:fontRef idx="minor">
+            <a:schemeClr val="lt1"/>
+          </a:fontRef>
+        </p:style>
+        <p:txBody>
+          <a:bodyPr rtlCol="0" anchor="ctr" wrap="square" lIns="45720" rIns="45720" tIns="9144" bIns="9144"/>
+          <a:lstStyle/>
+          <a:p>
+            <a:pPr algn="ctr">
+              <a:lnSpc>
+                <a:spcPct val="100000"/>
+              </a:lnSpc>
+              <a:spcBef>
+                <a:spcPts val="0"/>
+              </a:spcBef>
+              <a:spcAft>
+                <a:spcPts val="0"/>
+              </a:spcAft>
+            </a:pPr>
+            <a:r>
+              <a:rPr sz="850" b="0">
+                <a:solidFill>
+                  <a:srgbClr val="1A1D21"/>
+                </a:solidFill>
+                <a:latin typeface="맑은 고딕"/>
+              </a:rPr>
+              <a:t>/dist</a:t>
+            </a:r>
+          </a:p>
+        </p:txBody>
+      </p:sp>
+      <p:sp>
+        <p:nvSpPr>
+          <p:cNvPr id="25" name="Rounded Rectangle 24"/>
+          <p:cNvSpPr/>
+          <p:nvPr/>
+        </p:nvSpPr>
+        <p:spPr>
+          <a:xfrm>
+            <a:off x="10484244" y="3310128"/>
+            <a:ext cx="1247502" cy="365760"/>
+          </a:xfrm>
+          <a:prstGeom prst="roundRect">
+            <a:avLst/>
+          </a:prstGeom>
+          <a:solidFill>
+            <a:srgbClr val="EEF4FC"/>
+          </a:solidFill>
+          <a:ln w="9525">
+            <a:solidFill>
+              <a:srgbClr val="BCD6F2"/>
+            </a:solidFill>
+          </a:ln>
+          <a:effectLst/>
+        </p:spPr>
+        <p:style>
+          <a:lnRef idx="1">
+            <a:schemeClr val="accent1"/>
+          </a:lnRef>
+          <a:fillRef idx="3">
+            <a:schemeClr val="accent1"/>
+          </a:fillRef>
+          <a:effectRef idx="2">
+            <a:schemeClr val="accent1"/>
+          </a:effectRef>
+          <a:fontRef idx="minor">
+            <a:schemeClr val="lt1"/>
+          </a:fontRef>
+        </p:style>
+        <p:txBody>
+          <a:bodyPr rtlCol="0" anchor="ctr" wrap="square" lIns="45720" rIns="45720" tIns="9144" bIns="9144"/>
+          <a:lstStyle/>
+          <a:p>
+            <a:pPr algn="ctr">
+              <a:lnSpc>
+                <a:spcPct val="100000"/>
+              </a:lnSpc>
+              <a:spcBef>
+                <a:spcPts val="0"/>
+              </a:spcBef>
+              <a:spcAft>
+                <a:spcPts val="0"/>
+              </a:spcAft>
+            </a:pPr>
+            <a:r>
+              <a:rPr sz="850" b="0">
+                <a:solidFill>
+                  <a:srgbClr val="1A1D21"/>
+                </a:solidFill>
+                <a:latin typeface="맑은 고딕"/>
+              </a:rPr>
+              <a:t>/products</a:t>
+            </a:r>
+          </a:p>
+        </p:txBody>
+      </p:sp>
+      <p:sp>
+        <p:nvSpPr>
+          <p:cNvPr id="26" name="Down Arrow 25"/>
+          <p:cNvSpPr/>
+          <p:nvPr/>
+        </p:nvSpPr>
+        <p:spPr>
+          <a:xfrm>
+            <a:off x="7022592" y="3767328"/>
+            <a:ext cx="219456" cy="146304"/>
+          </a:xfrm>
+          <a:prstGeom prst="downArrow">
+            <a:avLst/>
+          </a:prstGeom>
+          <a:solidFill>
+            <a:srgbClr val="AAB4C0"/>
+          </a:solidFill>
+          <a:ln>
+            <a:noFill/>
+          </a:ln>
+          <a:effectLst/>
+        </p:spPr>
+        <p:style>
+          <a:lnRef idx="1">
+            <a:schemeClr val="accent1"/>
+          </a:lnRef>
+          <a:fillRef idx="3">
+            <a:schemeClr val="accent1"/>
+          </a:fillRef>
+          <a:effectRef idx="2">
+            <a:schemeClr val="accent1"/>
+          </a:effectRef>
+          <a:fontRef idx="minor">
+            <a:schemeClr val="lt1"/>
+          </a:fontRef>
+        </p:style>
+        <p:txBody>
+          <a:bodyPr rtlCol="0" anchor="ctr"/>
+          <a:lstStyle/>
+          <a:p>
+            <a:pPr algn="ctr"/>
+          </a:p>
+        </p:txBody>
+      </p:sp>
+      <p:sp>
+        <p:nvSpPr>
+          <p:cNvPr id="27" name="TextBox 26"/>
+          <p:cNvSpPr txBox="1"/>
+          <p:nvPr/>
+        </p:nvSpPr>
+        <p:spPr>
+          <a:xfrm>
+            <a:off x="7315200" y="3749040"/>
+            <a:ext cx="2743200" cy="146304"/>
+          </a:xfrm>
+          <a:prstGeom prst="rect">
+            <a:avLst/>
+          </a:prstGeom>
+          <a:noFill/>
+        </p:spPr>
+        <p:txBody>
+          <a:bodyPr wrap="square" anchor="ctr" lIns="0" rIns="0" tIns="9144" bIns="9144">
+            <a:spAutoFit/>
+          </a:bodyPr>
           <a:lstStyle/>
           <a:p>
             <a:pPr algn="l">
@@ -3966,31 +4597,94 @@
                 <a:spcPts val="0"/>
               </a:spcBef>
               <a:spcAft>
-                <a:spcPts val="100"/>
+                <a:spcPts val="0"/>
               </a:spcAft>
             </a:pPr>
             <a:r>
-              <a:rPr sz="950" b="0">
-                <a:solidFill>
-                  <a:srgbClr val="1A1D21"/>
+              <a:rPr sz="850" b="0">
+                <a:solidFill>
+                  <a:srgbClr val="5B6470"/>
                 </a:solidFill>
                 <a:latin typeface="맑은 고딕"/>
               </a:rPr>
-              <a:t>⑦⑧ 승인 · 감사로그</a:t>
-            </a:r>
-          </a:p>
-        </p:txBody>
-      </p:sp>
-      <p:sp>
-        <p:nvSpPr>
-          <p:cNvPr id="17" name="Rounded Rectangle 16"/>
+              <a:t>추론 호출</a:t>
+            </a:r>
+          </a:p>
+        </p:txBody>
+      </p:sp>
+      <p:sp>
+        <p:nvSpPr>
+          <p:cNvPr id="28" name="Rounded Rectangle 27"/>
           <p:cNvSpPr/>
           <p:nvPr/>
         </p:nvSpPr>
         <p:spPr>
           <a:xfrm>
-            <a:off x="3488436" y="4489704"/>
-            <a:ext cx="2729484" cy="420624"/>
+            <a:off x="457200" y="3931920"/>
+            <a:ext cx="1965960" cy="1371600"/>
+          </a:xfrm>
+          <a:prstGeom prst="roundRect">
+            <a:avLst/>
+          </a:prstGeom>
+          <a:solidFill>
+            <a:srgbClr val="5B3BBF"/>
+          </a:solidFill>
+          <a:ln>
+            <a:noFill/>
+          </a:ln>
+          <a:effectLst/>
+        </p:spPr>
+        <p:style>
+          <a:lnRef idx="1">
+            <a:schemeClr val="accent1"/>
+          </a:lnRef>
+          <a:fillRef idx="3">
+            <a:schemeClr val="accent1"/>
+          </a:fillRef>
+          <a:effectRef idx="2">
+            <a:schemeClr val="accent1"/>
+          </a:effectRef>
+          <a:fontRef idx="minor">
+            <a:schemeClr val="lt1"/>
+          </a:fontRef>
+        </p:style>
+        <p:txBody>
+          <a:bodyPr rtlCol="0" anchor="ctr" wrap="square" lIns="64008" rIns="64008" tIns="9144" bIns="9144"/>
+          <a:lstStyle/>
+          <a:p>
+            <a:pPr algn="ctr">
+              <a:lnSpc>
+                <a:spcPct val="100000"/>
+              </a:lnSpc>
+              <a:spcBef>
+                <a:spcPts val="0"/>
+              </a:spcBef>
+              <a:spcAft>
+                <a:spcPts val="0"/>
+              </a:spcAft>
+            </a:pPr>
+            <a:r>
+              <a:rPr sz="1250" b="1">
+                <a:solidFill>
+                  <a:srgbClr val="FFFFFF"/>
+                </a:solidFill>
+                <a:latin typeface="맑은 고딕"/>
+              </a:rPr>
+              <a:t>🧠 AI Agent/모델</a:t>
+            </a:r>
+          </a:p>
+        </p:txBody>
+      </p:sp>
+      <p:sp>
+        <p:nvSpPr>
+          <p:cNvPr id="29" name="Rounded Rectangle 28"/>
+          <p:cNvSpPr/>
+          <p:nvPr/>
+        </p:nvSpPr>
+        <p:spPr>
+          <a:xfrm>
+            <a:off x="2560320" y="3931920"/>
+            <a:ext cx="9171432" cy="1371600"/>
           </a:xfrm>
           <a:prstGeom prst="roundRect">
             <a:avLst/>
@@ -3998,7 +4692,7 @@
           <a:solidFill>
             <a:srgbClr val="F0ECFF"/>
           </a:solidFill>
-          <a:ln w="9525">
+          <a:ln w="12700">
             <a:solidFill>
               <a:srgbClr val="CDBFF0"/>
             </a:solidFill>
@@ -4020,7 +4714,33 @@
           </a:fontRef>
         </p:style>
         <p:txBody>
-          <a:bodyPr rtlCol="0" anchor="ctr" wrap="square" lIns="109728" rIns="109728" tIns="18288" bIns="18288"/>
+          <a:bodyPr rtlCol="0" anchor="ctr" wrap="square" lIns="64008" rIns="64008" tIns="9144" bIns="9144"/>
+          <a:lstStyle/>
+          <a:p>
+            <a:pPr algn="ctr"/>
+          </a:p>
+        </p:txBody>
+      </p:sp>
+      <p:sp>
+        <p:nvSpPr>
+          <p:cNvPr id="30" name="TextBox 29"/>
+          <p:cNvSpPr txBox="1"/>
+          <p:nvPr/>
+        </p:nvSpPr>
+        <p:spPr>
+          <a:xfrm>
+            <a:off x="2706624" y="4005072"/>
+            <a:ext cx="8897112" cy="219456"/>
+          </a:xfrm>
+          <a:prstGeom prst="rect">
+            <a:avLst/>
+          </a:prstGeom>
+          <a:noFill/>
+        </p:spPr>
+        <p:txBody>
+          <a:bodyPr wrap="square" anchor="t" lIns="0" rIns="0" tIns="9144" bIns="9144">
+            <a:spAutoFit/>
+          </a:bodyPr>
           <a:lstStyle/>
           <a:p>
             <a:pPr algn="l">
@@ -4031,337 +4751,31 @@
                 <a:spcPts val="0"/>
               </a:spcBef>
               <a:spcAft>
-                <a:spcPts val="100"/>
+                <a:spcPts val="0"/>
               </a:spcAft>
             </a:pPr>
             <a:r>
-              <a:rPr sz="950" b="1">
-                <a:solidFill>
-                  <a:srgbClr val="003A6E"/>
+              <a:rPr sz="1000" b="1">
+                <a:solidFill>
+                  <a:srgbClr val="5B3BBF"/>
                 </a:solidFill>
                 <a:latin typeface="맑은 고딕"/>
               </a:rPr>
-              <a:t>★준법 오토파일럿 (자율 개선)</a:t>
-            </a:r>
-          </a:p>
-        </p:txBody>
-      </p:sp>
-      <p:sp>
-        <p:nvSpPr>
-          <p:cNvPr id="18" name="Rounded Rectangle 17"/>
+              <a:t>Orchestrator · 명시적 파이썬 파이프라인 (app/pipeline)</a:t>
+            </a:r>
+          </a:p>
+        </p:txBody>
+      </p:sp>
+      <p:sp>
+        <p:nvSpPr>
+          <p:cNvPr id="31" name="Rounded Rectangle 30"/>
           <p:cNvSpPr/>
           <p:nvPr/>
         </p:nvSpPr>
         <p:spPr>
           <a:xfrm>
-            <a:off x="594360" y="5056632"/>
-            <a:ext cx="5623560" cy="548640"/>
-          </a:xfrm>
-          <a:prstGeom prst="roundRect">
-            <a:avLst/>
-          </a:prstGeom>
-          <a:solidFill>
-            <a:srgbClr val="1F2D44"/>
-          </a:solidFill>
-          <a:ln>
-            <a:noFill/>
-          </a:ln>
-          <a:effectLst/>
-        </p:spPr>
-        <p:style>
-          <a:lnRef idx="1">
-            <a:schemeClr val="accent1"/>
-          </a:lnRef>
-          <a:fillRef idx="3">
-            <a:schemeClr val="accent1"/>
-          </a:fillRef>
-          <a:effectRef idx="2">
-            <a:schemeClr val="accent1"/>
-          </a:effectRef>
-          <a:fontRef idx="minor">
-            <a:schemeClr val="lt1"/>
-          </a:fontRef>
-        </p:style>
-        <p:txBody>
-          <a:bodyPr rtlCol="0" anchor="ctr" wrap="square" lIns="146304" rIns="146304" tIns="18288" bIns="18288"/>
-          <a:lstStyle/>
-          <a:p>
-            <a:pPr algn="l">
-              <a:lnSpc>
-                <a:spcPct val="100000"/>
-              </a:lnSpc>
-              <a:spcBef>
-                <a:spcPts val="0"/>
-              </a:spcBef>
-              <a:spcAft>
-                <a:spcPts val="100"/>
-              </a:spcAft>
-            </a:pPr>
-            <a:r>
-              <a:rPr sz="1050" b="1">
-                <a:solidFill>
-                  <a:srgbClr val="FFFFFF"/>
-                </a:solidFill>
-                <a:latin typeface="맑은 고딕"/>
-              </a:rPr>
-              <a:t>LLM 서버 · Ollama  (Qwen2.5-7B-Instruct)</a:t>
-            </a:r>
-          </a:p>
-          <a:p>
-            <a:pPr algn="l">
-              <a:lnSpc>
-                <a:spcPct val="100000"/>
-              </a:lnSpc>
-              <a:spcBef>
-                <a:spcPts val="0"/>
-              </a:spcBef>
-              <a:spcAft>
-                <a:spcPts val="100"/>
-              </a:spcAft>
-            </a:pPr>
-            <a:r>
-              <a:rPr sz="900" b="0">
-                <a:solidFill>
-                  <a:srgbClr val="C7D2E0"/>
-                </a:solidFill>
-                <a:latin typeface="맑은 고딕"/>
-              </a:rPr>
-              <a:t>미연결 시 룰 기반 결정적 폴백</a:t>
-            </a:r>
-          </a:p>
-        </p:txBody>
-      </p:sp>
-      <p:sp>
-        <p:nvSpPr>
-          <p:cNvPr id="19" name="TextBox 18"/>
-          <p:cNvSpPr txBox="1"/>
-          <p:nvPr/>
-        </p:nvSpPr>
-        <p:spPr>
-          <a:xfrm>
-            <a:off x="612648" y="5660136"/>
-            <a:ext cx="5623560" cy="219456"/>
-          </a:xfrm>
-          <a:prstGeom prst="rect">
-            <a:avLst/>
-          </a:prstGeom>
-          <a:noFill/>
-        </p:spPr>
-        <p:txBody>
-          <a:bodyPr wrap="square" anchor="t" lIns="0" rIns="0" tIns="18288" bIns="18288">
-            <a:spAutoFit/>
-          </a:bodyPr>
-          <a:lstStyle/>
-          <a:p>
-            <a:pPr algn="l">
-              <a:lnSpc>
-                <a:spcPct val="100000"/>
-              </a:lnSpc>
-              <a:spcBef>
-                <a:spcPts val="0"/>
-              </a:spcBef>
-              <a:spcAft>
-                <a:spcPts val="100"/>
-              </a:spcAft>
-            </a:pPr>
-            <a:r>
-              <a:rPr sz="850" b="0">
-                <a:solidFill>
-                  <a:srgbClr val="5B6470"/>
-                </a:solidFill>
-                <a:latin typeface="맑은 고딕"/>
-              </a:rPr>
-              <a:t>✓ 결정적 룰엔진이 등급 관리 · LLM은 보조 · 합격 위장 불가</a:t>
-            </a:r>
-          </a:p>
-        </p:txBody>
-      </p:sp>
-      <p:sp>
-        <p:nvSpPr>
-          <p:cNvPr id="20" name="Rounded Rectangle 19"/>
-          <p:cNvSpPr/>
-          <p:nvPr/>
-        </p:nvSpPr>
-        <p:spPr>
-          <a:xfrm>
-            <a:off x="6565392" y="1325880"/>
-            <a:ext cx="2057400" cy="5074920"/>
-          </a:xfrm>
-          <a:prstGeom prst="roundRect">
-            <a:avLst/>
-          </a:prstGeom>
-          <a:solidFill>
-            <a:srgbClr val="FEF7E6"/>
-          </a:solidFill>
-          <a:ln w="12700">
-            <a:solidFill>
-              <a:srgbClr val="F0D99A"/>
-            </a:solidFill>
-          </a:ln>
-          <a:effectLst/>
-        </p:spPr>
-        <p:style>
-          <a:lnRef idx="1">
-            <a:schemeClr val="accent1"/>
-          </a:lnRef>
-          <a:fillRef idx="3">
-            <a:schemeClr val="accent1"/>
-          </a:fillRef>
-          <a:effectRef idx="2">
-            <a:schemeClr val="accent1"/>
-          </a:effectRef>
-          <a:fontRef idx="minor">
-            <a:schemeClr val="lt1"/>
-          </a:fontRef>
-        </p:style>
-        <p:txBody>
-          <a:bodyPr rtlCol="0" anchor="ctr" wrap="square" lIns="54864" rIns="54864" tIns="18288" bIns="18288"/>
-          <a:lstStyle/>
-          <a:p>
-            <a:pPr algn="ctr"/>
-          </a:p>
-        </p:txBody>
-      </p:sp>
-      <p:sp>
-        <p:nvSpPr>
-          <p:cNvPr id="21" name="Rounded Rectangle 20"/>
-          <p:cNvSpPr/>
-          <p:nvPr/>
-        </p:nvSpPr>
-        <p:spPr>
-          <a:xfrm>
-            <a:off x="6565392" y="1325880"/>
-            <a:ext cx="2057400" cy="475488"/>
-          </a:xfrm>
-          <a:prstGeom prst="roundRect">
-            <a:avLst/>
-          </a:prstGeom>
-          <a:solidFill>
-            <a:srgbClr val="FBEECB"/>
-          </a:solidFill>
-          <a:ln>
-            <a:noFill/>
-          </a:ln>
-          <a:effectLst/>
-        </p:spPr>
-        <p:style>
-          <a:lnRef idx="1">
-            <a:schemeClr val="accent1"/>
-          </a:lnRef>
-          <a:fillRef idx="3">
-            <a:schemeClr val="accent1"/>
-          </a:fillRef>
-          <a:effectRef idx="2">
-            <a:schemeClr val="accent1"/>
-          </a:effectRef>
-          <a:fontRef idx="minor">
-            <a:schemeClr val="lt1"/>
-          </a:fontRef>
-        </p:style>
-        <p:txBody>
-          <a:bodyPr rtlCol="0" anchor="ctr" wrap="square" lIns="54864" rIns="54864" tIns="18288" bIns="18288"/>
-          <a:lstStyle/>
-          <a:p>
-            <a:pPr algn="ctr">
-              <a:lnSpc>
-                <a:spcPct val="100000"/>
-              </a:lnSpc>
-              <a:spcBef>
-                <a:spcPts val="0"/>
-              </a:spcBef>
-              <a:spcAft>
-                <a:spcPts val="100"/>
-              </a:spcAft>
-            </a:pPr>
-            <a:r>
-              <a:rPr sz="1300" b="1">
-                <a:solidFill>
-                  <a:srgbClr val="C78A06"/>
-                </a:solidFill>
-                <a:latin typeface="맑은 고딕"/>
-              </a:rPr>
-              <a:t>🔁 DMZ</a:t>
-            </a:r>
-          </a:p>
-          <a:p>
-            <a:pPr algn="ctr">
-              <a:lnSpc>
-                <a:spcPct val="100000"/>
-              </a:lnSpc>
-              <a:spcBef>
-                <a:spcPts val="0"/>
-              </a:spcBef>
-              <a:spcAft>
-                <a:spcPts val="100"/>
-              </a:spcAft>
-            </a:pPr>
-            <a:r>
-              <a:rPr sz="1050" b="1">
-                <a:solidFill>
-                  <a:srgbClr val="C78A06"/>
-                </a:solidFill>
-                <a:latin typeface="맑은 고딕"/>
-              </a:rPr>
-              <a:t>망연계 게이트웨이</a:t>
-            </a:r>
-          </a:p>
-        </p:txBody>
-      </p:sp>
-      <p:sp>
-        <p:nvSpPr>
-          <p:cNvPr id="22" name="TextBox 21"/>
-          <p:cNvSpPr txBox="1"/>
-          <p:nvPr/>
-        </p:nvSpPr>
-        <p:spPr>
-          <a:xfrm>
-            <a:off x="6675120" y="1892808"/>
-            <a:ext cx="1837944" cy="274320"/>
-          </a:xfrm>
-          <a:prstGeom prst="rect">
-            <a:avLst/>
-          </a:prstGeom>
-          <a:noFill/>
-        </p:spPr>
-        <p:txBody>
-          <a:bodyPr wrap="square" anchor="t" lIns="0" rIns="0" tIns="18288" bIns="18288">
-            <a:spAutoFit/>
-          </a:bodyPr>
-          <a:lstStyle/>
-          <a:p>
-            <a:pPr algn="ctr">
-              <a:lnSpc>
-                <a:spcPct val="100000"/>
-              </a:lnSpc>
-              <a:spcBef>
-                <a:spcPts val="0"/>
-              </a:spcBef>
-              <a:spcAft>
-                <a:spcPts val="100"/>
-              </a:spcAft>
-            </a:pPr>
-            <a:r>
-              <a:rPr sz="1000" b="1">
-                <a:solidFill>
-                  <a:srgbClr val="8A6200"/>
-                </a:solidFill>
-                <a:latin typeface="맑은 고딕"/>
-              </a:rPr>
-              <a:t>단방향 · 배치 · 검증</a:t>
-            </a:r>
-          </a:p>
-        </p:txBody>
-      </p:sp>
-      <p:sp>
-        <p:nvSpPr>
-          <p:cNvPr id="23" name="Rounded Rectangle 22"/>
-          <p:cNvSpPr/>
-          <p:nvPr/>
-        </p:nvSpPr>
-        <p:spPr>
-          <a:xfrm>
-            <a:off x="6885432" y="2697480"/>
-            <a:ext cx="1417320" cy="548640"/>
+            <a:off x="2706624" y="4279392"/>
+            <a:ext cx="1197864" cy="438912"/>
           </a:xfrm>
           <a:prstGeom prst="roundRect">
             <a:avLst/>
@@ -4371,7 +4785,7 @@
           </a:solidFill>
           <a:ln w="9525">
             <a:solidFill>
-              <a:srgbClr val="F0D99A"/>
+              <a:srgbClr val="CDBFF0"/>
             </a:solidFill>
           </a:ln>
           <a:effectLst/>
@@ -4391,7 +4805,7 @@
           </a:fontRef>
         </p:style>
         <p:txBody>
-          <a:bodyPr rtlCol="0" anchor="ctr" wrap="square" lIns="54864" rIns="54864" tIns="18288" bIns="18288"/>
+          <a:bodyPr rtlCol="0" anchor="ctr" wrap="square" lIns="36576" rIns="36576" tIns="9144" bIns="9144"/>
           <a:lstStyle/>
           <a:p>
             <a:pPr algn="ctr">
@@ -4402,31 +4816,31 @@
                 <a:spcPts val="0"/>
               </a:spcBef>
               <a:spcAft>
-                <a:spcPts val="100"/>
+                <a:spcPts val="0"/>
               </a:spcAft>
             </a:pPr>
             <a:r>
-              <a:rPr sz="2200" b="1">
-                <a:solidFill>
-                  <a:srgbClr val="C78A06"/>
+              <a:rPr sz="850" b="0">
+                <a:solidFill>
+                  <a:srgbClr val="1A1D21"/>
                 </a:solidFill>
                 <a:latin typeface="맑은 고딕"/>
               </a:rPr>
-              <a:t>⇄</a:t>
-            </a:r>
-          </a:p>
-        </p:txBody>
-      </p:sp>
-      <p:sp>
-        <p:nvSpPr>
-          <p:cNvPr id="24" name="Rounded Rectangle 23"/>
+              <a:t>①유형분류</a:t>
+            </a:r>
+          </a:p>
+        </p:txBody>
+      </p:sp>
+      <p:sp>
+        <p:nvSpPr>
+          <p:cNvPr id="32" name="Rounded Rectangle 31"/>
           <p:cNvSpPr/>
           <p:nvPr/>
         </p:nvSpPr>
         <p:spPr>
           <a:xfrm>
-            <a:off x="6729984" y="3474720"/>
-            <a:ext cx="1728216" cy="548640"/>
+            <a:off x="3986784" y="4279392"/>
+            <a:ext cx="1197864" cy="438912"/>
           </a:xfrm>
           <a:prstGeom prst="roundRect">
             <a:avLst/>
@@ -4436,7 +4850,7 @@
           </a:solidFill>
           <a:ln w="9525">
             <a:solidFill>
-              <a:srgbClr val="F0D99A"/>
+              <a:srgbClr val="CDBFF0"/>
             </a:solidFill>
           </a:ln>
           <a:effectLst/>
@@ -4456,7 +4870,7 @@
           </a:fontRef>
         </p:style>
         <p:txBody>
-          <a:bodyPr rtlCol="0" anchor="ctr" wrap="square" lIns="54864" rIns="54864" tIns="18288" bIns="18288"/>
+          <a:bodyPr rtlCol="0" anchor="ctr" wrap="square" lIns="36576" rIns="36576" tIns="9144" bIns="9144"/>
           <a:lstStyle/>
           <a:p>
             <a:pPr algn="ctr">
@@ -4467,53 +4881,31 @@
                 <a:spcPts val="0"/>
               </a:spcBef>
               <a:spcAft>
-                <a:spcPts val="100"/>
+                <a:spcPts val="0"/>
               </a:spcAft>
             </a:pPr>
             <a:r>
-              <a:rPr sz="950" b="1">
+              <a:rPr sz="850" b="0">
                 <a:solidFill>
                   <a:srgbClr val="1A1D21"/>
                 </a:solidFill>
                 <a:latin typeface="맑은 고딕"/>
               </a:rPr>
-              <a:t>◀ 배치 수신</a:t>
-            </a:r>
-          </a:p>
-          <a:p>
-            <a:pPr algn="ctr">
-              <a:lnSpc>
-                <a:spcPct val="100000"/>
-              </a:lnSpc>
-              <a:spcBef>
-                <a:spcPts val="0"/>
-              </a:spcBef>
-              <a:spcAft>
-                <a:spcPts val="100"/>
-              </a:spcAft>
-            </a:pPr>
-            <a:r>
-              <a:rPr sz="850" b="0">
-                <a:solidFill>
-                  <a:srgbClr val="5B6470"/>
-                </a:solidFill>
-                <a:latin typeface="맑은 고딕"/>
-              </a:rPr>
-              <a:t>규제 피드</a:t>
-            </a:r>
-          </a:p>
-        </p:txBody>
-      </p:sp>
-      <p:sp>
-        <p:nvSpPr>
-          <p:cNvPr id="25" name="Rounded Rectangle 24"/>
+              <a:t>②RAG 근거검색</a:t>
+            </a:r>
+          </a:p>
+        </p:txBody>
+      </p:sp>
+      <p:sp>
+        <p:nvSpPr>
+          <p:cNvPr id="33" name="Rounded Rectangle 32"/>
           <p:cNvSpPr/>
           <p:nvPr/>
         </p:nvSpPr>
         <p:spPr>
           <a:xfrm>
-            <a:off x="6729984" y="4114800"/>
-            <a:ext cx="1728216" cy="548640"/>
+            <a:off x="5266944" y="4279392"/>
+            <a:ext cx="1197864" cy="438912"/>
           </a:xfrm>
           <a:prstGeom prst="roundRect">
             <a:avLst/>
@@ -4523,7 +4915,7 @@
           </a:solidFill>
           <a:ln w="9525">
             <a:solidFill>
-              <a:srgbClr val="F0D99A"/>
+              <a:srgbClr val="CDBFF0"/>
             </a:solidFill>
           </a:ln>
           <a:effectLst/>
@@ -4543,7 +4935,7 @@
           </a:fontRef>
         </p:style>
         <p:txBody>
-          <a:bodyPr rtlCol="0" anchor="ctr" wrap="square" lIns="54864" rIns="54864" tIns="18288" bIns="18288"/>
+          <a:bodyPr rtlCol="0" anchor="ctr" wrap="square" lIns="36576" rIns="36576" tIns="9144" bIns="9144"/>
           <a:lstStyle/>
           <a:p>
             <a:pPr algn="ctr">
@@ -4554,98 +4946,31 @@
                 <a:spcPts val="0"/>
               </a:spcBef>
               <a:spcAft>
-                <a:spcPts val="100"/>
+                <a:spcPts val="0"/>
               </a:spcAft>
             </a:pPr>
             <a:r>
-              <a:rPr sz="950" b="1">
-                <a:solidFill>
-                  <a:srgbClr val="1A1D21"/>
+              <a:rPr sz="850" b="1">
+                <a:solidFill>
+                  <a:srgbClr val="5B3BBF"/>
                 </a:solidFill>
                 <a:latin typeface="맑은 고딕"/>
               </a:rPr>
-              <a:t>승인본 발송 ▶</a:t>
-            </a:r>
-          </a:p>
-          <a:p>
-            <a:pPr algn="ctr">
-              <a:lnSpc>
-                <a:spcPct val="100000"/>
-              </a:lnSpc>
-              <a:spcBef>
-                <a:spcPts val="0"/>
-              </a:spcBef>
-              <a:spcAft>
-                <a:spcPts val="100"/>
-              </a:spcAft>
-            </a:pPr>
-            <a:r>
-              <a:rPr sz="850" b="0">
-                <a:solidFill>
-                  <a:srgbClr val="5B6470"/>
-                </a:solidFill>
-                <a:latin typeface="맑은 고딕"/>
-              </a:rPr>
-              <a:t>알림 요청</a:t>
-            </a:r>
-          </a:p>
-        </p:txBody>
-      </p:sp>
-      <p:sp>
-        <p:nvSpPr>
-          <p:cNvPr id="26" name="TextBox 25"/>
-          <p:cNvSpPr txBox="1"/>
-          <p:nvPr/>
-        </p:nvSpPr>
-        <p:spPr>
-          <a:xfrm>
-            <a:off x="6693408" y="4937760"/>
-            <a:ext cx="1801368" cy="1097280"/>
-          </a:xfrm>
-          <a:prstGeom prst="rect">
-            <a:avLst/>
-          </a:prstGeom>
-          <a:noFill/>
-        </p:spPr>
-        <p:txBody>
-          <a:bodyPr wrap="square" anchor="t" lIns="0" rIns="0" tIns="18288" bIns="18288">
-            <a:spAutoFit/>
-          </a:bodyPr>
-          <a:lstStyle/>
-          <a:p>
-            <a:pPr algn="ctr">
-              <a:lnSpc>
-                <a:spcPct val="100000"/>
-              </a:lnSpc>
-              <a:spcBef>
-                <a:spcPts val="0"/>
-              </a:spcBef>
-              <a:spcAft>
-                <a:spcPts val="100"/>
-              </a:spcAft>
-            </a:pPr>
-            <a:r>
-              <a:rPr sz="850" b="0">
-                <a:solidFill>
-                  <a:srgbClr val="8A6200"/>
-                </a:solidFill>
-                <a:latin typeface="맑은 고딕"/>
-              </a:rPr>
-              <a:t>실시간 그룹/직접 발송 아님 · 보안 검토 통과 트래픽만 허용</a:t>
-            </a:r>
-          </a:p>
-        </p:txBody>
-      </p:sp>
-      <p:sp>
-        <p:nvSpPr>
-          <p:cNvPr id="27" name="Rounded Rectangle 26"/>
+              <a:t>③룰엔진(결정적)</a:t>
+            </a:r>
+          </a:p>
+        </p:txBody>
+      </p:sp>
+      <p:sp>
+        <p:nvSpPr>
+          <p:cNvPr id="34" name="Rounded Rectangle 33"/>
           <p:cNvSpPr/>
           <p:nvPr/>
         </p:nvSpPr>
         <p:spPr>
           <a:xfrm>
-            <a:off x="8778240" y="1325880"/>
-            <a:ext cx="2999232" cy="5074920"/>
+            <a:off x="6547104" y="4279392"/>
+            <a:ext cx="1197864" cy="438912"/>
           </a:xfrm>
           <a:prstGeom prst="roundRect">
             <a:avLst/>
@@ -4653,9 +4978,9 @@
           <a:solidFill>
             <a:srgbClr val="FFFFFF"/>
           </a:solidFill>
-          <a:ln w="12700">
+          <a:ln w="9525">
             <a:solidFill>
-              <a:srgbClr val="D8DEE6"/>
+              <a:srgbClr val="CDBFF0"/>
             </a:solidFill>
           </a:ln>
           <a:effectLst/>
@@ -4675,29 +5000,491 @@
           </a:fontRef>
         </p:style>
         <p:txBody>
-          <a:bodyPr rtlCol="0" anchor="ctr" wrap="square" lIns="54864" rIns="54864" tIns="18288" bIns="18288"/>
-          <a:lstStyle/>
-          <a:p>
-            <a:pPr algn="ctr"/>
-          </a:p>
-        </p:txBody>
-      </p:sp>
-      <p:sp>
-        <p:nvSpPr>
-          <p:cNvPr id="28" name="Rounded Rectangle 27"/>
+          <a:bodyPr rtlCol="0" anchor="ctr" wrap="square" lIns="36576" rIns="36576" tIns="9144" bIns="9144"/>
+          <a:lstStyle/>
+          <a:p>
+            <a:pPr algn="ctr">
+              <a:lnSpc>
+                <a:spcPct val="100000"/>
+              </a:lnSpc>
+              <a:spcBef>
+                <a:spcPts val="0"/>
+              </a:spcBef>
+              <a:spcAft>
+                <a:spcPts val="0"/>
+              </a:spcAft>
+            </a:pPr>
+            <a:r>
+              <a:rPr sz="850" b="0">
+                <a:solidFill>
+                  <a:srgbClr val="1A1D21"/>
+                </a:solidFill>
+                <a:latin typeface="맑은 고딕"/>
+              </a:rPr>
+              <a:t>④LLM 뉘앙스 심의</a:t>
+            </a:r>
+          </a:p>
+        </p:txBody>
+      </p:sp>
+      <p:sp>
+        <p:nvSpPr>
+          <p:cNvPr id="35" name="Rounded Rectangle 34"/>
           <p:cNvSpPr/>
           <p:nvPr/>
         </p:nvSpPr>
         <p:spPr>
           <a:xfrm>
-            <a:off x="8778240" y="1325880"/>
-            <a:ext cx="2999232" cy="475488"/>
+            <a:off x="7827264" y="4279392"/>
+            <a:ext cx="1197864" cy="438912"/>
           </a:xfrm>
           <a:prstGeom prst="roundRect">
             <a:avLst/>
           </a:prstGeom>
           <a:solidFill>
-            <a:srgbClr val="EEF1F5"/>
+            <a:srgbClr val="FFFFFF"/>
+          </a:solidFill>
+          <a:ln w="9525">
+            <a:solidFill>
+              <a:srgbClr val="CDBFF0"/>
+            </a:solidFill>
+          </a:ln>
+          <a:effectLst/>
+        </p:spPr>
+        <p:style>
+          <a:lnRef idx="1">
+            <a:schemeClr val="accent1"/>
+          </a:lnRef>
+          <a:fillRef idx="3">
+            <a:schemeClr val="accent1"/>
+          </a:fillRef>
+          <a:effectRef idx="2">
+            <a:schemeClr val="accent1"/>
+          </a:effectRef>
+          <a:fontRef idx="minor">
+            <a:schemeClr val="lt1"/>
+          </a:fontRef>
+        </p:style>
+        <p:txBody>
+          <a:bodyPr rtlCol="0" anchor="ctr" wrap="square" lIns="36576" rIns="36576" tIns="9144" bIns="9144"/>
+          <a:lstStyle/>
+          <a:p>
+            <a:pPr algn="ctr">
+              <a:lnSpc>
+                <a:spcPct val="100000"/>
+              </a:lnSpc>
+              <a:spcBef>
+                <a:spcPts val="0"/>
+              </a:spcBef>
+              <a:spcAft>
+                <a:spcPts val="0"/>
+              </a:spcAft>
+            </a:pPr>
+            <a:r>
+              <a:rPr sz="850" b="1">
+                <a:solidFill>
+                  <a:srgbClr val="5B3BBF"/>
+                </a:solidFill>
+                <a:latin typeface="맑은 고딕"/>
+              </a:rPr>
+              <a:t>⑤★오인 시뮬레이터</a:t>
+            </a:r>
+          </a:p>
+        </p:txBody>
+      </p:sp>
+      <p:sp>
+        <p:nvSpPr>
+          <p:cNvPr id="36" name="Rounded Rectangle 35"/>
+          <p:cNvSpPr/>
+          <p:nvPr/>
+        </p:nvSpPr>
+        <p:spPr>
+          <a:xfrm>
+            <a:off x="9107424" y="4279392"/>
+            <a:ext cx="1197864" cy="438912"/>
+          </a:xfrm>
+          <a:prstGeom prst="roundRect">
+            <a:avLst/>
+          </a:prstGeom>
+          <a:solidFill>
+            <a:srgbClr val="FFFFFF"/>
+          </a:solidFill>
+          <a:ln w="9525">
+            <a:solidFill>
+              <a:srgbClr val="CDBFF0"/>
+            </a:solidFill>
+          </a:ln>
+          <a:effectLst/>
+        </p:spPr>
+        <p:style>
+          <a:lnRef idx="1">
+            <a:schemeClr val="accent1"/>
+          </a:lnRef>
+          <a:fillRef idx="3">
+            <a:schemeClr val="accent1"/>
+          </a:fillRef>
+          <a:effectRef idx="2">
+            <a:schemeClr val="accent1"/>
+          </a:effectRef>
+          <a:fontRef idx="minor">
+            <a:schemeClr val="lt1"/>
+          </a:fontRef>
+        </p:style>
+        <p:txBody>
+          <a:bodyPr rtlCol="0" anchor="ctr" wrap="square" lIns="36576" rIns="36576" tIns="9144" bIns="9144"/>
+          <a:lstStyle/>
+          <a:p>
+            <a:pPr algn="ctr">
+              <a:lnSpc>
+                <a:spcPct val="100000"/>
+              </a:lnSpc>
+              <a:spcBef>
+                <a:spcPts val="0"/>
+              </a:spcBef>
+              <a:spcAft>
+                <a:spcPts val="0"/>
+              </a:spcAft>
+            </a:pPr>
+            <a:r>
+              <a:rPr sz="850" b="0">
+                <a:solidFill>
+                  <a:srgbClr val="1A1D21"/>
+                </a:solidFill>
+                <a:latin typeface="맑은 고딕"/>
+              </a:rPr>
+              <a:t>⑥리포트·점수</a:t>
+            </a:r>
+          </a:p>
+        </p:txBody>
+      </p:sp>
+      <p:sp>
+        <p:nvSpPr>
+          <p:cNvPr id="37" name="Rounded Rectangle 36"/>
+          <p:cNvSpPr/>
+          <p:nvPr/>
+        </p:nvSpPr>
+        <p:spPr>
+          <a:xfrm>
+            <a:off x="10387584" y="4279392"/>
+            <a:ext cx="1197864" cy="438912"/>
+          </a:xfrm>
+          <a:prstGeom prst="roundRect">
+            <a:avLst/>
+          </a:prstGeom>
+          <a:solidFill>
+            <a:srgbClr val="FFFFFF"/>
+          </a:solidFill>
+          <a:ln w="9525">
+            <a:solidFill>
+              <a:srgbClr val="CDBFF0"/>
+            </a:solidFill>
+          </a:ln>
+          <a:effectLst/>
+        </p:spPr>
+        <p:style>
+          <a:lnRef idx="1">
+            <a:schemeClr val="accent1"/>
+          </a:lnRef>
+          <a:fillRef idx="3">
+            <a:schemeClr val="accent1"/>
+          </a:fillRef>
+          <a:effectRef idx="2">
+            <a:schemeClr val="accent1"/>
+          </a:effectRef>
+          <a:fontRef idx="minor">
+            <a:schemeClr val="lt1"/>
+          </a:fontRef>
+        </p:style>
+        <p:txBody>
+          <a:bodyPr rtlCol="0" anchor="ctr" wrap="square" lIns="36576" rIns="36576" tIns="9144" bIns="9144"/>
+          <a:lstStyle/>
+          <a:p>
+            <a:pPr algn="ctr">
+              <a:lnSpc>
+                <a:spcPct val="100000"/>
+              </a:lnSpc>
+              <a:spcBef>
+                <a:spcPts val="0"/>
+              </a:spcBef>
+              <a:spcAft>
+                <a:spcPts val="0"/>
+              </a:spcAft>
+            </a:pPr>
+            <a:r>
+              <a:rPr sz="850" b="0">
+                <a:solidFill>
+                  <a:srgbClr val="1A1D21"/>
+                </a:solidFill>
+                <a:latin typeface="맑은 고딕"/>
+              </a:rPr>
+              <a:t>⑦⑧승인·감사</a:t>
+            </a:r>
+          </a:p>
+        </p:txBody>
+      </p:sp>
+      <p:sp>
+        <p:nvSpPr>
+          <p:cNvPr id="38" name="Rounded Rectangle 37"/>
+          <p:cNvSpPr/>
+          <p:nvPr/>
+        </p:nvSpPr>
+        <p:spPr>
+          <a:xfrm>
+            <a:off x="2706624" y="4800600"/>
+            <a:ext cx="4754880" cy="420624"/>
+          </a:xfrm>
+          <a:prstGeom prst="roundRect">
+            <a:avLst/>
+          </a:prstGeom>
+          <a:solidFill>
+            <a:srgbClr val="F7F4FF"/>
+          </a:solidFill>
+          <a:ln w="9525">
+            <a:solidFill>
+              <a:srgbClr val="CDBFF0"/>
+            </a:solidFill>
+          </a:ln>
+          <a:effectLst/>
+        </p:spPr>
+        <p:style>
+          <a:lnRef idx="1">
+            <a:schemeClr val="accent1"/>
+          </a:lnRef>
+          <a:fillRef idx="3">
+            <a:schemeClr val="accent1"/>
+          </a:fillRef>
+          <a:effectRef idx="2">
+            <a:schemeClr val="accent1"/>
+          </a:effectRef>
+          <a:fontRef idx="minor">
+            <a:schemeClr val="lt1"/>
+          </a:fontRef>
+        </p:style>
+        <p:txBody>
+          <a:bodyPr rtlCol="0" anchor="ctr" wrap="square" lIns="109728" rIns="109728" tIns="9144" bIns="9144"/>
+          <a:lstStyle/>
+          <a:p>
+            <a:pPr algn="l">
+              <a:lnSpc>
+                <a:spcPct val="100000"/>
+              </a:lnSpc>
+              <a:spcBef>
+                <a:spcPts val="0"/>
+              </a:spcBef>
+              <a:spcAft>
+                <a:spcPts val="0"/>
+              </a:spcAft>
+            </a:pPr>
+            <a:r>
+              <a:rPr sz="950" b="1">
+                <a:solidFill>
+                  <a:srgbClr val="5B3BBF"/>
+                </a:solidFill>
+                <a:latin typeface="맑은 고딕"/>
+              </a:rPr>
+              <a:t>★준법 오토파일럿</a:t>
+            </a:r>
+            <a:r>
+              <a:rPr sz="850" b="0">
+                <a:solidFill>
+                  <a:srgbClr val="5B6470"/>
+                </a:solidFill>
+                <a:latin typeface="맑은 고딕"/>
+              </a:rPr>
+              <a:t> — 판단→고쳐쓰기→재심의 자율 루프(통과까지)</a:t>
+            </a:r>
+          </a:p>
+        </p:txBody>
+      </p:sp>
+      <p:sp>
+        <p:nvSpPr>
+          <p:cNvPr id="39" name="Rounded Rectangle 38"/>
+          <p:cNvSpPr/>
+          <p:nvPr/>
+        </p:nvSpPr>
+        <p:spPr>
+          <a:xfrm>
+            <a:off x="7589520" y="4800600"/>
+            <a:ext cx="1920240" cy="420624"/>
+          </a:xfrm>
+          <a:prstGeom prst="roundRect">
+            <a:avLst/>
+          </a:prstGeom>
+          <a:solidFill>
+            <a:srgbClr val="E7ECF5"/>
+          </a:solidFill>
+          <a:ln w="9525">
+            <a:solidFill>
+              <a:srgbClr val="BCD6F2"/>
+            </a:solidFill>
+          </a:ln>
+          <a:effectLst/>
+        </p:spPr>
+        <p:style>
+          <a:lnRef idx="1">
+            <a:schemeClr val="accent1"/>
+          </a:lnRef>
+          <a:fillRef idx="3">
+            <a:schemeClr val="accent1"/>
+          </a:fillRef>
+          <a:effectRef idx="2">
+            <a:schemeClr val="accent1"/>
+          </a:effectRef>
+          <a:fontRef idx="minor">
+            <a:schemeClr val="lt1"/>
+          </a:fontRef>
+        </p:style>
+        <p:txBody>
+          <a:bodyPr rtlCol="0" anchor="ctr" wrap="square" lIns="45720" rIns="45720" tIns="9144" bIns="9144"/>
+          <a:lstStyle/>
+          <a:p>
+            <a:pPr algn="ctr">
+              <a:lnSpc>
+                <a:spcPct val="100000"/>
+              </a:lnSpc>
+              <a:spcBef>
+                <a:spcPts val="0"/>
+              </a:spcBef>
+              <a:spcAft>
+                <a:spcPts val="0"/>
+              </a:spcAft>
+            </a:pPr>
+            <a:r>
+              <a:rPr sz="900" b="1">
+                <a:solidFill>
+                  <a:srgbClr val="003A6E"/>
+                </a:solidFill>
+                <a:latin typeface="맑은 고딕"/>
+              </a:rPr>
+              <a:t>🤖 Ollama · Qwen2.5-7B</a:t>
+            </a:r>
+          </a:p>
+          <a:p>
+            <a:pPr algn="ctr">
+              <a:lnSpc>
+                <a:spcPct val="100000"/>
+              </a:lnSpc>
+              <a:spcBef>
+                <a:spcPts val="0"/>
+              </a:spcBef>
+              <a:spcAft>
+                <a:spcPts val="0"/>
+              </a:spcAft>
+            </a:pPr>
+            <a:r>
+              <a:rPr sz="800" b="0">
+                <a:solidFill>
+                  <a:srgbClr val="5B6470"/>
+                </a:solidFill>
+                <a:latin typeface="맑은 고딕"/>
+              </a:rPr>
+              <a:t>LLM 추론</a:t>
+            </a:r>
+          </a:p>
+        </p:txBody>
+      </p:sp>
+      <p:sp>
+        <p:nvSpPr>
+          <p:cNvPr id="40" name="Rounded Rectangle 39"/>
+          <p:cNvSpPr/>
+          <p:nvPr/>
+        </p:nvSpPr>
+        <p:spPr>
+          <a:xfrm>
+            <a:off x="9601200" y="4800600"/>
+            <a:ext cx="1984248" cy="420624"/>
+          </a:xfrm>
+          <a:prstGeom prst="roundRect">
+            <a:avLst/>
+          </a:prstGeom>
+          <a:solidFill>
+            <a:srgbClr val="E7ECF5"/>
+          </a:solidFill>
+          <a:ln w="9525">
+            <a:solidFill>
+              <a:srgbClr val="BCD6F2"/>
+            </a:solidFill>
+          </a:ln>
+          <a:effectLst/>
+        </p:spPr>
+        <p:style>
+          <a:lnRef idx="1">
+            <a:schemeClr val="accent1"/>
+          </a:lnRef>
+          <a:fillRef idx="3">
+            <a:schemeClr val="accent1"/>
+          </a:fillRef>
+          <a:effectRef idx="2">
+            <a:schemeClr val="accent1"/>
+          </a:effectRef>
+          <a:fontRef idx="minor">
+            <a:schemeClr val="lt1"/>
+          </a:fontRef>
+        </p:style>
+        <p:txBody>
+          <a:bodyPr rtlCol="0" anchor="ctr" wrap="square" lIns="45720" rIns="45720" tIns="9144" bIns="9144"/>
+          <a:lstStyle/>
+          <a:p>
+            <a:pPr algn="ctr">
+              <a:lnSpc>
+                <a:spcPct val="100000"/>
+              </a:lnSpc>
+              <a:spcBef>
+                <a:spcPts val="0"/>
+              </a:spcBef>
+              <a:spcAft>
+                <a:spcPts val="0"/>
+              </a:spcAft>
+            </a:pPr>
+            <a:r>
+              <a:rPr sz="900" b="1">
+                <a:solidFill>
+                  <a:srgbClr val="003A6E"/>
+                </a:solidFill>
+                <a:latin typeface="맑은 고딕"/>
+              </a:rPr>
+              <a:t>🔎 BGE-m3 임베딩</a:t>
+            </a:r>
+          </a:p>
+          <a:p>
+            <a:pPr algn="ctr">
+              <a:lnSpc>
+                <a:spcPct val="100000"/>
+              </a:lnSpc>
+              <a:spcBef>
+                <a:spcPts val="0"/>
+              </a:spcBef>
+              <a:spcAft>
+                <a:spcPts val="0"/>
+              </a:spcAft>
+            </a:pPr>
+            <a:r>
+              <a:rPr sz="800" b="0">
+                <a:solidFill>
+                  <a:srgbClr val="5B6470"/>
+                </a:solidFill>
+                <a:latin typeface="맑은 고딕"/>
+              </a:rPr>
+              <a:t>RAG (선택)</a:t>
+            </a:r>
+          </a:p>
+        </p:txBody>
+      </p:sp>
+      <p:sp>
+        <p:nvSpPr>
+          <p:cNvPr id="41" name="Down Arrow 40"/>
+          <p:cNvSpPr/>
+          <p:nvPr/>
+        </p:nvSpPr>
+        <p:spPr>
+          <a:xfrm>
+            <a:off x="7022592" y="5321808"/>
+            <a:ext cx="219456" cy="146304"/>
+          </a:xfrm>
+          <a:prstGeom prst="downArrow">
+            <a:avLst/>
+          </a:prstGeom>
+          <a:solidFill>
+            <a:srgbClr val="AAB4C0"/>
           </a:solidFill>
           <a:ln>
             <a:noFill/>
@@ -4719,7 +5506,33 @@
           </a:fontRef>
         </p:style>
         <p:txBody>
-          <a:bodyPr rtlCol="0" anchor="ctr" wrap="square" lIns="164592" rIns="164592" tIns="18288" bIns="18288"/>
+          <a:bodyPr rtlCol="0" anchor="ctr"/>
+          <a:lstStyle/>
+          <a:p>
+            <a:pPr algn="ctr"/>
+          </a:p>
+        </p:txBody>
+      </p:sp>
+      <p:sp>
+        <p:nvSpPr>
+          <p:cNvPr id="42" name="TextBox 41"/>
+          <p:cNvSpPr txBox="1"/>
+          <p:nvPr/>
+        </p:nvSpPr>
+        <p:spPr>
+          <a:xfrm>
+            <a:off x="7315200" y="5303520"/>
+            <a:ext cx="2743200" cy="146304"/>
+          </a:xfrm>
+          <a:prstGeom prst="rect">
+            <a:avLst/>
+          </a:prstGeom>
+          <a:noFill/>
+        </p:spPr>
+        <p:txBody>
+          <a:bodyPr wrap="square" anchor="ctr" lIns="0" rIns="0" tIns="9144" bIns="9144">
+            <a:spAutoFit/>
+          </a:bodyPr>
           <a:lstStyle/>
           <a:p>
             <a:pPr algn="l">
@@ -4730,46 +5543,100 @@
                 <a:spcPts val="0"/>
               </a:spcBef>
               <a:spcAft>
-                <a:spcPts val="100"/>
+                <a:spcPts val="0"/>
               </a:spcAft>
             </a:pPr>
             <a:r>
-              <a:rPr sz="1350" b="1">
-                <a:solidFill>
-                  <a:srgbClr val="003A6E"/>
+              <a:rPr sz="850" b="0">
+                <a:solidFill>
+                  <a:srgbClr val="5B6470"/>
                 </a:solidFill>
                 <a:latin typeface="맑은 고딕"/>
               </a:rPr>
-              <a:t>🌐  외부망</a:t>
-            </a:r>
-            <a:r>
-              <a:rPr sz="1000" b="1">
-                <a:solidFill>
-                  <a:srgbClr val="5B6470"/>
-                </a:solidFill>
-                <a:latin typeface="맑은 고딕"/>
-              </a:rPr>
-              <a:t>   [어댑터 교체]</a:t>
-            </a:r>
-          </a:p>
-        </p:txBody>
-      </p:sp>
-      <p:sp>
-        <p:nvSpPr>
-          <p:cNvPr id="29" name="Rounded Rectangle 28"/>
+              <a:t>조회 · 기록</a:t>
+            </a:r>
+          </a:p>
+        </p:txBody>
+      </p:sp>
+      <p:sp>
+        <p:nvSpPr>
+          <p:cNvPr id="43" name="Rounded Rectangle 42"/>
           <p:cNvSpPr/>
           <p:nvPr/>
         </p:nvSpPr>
         <p:spPr>
           <a:xfrm>
-            <a:off x="8961120" y="1965960"/>
-            <a:ext cx="2633472" cy="713232"/>
+            <a:off x="457200" y="5486400"/>
+            <a:ext cx="1965960" cy="859536"/>
           </a:xfrm>
           <a:prstGeom prst="roundRect">
             <a:avLst/>
           </a:prstGeom>
           <a:solidFill>
-            <a:srgbClr val="F7F9FC"/>
+            <a:srgbClr val="003A6E"/>
+          </a:solidFill>
+          <a:ln>
+            <a:noFill/>
+          </a:ln>
+          <a:effectLst/>
+        </p:spPr>
+        <p:style>
+          <a:lnRef idx="1">
+            <a:schemeClr val="accent1"/>
+          </a:lnRef>
+          <a:fillRef idx="3">
+            <a:schemeClr val="accent1"/>
+          </a:fillRef>
+          <a:effectRef idx="2">
+            <a:schemeClr val="accent1"/>
+          </a:effectRef>
+          <a:fontRef idx="minor">
+            <a:schemeClr val="lt1"/>
+          </a:fontRef>
+        </p:style>
+        <p:txBody>
+          <a:bodyPr rtlCol="0" anchor="ctr" wrap="square" lIns="64008" rIns="64008" tIns="9144" bIns="9144"/>
+          <a:lstStyle/>
+          <a:p>
+            <a:pPr algn="ctr">
+              <a:lnSpc>
+                <a:spcPct val="100000"/>
+              </a:lnSpc>
+              <a:spcBef>
+                <a:spcPts val="0"/>
+              </a:spcBef>
+              <a:spcAft>
+                <a:spcPts val="0"/>
+              </a:spcAft>
+            </a:pPr>
+            <a:r>
+              <a:rPr sz="1250" b="1">
+                <a:solidFill>
+                  <a:srgbClr val="FFFFFF"/>
+                </a:solidFill>
+                <a:latin typeface="맑은 고딕"/>
+              </a:rPr>
+              <a:t>🗄 DB/외부연동</a:t>
+            </a:r>
+          </a:p>
+        </p:txBody>
+      </p:sp>
+      <p:sp>
+        <p:nvSpPr>
+          <p:cNvPr id="44" name="Rounded Rectangle 43"/>
+          <p:cNvSpPr/>
+          <p:nvPr/>
+        </p:nvSpPr>
+        <p:spPr>
+          <a:xfrm>
+            <a:off x="2560320" y="5486400"/>
+            <a:ext cx="4480560" cy="384048"/>
+          </a:xfrm>
+          <a:prstGeom prst="roundRect">
+            <a:avLst/>
+          </a:prstGeom>
+          <a:solidFill>
+            <a:srgbClr val="EEF2F8"/>
           </a:solidFill>
           <a:ln w="9525">
             <a:solidFill>
@@ -4793,7 +5660,7 @@
           </a:fontRef>
         </p:style>
         <p:txBody>
-          <a:bodyPr rtlCol="0" anchor="ctr" wrap="square" lIns="128016" rIns="128016" tIns="18288" bIns="18288"/>
+          <a:bodyPr rtlCol="0" anchor="ctr" wrap="square" lIns="109728" rIns="109728" tIns="9144" bIns="9144"/>
           <a:lstStyle/>
           <a:p>
             <a:pPr algn="l">
@@ -4804,19 +5671,71 @@
                 <a:spcPts val="0"/>
               </a:spcBef>
               <a:spcAft>
-                <a:spcPts val="100"/>
+                <a:spcPts val="0"/>
               </a:spcAft>
             </a:pPr>
             <a:r>
-              <a:rPr sz="1100" b="1">
+              <a:rPr sz="950" b="1">
                 <a:solidFill>
                   <a:srgbClr val="1A1D21"/>
                 </a:solidFill>
                 <a:latin typeface="맑은 고딕"/>
               </a:rPr>
-              <a:t>법제처 OpenAPI</a:t>
-            </a:r>
-          </a:p>
+              <a:t>SQLite (store.py)</a:t>
+            </a:r>
+            <a:r>
+              <a:rPr sz="850" b="0">
+                <a:solidFill>
+                  <a:srgbClr val="5B6470"/>
+                </a:solidFill>
+                <a:latin typeface="맑은 고딕"/>
+              </a:rPr>
+              <a:t>  승인·감사로그·내규·배포 로그</a:t>
+            </a:r>
+          </a:p>
+        </p:txBody>
+      </p:sp>
+      <p:sp>
+        <p:nvSpPr>
+          <p:cNvPr id="45" name="Rounded Rectangle 44"/>
+          <p:cNvSpPr/>
+          <p:nvPr/>
+        </p:nvSpPr>
+        <p:spPr>
+          <a:xfrm>
+            <a:off x="7178040" y="5486400"/>
+            <a:ext cx="4553712" cy="384048"/>
+          </a:xfrm>
+          <a:prstGeom prst="roundRect">
+            <a:avLst/>
+          </a:prstGeom>
+          <a:solidFill>
+            <a:srgbClr val="EEF2F8"/>
+          </a:solidFill>
+          <a:ln w="9525">
+            <a:solidFill>
+              <a:srgbClr val="D8DEE6"/>
+            </a:solidFill>
+          </a:ln>
+          <a:effectLst/>
+        </p:spPr>
+        <p:style>
+          <a:lnRef idx="1">
+            <a:schemeClr val="accent1"/>
+          </a:lnRef>
+          <a:fillRef idx="3">
+            <a:schemeClr val="accent1"/>
+          </a:fillRef>
+          <a:effectRef idx="2">
+            <a:schemeClr val="accent1"/>
+          </a:effectRef>
+          <a:fontRef idx="minor">
+            <a:schemeClr val="lt1"/>
+          </a:fontRef>
+        </p:style>
+        <p:txBody>
+          <a:bodyPr rtlCol="0" anchor="ctr" wrap="square" lIns="109728" rIns="109728" tIns="9144" bIns="9144"/>
+          <a:lstStyle/>
           <a:p>
             <a:pPr algn="l">
               <a:lnSpc>
@@ -4826,31 +5745,114 @@
                 <a:spcPts val="0"/>
               </a:spcBef>
               <a:spcAft>
-                <a:spcPts val="100"/>
+                <a:spcPts val="0"/>
               </a:spcAft>
             </a:pPr>
             <a:r>
-              <a:rPr sz="900" b="0">
-                <a:solidFill>
-                  <a:srgbClr val="5B6470"/>
+              <a:rPr sz="950" b="1">
+                <a:solidFill>
+                  <a:srgbClr val="1A1D21"/>
                 </a:solidFill>
                 <a:latin typeface="맑은 고딕"/>
               </a:rPr>
-              <a:t>규제 변경 · 개정 피드</a:t>
-            </a:r>
-          </a:p>
-        </p:txBody>
-      </p:sp>
-      <p:sp>
-        <p:nvSpPr>
-          <p:cNvPr id="30" name="Rounded Rectangle 29"/>
+              <a:t>규제 지식베이스</a:t>
+            </a:r>
+            <a:r>
+              <a:rPr sz="850" b="0">
+                <a:solidFill>
+                  <a:srgbClr val="5B6470"/>
+                </a:solidFill>
+                <a:latin typeface="맑은 고딕"/>
+              </a:rPr>
+              <a:t>  regulations.json · rules.yaml</a:t>
+            </a:r>
+          </a:p>
+        </p:txBody>
+      </p:sp>
+      <p:sp>
+        <p:nvSpPr>
+          <p:cNvPr id="46" name="Rounded Rectangle 45"/>
           <p:cNvSpPr/>
           <p:nvPr/>
         </p:nvSpPr>
         <p:spPr>
           <a:xfrm>
-            <a:off x="11064240" y="2185416"/>
-            <a:ext cx="457200" cy="274320"/>
+            <a:off x="2560320" y="5925312"/>
+            <a:ext cx="2959608" cy="384048"/>
+          </a:xfrm>
+          <a:prstGeom prst="roundRect">
+            <a:avLst/>
+          </a:prstGeom>
+          <a:solidFill>
+            <a:srgbClr val="FFF7E6"/>
+          </a:solidFill>
+          <a:ln w="9525">
+            <a:solidFill>
+              <a:srgbClr val="F0D99A"/>
+            </a:solidFill>
+          </a:ln>
+          <a:effectLst/>
+        </p:spPr>
+        <p:style>
+          <a:lnRef idx="1">
+            <a:schemeClr val="accent1"/>
+          </a:lnRef>
+          <a:fillRef idx="3">
+            <a:schemeClr val="accent1"/>
+          </a:fillRef>
+          <a:effectRef idx="2">
+            <a:schemeClr val="accent1"/>
+          </a:effectRef>
+          <a:fontRef idx="minor">
+            <a:schemeClr val="lt1"/>
+          </a:fontRef>
+        </p:style>
+        <p:txBody>
+          <a:bodyPr rtlCol="0" anchor="ctr" wrap="square" tIns="9144" bIns="9144"/>
+          <a:lstStyle/>
+          <a:p>
+            <a:pPr algn="l">
+              <a:lnSpc>
+                <a:spcPct val="100000"/>
+              </a:lnSpc>
+              <a:spcBef>
+                <a:spcPts val="0"/>
+              </a:spcBef>
+              <a:spcAft>
+                <a:spcPts val="0"/>
+              </a:spcAft>
+            </a:pPr>
+            <a:r>
+              <a:rPr sz="900" b="1">
+                <a:solidFill>
+                  <a:srgbClr val="003A6E"/>
+                </a:solidFill>
+                <a:latin typeface="맑은 고딕"/>
+              </a:rPr>
+              <a:t>🔌 법제처 OpenAPI</a:t>
+            </a:r>
+            <a:r>
+              <a:rPr sz="800" b="0">
+                <a:solidFill>
+                  <a:srgbClr val="5B6470"/>
+                </a:solidFill>
+                <a:latin typeface="맑은 고딕"/>
+              </a:rPr>
+              <a:t>  규제 피드</a:t>
+            </a:r>
+          </a:p>
+        </p:txBody>
+      </p:sp>
+      <p:sp>
+        <p:nvSpPr>
+          <p:cNvPr id="47" name="Rounded Rectangle 46"/>
+          <p:cNvSpPr/>
+          <p:nvPr/>
+        </p:nvSpPr>
+        <p:spPr>
+          <a:xfrm>
+            <a:off x="5062728" y="5989320"/>
+            <a:ext cx="384048" cy="256032"/>
           </a:xfrm>
           <a:prstGeom prst="roundRect">
             <a:avLst/>
@@ -4878,7 +5880,7 @@
           </a:fontRef>
         </p:style>
         <p:txBody>
-          <a:bodyPr rtlCol="0" anchor="ctr" wrap="square" lIns="54864" rIns="54864" tIns="18288" bIns="18288"/>
+          <a:bodyPr rtlCol="0" anchor="ctr" wrap="square" lIns="18288" rIns="18288" tIns="9144" bIns="9144"/>
           <a:lstStyle/>
           <a:p>
             <a:pPr algn="ctr">
@@ -4889,11 +5891,11 @@
                 <a:spcPts val="0"/>
               </a:spcBef>
               <a:spcAft>
-                <a:spcPts val="100"/>
+                <a:spcPts val="0"/>
               </a:spcAft>
             </a:pPr>
             <a:r>
-              <a:rPr sz="900" b="1">
+              <a:rPr sz="800" b="1">
                 <a:solidFill>
                   <a:srgbClr val="FFFFFF"/>
                 </a:solidFill>
@@ -4906,24 +5908,24 @@
       </p:sp>
       <p:sp>
         <p:nvSpPr>
-          <p:cNvPr id="31" name="Rounded Rectangle 30"/>
+          <p:cNvPr id="48" name="Rounded Rectangle 47"/>
           <p:cNvSpPr/>
           <p:nvPr/>
         </p:nvSpPr>
         <p:spPr>
           <a:xfrm>
-            <a:off x="8961120" y="2834640"/>
-            <a:ext cx="2633472" cy="713232"/>
+            <a:off x="5666232" y="5925312"/>
+            <a:ext cx="2959608" cy="384048"/>
           </a:xfrm>
           <a:prstGeom prst="roundRect">
             <a:avLst/>
           </a:prstGeom>
           <a:solidFill>
-            <a:srgbClr val="F7F9FC"/>
+            <a:srgbClr val="FFF7E6"/>
           </a:solidFill>
           <a:ln w="9525">
             <a:solidFill>
-              <a:srgbClr val="D8DEE6"/>
+              <a:srgbClr val="F0D99A"/>
             </a:solidFill>
           </a:ln>
           <a:effectLst/>
@@ -4943,7 +5945,7 @@
           </a:fontRef>
         </p:style>
         <p:txBody>
-          <a:bodyPr rtlCol="0" anchor="ctr" wrap="square" lIns="128016" rIns="128016" tIns="18288" bIns="18288"/>
+          <a:bodyPr rtlCol="0" anchor="ctr" wrap="square" tIns="9144" bIns="9144"/>
           <a:lstStyle/>
           <a:p>
             <a:pPr algn="l">
@@ -4954,53 +5956,40 @@
                 <a:spcPts val="0"/>
               </a:spcBef>
               <a:spcAft>
-                <a:spcPts val="100"/>
+                <a:spcPts val="0"/>
               </a:spcAft>
             </a:pPr>
             <a:r>
-              <a:rPr sz="1100" b="1">
-                <a:solidFill>
-                  <a:srgbClr val="1A1D21"/>
+              <a:rPr sz="900" b="1">
+                <a:solidFill>
+                  <a:srgbClr val="003A6E"/>
                 </a:solidFill>
                 <a:latin typeface="맑은 고딕"/>
               </a:rPr>
-              <a:t>FCM · SNS · 알림톡</a:t>
-            </a:r>
-          </a:p>
-          <a:p>
-            <a:pPr algn="l">
-              <a:lnSpc>
-                <a:spcPct val="100000"/>
-              </a:lnSpc>
-              <a:spcBef>
-                <a:spcPts val="0"/>
-              </a:spcBef>
-              <a:spcAft>
-                <a:spcPts val="100"/>
-              </a:spcAft>
-            </a:pPr>
-            <a:r>
-              <a:rPr sz="900" b="0">
+              <a:t>🔌 FCM·SNS·알림톡</a:t>
+            </a:r>
+            <a:r>
+              <a:rPr sz="800" b="0">
                 <a:solidFill>
                   <a:srgbClr val="5B6470"/>
                 </a:solidFill>
                 <a:latin typeface="맑은 고딕"/>
               </a:rPr>
-              <a:t>승인본 채널 발송</a:t>
-            </a:r>
-          </a:p>
-        </p:txBody>
-      </p:sp>
-      <p:sp>
-        <p:nvSpPr>
-          <p:cNvPr id="32" name="Rounded Rectangle 31"/>
+              <a:t>  승인본 발송</a:t>
+            </a:r>
+          </a:p>
+        </p:txBody>
+      </p:sp>
+      <p:sp>
+        <p:nvSpPr>
+          <p:cNvPr id="49" name="Rounded Rectangle 48"/>
           <p:cNvSpPr/>
           <p:nvPr/>
         </p:nvSpPr>
         <p:spPr>
           <a:xfrm>
-            <a:off x="11064240" y="3054096"/>
-            <a:ext cx="457200" cy="274320"/>
+            <a:off x="8168640" y="5989320"/>
+            <a:ext cx="384048" cy="256032"/>
           </a:xfrm>
           <a:prstGeom prst="roundRect">
             <a:avLst/>
@@ -5028,7 +6017,7 @@
           </a:fontRef>
         </p:style>
         <p:txBody>
-          <a:bodyPr rtlCol="0" anchor="ctr" wrap="square" lIns="54864" rIns="54864" tIns="18288" bIns="18288"/>
+          <a:bodyPr rtlCol="0" anchor="ctr" wrap="square" lIns="18288" rIns="18288" tIns="9144" bIns="9144"/>
           <a:lstStyle/>
           <a:p>
             <a:pPr algn="ctr">
@@ -5039,11 +6028,11 @@
                 <a:spcPts val="0"/>
               </a:spcBef>
               <a:spcAft>
-                <a:spcPts val="100"/>
+                <a:spcPts val="0"/>
               </a:spcAft>
             </a:pPr>
             <a:r>
-              <a:rPr sz="900" b="1">
+              <a:rPr sz="800" b="1">
                 <a:solidFill>
                   <a:srgbClr val="FFFFFF"/>
                 </a:solidFill>
@@ -5056,24 +6045,24 @@
       </p:sp>
       <p:sp>
         <p:nvSpPr>
-          <p:cNvPr id="33" name="Rounded Rectangle 32"/>
+          <p:cNvPr id="50" name="Rounded Rectangle 49"/>
           <p:cNvSpPr/>
           <p:nvPr/>
         </p:nvSpPr>
         <p:spPr>
           <a:xfrm>
-            <a:off x="8961120" y="3703320"/>
-            <a:ext cx="2633472" cy="713232"/>
+            <a:off x="8772144" y="5925312"/>
+            <a:ext cx="2959608" cy="384048"/>
           </a:xfrm>
           <a:prstGeom prst="roundRect">
             <a:avLst/>
           </a:prstGeom>
           <a:solidFill>
-            <a:srgbClr val="F7F9FC"/>
+            <a:srgbClr val="FFF7E6"/>
           </a:solidFill>
           <a:ln w="9525">
             <a:solidFill>
-              <a:srgbClr val="D8DEE6"/>
+              <a:srgbClr val="F0D99A"/>
             </a:solidFill>
           </a:ln>
           <a:effectLst/>
@@ -5093,7 +6082,7 @@
           </a:fontRef>
         </p:style>
         <p:txBody>
-          <a:bodyPr rtlCol="0" anchor="ctr" wrap="square" lIns="128016" rIns="128016" tIns="18288" bIns="18288"/>
+          <a:bodyPr rtlCol="0" anchor="ctr" wrap="square" tIns="9144" bIns="9144"/>
           <a:lstStyle/>
           <a:p>
             <a:pPr algn="l">
@@ -5104,53 +6093,40 @@
                 <a:spcPts val="0"/>
               </a:spcBef>
               <a:spcAft>
-                <a:spcPts val="100"/>
+                <a:spcPts val="0"/>
               </a:spcAft>
             </a:pPr>
             <a:r>
-              <a:rPr sz="1100" b="1">
-                <a:solidFill>
-                  <a:srgbClr val="1A1D21"/>
+              <a:rPr sz="900" b="1">
+                <a:solidFill>
+                  <a:srgbClr val="003A6E"/>
                 </a:solidFill>
                 <a:latin typeface="맑은 고딕"/>
               </a:rPr>
-              <a:t>코어뱅킹 상품 DB</a:t>
-            </a:r>
-          </a:p>
-          <a:p>
-            <a:pPr algn="l">
-              <a:lnSpc>
-                <a:spcPct val="100000"/>
-              </a:lnSpc>
-              <a:spcBef>
-                <a:spcPts val="0"/>
-              </a:spcBef>
-              <a:spcAft>
-                <a:spcPts val="100"/>
-              </a:spcAft>
-            </a:pPr>
-            <a:r>
-              <a:rPr sz="900" b="0">
+              <a:t>🔌 코어뱅킹 API</a:t>
+            </a:r>
+            <a:r>
+              <a:rPr sz="800" b="0">
                 <a:solidFill>
                   <a:srgbClr val="5B6470"/>
                 </a:solidFill>
                 <a:latin typeface="맑은 고딕"/>
               </a:rPr>
-              <a:t>상품조건 자동 주입</a:t>
-            </a:r>
-          </a:p>
-        </p:txBody>
-      </p:sp>
-      <p:sp>
-        <p:nvSpPr>
-          <p:cNvPr id="34" name="Rounded Rectangle 33"/>
+              <a:t>  상품조건</a:t>
+            </a:r>
+          </a:p>
+        </p:txBody>
+      </p:sp>
+      <p:sp>
+        <p:nvSpPr>
+          <p:cNvPr id="51" name="Rounded Rectangle 50"/>
           <p:cNvSpPr/>
           <p:nvPr/>
         </p:nvSpPr>
         <p:spPr>
           <a:xfrm>
-            <a:off x="11064240" y="3922776"/>
-            <a:ext cx="457200" cy="274320"/>
+            <a:off x="11274552" y="5989320"/>
+            <a:ext cx="384048" cy="256032"/>
           </a:xfrm>
           <a:prstGeom prst="roundRect">
             <a:avLst/>
@@ -5178,7 +6154,7 @@
           </a:fontRef>
         </p:style>
         <p:txBody>
-          <a:bodyPr rtlCol="0" anchor="ctr" wrap="square" lIns="54864" rIns="54864" tIns="18288" bIns="18288"/>
+          <a:bodyPr rtlCol="0" anchor="ctr" wrap="square" lIns="18288" rIns="18288" tIns="9144" bIns="9144"/>
           <a:lstStyle/>
           <a:p>
             <a:pPr algn="ctr">
@@ -5189,11 +6165,11 @@
                 <a:spcPts val="0"/>
               </a:spcBef>
               <a:spcAft>
-                <a:spcPts val="100"/>
+                <a:spcPts val="0"/>
               </a:spcAft>
             </a:pPr>
             <a:r>
-              <a:rPr sz="900" b="1">
+              <a:rPr sz="800" b="1">
                 <a:solidFill>
                   <a:srgbClr val="FFFFFF"/>
                 </a:solidFill>
@@ -5206,14 +6182,14 @@
       </p:sp>
       <p:sp>
         <p:nvSpPr>
-          <p:cNvPr id="35" name="TextBox 34"/>
+          <p:cNvPr id="52" name="TextBox 51"/>
           <p:cNvSpPr txBox="1"/>
           <p:nvPr/>
         </p:nvSpPr>
         <p:spPr>
           <a:xfrm>
-            <a:off x="8961120" y="4617720"/>
-            <a:ext cx="2633472" cy="914400"/>
+            <a:off x="457200" y="6473952"/>
+            <a:ext cx="11338560" cy="274320"/>
           </a:xfrm>
           <a:prstGeom prst="rect">
             <a:avLst/>
@@ -5221,7 +6197,7 @@
           <a:noFill/>
         </p:spPr>
         <p:txBody>
-          <a:bodyPr wrap="square" anchor="t" lIns="0" rIns="0" tIns="18288" bIns="18288">
+          <a:bodyPr wrap="square" anchor="t" lIns="0" rIns="0" tIns="9144" bIns="9144">
             <a:spAutoFit/>
           </a:bodyPr>
           <a:lstStyle/>
@@ -5234,7 +6210,7 @@
                 <a:spcPts val="0"/>
               </a:spcBef>
               <a:spcAft>
-                <a:spcPts val="100"/>
+                <a:spcPts val="0"/>
               </a:spcAft>
             </a:pPr>
             <a:r>
@@ -5244,140 +6220,7 @@
                 </a:solidFill>
                 <a:latin typeface="맑은 고딕"/>
               </a:rPr>
-              <a:t>운영 변동성(규제·발송·상품)을 외부망으로 분리 — 금융권 내부망/외부망 분리 원칙 준수</a:t>
-            </a:r>
-          </a:p>
-        </p:txBody>
-      </p:sp>
-      <p:sp>
-        <p:nvSpPr>
-          <p:cNvPr id="36" name="Left-Right Arrow 35"/>
-          <p:cNvSpPr/>
-          <p:nvPr/>
-        </p:nvSpPr>
-        <p:spPr>
-          <a:xfrm>
-            <a:off x="6364224" y="3520440"/>
-            <a:ext cx="237744" cy="457200"/>
-          </a:xfrm>
-          <a:prstGeom prst="leftRightArrow">
-            <a:avLst/>
-          </a:prstGeom>
-          <a:solidFill>
-            <a:srgbClr val="9AA7B4"/>
-          </a:solidFill>
-          <a:ln>
-            <a:noFill/>
-          </a:ln>
-          <a:effectLst/>
-        </p:spPr>
-        <p:style>
-          <a:lnRef idx="1">
-            <a:schemeClr val="accent1"/>
-          </a:lnRef>
-          <a:fillRef idx="3">
-            <a:schemeClr val="accent1"/>
-          </a:fillRef>
-          <a:effectRef idx="2">
-            <a:schemeClr val="accent1"/>
-          </a:effectRef>
-          <a:fontRef idx="minor">
-            <a:schemeClr val="lt1"/>
-          </a:fontRef>
-        </p:style>
-        <p:txBody>
-          <a:bodyPr rtlCol="0" anchor="ctr"/>
-          <a:lstStyle/>
-          <a:p>
-            <a:pPr algn="ctr"/>
-          </a:p>
-        </p:txBody>
-      </p:sp>
-      <p:sp>
-        <p:nvSpPr>
-          <p:cNvPr id="37" name="Left-Right Arrow 36"/>
-          <p:cNvSpPr/>
-          <p:nvPr/>
-        </p:nvSpPr>
-        <p:spPr>
-          <a:xfrm>
-            <a:off x="8558784" y="3520440"/>
-            <a:ext cx="256032" cy="457200"/>
-          </a:xfrm>
-          <a:prstGeom prst="leftRightArrow">
-            <a:avLst/>
-          </a:prstGeom>
-          <a:solidFill>
-            <a:srgbClr val="9AA7B4"/>
-          </a:solidFill>
-          <a:ln>
-            <a:noFill/>
-          </a:ln>
-          <a:effectLst/>
-        </p:spPr>
-        <p:style>
-          <a:lnRef idx="1">
-            <a:schemeClr val="accent1"/>
-          </a:lnRef>
-          <a:fillRef idx="3">
-            <a:schemeClr val="accent1"/>
-          </a:fillRef>
-          <a:effectRef idx="2">
-            <a:schemeClr val="accent1"/>
-          </a:effectRef>
-          <a:fontRef idx="minor">
-            <a:schemeClr val="lt1"/>
-          </a:fontRef>
-        </p:style>
-        <p:txBody>
-          <a:bodyPr rtlCol="0" anchor="ctr"/>
-          <a:lstStyle/>
-          <a:p>
-            <a:pPr algn="ctr"/>
-          </a:p>
-        </p:txBody>
-      </p:sp>
-      <p:sp>
-        <p:nvSpPr>
-          <p:cNvPr id="38" name="TextBox 37"/>
-          <p:cNvSpPr txBox="1"/>
-          <p:nvPr/>
-        </p:nvSpPr>
-        <p:spPr>
-          <a:xfrm>
-            <a:off x="411480" y="6400800"/>
-            <a:ext cx="11338560" cy="320040"/>
-          </a:xfrm>
-          <a:prstGeom prst="rect">
-            <a:avLst/>
-          </a:prstGeom>
-          <a:noFill/>
-        </p:spPr>
-        <p:txBody>
-          <a:bodyPr wrap="square" anchor="t" lIns="0" rIns="0" tIns="18288" bIns="18288">
-            <a:spAutoFit/>
-          </a:bodyPr>
-          <a:lstStyle/>
-          <a:p>
-            <a:pPr algn="l">
-              <a:lnSpc>
-                <a:spcPct val="100000"/>
-              </a:lnSpc>
-              <a:spcBef>
-                <a:spcPts val="0"/>
-              </a:spcBef>
-              <a:spcAft>
-                <a:spcPts val="100"/>
-              </a:spcAft>
-            </a:pPr>
-            <a:r>
-              <a:rPr sz="950" b="0">
-                <a:solidFill>
-                  <a:srgbClr val="5B6470"/>
-                </a:solidFill>
-                <a:latin typeface="맑은 고딕"/>
-              </a:rPr>
-              <a:t>JB금융그룹 Fin:AI Challenge · 지정주제2 준법자문가 AI Agent · JB 준법 코파일럿</a:t>
+              <a:t>외부 연동(법제처·발송채널·코어뱅킹)은 어댑터로 분리 — 데모는 목/피드, 운영 시 실제 API로 교체 · 전 과정 온프레미스</a:t>
             </a:r>
           </a:p>
         </p:txBody>

</xml_diff>

<commit_message>
docs: redraw architecture in diagram style (icons/cylinders/cloud + flow arrows)
일반적인 시스템 아키텍처 그림 스타일로 재구성: 사용자→프론트엔드/UI→백엔드API·AI Agent
코어→(조회·기록/연동)→DB 실린더(SQLite·규제KB)·외부연동 클라우드(법제처/FCM/코어뱅킹).
구성요소별 도형·방향 화살표·실린더·클라우드. 전부 편집 가능한 PowerPoint 도형.

Co-Authored-By: Claude Opus 4.8 (1M context) <noreply@anthropic.com>
</commit_message>
<xml_diff>
--- a/docs/submission/JB준법코파일럿_시스템아키텍처.pptx
+++ b/docs/submission/JB준법코파일럿_시스템아키텍처.pptx
@@ -3096,7 +3096,7 @@
         </p:nvSpPr>
         <p:spPr>
           <a:xfrm>
-            <a:off x="411480" y="219456"/>
+            <a:off x="411480" y="201168"/>
             <a:ext cx="10058400" cy="457200"/>
           </a:xfrm>
           <a:prstGeom prst="rect">
@@ -3141,8 +3141,8 @@
         </p:nvSpPr>
         <p:spPr>
           <a:xfrm>
-            <a:off x="429768" y="694944"/>
-            <a:ext cx="10972800" cy="292608"/>
+            <a:off x="429768" y="676656"/>
+            <a:ext cx="10972800" cy="274320"/>
           </a:xfrm>
           <a:prstGeom prst="rect">
             <a:avLst/>
@@ -3167,13 +3167,13 @@
               </a:spcAft>
             </a:pPr>
             <a:r>
-              <a:rPr sz="1150" b="0">
+              <a:rPr sz="1100" b="0">
                 <a:solidFill>
                   <a:srgbClr val="5B6470"/>
                 </a:solidFill>
                 <a:latin typeface="맑은 고딕"/>
               </a:rPr>
-              <a:t>사용자 → 프론트엔드/UI → 백엔드/API → AI Agent·모델 → DB·외부연동 (전 과정 온프레미스 · 휴먼인더루프)</a:t>
+              <a:t>사용자 · 프론트엔드 · 백엔드 API · AI Agent/모델 · DB/외부연동 — 전 과정 온프레미스 · 휴먼인더루프</a:t>
             </a:r>
           </a:p>
         </p:txBody>
@@ -3186,7 +3186,7 @@
         </p:nvSpPr>
         <p:spPr>
           <a:xfrm>
-            <a:off x="411480" y="1033271"/>
+            <a:off x="411480" y="1005840"/>
             <a:ext cx="11365992" cy="31750"/>
           </a:xfrm>
           <a:prstGeom prst="rect">
@@ -3215,7 +3215,7 @@
           </a:fontRef>
         </p:style>
         <p:txBody>
-          <a:bodyPr rtlCol="0" anchor="ctr" wrap="square" lIns="64008" rIns="64008" tIns="9144" bIns="9144"/>
+          <a:bodyPr rtlCol="0" anchor="ctr"/>
           <a:lstStyle/>
           <a:p>
             <a:pPr algn="ctr"/>
@@ -3230,14 +3230,323 @@
         </p:nvSpPr>
         <p:spPr>
           <a:xfrm>
-            <a:off x="457200" y="1207008"/>
-            <a:ext cx="1965960" cy="658368"/>
+            <a:off x="411480" y="1600200"/>
+            <a:ext cx="1874519" cy="2194560"/>
           </a:xfrm>
           <a:prstGeom prst="roundRect">
             <a:avLst/>
           </a:prstGeom>
           <a:solidFill>
-            <a:srgbClr val="5B6470"/>
+            <a:srgbClr val="F4F6F8"/>
+          </a:solidFill>
+          <a:ln w="15875">
+            <a:solidFill>
+              <a:srgbClr val="5B6470"/>
+            </a:solidFill>
+          </a:ln>
+          <a:effectLst/>
+        </p:spPr>
+        <p:style>
+          <a:lnRef idx="1">
+            <a:schemeClr val="accent1"/>
+          </a:lnRef>
+          <a:fillRef idx="3">
+            <a:schemeClr val="accent1"/>
+          </a:fillRef>
+          <a:effectRef idx="2">
+            <a:schemeClr val="accent1"/>
+          </a:effectRef>
+          <a:fontRef idx="minor">
+            <a:schemeClr val="lt1"/>
+          </a:fontRef>
+        </p:style>
+        <p:txBody>
+          <a:bodyPr rtlCol="0" anchor="ctr"/>
+          <a:lstStyle/>
+          <a:p>
+            <a:pPr algn="ctr"/>
+          </a:p>
+        </p:txBody>
+      </p:sp>
+      <p:sp>
+        <p:nvSpPr>
+          <p:cNvPr id="6" name="TextBox 5"/>
+          <p:cNvSpPr txBox="1"/>
+          <p:nvPr/>
+        </p:nvSpPr>
+        <p:spPr>
+          <a:xfrm>
+            <a:off x="411480" y="1691640"/>
+            <a:ext cx="1874519" cy="274320"/>
+          </a:xfrm>
+          <a:prstGeom prst="rect">
+            <a:avLst/>
+          </a:prstGeom>
+          <a:noFill/>
+        </p:spPr>
+        <p:txBody>
+          <a:bodyPr wrap="square" anchor="t" lIns="0" rIns="0" tIns="9144" bIns="9144">
+            <a:spAutoFit/>
+          </a:bodyPr>
+          <a:lstStyle/>
+          <a:p>
+            <a:pPr algn="ctr">
+              <a:lnSpc>
+                <a:spcPct val="100000"/>
+              </a:lnSpc>
+              <a:spcBef>
+                <a:spcPts val="0"/>
+              </a:spcBef>
+              <a:spcAft>
+                <a:spcPts val="0"/>
+              </a:spcAft>
+            </a:pPr>
+            <a:r>
+              <a:rPr sz="1250" b="1">
+                <a:solidFill>
+                  <a:srgbClr val="5B6470"/>
+                </a:solidFill>
+                <a:latin typeface="맑은 고딕"/>
+              </a:rPr>
+              <a:t>👤 사용자</a:t>
+            </a:r>
+          </a:p>
+        </p:txBody>
+      </p:sp>
+      <p:sp>
+        <p:nvSpPr>
+          <p:cNvPr id="7" name="Rounded Rectangle 6"/>
+          <p:cNvSpPr/>
+          <p:nvPr/>
+        </p:nvSpPr>
+        <p:spPr>
+          <a:xfrm>
+            <a:off x="548640" y="2057400"/>
+            <a:ext cx="1600199" cy="749808"/>
+          </a:xfrm>
+          <a:prstGeom prst="roundRect">
+            <a:avLst/>
+          </a:prstGeom>
+          <a:solidFill>
+            <a:srgbClr val="FFFFFF"/>
+          </a:solidFill>
+          <a:ln w="9525">
+            <a:solidFill>
+              <a:srgbClr val="CDD5DE"/>
+            </a:solidFill>
+          </a:ln>
+          <a:effectLst/>
+        </p:spPr>
+        <p:style>
+          <a:lnRef idx="1">
+            <a:schemeClr val="accent1"/>
+          </a:lnRef>
+          <a:fillRef idx="3">
+            <a:schemeClr val="accent1"/>
+          </a:fillRef>
+          <a:effectRef idx="2">
+            <a:schemeClr val="accent1"/>
+          </a:effectRef>
+          <a:fontRef idx="minor">
+            <a:schemeClr val="lt1"/>
+          </a:fontRef>
+        </p:style>
+        <p:txBody>
+          <a:bodyPr rtlCol="0" anchor="ctr" wrap="square" lIns="73152" rIns="73152" tIns="9144" bIns="9144"/>
+          <a:lstStyle/>
+          <a:p>
+            <a:pPr algn="ctr">
+              <a:lnSpc>
+                <a:spcPct val="100000"/>
+              </a:lnSpc>
+              <a:spcBef>
+                <a:spcPts val="0"/>
+              </a:spcBef>
+              <a:spcAft>
+                <a:spcPts val="0"/>
+              </a:spcAft>
+            </a:pPr>
+            <a:r>
+              <a:rPr sz="1000" b="1">
+                <a:solidFill>
+                  <a:srgbClr val="1A1D21"/>
+                </a:solidFill>
+                <a:latin typeface="맑은 고딕"/>
+              </a:rPr>
+              <a:t>마케팅·지점 담당자</a:t>
+            </a:r>
+          </a:p>
+          <a:p>
+            <a:pPr algn="ctr">
+              <a:lnSpc>
+                <a:spcPct val="100000"/>
+              </a:lnSpc>
+              <a:spcBef>
+                <a:spcPts val="0"/>
+              </a:spcBef>
+              <a:spcAft>
+                <a:spcPts val="0"/>
+              </a:spcAft>
+            </a:pPr>
+            <a:r>
+              <a:rPr sz="850" b="0">
+                <a:solidFill>
+                  <a:srgbClr val="5B6470"/>
+                </a:solidFill>
+                <a:latin typeface="맑은 고딕"/>
+              </a:rPr>
+              <a:t>금융 콘텐츠</a:t>
+            </a:r>
+          </a:p>
+          <a:p>
+            <a:pPr algn="ctr">
+              <a:lnSpc>
+                <a:spcPct val="100000"/>
+              </a:lnSpc>
+              <a:spcBef>
+                <a:spcPts val="0"/>
+              </a:spcBef>
+              <a:spcAft>
+                <a:spcPts val="0"/>
+              </a:spcAft>
+            </a:pPr>
+            <a:r>
+              <a:rPr sz="850" b="0">
+                <a:solidFill>
+                  <a:srgbClr val="5B6470"/>
+                </a:solidFill>
+                <a:latin typeface="맑은 고딕"/>
+              </a:rPr>
+              <a:t>초안 작성(실시간)</a:t>
+            </a:r>
+          </a:p>
+        </p:txBody>
+      </p:sp>
+      <p:sp>
+        <p:nvSpPr>
+          <p:cNvPr id="8" name="Rounded Rectangle 7"/>
+          <p:cNvSpPr/>
+          <p:nvPr/>
+        </p:nvSpPr>
+        <p:spPr>
+          <a:xfrm>
+            <a:off x="548640" y="2898648"/>
+            <a:ext cx="1600199" cy="749808"/>
+          </a:xfrm>
+          <a:prstGeom prst="roundRect">
+            <a:avLst/>
+          </a:prstGeom>
+          <a:solidFill>
+            <a:srgbClr val="FFFFFF"/>
+          </a:solidFill>
+          <a:ln w="9525">
+            <a:solidFill>
+              <a:srgbClr val="CDD5DE"/>
+            </a:solidFill>
+          </a:ln>
+          <a:effectLst/>
+        </p:spPr>
+        <p:style>
+          <a:lnRef idx="1">
+            <a:schemeClr val="accent1"/>
+          </a:lnRef>
+          <a:fillRef idx="3">
+            <a:schemeClr val="accent1"/>
+          </a:fillRef>
+          <a:effectRef idx="2">
+            <a:schemeClr val="accent1"/>
+          </a:effectRef>
+          <a:fontRef idx="minor">
+            <a:schemeClr val="lt1"/>
+          </a:fontRef>
+        </p:style>
+        <p:txBody>
+          <a:bodyPr rtlCol="0" anchor="ctr" wrap="square" lIns="73152" rIns="73152" tIns="9144" bIns="9144"/>
+          <a:lstStyle/>
+          <a:p>
+            <a:pPr algn="ctr">
+              <a:lnSpc>
+                <a:spcPct val="100000"/>
+              </a:lnSpc>
+              <a:spcBef>
+                <a:spcPts val="0"/>
+              </a:spcBef>
+              <a:spcAft>
+                <a:spcPts val="0"/>
+              </a:spcAft>
+            </a:pPr>
+            <a:r>
+              <a:rPr sz="1000" b="1">
+                <a:solidFill>
+                  <a:srgbClr val="1A1D21"/>
+                </a:solidFill>
+                <a:latin typeface="맑은 고딕"/>
+              </a:rPr>
+              <a:t>준법관리자</a:t>
+            </a:r>
+          </a:p>
+          <a:p>
+            <a:pPr algn="ctr">
+              <a:lnSpc>
+                <a:spcPct val="100000"/>
+              </a:lnSpc>
+              <a:spcBef>
+                <a:spcPts val="0"/>
+              </a:spcBef>
+              <a:spcAft>
+                <a:spcPts val="0"/>
+              </a:spcAft>
+            </a:pPr>
+            <a:r>
+              <a:rPr sz="850" b="0">
+                <a:solidFill>
+                  <a:srgbClr val="5B6470"/>
+                </a:solidFill>
+                <a:latin typeface="맑은 고딕"/>
+              </a:rPr>
+              <a:t>준법감시부</a:t>
+            </a:r>
+          </a:p>
+          <a:p>
+            <a:pPr algn="ctr">
+              <a:lnSpc>
+                <a:spcPct val="100000"/>
+              </a:lnSpc>
+              <a:spcBef>
+                <a:spcPts val="0"/>
+              </a:spcBef>
+              <a:spcAft>
+                <a:spcPts val="0"/>
+              </a:spcAft>
+            </a:pPr>
+            <a:r>
+              <a:rPr sz="850" b="0">
+                <a:solidFill>
+                  <a:srgbClr val="5B6470"/>
+                </a:solidFill>
+                <a:latin typeface="맑은 고딕"/>
+              </a:rPr>
+              <a:t>검토·승인(HITL)</a:t>
+            </a:r>
+          </a:p>
+        </p:txBody>
+      </p:sp>
+      <p:sp>
+        <p:nvSpPr>
+          <p:cNvPr id="9" name="Right Arrow 8"/>
+          <p:cNvSpPr/>
+          <p:nvPr/>
+        </p:nvSpPr>
+        <p:spPr>
+          <a:xfrm>
+            <a:off x="2377440" y="2514600"/>
+            <a:ext cx="411480" cy="365760"/>
+          </a:xfrm>
+          <a:prstGeom prst="rightArrow">
+            <a:avLst/>
+          </a:prstGeom>
+          <a:solidFill>
+            <a:srgbClr val="8AA0B5"/>
           </a:solidFill>
           <a:ln>
             <a:noFill/>
@@ -3259,7 +3568,79 @@
           </a:fontRef>
         </p:style>
         <p:txBody>
-          <a:bodyPr rtlCol="0" anchor="ctr" wrap="square" lIns="64008" rIns="64008" tIns="9144" bIns="9144"/>
+          <a:bodyPr rtlCol="0" anchor="ctr"/>
+          <a:lstStyle/>
+          <a:p>
+            <a:pPr algn="ctr"/>
+          </a:p>
+        </p:txBody>
+      </p:sp>
+      <p:sp>
+        <p:nvSpPr>
+          <p:cNvPr id="10" name="Rounded Rectangle 9"/>
+          <p:cNvSpPr/>
+          <p:nvPr/>
+        </p:nvSpPr>
+        <p:spPr>
+          <a:xfrm>
+            <a:off x="2880360" y="1600200"/>
+            <a:ext cx="2331720" cy="2194560"/>
+          </a:xfrm>
+          <a:prstGeom prst="roundRect">
+            <a:avLst/>
+          </a:prstGeom>
+          <a:solidFill>
+            <a:srgbClr val="EAFAF0"/>
+          </a:solidFill>
+          <a:ln w="15875">
+            <a:solidFill>
+              <a:srgbClr val="1F9D55"/>
+            </a:solidFill>
+          </a:ln>
+          <a:effectLst/>
+        </p:spPr>
+        <p:style>
+          <a:lnRef idx="1">
+            <a:schemeClr val="accent1"/>
+          </a:lnRef>
+          <a:fillRef idx="3">
+            <a:schemeClr val="accent1"/>
+          </a:fillRef>
+          <a:effectRef idx="2">
+            <a:schemeClr val="accent1"/>
+          </a:effectRef>
+          <a:fontRef idx="minor">
+            <a:schemeClr val="lt1"/>
+          </a:fontRef>
+        </p:style>
+        <p:txBody>
+          <a:bodyPr rtlCol="0" anchor="ctr"/>
+          <a:lstStyle/>
+          <a:p>
+            <a:pPr algn="ctr"/>
+          </a:p>
+        </p:txBody>
+      </p:sp>
+      <p:sp>
+        <p:nvSpPr>
+          <p:cNvPr id="11" name="TextBox 10"/>
+          <p:cNvSpPr txBox="1"/>
+          <p:nvPr/>
+        </p:nvSpPr>
+        <p:spPr>
+          <a:xfrm>
+            <a:off x="2880360" y="1691640"/>
+            <a:ext cx="2331720" cy="274320"/>
+          </a:xfrm>
+          <a:prstGeom prst="rect">
+            <a:avLst/>
+          </a:prstGeom>
+          <a:noFill/>
+        </p:spPr>
+        <p:txBody>
+          <a:bodyPr wrap="square" anchor="t" lIns="0" rIns="0" tIns="9144" bIns="9144">
+            <a:spAutoFit/>
+          </a:bodyPr>
           <a:lstStyle/>
           <a:p>
             <a:pPr algn="ctr">
@@ -3274,273 +3655,37 @@
               </a:spcAft>
             </a:pPr>
             <a:r>
-              <a:rPr sz="1250" b="1">
-                <a:solidFill>
-                  <a:srgbClr val="FFFFFF"/>
+              <a:rPr sz="1200" b="1">
+                <a:solidFill>
+                  <a:srgbClr val="1F9D55"/>
                 </a:solidFill>
                 <a:latin typeface="맑은 고딕"/>
               </a:rPr>
-              <a:t>👤 사용자</a:t>
-            </a:r>
-          </a:p>
-        </p:txBody>
-      </p:sp>
-      <p:sp>
-        <p:nvSpPr>
-          <p:cNvPr id="6" name="Rounded Rectangle 5"/>
-          <p:cNvSpPr/>
+              <a:t>🖥 프론트엔드 / UI</a:t>
+            </a:r>
+          </a:p>
+        </p:txBody>
+      </p:sp>
+      <p:sp>
+        <p:nvSpPr>
+          <p:cNvPr id="12" name="TextBox 11"/>
+          <p:cNvSpPr txBox="1"/>
           <p:nvPr/>
         </p:nvSpPr>
         <p:spPr>
           <a:xfrm>
-            <a:off x="2560320" y="1207008"/>
-            <a:ext cx="4512564" cy="658368"/>
-          </a:xfrm>
-          <a:prstGeom prst="roundRect">
+            <a:off x="2880360" y="1984248"/>
+            <a:ext cx="2331720" cy="219456"/>
+          </a:xfrm>
+          <a:prstGeom prst="rect">
             <a:avLst/>
           </a:prstGeom>
-          <a:solidFill>
-            <a:srgbClr val="EEF1F5"/>
-          </a:solidFill>
-          <a:ln w="9525">
-            <a:solidFill>
-              <a:srgbClr val="D8DEE6"/>
-            </a:solidFill>
-          </a:ln>
-          <a:effectLst/>
-        </p:spPr>
-        <p:style>
-          <a:lnRef idx="1">
-            <a:schemeClr val="accent1"/>
-          </a:lnRef>
-          <a:fillRef idx="3">
-            <a:schemeClr val="accent1"/>
-          </a:fillRef>
-          <a:effectRef idx="2">
-            <a:schemeClr val="accent1"/>
-          </a:effectRef>
-          <a:fontRef idx="minor">
-            <a:schemeClr val="lt1"/>
-          </a:fontRef>
-        </p:style>
-        <p:txBody>
-          <a:bodyPr rtlCol="0" anchor="ctr" wrap="square" lIns="64008" rIns="64008" tIns="9144" bIns="9144"/>
-          <a:lstStyle/>
-          <a:p>
-            <a:pPr algn="l">
-              <a:lnSpc>
-                <a:spcPct val="100000"/>
-              </a:lnSpc>
-              <a:spcBef>
-                <a:spcPts val="0"/>
-              </a:spcBef>
-              <a:spcAft>
-                <a:spcPts val="0"/>
-              </a:spcAft>
-            </a:pPr>
-            <a:r>
-              <a:rPr sz="1050" b="1">
-                <a:solidFill>
-                  <a:srgbClr val="1A1D21"/>
-                </a:solidFill>
-                <a:latin typeface="맑은 고딕"/>
-              </a:rPr>
-              <a:t>마케팅 · 지점 담당자</a:t>
-            </a:r>
-          </a:p>
-          <a:p>
-            <a:pPr algn="l">
-              <a:lnSpc>
-                <a:spcPct val="100000"/>
-              </a:lnSpc>
-              <a:spcBef>
-                <a:spcPts val="0"/>
-              </a:spcBef>
-              <a:spcAft>
-                <a:spcPts val="0"/>
-              </a:spcAft>
-            </a:pPr>
-            <a:r>
-              <a:rPr sz="900" b="0">
-                <a:solidFill>
-                  <a:srgbClr val="5B6470"/>
-                </a:solidFill>
-                <a:latin typeface="맑은 고딕"/>
-              </a:rPr>
-              <a:t>금융 콘텐츠 초안 작성 (작성 시점 실시간)</a:t>
-            </a:r>
-          </a:p>
-        </p:txBody>
-      </p:sp>
-      <p:sp>
-        <p:nvSpPr>
-          <p:cNvPr id="7" name="Rounded Rectangle 6"/>
-          <p:cNvSpPr/>
-          <p:nvPr/>
-        </p:nvSpPr>
-        <p:spPr>
-          <a:xfrm>
-            <a:off x="7219188" y="1207008"/>
-            <a:ext cx="4512564" cy="658368"/>
-          </a:xfrm>
-          <a:prstGeom prst="roundRect">
-            <a:avLst/>
-          </a:prstGeom>
-          <a:solidFill>
-            <a:srgbClr val="EEF1F5"/>
-          </a:solidFill>
-          <a:ln w="9525">
-            <a:solidFill>
-              <a:srgbClr val="D8DEE6"/>
-            </a:solidFill>
-          </a:ln>
-          <a:effectLst/>
-        </p:spPr>
-        <p:style>
-          <a:lnRef idx="1">
-            <a:schemeClr val="accent1"/>
-          </a:lnRef>
-          <a:fillRef idx="3">
-            <a:schemeClr val="accent1"/>
-          </a:fillRef>
-          <a:effectRef idx="2">
-            <a:schemeClr val="accent1"/>
-          </a:effectRef>
-          <a:fontRef idx="minor">
-            <a:schemeClr val="lt1"/>
-          </a:fontRef>
-        </p:style>
-        <p:txBody>
-          <a:bodyPr rtlCol="0" anchor="ctr" wrap="square" lIns="64008" rIns="64008" tIns="9144" bIns="9144"/>
-          <a:lstStyle/>
-          <a:p>
-            <a:pPr algn="l">
-              <a:lnSpc>
-                <a:spcPct val="100000"/>
-              </a:lnSpc>
-              <a:spcBef>
-                <a:spcPts val="0"/>
-              </a:spcBef>
-              <a:spcAft>
-                <a:spcPts val="0"/>
-              </a:spcAft>
-            </a:pPr>
-            <a:r>
-              <a:rPr sz="1050" b="1">
-                <a:solidFill>
-                  <a:srgbClr val="1A1D21"/>
-                </a:solidFill>
-                <a:latin typeface="맑은 고딕"/>
-              </a:rPr>
-              <a:t>준법관리자 (준법감시부)</a:t>
-            </a:r>
-          </a:p>
-          <a:p>
-            <a:pPr algn="l">
-              <a:lnSpc>
-                <a:spcPct val="100000"/>
-              </a:lnSpc>
-              <a:spcBef>
-                <a:spcPts val="0"/>
-              </a:spcBef>
-              <a:spcAft>
-                <a:spcPts val="0"/>
-              </a:spcAft>
-            </a:pPr>
-            <a:r>
-              <a:rPr sz="900" b="0">
-                <a:solidFill>
-                  <a:srgbClr val="5B6470"/>
-                </a:solidFill>
-                <a:latin typeface="맑은 고딕"/>
-              </a:rPr>
-              <a:t>검토 · 승인 (Human-in-the-loop)</a:t>
-            </a:r>
-          </a:p>
-        </p:txBody>
-      </p:sp>
-      <p:sp>
-        <p:nvSpPr>
-          <p:cNvPr id="8" name="Down Arrow 7"/>
-          <p:cNvSpPr/>
-          <p:nvPr/>
-        </p:nvSpPr>
-        <p:spPr>
-          <a:xfrm>
-            <a:off x="7022592" y="1883664"/>
-            <a:ext cx="219456" cy="146304"/>
-          </a:xfrm>
-          <a:prstGeom prst="downArrow">
-            <a:avLst/>
-          </a:prstGeom>
-          <a:solidFill>
-            <a:srgbClr val="AAB4C0"/>
-          </a:solidFill>
-          <a:ln>
-            <a:noFill/>
-          </a:ln>
-          <a:effectLst/>
-        </p:spPr>
-        <p:style>
-          <a:lnRef idx="1">
-            <a:schemeClr val="accent1"/>
-          </a:lnRef>
-          <a:fillRef idx="3">
-            <a:schemeClr val="accent1"/>
-          </a:fillRef>
-          <a:effectRef idx="2">
-            <a:schemeClr val="accent1"/>
-          </a:effectRef>
-          <a:fontRef idx="minor">
-            <a:schemeClr val="lt1"/>
-          </a:fontRef>
-        </p:style>
-        <p:txBody>
-          <a:bodyPr rtlCol="0" anchor="ctr"/>
-          <a:lstStyle/>
-          <a:p>
-            <a:pPr algn="ctr"/>
-          </a:p>
-        </p:txBody>
-      </p:sp>
-      <p:sp>
-        <p:nvSpPr>
-          <p:cNvPr id="9" name="Rounded Rectangle 8"/>
-          <p:cNvSpPr/>
-          <p:nvPr/>
-        </p:nvSpPr>
-        <p:spPr>
-          <a:xfrm>
-            <a:off x="457200" y="2048256"/>
-            <a:ext cx="1965960" cy="786384"/>
-          </a:xfrm>
-          <a:prstGeom prst="roundRect">
-            <a:avLst/>
-          </a:prstGeom>
-          <a:solidFill>
-            <a:srgbClr val="1F9D55"/>
-          </a:solidFill>
-          <a:ln>
-            <a:noFill/>
-          </a:ln>
-          <a:effectLst/>
-        </p:spPr>
-        <p:style>
-          <a:lnRef idx="1">
-            <a:schemeClr val="accent1"/>
-          </a:lnRef>
-          <a:fillRef idx="3">
-            <a:schemeClr val="accent1"/>
-          </a:fillRef>
-          <a:effectRef idx="2">
-            <a:schemeClr val="accent1"/>
-          </a:effectRef>
-          <a:fontRef idx="minor">
-            <a:schemeClr val="lt1"/>
-          </a:fontRef>
-        </p:style>
-        <p:txBody>
-          <a:bodyPr rtlCol="0" anchor="ctr" wrap="square" lIns="64008" rIns="64008" tIns="9144" bIns="9144"/>
+          <a:noFill/>
+        </p:spPr>
+        <p:txBody>
+          <a:bodyPr wrap="square" anchor="t" lIns="0" rIns="0" tIns="9144" bIns="9144">
+            <a:spAutoFit/>
+          </a:bodyPr>
           <a:lstStyle/>
           <a:p>
             <a:pPr algn="ctr">
@@ -3555,78 +3700,33 @@
               </a:spcAft>
             </a:pPr>
             <a:r>
-              <a:rPr sz="1250" b="1">
-                <a:solidFill>
-                  <a:srgbClr val="FFFFFF"/>
+              <a:rPr sz="850" b="0">
+                <a:solidFill>
+                  <a:srgbClr val="5B6470"/>
                 </a:solidFill>
                 <a:latin typeface="맑은 고딕"/>
               </a:rPr>
-              <a:t>🖥 프론트엔드/UI</a:t>
-            </a:r>
-          </a:p>
-        </p:txBody>
-      </p:sp>
-      <p:sp>
-        <p:nvSpPr>
-          <p:cNvPr id="10" name="TextBox 9"/>
-          <p:cNvSpPr txBox="1"/>
-          <p:nvPr/>
-        </p:nvSpPr>
-        <p:spPr>
-          <a:xfrm>
-            <a:off x="2606040" y="2084832"/>
-            <a:ext cx="9171432" cy="219456"/>
-          </a:xfrm>
-          <a:prstGeom prst="rect">
-            <a:avLst/>
-          </a:prstGeom>
-          <a:noFill/>
-        </p:spPr>
-        <p:txBody>
-          <a:bodyPr wrap="square" anchor="t" lIns="0" rIns="0" tIns="9144" bIns="9144">
-            <a:spAutoFit/>
-          </a:bodyPr>
-          <a:lstStyle/>
-          <a:p>
-            <a:pPr algn="l">
-              <a:lnSpc>
-                <a:spcPct val="100000"/>
-              </a:lnSpc>
-              <a:spcBef>
-                <a:spcPts val="0"/>
-              </a:spcBef>
-              <a:spcAft>
-                <a:spcPts val="0"/>
-              </a:spcAft>
-            </a:pPr>
-            <a:r>
-              <a:rPr sz="950" b="1">
-                <a:solidFill>
-                  <a:srgbClr val="1F9D55"/>
-                </a:solidFill>
-                <a:latin typeface="맑은 고딕"/>
-              </a:rPr>
-              <a:t>정적 SPA · 바닐라 JS (빌드리스, FastAPI가 서빙)</a:t>
-            </a:r>
-          </a:p>
-        </p:txBody>
-      </p:sp>
-      <p:sp>
-        <p:nvSpPr>
-          <p:cNvPr id="11" name="Rounded Rectangle 10"/>
+              <a:t>정적 SPA · 바닐라 JS (FastAPI 서빙)</a:t>
+            </a:r>
+          </a:p>
+        </p:txBody>
+      </p:sp>
+      <p:sp>
+        <p:nvSpPr>
+          <p:cNvPr id="13" name="Rounded Rectangle 12"/>
           <p:cNvSpPr/>
           <p:nvPr/>
         </p:nvSpPr>
         <p:spPr>
           <a:xfrm>
-            <a:off x="2560320" y="2359152"/>
-            <a:ext cx="2210562" cy="402336"/>
+            <a:off x="3017520" y="2258568"/>
+            <a:ext cx="2057400" cy="310896"/>
           </a:xfrm>
           <a:prstGeom prst="roundRect">
             <a:avLst/>
           </a:prstGeom>
           <a:solidFill>
-            <a:srgbClr val="E9F7EF"/>
+            <a:srgbClr val="FFFFFF"/>
           </a:solidFill>
           <a:ln w="9525">
             <a:solidFill>
@@ -3678,20 +3778,20 @@
       </p:sp>
       <p:sp>
         <p:nvSpPr>
-          <p:cNvPr id="12" name="Rounded Rectangle 11"/>
+          <p:cNvPr id="14" name="Rounded Rectangle 13"/>
           <p:cNvSpPr/>
           <p:nvPr/>
         </p:nvSpPr>
         <p:spPr>
           <a:xfrm>
-            <a:off x="4880610" y="2359152"/>
-            <a:ext cx="2210562" cy="402336"/>
+            <a:off x="3017520" y="2624328"/>
+            <a:ext cx="2057400" cy="310896"/>
           </a:xfrm>
           <a:prstGeom prst="roundRect">
             <a:avLst/>
           </a:prstGeom>
           <a:solidFill>
-            <a:srgbClr val="E9F7EF"/>
+            <a:srgbClr val="FFFFFF"/>
           </a:solidFill>
           <a:ln w="9525">
             <a:solidFill>
@@ -3730,7 +3830,7 @@
               </a:spcAft>
             </a:pPr>
             <a:r>
-              <a:rPr sz="950" b="0">
+              <a:rPr sz="950" b="1">
                 <a:solidFill>
                   <a:srgbClr val="1A1D21"/>
                 </a:solidFill>
@@ -3743,20 +3843,20 @@
       </p:sp>
       <p:sp>
         <p:nvSpPr>
-          <p:cNvPr id="13" name="Rounded Rectangle 12"/>
+          <p:cNvPr id="15" name="Rounded Rectangle 14"/>
           <p:cNvSpPr/>
           <p:nvPr/>
         </p:nvSpPr>
         <p:spPr>
           <a:xfrm>
-            <a:off x="7200900" y="2359152"/>
-            <a:ext cx="2210562" cy="402336"/>
+            <a:off x="3017520" y="2990088"/>
+            <a:ext cx="2057400" cy="310896"/>
           </a:xfrm>
           <a:prstGeom prst="roundRect">
             <a:avLst/>
           </a:prstGeom>
           <a:solidFill>
-            <a:srgbClr val="E9F7EF"/>
+            <a:srgbClr val="FFFFFF"/>
           </a:solidFill>
           <a:ln w="9525">
             <a:solidFill>
@@ -3808,20 +3908,20 @@
       </p:sp>
       <p:sp>
         <p:nvSpPr>
-          <p:cNvPr id="14" name="Rounded Rectangle 13"/>
+          <p:cNvPr id="16" name="Rounded Rectangle 15"/>
           <p:cNvSpPr/>
           <p:nvPr/>
         </p:nvSpPr>
         <p:spPr>
           <a:xfrm>
-            <a:off x="9521190" y="2359152"/>
-            <a:ext cx="2210562" cy="402336"/>
+            <a:off x="3017520" y="3355848"/>
+            <a:ext cx="2057400" cy="310896"/>
           </a:xfrm>
           <a:prstGeom prst="roundRect">
             <a:avLst/>
           </a:prstGeom>
           <a:solidFill>
-            <a:srgbClr val="E9F7EF"/>
+            <a:srgbClr val="FFFFFF"/>
           </a:solidFill>
           <a:ln w="9525">
             <a:solidFill>
@@ -3873,20 +3973,20 @@
       </p:sp>
       <p:sp>
         <p:nvSpPr>
-          <p:cNvPr id="15" name="Down Arrow 14"/>
+          <p:cNvPr id="17" name="Right Arrow 16"/>
           <p:cNvSpPr/>
           <p:nvPr/>
         </p:nvSpPr>
         <p:spPr>
           <a:xfrm>
-            <a:off x="7022592" y="2852928"/>
-            <a:ext cx="219456" cy="146304"/>
-          </a:xfrm>
-          <a:prstGeom prst="downArrow">
+            <a:off x="5303520" y="2514600"/>
+            <a:ext cx="411480" cy="365760"/>
+          </a:xfrm>
+          <a:prstGeom prst="rightArrow">
             <a:avLst/>
           </a:prstGeom>
           <a:solidFill>
-            <a:srgbClr val="AAB4C0"/>
+            <a:srgbClr val="8AA0B5"/>
           </a:solidFill>
           <a:ln>
             <a:noFill/>
@@ -3917,14 +4017,14 @@
       </p:sp>
       <p:sp>
         <p:nvSpPr>
-          <p:cNvPr id="16" name="TextBox 15"/>
+          <p:cNvPr id="18" name="TextBox 17"/>
           <p:cNvSpPr txBox="1"/>
           <p:nvPr/>
         </p:nvSpPr>
         <p:spPr>
           <a:xfrm>
-            <a:off x="7315200" y="2834640"/>
-            <a:ext cx="2743200" cy="146304"/>
+            <a:off x="5029200" y="2240280"/>
+            <a:ext cx="960120" cy="228600"/>
           </a:xfrm>
           <a:prstGeom prst="rect">
             <a:avLst/>
@@ -3932,12 +4032,12 @@
           <a:noFill/>
         </p:spPr>
         <p:txBody>
-          <a:bodyPr wrap="square" anchor="ctr" lIns="0" rIns="0" tIns="9144" bIns="9144">
+          <a:bodyPr wrap="square" anchor="t" lIns="0" rIns="0" tIns="9144" bIns="9144">
             <a:spAutoFit/>
           </a:bodyPr>
           <a:lstStyle/>
           <a:p>
-            <a:pPr algn="l">
+            <a:pPr algn="ctr">
               <a:lnSpc>
                 <a:spcPct val="100000"/>
               </a:lnSpc>
@@ -3949,36 +4049,38 @@
               </a:spcAft>
             </a:pPr>
             <a:r>
-              <a:rPr sz="850" b="0">
+              <a:rPr sz="850" b="1">
                 <a:solidFill>
                   <a:srgbClr val="5B6470"/>
                 </a:solidFill>
                 <a:latin typeface="맑은 고딕"/>
               </a:rPr>
-              <a:t>REST (JSON)</a:t>
-            </a:r>
-          </a:p>
-        </p:txBody>
-      </p:sp>
-      <p:sp>
-        <p:nvSpPr>
-          <p:cNvPr id="17" name="Rounded Rectangle 16"/>
+              <a:t>REST(JSON)</a:t>
+            </a:r>
+          </a:p>
+        </p:txBody>
+      </p:sp>
+      <p:sp>
+        <p:nvSpPr>
+          <p:cNvPr id="19" name="Rounded Rectangle 18"/>
           <p:cNvSpPr/>
           <p:nvPr/>
         </p:nvSpPr>
         <p:spPr>
           <a:xfrm>
-            <a:off x="457200" y="3017520"/>
-            <a:ext cx="1965960" cy="731520"/>
+            <a:off x="5806440" y="1371600"/>
+            <a:ext cx="5943600" cy="3246120"/>
           </a:xfrm>
           <a:prstGeom prst="roundRect">
             <a:avLst/>
           </a:prstGeom>
           <a:solidFill>
-            <a:srgbClr val="00529B"/>
+            <a:srgbClr val="FAF8FF"/>
           </a:solidFill>
-          <a:ln>
-            <a:noFill/>
+          <a:ln w="15875">
+            <a:solidFill>
+              <a:srgbClr val="5B3BBF"/>
+            </a:solidFill>
           </a:ln>
           <a:effectLst/>
         </p:spPr>
@@ -3997,87 +4099,23 @@
           </a:fontRef>
         </p:style>
         <p:txBody>
-          <a:bodyPr rtlCol="0" anchor="ctr" wrap="square" lIns="64008" rIns="64008" tIns="9144" bIns="9144"/>
-          <a:lstStyle/>
-          <a:p>
-            <a:pPr algn="ctr">
-              <a:lnSpc>
-                <a:spcPct val="100000"/>
-              </a:lnSpc>
-              <a:spcBef>
-                <a:spcPts val="0"/>
-              </a:spcBef>
-              <a:spcAft>
-                <a:spcPts val="0"/>
-              </a:spcAft>
-            </a:pPr>
-            <a:r>
-              <a:rPr sz="1250" b="1">
-                <a:solidFill>
-                  <a:srgbClr val="FFFFFF"/>
-                </a:solidFill>
-                <a:latin typeface="맑은 고딕"/>
-              </a:rPr>
-              <a:t>⚙ 백엔드/API</a:t>
-            </a:r>
-          </a:p>
-        </p:txBody>
-      </p:sp>
-      <p:sp>
-        <p:nvSpPr>
-          <p:cNvPr id="18" name="TextBox 17"/>
-          <p:cNvSpPr txBox="1"/>
-          <p:nvPr/>
-        </p:nvSpPr>
-        <p:spPr>
-          <a:xfrm>
-            <a:off x="2606040" y="3054096"/>
-            <a:ext cx="9171432" cy="219456"/>
-          </a:xfrm>
-          <a:prstGeom prst="rect">
-            <a:avLst/>
-          </a:prstGeom>
-          <a:noFill/>
-        </p:spPr>
-        <p:txBody>
-          <a:bodyPr wrap="square" anchor="t" lIns="0" rIns="0" tIns="9144" bIns="9144">
-            <a:spAutoFit/>
-          </a:bodyPr>
-          <a:lstStyle/>
-          <a:p>
-            <a:pPr algn="l">
-              <a:lnSpc>
-                <a:spcPct val="100000"/>
-              </a:lnSpc>
-              <a:spcBef>
-                <a:spcPts val="0"/>
-              </a:spcBef>
-              <a:spcAft>
-                <a:spcPts val="0"/>
-              </a:spcAft>
-            </a:pPr>
-            <a:r>
-              <a:rPr sz="950" b="1">
-                <a:solidFill>
-                  <a:srgbClr val="00529B"/>
-                </a:solidFill>
-                <a:latin typeface="맑은 고딕"/>
-              </a:rPr>
-              <a:t>FastAPI · app/main.py — REST 엔드포인트</a:t>
-            </a:r>
-          </a:p>
-        </p:txBody>
-      </p:sp>
-      <p:sp>
-        <p:nvSpPr>
-          <p:cNvPr id="19" name="Rounded Rectangle 18"/>
+          <a:bodyPr rtlCol="0" anchor="ctr"/>
+          <a:lstStyle/>
+          <a:p>
+            <a:pPr algn="ctr"/>
+          </a:p>
+        </p:txBody>
+      </p:sp>
+      <p:sp>
+        <p:nvSpPr>
+          <p:cNvPr id="20" name="Rounded Rectangle 19"/>
           <p:cNvSpPr/>
           <p:nvPr/>
         </p:nvSpPr>
         <p:spPr>
           <a:xfrm>
-            <a:off x="2560320" y="3310128"/>
-            <a:ext cx="1247502" cy="365760"/>
+            <a:off x="5952744" y="1499616"/>
+            <a:ext cx="5650992" cy="566928"/>
           </a:xfrm>
           <a:prstGeom prst="roundRect">
             <a:avLst/>
@@ -4107,10 +4145,36 @@
           </a:fontRef>
         </p:style>
         <p:txBody>
-          <a:bodyPr rtlCol="0" anchor="ctr" wrap="square" lIns="45720" rIns="45720" tIns="9144" bIns="9144"/>
-          <a:lstStyle/>
-          <a:p>
-            <a:pPr algn="ctr">
+          <a:bodyPr rtlCol="0" anchor="ctr"/>
+          <a:lstStyle/>
+          <a:p>
+            <a:pPr algn="ctr"/>
+          </a:p>
+        </p:txBody>
+      </p:sp>
+      <p:sp>
+        <p:nvSpPr>
+          <p:cNvPr id="21" name="TextBox 20"/>
+          <p:cNvSpPr txBox="1"/>
+          <p:nvPr/>
+        </p:nvSpPr>
+        <p:spPr>
+          <a:xfrm>
+            <a:off x="6080760" y="1536192"/>
+            <a:ext cx="5486400" cy="201168"/>
+          </a:xfrm>
+          <a:prstGeom prst="rect">
+            <a:avLst/>
+          </a:prstGeom>
+          <a:noFill/>
+        </p:spPr>
+        <p:txBody>
+          <a:bodyPr wrap="square" anchor="t" lIns="0" rIns="0" tIns="9144" bIns="9144">
+            <a:spAutoFit/>
+          </a:bodyPr>
+          <a:lstStyle/>
+          <a:p>
+            <a:pPr algn="l">
               <a:lnSpc>
                 <a:spcPct val="100000"/>
               </a:lnSpc>
@@ -4122,33 +4186,33 @@
               </a:spcAft>
             </a:pPr>
             <a:r>
-              <a:rPr sz="850" b="0">
-                <a:solidFill>
-                  <a:srgbClr val="1A1D21"/>
+              <a:rPr sz="950" b="1">
+                <a:solidFill>
+                  <a:srgbClr val="00529B"/>
                 </a:solidFill>
                 <a:latin typeface="맑은 고딕"/>
               </a:rPr>
-              <a:t>/review</a:t>
-            </a:r>
-          </a:p>
-        </p:txBody>
-      </p:sp>
-      <p:sp>
-        <p:nvSpPr>
-          <p:cNvPr id="20" name="Rounded Rectangle 19"/>
+              <a:t>⚙ 백엔드 / API — FastAPI (app/main.py) · REST 엔드포인트</a:t>
+            </a:r>
+          </a:p>
+        </p:txBody>
+      </p:sp>
+      <p:sp>
+        <p:nvSpPr>
+          <p:cNvPr id="22" name="Rounded Rectangle 21"/>
           <p:cNvSpPr/>
           <p:nvPr/>
         </p:nvSpPr>
         <p:spPr>
           <a:xfrm>
-            <a:off x="3880974" y="3310128"/>
-            <a:ext cx="1247502" cy="365760"/>
+            <a:off x="6035040" y="1773936"/>
+            <a:ext cx="728907" cy="237744"/>
           </a:xfrm>
           <a:prstGeom prst="roundRect">
             <a:avLst/>
           </a:prstGeom>
           <a:solidFill>
-            <a:srgbClr val="EEF4FC"/>
+            <a:srgbClr val="FFFFFF"/>
           </a:solidFill>
           <a:ln w="9525">
             <a:solidFill>
@@ -4172,7 +4236,7 @@
           </a:fontRef>
         </p:style>
         <p:txBody>
-          <a:bodyPr rtlCol="0" anchor="ctr" wrap="square" lIns="45720" rIns="45720" tIns="9144" bIns="9144"/>
+          <a:bodyPr rtlCol="0" anchor="ctr" wrap="square" lIns="18288" rIns="18288" tIns="9144" bIns="9144"/>
           <a:lstStyle/>
           <a:p>
             <a:pPr algn="ctr">
@@ -4187,33 +4251,33 @@
               </a:spcAft>
             </a:pPr>
             <a:r>
-              <a:rPr sz="850" b="0">
-                <a:solidFill>
-                  <a:srgbClr val="1A1D21"/>
+              <a:rPr sz="780" b="0">
+                <a:solidFill>
+                  <a:srgbClr val="003A6E"/>
                 </a:solidFill>
                 <a:latin typeface="맑은 고딕"/>
               </a:rPr>
-              <a:t>/autopilot</a:t>
-            </a:r>
-          </a:p>
-        </p:txBody>
-      </p:sp>
-      <p:sp>
-        <p:nvSpPr>
-          <p:cNvPr id="21" name="Rounded Rectangle 20"/>
+              <a:t>/review</a:t>
+            </a:r>
+          </a:p>
+        </p:txBody>
+      </p:sp>
+      <p:sp>
+        <p:nvSpPr>
+          <p:cNvPr id="23" name="Rounded Rectangle 22"/>
           <p:cNvSpPr/>
           <p:nvPr/>
         </p:nvSpPr>
         <p:spPr>
           <a:xfrm>
-            <a:off x="5201628" y="3310128"/>
-            <a:ext cx="1247502" cy="365760"/>
+            <a:off x="6827955" y="1773936"/>
+            <a:ext cx="728907" cy="237744"/>
           </a:xfrm>
           <a:prstGeom prst="roundRect">
             <a:avLst/>
           </a:prstGeom>
           <a:solidFill>
-            <a:srgbClr val="EEF4FC"/>
+            <a:srgbClr val="FFFFFF"/>
           </a:solidFill>
           <a:ln w="9525">
             <a:solidFill>
@@ -4237,7 +4301,7 @@
           </a:fontRef>
         </p:style>
         <p:txBody>
-          <a:bodyPr rtlCol="0" anchor="ctr" wrap="square" lIns="45720" rIns="45720" tIns="9144" bIns="9144"/>
+          <a:bodyPr rtlCol="0" anchor="ctr" wrap="square" lIns="18288" rIns="18288" tIns="9144" bIns="9144"/>
           <a:lstStyle/>
           <a:p>
             <a:pPr algn="ctr">
@@ -4252,33 +4316,33 @@
               </a:spcAft>
             </a:pPr>
             <a:r>
-              <a:rPr sz="850" b="0">
-                <a:solidFill>
-                  <a:srgbClr val="1A1D21"/>
+              <a:rPr sz="780" b="0">
+                <a:solidFill>
+                  <a:srgbClr val="003A6E"/>
                 </a:solidFill>
                 <a:latin typeface="맑은 고딕"/>
               </a:rPr>
-              <a:t>/submissions</a:t>
-            </a:r>
-          </a:p>
-        </p:txBody>
-      </p:sp>
-      <p:sp>
-        <p:nvSpPr>
-          <p:cNvPr id="22" name="Rounded Rectangle 21"/>
+              <a:t>/autopilot</a:t>
+            </a:r>
+          </a:p>
+        </p:txBody>
+      </p:sp>
+      <p:sp>
+        <p:nvSpPr>
+          <p:cNvPr id="24" name="Rounded Rectangle 23"/>
           <p:cNvSpPr/>
           <p:nvPr/>
         </p:nvSpPr>
         <p:spPr>
           <a:xfrm>
-            <a:off x="6522282" y="3310128"/>
-            <a:ext cx="1247502" cy="365760"/>
+            <a:off x="7620870" y="1773936"/>
+            <a:ext cx="728907" cy="237744"/>
           </a:xfrm>
           <a:prstGeom prst="roundRect">
             <a:avLst/>
           </a:prstGeom>
           <a:solidFill>
-            <a:srgbClr val="EEF4FC"/>
+            <a:srgbClr val="FFFFFF"/>
           </a:solidFill>
           <a:ln w="9525">
             <a:solidFill>
@@ -4302,7 +4366,7 @@
           </a:fontRef>
         </p:style>
         <p:txBody>
-          <a:bodyPr rtlCol="0" anchor="ctr" wrap="square" lIns="45720" rIns="45720" tIns="9144" bIns="9144"/>
+          <a:bodyPr rtlCol="0" anchor="ctr" wrap="square" lIns="18288" rIns="18288" tIns="9144" bIns="9144"/>
           <a:lstStyle/>
           <a:p>
             <a:pPr algn="ctr">
@@ -4317,33 +4381,33 @@
               </a:spcAft>
             </a:pPr>
             <a:r>
-              <a:rPr sz="850" b="0">
-                <a:solidFill>
-                  <a:srgbClr val="1A1D21"/>
+              <a:rPr sz="780" b="0">
+                <a:solidFill>
+                  <a:srgbClr val="003A6E"/>
                 </a:solidFill>
                 <a:latin typeface="맑은 고딕"/>
               </a:rPr>
-              <a:t>/internal-rules</a:t>
-            </a:r>
-          </a:p>
-        </p:txBody>
-      </p:sp>
-      <p:sp>
-        <p:nvSpPr>
-          <p:cNvPr id="23" name="Rounded Rectangle 22"/>
+              <a:t>/submissions</a:t>
+            </a:r>
+          </a:p>
+        </p:txBody>
+      </p:sp>
+      <p:sp>
+        <p:nvSpPr>
+          <p:cNvPr id="25" name="Rounded Rectangle 24"/>
           <p:cNvSpPr/>
           <p:nvPr/>
         </p:nvSpPr>
         <p:spPr>
           <a:xfrm>
-            <a:off x="7842936" y="3310128"/>
-            <a:ext cx="1247502" cy="365760"/>
+            <a:off x="8413785" y="1773936"/>
+            <a:ext cx="728907" cy="237744"/>
           </a:xfrm>
           <a:prstGeom prst="roundRect">
             <a:avLst/>
           </a:prstGeom>
           <a:solidFill>
-            <a:srgbClr val="EEF4FC"/>
+            <a:srgbClr val="FFFFFF"/>
           </a:solidFill>
           <a:ln w="9525">
             <a:solidFill>
@@ -4367,7 +4431,7 @@
           </a:fontRef>
         </p:style>
         <p:txBody>
-          <a:bodyPr rtlCol="0" anchor="ctr" wrap="square" lIns="45720" rIns="45720" tIns="9144" bIns="9144"/>
+          <a:bodyPr rtlCol="0" anchor="ctr" wrap="square" lIns="18288" rIns="18288" tIns="9144" bIns="9144"/>
           <a:lstStyle/>
           <a:p>
             <a:pPr algn="ctr">
@@ -4382,33 +4446,33 @@
               </a:spcAft>
             </a:pPr>
             <a:r>
-              <a:rPr sz="850" b="0">
-                <a:solidFill>
-                  <a:srgbClr val="1A1D21"/>
+              <a:rPr sz="780" b="0">
+                <a:solidFill>
+                  <a:srgbClr val="003A6E"/>
                 </a:solidFill>
                 <a:latin typeface="맑은 고딕"/>
               </a:rPr>
-              <a:t>/regwatch</a:t>
-            </a:r>
-          </a:p>
-        </p:txBody>
-      </p:sp>
-      <p:sp>
-        <p:nvSpPr>
-          <p:cNvPr id="24" name="Rounded Rectangle 23"/>
+              <a:t>/internal-rules</a:t>
+            </a:r>
+          </a:p>
+        </p:txBody>
+      </p:sp>
+      <p:sp>
+        <p:nvSpPr>
+          <p:cNvPr id="26" name="Rounded Rectangle 25"/>
           <p:cNvSpPr/>
           <p:nvPr/>
         </p:nvSpPr>
         <p:spPr>
           <a:xfrm>
-            <a:off x="9163590" y="3310128"/>
-            <a:ext cx="1247502" cy="365760"/>
+            <a:off x="9206700" y="1773936"/>
+            <a:ext cx="728907" cy="237744"/>
           </a:xfrm>
           <a:prstGeom prst="roundRect">
             <a:avLst/>
           </a:prstGeom>
           <a:solidFill>
-            <a:srgbClr val="EEF4FC"/>
+            <a:srgbClr val="FFFFFF"/>
           </a:solidFill>
           <a:ln w="9525">
             <a:solidFill>
@@ -4432,7 +4496,7 @@
           </a:fontRef>
         </p:style>
         <p:txBody>
-          <a:bodyPr rtlCol="0" anchor="ctr" wrap="square" lIns="45720" rIns="45720" tIns="9144" bIns="9144"/>
+          <a:bodyPr rtlCol="0" anchor="ctr" wrap="square" lIns="18288" rIns="18288" tIns="9144" bIns="9144"/>
           <a:lstStyle/>
           <a:p>
             <a:pPr algn="ctr">
@@ -4447,33 +4511,33 @@
               </a:spcAft>
             </a:pPr>
             <a:r>
-              <a:rPr sz="850" b="0">
-                <a:solidFill>
-                  <a:srgbClr val="1A1D21"/>
+              <a:rPr sz="780" b="0">
+                <a:solidFill>
+                  <a:srgbClr val="003A6E"/>
                 </a:solidFill>
                 <a:latin typeface="맑은 고딕"/>
               </a:rPr>
-              <a:t>/dist</a:t>
-            </a:r>
-          </a:p>
-        </p:txBody>
-      </p:sp>
-      <p:sp>
-        <p:nvSpPr>
-          <p:cNvPr id="25" name="Rounded Rectangle 24"/>
+              <a:t>/regwatch</a:t>
+            </a:r>
+          </a:p>
+        </p:txBody>
+      </p:sp>
+      <p:sp>
+        <p:nvSpPr>
+          <p:cNvPr id="27" name="Rounded Rectangle 26"/>
           <p:cNvSpPr/>
           <p:nvPr/>
         </p:nvSpPr>
         <p:spPr>
           <a:xfrm>
-            <a:off x="10484244" y="3310128"/>
-            <a:ext cx="1247502" cy="365760"/>
+            <a:off x="9999615" y="1773936"/>
+            <a:ext cx="728907" cy="237744"/>
           </a:xfrm>
           <a:prstGeom prst="roundRect">
             <a:avLst/>
           </a:prstGeom>
           <a:solidFill>
-            <a:srgbClr val="EEF4FC"/>
+            <a:srgbClr val="FFFFFF"/>
           </a:solidFill>
           <a:ln w="9525">
             <a:solidFill>
@@ -4497,7 +4561,7 @@
           </a:fontRef>
         </p:style>
         <p:txBody>
-          <a:bodyPr rtlCol="0" anchor="ctr" wrap="square" lIns="45720" rIns="45720" tIns="9144" bIns="9144"/>
+          <a:bodyPr rtlCol="0" anchor="ctr" wrap="square" lIns="18288" rIns="18288" tIns="9144" bIns="9144"/>
           <a:lstStyle/>
           <a:p>
             <a:pPr algn="ctr">
@@ -4512,36 +4576,38 @@
               </a:spcAft>
             </a:pPr>
             <a:r>
-              <a:rPr sz="850" b="0">
-                <a:solidFill>
-                  <a:srgbClr val="1A1D21"/>
+              <a:rPr sz="780" b="0">
+                <a:solidFill>
+                  <a:srgbClr val="003A6E"/>
                 </a:solidFill>
                 <a:latin typeface="맑은 고딕"/>
               </a:rPr>
-              <a:t>/products</a:t>
-            </a:r>
-          </a:p>
-        </p:txBody>
-      </p:sp>
-      <p:sp>
-        <p:nvSpPr>
-          <p:cNvPr id="26" name="Down Arrow 25"/>
+              <a:t>/dist</a:t>
+            </a:r>
+          </a:p>
+        </p:txBody>
+      </p:sp>
+      <p:sp>
+        <p:nvSpPr>
+          <p:cNvPr id="28" name="Rounded Rectangle 27"/>
           <p:cNvSpPr/>
           <p:nvPr/>
         </p:nvSpPr>
         <p:spPr>
           <a:xfrm>
-            <a:off x="7022592" y="3767328"/>
-            <a:ext cx="219456" cy="146304"/>
-          </a:xfrm>
-          <a:prstGeom prst="downArrow">
+            <a:off x="10792530" y="1773936"/>
+            <a:ext cx="728907" cy="237744"/>
+          </a:xfrm>
+          <a:prstGeom prst="roundRect">
             <a:avLst/>
           </a:prstGeom>
           <a:solidFill>
-            <a:srgbClr val="AAB4C0"/>
+            <a:srgbClr val="FFFFFF"/>
           </a:solidFill>
-          <a:ln>
-            <a:noFill/>
+          <a:ln w="9525">
+            <a:solidFill>
+              <a:srgbClr val="BCD6F2"/>
+            </a:solidFill>
           </a:ln>
           <a:effectLst/>
         </p:spPr>
@@ -4560,23 +4626,42 @@
           </a:fontRef>
         </p:style>
         <p:txBody>
-          <a:bodyPr rtlCol="0" anchor="ctr"/>
-          <a:lstStyle/>
-          <a:p>
-            <a:pPr algn="ctr"/>
-          </a:p>
-        </p:txBody>
-      </p:sp>
-      <p:sp>
-        <p:nvSpPr>
-          <p:cNvPr id="27" name="TextBox 26"/>
+          <a:bodyPr rtlCol="0" anchor="ctr" wrap="square" lIns="18288" rIns="18288" tIns="9144" bIns="9144"/>
+          <a:lstStyle/>
+          <a:p>
+            <a:pPr algn="ctr">
+              <a:lnSpc>
+                <a:spcPct val="100000"/>
+              </a:lnSpc>
+              <a:spcBef>
+                <a:spcPts val="0"/>
+              </a:spcBef>
+              <a:spcAft>
+                <a:spcPts val="0"/>
+              </a:spcAft>
+            </a:pPr>
+            <a:r>
+              <a:rPr sz="780" b="0">
+                <a:solidFill>
+                  <a:srgbClr val="003A6E"/>
+                </a:solidFill>
+                <a:latin typeface="맑은 고딕"/>
+              </a:rPr>
+              <a:t>/products</a:t>
+            </a:r>
+          </a:p>
+        </p:txBody>
+      </p:sp>
+      <p:sp>
+        <p:nvSpPr>
+          <p:cNvPr id="29" name="TextBox 28"/>
           <p:cNvSpPr txBox="1"/>
           <p:nvPr/>
         </p:nvSpPr>
         <p:spPr>
           <a:xfrm>
-            <a:off x="7315200" y="3749040"/>
-            <a:ext cx="2743200" cy="146304"/>
+            <a:off x="6080760" y="2157984"/>
+            <a:ext cx="5486400" cy="219456"/>
           </a:xfrm>
           <a:prstGeom prst="rect">
             <a:avLst/>
@@ -4584,7 +4669,7 @@
           <a:noFill/>
         </p:spPr>
         <p:txBody>
-          <a:bodyPr wrap="square" anchor="ctr" lIns="0" rIns="0" tIns="9144" bIns="9144">
+          <a:bodyPr wrap="square" anchor="t" lIns="0" rIns="0" tIns="9144" bIns="9144">
             <a:spAutoFit/>
           </a:bodyPr>
           <a:lstStyle/>
@@ -4601,181 +4686,27 @@
               </a:spcAft>
             </a:pPr>
             <a:r>
-              <a:rPr sz="850" b="0">
-                <a:solidFill>
-                  <a:srgbClr val="5B6470"/>
+              <a:rPr sz="950" b="1">
+                <a:solidFill>
+                  <a:srgbClr val="5B3BBF"/>
                 </a:solidFill>
                 <a:latin typeface="맑은 고딕"/>
               </a:rPr>
-              <a:t>추론 호출</a:t>
-            </a:r>
-          </a:p>
-        </p:txBody>
-      </p:sp>
-      <p:sp>
-        <p:nvSpPr>
-          <p:cNvPr id="28" name="Rounded Rectangle 27"/>
+              <a:t>🧠 AI Agent · Orchestrator (명시적 파이썬 파이프라인)</a:t>
+            </a:r>
+          </a:p>
+        </p:txBody>
+      </p:sp>
+      <p:sp>
+        <p:nvSpPr>
+          <p:cNvPr id="30" name="Rounded Rectangle 29"/>
           <p:cNvSpPr/>
           <p:nvPr/>
         </p:nvSpPr>
         <p:spPr>
           <a:xfrm>
-            <a:off x="457200" y="3931920"/>
-            <a:ext cx="1965960" cy="1371600"/>
-          </a:xfrm>
-          <a:prstGeom prst="roundRect">
-            <a:avLst/>
-          </a:prstGeom>
-          <a:solidFill>
-            <a:srgbClr val="5B3BBF"/>
-          </a:solidFill>
-          <a:ln>
-            <a:noFill/>
-          </a:ln>
-          <a:effectLst/>
-        </p:spPr>
-        <p:style>
-          <a:lnRef idx="1">
-            <a:schemeClr val="accent1"/>
-          </a:lnRef>
-          <a:fillRef idx="3">
-            <a:schemeClr val="accent1"/>
-          </a:fillRef>
-          <a:effectRef idx="2">
-            <a:schemeClr val="accent1"/>
-          </a:effectRef>
-          <a:fontRef idx="minor">
-            <a:schemeClr val="lt1"/>
-          </a:fontRef>
-        </p:style>
-        <p:txBody>
-          <a:bodyPr rtlCol="0" anchor="ctr" wrap="square" lIns="64008" rIns="64008" tIns="9144" bIns="9144"/>
-          <a:lstStyle/>
-          <a:p>
-            <a:pPr algn="ctr">
-              <a:lnSpc>
-                <a:spcPct val="100000"/>
-              </a:lnSpc>
-              <a:spcBef>
-                <a:spcPts val="0"/>
-              </a:spcBef>
-              <a:spcAft>
-                <a:spcPts val="0"/>
-              </a:spcAft>
-            </a:pPr>
-            <a:r>
-              <a:rPr sz="1250" b="1">
-                <a:solidFill>
-                  <a:srgbClr val="FFFFFF"/>
-                </a:solidFill>
-                <a:latin typeface="맑은 고딕"/>
-              </a:rPr>
-              <a:t>🧠 AI Agent/모델</a:t>
-            </a:r>
-          </a:p>
-        </p:txBody>
-      </p:sp>
-      <p:sp>
-        <p:nvSpPr>
-          <p:cNvPr id="29" name="Rounded Rectangle 28"/>
-          <p:cNvSpPr/>
-          <p:nvPr/>
-        </p:nvSpPr>
-        <p:spPr>
-          <a:xfrm>
-            <a:off x="2560320" y="3931920"/>
-            <a:ext cx="9171432" cy="1371600"/>
-          </a:xfrm>
-          <a:prstGeom prst="roundRect">
-            <a:avLst/>
-          </a:prstGeom>
-          <a:solidFill>
-            <a:srgbClr val="F0ECFF"/>
-          </a:solidFill>
-          <a:ln w="12700">
-            <a:solidFill>
-              <a:srgbClr val="CDBFF0"/>
-            </a:solidFill>
-          </a:ln>
-          <a:effectLst/>
-        </p:spPr>
-        <p:style>
-          <a:lnRef idx="1">
-            <a:schemeClr val="accent1"/>
-          </a:lnRef>
-          <a:fillRef idx="3">
-            <a:schemeClr val="accent1"/>
-          </a:fillRef>
-          <a:effectRef idx="2">
-            <a:schemeClr val="accent1"/>
-          </a:effectRef>
-          <a:fontRef idx="minor">
-            <a:schemeClr val="lt1"/>
-          </a:fontRef>
-        </p:style>
-        <p:txBody>
-          <a:bodyPr rtlCol="0" anchor="ctr" wrap="square" lIns="64008" rIns="64008" tIns="9144" bIns="9144"/>
-          <a:lstStyle/>
-          <a:p>
-            <a:pPr algn="ctr"/>
-          </a:p>
-        </p:txBody>
-      </p:sp>
-      <p:sp>
-        <p:nvSpPr>
-          <p:cNvPr id="30" name="TextBox 29"/>
-          <p:cNvSpPr txBox="1"/>
-          <p:nvPr/>
-        </p:nvSpPr>
-        <p:spPr>
-          <a:xfrm>
-            <a:off x="2706624" y="4005072"/>
-            <a:ext cx="8897112" cy="219456"/>
-          </a:xfrm>
-          <a:prstGeom prst="rect">
-            <a:avLst/>
-          </a:prstGeom>
-          <a:noFill/>
-        </p:spPr>
-        <p:txBody>
-          <a:bodyPr wrap="square" anchor="t" lIns="0" rIns="0" tIns="9144" bIns="9144">
-            <a:spAutoFit/>
-          </a:bodyPr>
-          <a:lstStyle/>
-          <a:p>
-            <a:pPr algn="l">
-              <a:lnSpc>
-                <a:spcPct val="100000"/>
-              </a:lnSpc>
-              <a:spcBef>
-                <a:spcPts val="0"/>
-              </a:spcBef>
-              <a:spcAft>
-                <a:spcPts val="0"/>
-              </a:spcAft>
-            </a:pPr>
-            <a:r>
-              <a:rPr sz="1000" b="1">
-                <a:solidFill>
-                  <a:srgbClr val="5B3BBF"/>
-                </a:solidFill>
-                <a:latin typeface="맑은 고딕"/>
-              </a:rPr>
-              <a:t>Orchestrator · 명시적 파이썬 파이프라인 (app/pipeline)</a:t>
-            </a:r>
-          </a:p>
-        </p:txBody>
-      </p:sp>
-      <p:sp>
-        <p:nvSpPr>
-          <p:cNvPr id="31" name="Rounded Rectangle 30"/>
-          <p:cNvSpPr/>
-          <p:nvPr/>
-        </p:nvSpPr>
-        <p:spPr>
-          <a:xfrm>
-            <a:off x="2706624" y="4279392"/>
-            <a:ext cx="1197864" cy="438912"/>
+            <a:off x="6035040" y="2395728"/>
+            <a:ext cx="728907" cy="457200"/>
           </a:xfrm>
           <a:prstGeom prst="roundRect">
             <a:avLst/>
@@ -4805,7 +4736,7 @@
           </a:fontRef>
         </p:style>
         <p:txBody>
-          <a:bodyPr rtlCol="0" anchor="ctr" wrap="square" lIns="36576" rIns="36576" tIns="9144" bIns="9144"/>
+          <a:bodyPr rtlCol="0" anchor="ctr" wrap="square" lIns="27432" rIns="27432" tIns="9144" bIns="9144"/>
           <a:lstStyle/>
           <a:p>
             <a:pPr algn="ctr">
@@ -4820,7 +4751,7 @@
               </a:spcAft>
             </a:pPr>
             <a:r>
-              <a:rPr sz="850" b="0">
+              <a:rPr sz="830" b="0">
                 <a:solidFill>
                   <a:srgbClr val="1A1D21"/>
                 </a:solidFill>
@@ -4833,14 +4764,59 @@
       </p:sp>
       <p:sp>
         <p:nvSpPr>
+          <p:cNvPr id="31" name="TextBox 30"/>
+          <p:cNvSpPr txBox="1"/>
+          <p:nvPr/>
+        </p:nvSpPr>
+        <p:spPr>
+          <a:xfrm>
+            <a:off x="6727371" y="2395728"/>
+            <a:ext cx="109728" cy="457200"/>
+          </a:xfrm>
+          <a:prstGeom prst="rect">
+            <a:avLst/>
+          </a:prstGeom>
+          <a:noFill/>
+        </p:spPr>
+        <p:txBody>
+          <a:bodyPr wrap="square" anchor="ctr" lIns="0" rIns="0" tIns="9144" bIns="9144">
+            <a:spAutoFit/>
+          </a:bodyPr>
+          <a:lstStyle/>
+          <a:p>
+            <a:pPr algn="ctr">
+              <a:lnSpc>
+                <a:spcPct val="100000"/>
+              </a:lnSpc>
+              <a:spcBef>
+                <a:spcPts val="0"/>
+              </a:spcBef>
+              <a:spcAft>
+                <a:spcPts val="0"/>
+              </a:spcAft>
+            </a:pPr>
+            <a:r>
+              <a:rPr sz="800" b="1">
+                <a:solidFill>
+                  <a:srgbClr val="5B6470"/>
+                </a:solidFill>
+                <a:latin typeface="맑은 고딕"/>
+              </a:rPr>
+              <a:t>▸</a:t>
+            </a:r>
+          </a:p>
+        </p:txBody>
+      </p:sp>
+      <p:sp>
+        <p:nvSpPr>
           <p:cNvPr id="32" name="Rounded Rectangle 31"/>
           <p:cNvSpPr/>
           <p:nvPr/>
         </p:nvSpPr>
         <p:spPr>
           <a:xfrm>
-            <a:off x="3986784" y="4279392"/>
-            <a:ext cx="1197864" cy="438912"/>
+            <a:off x="6827955" y="2395728"/>
+            <a:ext cx="728907" cy="457200"/>
           </a:xfrm>
           <a:prstGeom prst="roundRect">
             <a:avLst/>
@@ -4870,7 +4846,7 @@
           </a:fontRef>
         </p:style>
         <p:txBody>
-          <a:bodyPr rtlCol="0" anchor="ctr" wrap="square" lIns="36576" rIns="36576" tIns="9144" bIns="9144"/>
+          <a:bodyPr rtlCol="0" anchor="ctr" wrap="square" lIns="27432" rIns="27432" tIns="9144" bIns="9144"/>
           <a:lstStyle/>
           <a:p>
             <a:pPr algn="ctr">
@@ -4885,27 +4861,182 @@
               </a:spcAft>
             </a:pPr>
             <a:r>
-              <a:rPr sz="850" b="0">
+              <a:rPr sz="830" b="0">
                 <a:solidFill>
                   <a:srgbClr val="1A1D21"/>
                 </a:solidFill>
                 <a:latin typeface="맑은 고딕"/>
               </a:rPr>
-              <a:t>②RAG 근거검색</a:t>
-            </a:r>
-          </a:p>
-        </p:txBody>
-      </p:sp>
-      <p:sp>
-        <p:nvSpPr>
-          <p:cNvPr id="33" name="Rounded Rectangle 32"/>
+              <a:t>②RAG 검색</a:t>
+            </a:r>
+          </a:p>
+        </p:txBody>
+      </p:sp>
+      <p:sp>
+        <p:nvSpPr>
+          <p:cNvPr id="33" name="TextBox 32"/>
+          <p:cNvSpPr txBox="1"/>
+          <p:nvPr/>
+        </p:nvSpPr>
+        <p:spPr>
+          <a:xfrm>
+            <a:off x="7520286" y="2395728"/>
+            <a:ext cx="109728" cy="457200"/>
+          </a:xfrm>
+          <a:prstGeom prst="rect">
+            <a:avLst/>
+          </a:prstGeom>
+          <a:noFill/>
+        </p:spPr>
+        <p:txBody>
+          <a:bodyPr wrap="square" anchor="ctr" lIns="0" rIns="0" tIns="9144" bIns="9144">
+            <a:spAutoFit/>
+          </a:bodyPr>
+          <a:lstStyle/>
+          <a:p>
+            <a:pPr algn="ctr">
+              <a:lnSpc>
+                <a:spcPct val="100000"/>
+              </a:lnSpc>
+              <a:spcBef>
+                <a:spcPts val="0"/>
+              </a:spcBef>
+              <a:spcAft>
+                <a:spcPts val="0"/>
+              </a:spcAft>
+            </a:pPr>
+            <a:r>
+              <a:rPr sz="800" b="1">
+                <a:solidFill>
+                  <a:srgbClr val="5B6470"/>
+                </a:solidFill>
+                <a:latin typeface="맑은 고딕"/>
+              </a:rPr>
+              <a:t>▸</a:t>
+            </a:r>
+          </a:p>
+        </p:txBody>
+      </p:sp>
+      <p:sp>
+        <p:nvSpPr>
+          <p:cNvPr id="34" name="Rounded Rectangle 33"/>
           <p:cNvSpPr/>
           <p:nvPr/>
         </p:nvSpPr>
         <p:spPr>
           <a:xfrm>
-            <a:off x="5266944" y="4279392"/>
-            <a:ext cx="1197864" cy="438912"/>
+            <a:off x="7620870" y="2395728"/>
+            <a:ext cx="728907" cy="457200"/>
+          </a:xfrm>
+          <a:prstGeom prst="roundRect">
+            <a:avLst/>
+          </a:prstGeom>
+          <a:solidFill>
+            <a:srgbClr val="F0ECFF"/>
+          </a:solidFill>
+          <a:ln w="9525">
+            <a:solidFill>
+              <a:srgbClr val="CDBFF0"/>
+            </a:solidFill>
+          </a:ln>
+          <a:effectLst/>
+        </p:spPr>
+        <p:style>
+          <a:lnRef idx="1">
+            <a:schemeClr val="accent1"/>
+          </a:lnRef>
+          <a:fillRef idx="3">
+            <a:schemeClr val="accent1"/>
+          </a:fillRef>
+          <a:effectRef idx="2">
+            <a:schemeClr val="accent1"/>
+          </a:effectRef>
+          <a:fontRef idx="minor">
+            <a:schemeClr val="lt1"/>
+          </a:fontRef>
+        </p:style>
+        <p:txBody>
+          <a:bodyPr rtlCol="0" anchor="ctr" wrap="square" lIns="27432" rIns="27432" tIns="9144" bIns="9144"/>
+          <a:lstStyle/>
+          <a:p>
+            <a:pPr algn="ctr">
+              <a:lnSpc>
+                <a:spcPct val="100000"/>
+              </a:lnSpc>
+              <a:spcBef>
+                <a:spcPts val="0"/>
+              </a:spcBef>
+              <a:spcAft>
+                <a:spcPts val="0"/>
+              </a:spcAft>
+            </a:pPr>
+            <a:r>
+              <a:rPr sz="830" b="1">
+                <a:solidFill>
+                  <a:srgbClr val="5B3BBF"/>
+                </a:solidFill>
+                <a:latin typeface="맑은 고딕"/>
+              </a:rPr>
+              <a:t>③룰엔진</a:t>
+            </a:r>
+          </a:p>
+        </p:txBody>
+      </p:sp>
+      <p:sp>
+        <p:nvSpPr>
+          <p:cNvPr id="35" name="TextBox 34"/>
+          <p:cNvSpPr txBox="1"/>
+          <p:nvPr/>
+        </p:nvSpPr>
+        <p:spPr>
+          <a:xfrm>
+            <a:off x="8313201" y="2395728"/>
+            <a:ext cx="109728" cy="457200"/>
+          </a:xfrm>
+          <a:prstGeom prst="rect">
+            <a:avLst/>
+          </a:prstGeom>
+          <a:noFill/>
+        </p:spPr>
+        <p:txBody>
+          <a:bodyPr wrap="square" anchor="ctr" lIns="0" rIns="0" tIns="9144" bIns="9144">
+            <a:spAutoFit/>
+          </a:bodyPr>
+          <a:lstStyle/>
+          <a:p>
+            <a:pPr algn="ctr">
+              <a:lnSpc>
+                <a:spcPct val="100000"/>
+              </a:lnSpc>
+              <a:spcBef>
+                <a:spcPts val="0"/>
+              </a:spcBef>
+              <a:spcAft>
+                <a:spcPts val="0"/>
+              </a:spcAft>
+            </a:pPr>
+            <a:r>
+              <a:rPr sz="800" b="1">
+                <a:solidFill>
+                  <a:srgbClr val="5B6470"/>
+                </a:solidFill>
+                <a:latin typeface="맑은 고딕"/>
+              </a:rPr>
+              <a:t>▸</a:t>
+            </a:r>
+          </a:p>
+        </p:txBody>
+      </p:sp>
+      <p:sp>
+        <p:nvSpPr>
+          <p:cNvPr id="36" name="Rounded Rectangle 35"/>
+          <p:cNvSpPr/>
+          <p:nvPr/>
+        </p:nvSpPr>
+        <p:spPr>
+          <a:xfrm>
+            <a:off x="8413785" y="2395728"/>
+            <a:ext cx="728907" cy="457200"/>
           </a:xfrm>
           <a:prstGeom prst="roundRect">
             <a:avLst/>
@@ -4935,7 +5066,7 @@
           </a:fontRef>
         </p:style>
         <p:txBody>
-          <a:bodyPr rtlCol="0" anchor="ctr" wrap="square" lIns="36576" rIns="36576" tIns="9144" bIns="9144"/>
+          <a:bodyPr rtlCol="0" anchor="ctr" wrap="square" lIns="27432" rIns="27432" tIns="9144" bIns="9144"/>
           <a:lstStyle/>
           <a:p>
             <a:pPr algn="ctr">
@@ -4950,27 +5081,182 @@
               </a:spcAft>
             </a:pPr>
             <a:r>
-              <a:rPr sz="850" b="1">
-                <a:solidFill>
-                  <a:srgbClr val="5B3BBF"/>
+              <a:rPr sz="830" b="0">
+                <a:solidFill>
+                  <a:srgbClr val="1A1D21"/>
                 </a:solidFill>
                 <a:latin typeface="맑은 고딕"/>
               </a:rPr>
-              <a:t>③룰엔진(결정적)</a:t>
-            </a:r>
-          </a:p>
-        </p:txBody>
-      </p:sp>
-      <p:sp>
-        <p:nvSpPr>
-          <p:cNvPr id="34" name="Rounded Rectangle 33"/>
+              <a:t>④LLM 심의</a:t>
+            </a:r>
+          </a:p>
+        </p:txBody>
+      </p:sp>
+      <p:sp>
+        <p:nvSpPr>
+          <p:cNvPr id="37" name="TextBox 36"/>
+          <p:cNvSpPr txBox="1"/>
+          <p:nvPr/>
+        </p:nvSpPr>
+        <p:spPr>
+          <a:xfrm>
+            <a:off x="9106116" y="2395728"/>
+            <a:ext cx="109728" cy="457200"/>
+          </a:xfrm>
+          <a:prstGeom prst="rect">
+            <a:avLst/>
+          </a:prstGeom>
+          <a:noFill/>
+        </p:spPr>
+        <p:txBody>
+          <a:bodyPr wrap="square" anchor="ctr" lIns="0" rIns="0" tIns="9144" bIns="9144">
+            <a:spAutoFit/>
+          </a:bodyPr>
+          <a:lstStyle/>
+          <a:p>
+            <a:pPr algn="ctr">
+              <a:lnSpc>
+                <a:spcPct val="100000"/>
+              </a:lnSpc>
+              <a:spcBef>
+                <a:spcPts val="0"/>
+              </a:spcBef>
+              <a:spcAft>
+                <a:spcPts val="0"/>
+              </a:spcAft>
+            </a:pPr>
+            <a:r>
+              <a:rPr sz="800" b="1">
+                <a:solidFill>
+                  <a:srgbClr val="5B6470"/>
+                </a:solidFill>
+                <a:latin typeface="맑은 고딕"/>
+              </a:rPr>
+              <a:t>▸</a:t>
+            </a:r>
+          </a:p>
+        </p:txBody>
+      </p:sp>
+      <p:sp>
+        <p:nvSpPr>
+          <p:cNvPr id="38" name="Rounded Rectangle 37"/>
           <p:cNvSpPr/>
           <p:nvPr/>
         </p:nvSpPr>
         <p:spPr>
           <a:xfrm>
-            <a:off x="6547104" y="4279392"/>
-            <a:ext cx="1197864" cy="438912"/>
+            <a:off x="9206700" y="2395728"/>
+            <a:ext cx="728907" cy="457200"/>
+          </a:xfrm>
+          <a:prstGeom prst="roundRect">
+            <a:avLst/>
+          </a:prstGeom>
+          <a:solidFill>
+            <a:srgbClr val="F0ECFF"/>
+          </a:solidFill>
+          <a:ln w="9525">
+            <a:solidFill>
+              <a:srgbClr val="CDBFF0"/>
+            </a:solidFill>
+          </a:ln>
+          <a:effectLst/>
+        </p:spPr>
+        <p:style>
+          <a:lnRef idx="1">
+            <a:schemeClr val="accent1"/>
+          </a:lnRef>
+          <a:fillRef idx="3">
+            <a:schemeClr val="accent1"/>
+          </a:fillRef>
+          <a:effectRef idx="2">
+            <a:schemeClr val="accent1"/>
+          </a:effectRef>
+          <a:fontRef idx="minor">
+            <a:schemeClr val="lt1"/>
+          </a:fontRef>
+        </p:style>
+        <p:txBody>
+          <a:bodyPr rtlCol="0" anchor="ctr" wrap="square" lIns="27432" rIns="27432" tIns="9144" bIns="9144"/>
+          <a:lstStyle/>
+          <a:p>
+            <a:pPr algn="ctr">
+              <a:lnSpc>
+                <a:spcPct val="100000"/>
+              </a:lnSpc>
+              <a:spcBef>
+                <a:spcPts val="0"/>
+              </a:spcBef>
+              <a:spcAft>
+                <a:spcPts val="0"/>
+              </a:spcAft>
+            </a:pPr>
+            <a:r>
+              <a:rPr sz="830" b="1">
+                <a:solidFill>
+                  <a:srgbClr val="5B3BBF"/>
+                </a:solidFill>
+                <a:latin typeface="맑은 고딕"/>
+              </a:rPr>
+              <a:t>⑤시뮬레이터</a:t>
+            </a:r>
+          </a:p>
+        </p:txBody>
+      </p:sp>
+      <p:sp>
+        <p:nvSpPr>
+          <p:cNvPr id="39" name="TextBox 38"/>
+          <p:cNvSpPr txBox="1"/>
+          <p:nvPr/>
+        </p:nvSpPr>
+        <p:spPr>
+          <a:xfrm>
+            <a:off x="9899031" y="2395728"/>
+            <a:ext cx="109728" cy="457200"/>
+          </a:xfrm>
+          <a:prstGeom prst="rect">
+            <a:avLst/>
+          </a:prstGeom>
+          <a:noFill/>
+        </p:spPr>
+        <p:txBody>
+          <a:bodyPr wrap="square" anchor="ctr" lIns="0" rIns="0" tIns="9144" bIns="9144">
+            <a:spAutoFit/>
+          </a:bodyPr>
+          <a:lstStyle/>
+          <a:p>
+            <a:pPr algn="ctr">
+              <a:lnSpc>
+                <a:spcPct val="100000"/>
+              </a:lnSpc>
+              <a:spcBef>
+                <a:spcPts val="0"/>
+              </a:spcBef>
+              <a:spcAft>
+                <a:spcPts val="0"/>
+              </a:spcAft>
+            </a:pPr>
+            <a:r>
+              <a:rPr sz="800" b="1">
+                <a:solidFill>
+                  <a:srgbClr val="5B6470"/>
+                </a:solidFill>
+                <a:latin typeface="맑은 고딕"/>
+              </a:rPr>
+              <a:t>▸</a:t>
+            </a:r>
+          </a:p>
+        </p:txBody>
+      </p:sp>
+      <p:sp>
+        <p:nvSpPr>
+          <p:cNvPr id="40" name="Rounded Rectangle 39"/>
+          <p:cNvSpPr/>
+          <p:nvPr/>
+        </p:nvSpPr>
+        <p:spPr>
+          <a:xfrm>
+            <a:off x="9999615" y="2395728"/>
+            <a:ext cx="728907" cy="457200"/>
           </a:xfrm>
           <a:prstGeom prst="roundRect">
             <a:avLst/>
@@ -5000,7 +5286,7 @@
           </a:fontRef>
         </p:style>
         <p:txBody>
-          <a:bodyPr rtlCol="0" anchor="ctr" wrap="square" lIns="36576" rIns="36576" tIns="9144" bIns="9144"/>
+          <a:bodyPr rtlCol="0" anchor="ctr" wrap="square" lIns="27432" rIns="27432" tIns="9144" bIns="9144"/>
           <a:lstStyle/>
           <a:p>
             <a:pPr algn="ctr">
@@ -5015,27 +5301,72 @@
               </a:spcAft>
             </a:pPr>
             <a:r>
-              <a:rPr sz="850" b="0">
+              <a:rPr sz="830" b="0">
                 <a:solidFill>
                   <a:srgbClr val="1A1D21"/>
                 </a:solidFill>
                 <a:latin typeface="맑은 고딕"/>
               </a:rPr>
-              <a:t>④LLM 뉘앙스 심의</a:t>
-            </a:r>
-          </a:p>
-        </p:txBody>
-      </p:sp>
-      <p:sp>
-        <p:nvSpPr>
-          <p:cNvPr id="35" name="Rounded Rectangle 34"/>
+              <a:t>⑥리포트</a:t>
+            </a:r>
+          </a:p>
+        </p:txBody>
+      </p:sp>
+      <p:sp>
+        <p:nvSpPr>
+          <p:cNvPr id="41" name="TextBox 40"/>
+          <p:cNvSpPr txBox="1"/>
+          <p:nvPr/>
+        </p:nvSpPr>
+        <p:spPr>
+          <a:xfrm>
+            <a:off x="10691946" y="2395728"/>
+            <a:ext cx="109728" cy="457200"/>
+          </a:xfrm>
+          <a:prstGeom prst="rect">
+            <a:avLst/>
+          </a:prstGeom>
+          <a:noFill/>
+        </p:spPr>
+        <p:txBody>
+          <a:bodyPr wrap="square" anchor="ctr" lIns="0" rIns="0" tIns="9144" bIns="9144">
+            <a:spAutoFit/>
+          </a:bodyPr>
+          <a:lstStyle/>
+          <a:p>
+            <a:pPr algn="ctr">
+              <a:lnSpc>
+                <a:spcPct val="100000"/>
+              </a:lnSpc>
+              <a:spcBef>
+                <a:spcPts val="0"/>
+              </a:spcBef>
+              <a:spcAft>
+                <a:spcPts val="0"/>
+              </a:spcAft>
+            </a:pPr>
+            <a:r>
+              <a:rPr sz="800" b="1">
+                <a:solidFill>
+                  <a:srgbClr val="5B6470"/>
+                </a:solidFill>
+                <a:latin typeface="맑은 고딕"/>
+              </a:rPr>
+              <a:t>▸</a:t>
+            </a:r>
+          </a:p>
+        </p:txBody>
+      </p:sp>
+      <p:sp>
+        <p:nvSpPr>
+          <p:cNvPr id="42" name="Rounded Rectangle 41"/>
           <p:cNvSpPr/>
           <p:nvPr/>
         </p:nvSpPr>
         <p:spPr>
           <a:xfrm>
-            <a:off x="7827264" y="4279392"/>
-            <a:ext cx="1197864" cy="438912"/>
+            <a:off x="10792530" y="2395728"/>
+            <a:ext cx="728907" cy="457200"/>
           </a:xfrm>
           <a:prstGeom prst="roundRect">
             <a:avLst/>
@@ -5065,7 +5396,7 @@
           </a:fontRef>
         </p:style>
         <p:txBody>
-          <a:bodyPr rtlCol="0" anchor="ctr" wrap="square" lIns="36576" rIns="36576" tIns="9144" bIns="9144"/>
+          <a:bodyPr rtlCol="0" anchor="ctr" wrap="square" lIns="27432" rIns="27432" tIns="9144" bIns="9144"/>
           <a:lstStyle/>
           <a:p>
             <a:pPr algn="ctr">
@@ -5080,33 +5411,33 @@
               </a:spcAft>
             </a:pPr>
             <a:r>
-              <a:rPr sz="850" b="1">
-                <a:solidFill>
-                  <a:srgbClr val="5B3BBF"/>
+              <a:rPr sz="830" b="0">
+                <a:solidFill>
+                  <a:srgbClr val="1A1D21"/>
                 </a:solidFill>
                 <a:latin typeface="맑은 고딕"/>
               </a:rPr>
-              <a:t>⑤★오인 시뮬레이터</a:t>
-            </a:r>
-          </a:p>
-        </p:txBody>
-      </p:sp>
-      <p:sp>
-        <p:nvSpPr>
-          <p:cNvPr id="36" name="Rounded Rectangle 35"/>
+              <a:t>⑦⑧승인·감사</a:t>
+            </a:r>
+          </a:p>
+        </p:txBody>
+      </p:sp>
+      <p:sp>
+        <p:nvSpPr>
+          <p:cNvPr id="43" name="Rounded Rectangle 42"/>
           <p:cNvSpPr/>
           <p:nvPr/>
         </p:nvSpPr>
         <p:spPr>
           <a:xfrm>
-            <a:off x="9107424" y="4279392"/>
-            <a:ext cx="1197864" cy="438912"/>
+            <a:off x="6035040" y="2962656"/>
+            <a:ext cx="3017520" cy="402336"/>
           </a:xfrm>
           <a:prstGeom prst="roundRect">
             <a:avLst/>
           </a:prstGeom>
           <a:solidFill>
-            <a:srgbClr val="FFFFFF"/>
+            <a:srgbClr val="F0ECFF"/>
           </a:solidFill>
           <a:ln w="9525">
             <a:solidFill>
@@ -5130,137 +5461,7 @@
           </a:fontRef>
         </p:style>
         <p:txBody>
-          <a:bodyPr rtlCol="0" anchor="ctr" wrap="square" lIns="36576" rIns="36576" tIns="9144" bIns="9144"/>
-          <a:lstStyle/>
-          <a:p>
-            <a:pPr algn="ctr">
-              <a:lnSpc>
-                <a:spcPct val="100000"/>
-              </a:lnSpc>
-              <a:spcBef>
-                <a:spcPts val="0"/>
-              </a:spcBef>
-              <a:spcAft>
-                <a:spcPts val="0"/>
-              </a:spcAft>
-            </a:pPr>
-            <a:r>
-              <a:rPr sz="850" b="0">
-                <a:solidFill>
-                  <a:srgbClr val="1A1D21"/>
-                </a:solidFill>
-                <a:latin typeface="맑은 고딕"/>
-              </a:rPr>
-              <a:t>⑥리포트·점수</a:t>
-            </a:r>
-          </a:p>
-        </p:txBody>
-      </p:sp>
-      <p:sp>
-        <p:nvSpPr>
-          <p:cNvPr id="37" name="Rounded Rectangle 36"/>
-          <p:cNvSpPr/>
-          <p:nvPr/>
-        </p:nvSpPr>
-        <p:spPr>
-          <a:xfrm>
-            <a:off x="10387584" y="4279392"/>
-            <a:ext cx="1197864" cy="438912"/>
-          </a:xfrm>
-          <a:prstGeom prst="roundRect">
-            <a:avLst/>
-          </a:prstGeom>
-          <a:solidFill>
-            <a:srgbClr val="FFFFFF"/>
-          </a:solidFill>
-          <a:ln w="9525">
-            <a:solidFill>
-              <a:srgbClr val="CDBFF0"/>
-            </a:solidFill>
-          </a:ln>
-          <a:effectLst/>
-        </p:spPr>
-        <p:style>
-          <a:lnRef idx="1">
-            <a:schemeClr val="accent1"/>
-          </a:lnRef>
-          <a:fillRef idx="3">
-            <a:schemeClr val="accent1"/>
-          </a:fillRef>
-          <a:effectRef idx="2">
-            <a:schemeClr val="accent1"/>
-          </a:effectRef>
-          <a:fontRef idx="minor">
-            <a:schemeClr val="lt1"/>
-          </a:fontRef>
-        </p:style>
-        <p:txBody>
-          <a:bodyPr rtlCol="0" anchor="ctr" wrap="square" lIns="36576" rIns="36576" tIns="9144" bIns="9144"/>
-          <a:lstStyle/>
-          <a:p>
-            <a:pPr algn="ctr">
-              <a:lnSpc>
-                <a:spcPct val="100000"/>
-              </a:lnSpc>
-              <a:spcBef>
-                <a:spcPts val="0"/>
-              </a:spcBef>
-              <a:spcAft>
-                <a:spcPts val="0"/>
-              </a:spcAft>
-            </a:pPr>
-            <a:r>
-              <a:rPr sz="850" b="0">
-                <a:solidFill>
-                  <a:srgbClr val="1A1D21"/>
-                </a:solidFill>
-                <a:latin typeface="맑은 고딕"/>
-              </a:rPr>
-              <a:t>⑦⑧승인·감사</a:t>
-            </a:r>
-          </a:p>
-        </p:txBody>
-      </p:sp>
-      <p:sp>
-        <p:nvSpPr>
-          <p:cNvPr id="38" name="Rounded Rectangle 37"/>
-          <p:cNvSpPr/>
-          <p:nvPr/>
-        </p:nvSpPr>
-        <p:spPr>
-          <a:xfrm>
-            <a:off x="2706624" y="4800600"/>
-            <a:ext cx="4754880" cy="420624"/>
-          </a:xfrm>
-          <a:prstGeom prst="roundRect">
-            <a:avLst/>
-          </a:prstGeom>
-          <a:solidFill>
-            <a:srgbClr val="F7F4FF"/>
-          </a:solidFill>
-          <a:ln w="9525">
-            <a:solidFill>
-              <a:srgbClr val="CDBFF0"/>
-            </a:solidFill>
-          </a:ln>
-          <a:effectLst/>
-        </p:spPr>
-        <p:style>
-          <a:lnRef idx="1">
-            <a:schemeClr val="accent1"/>
-          </a:lnRef>
-          <a:fillRef idx="3">
-            <a:schemeClr val="accent1"/>
-          </a:fillRef>
-          <a:effectRef idx="2">
-            <a:schemeClr val="accent1"/>
-          </a:effectRef>
-          <a:fontRef idx="minor">
-            <a:schemeClr val="lt1"/>
-          </a:fontRef>
-        </p:style>
-        <p:txBody>
-          <a:bodyPr rtlCol="0" anchor="ctr" wrap="square" lIns="109728" rIns="109728" tIns="9144" bIns="9144"/>
+          <a:bodyPr rtlCol="0" anchor="ctr" wrap="square" tIns="9144" bIns="9144"/>
           <a:lstStyle/>
           <a:p>
             <a:pPr algn="l">
@@ -5275,7 +5476,7 @@
               </a:spcAft>
             </a:pPr>
             <a:r>
-              <a:rPr sz="950" b="1">
+              <a:rPr sz="900" b="1">
                 <a:solidFill>
                   <a:srgbClr val="5B3BBF"/>
                 </a:solidFill>
@@ -5284,27 +5485,27 @@
               <a:t>★준법 오토파일럿</a:t>
             </a:r>
             <a:r>
-              <a:rPr sz="850" b="0">
+              <a:rPr sz="800" b="0">
                 <a:solidFill>
                   <a:srgbClr val="5B6470"/>
                 </a:solidFill>
                 <a:latin typeface="맑은 고딕"/>
               </a:rPr>
-              <a:t> — 판단→고쳐쓰기→재심의 자율 루프(통과까지)</a:t>
-            </a:r>
-          </a:p>
-        </p:txBody>
-      </p:sp>
-      <p:sp>
-        <p:nvSpPr>
-          <p:cNvPr id="39" name="Rounded Rectangle 38"/>
+              <a:t> 자율 개선 루프</a:t>
+            </a:r>
+          </a:p>
+        </p:txBody>
+      </p:sp>
+      <p:sp>
+        <p:nvSpPr>
+          <p:cNvPr id="44" name="Rounded Rectangle 43"/>
           <p:cNvSpPr/>
           <p:nvPr/>
         </p:nvSpPr>
         <p:spPr>
           <a:xfrm>
-            <a:off x="7589520" y="4800600"/>
-            <a:ext cx="1920240" cy="420624"/>
+            <a:off x="9144000" y="2962656"/>
+            <a:ext cx="1325880" cy="402336"/>
           </a:xfrm>
           <a:prstGeom prst="roundRect">
             <a:avLst/>
@@ -5334,7 +5535,7 @@
           </a:fontRef>
         </p:style>
         <p:txBody>
-          <a:bodyPr rtlCol="0" anchor="ctr" wrap="square" lIns="45720" rIns="45720" tIns="9144" bIns="9144"/>
+          <a:bodyPr rtlCol="0" anchor="ctr" wrap="square" lIns="27432" rIns="27432" tIns="9144" bIns="9144"/>
           <a:lstStyle/>
           <a:p>
             <a:pPr algn="ctr">
@@ -5349,13 +5550,13 @@
               </a:spcAft>
             </a:pPr>
             <a:r>
-              <a:rPr sz="900" b="1">
+              <a:rPr sz="850" b="1">
                 <a:solidFill>
                   <a:srgbClr val="003A6E"/>
                 </a:solidFill>
                 <a:latin typeface="맑은 고딕"/>
               </a:rPr>
-              <a:t>🤖 Ollama · Qwen2.5-7B</a:t>
+              <a:t>🤖 Ollama</a:t>
             </a:r>
           </a:p>
           <a:p>
@@ -5371,27 +5572,27 @@
               </a:spcAft>
             </a:pPr>
             <a:r>
-              <a:rPr sz="800" b="0">
+              <a:rPr sz="750" b="0">
                 <a:solidFill>
                   <a:srgbClr val="5B6470"/>
                 </a:solidFill>
                 <a:latin typeface="맑은 고딕"/>
               </a:rPr>
-              <a:t>LLM 추론</a:t>
-            </a:r>
-          </a:p>
-        </p:txBody>
-      </p:sp>
-      <p:sp>
-        <p:nvSpPr>
-          <p:cNvPr id="40" name="Rounded Rectangle 39"/>
+              <a:t>Qwen2.5-7B</a:t>
+            </a:r>
+          </a:p>
+        </p:txBody>
+      </p:sp>
+      <p:sp>
+        <p:nvSpPr>
+          <p:cNvPr id="45" name="Rounded Rectangle 44"/>
           <p:cNvSpPr/>
           <p:nvPr/>
         </p:nvSpPr>
         <p:spPr>
           <a:xfrm>
-            <a:off x="9601200" y="4800600"/>
-            <a:ext cx="1984248" cy="420624"/>
+            <a:off x="10561320" y="2962656"/>
+            <a:ext cx="960120" cy="402336"/>
           </a:xfrm>
           <a:prstGeom prst="roundRect">
             <a:avLst/>
@@ -5421,7 +5622,7 @@
           </a:fontRef>
         </p:style>
         <p:txBody>
-          <a:bodyPr rtlCol="0" anchor="ctr" wrap="square" lIns="45720" rIns="45720" tIns="9144" bIns="9144"/>
+          <a:bodyPr rtlCol="0" anchor="ctr" wrap="square" lIns="27432" rIns="27432" tIns="9144" bIns="9144"/>
           <a:lstStyle/>
           <a:p>
             <a:pPr algn="ctr">
@@ -5436,13 +5637,13 @@
               </a:spcAft>
             </a:pPr>
             <a:r>
-              <a:rPr sz="900" b="1">
+              <a:rPr sz="850" b="1">
                 <a:solidFill>
                   <a:srgbClr val="003A6E"/>
                 </a:solidFill>
                 <a:latin typeface="맑은 고딕"/>
               </a:rPr>
-              <a:t>🔎 BGE-m3 임베딩</a:t>
+              <a:t>🔎 BGE-m3</a:t>
             </a:r>
           </a:p>
           <a:p>
@@ -5458,33 +5659,78 @@
               </a:spcAft>
             </a:pPr>
             <a:r>
-              <a:rPr sz="800" b="0">
+              <a:rPr sz="750" b="0">
                 <a:solidFill>
                   <a:srgbClr val="5B6470"/>
                 </a:solidFill>
                 <a:latin typeface="맑은 고딕"/>
               </a:rPr>
-              <a:t>RAG (선택)</a:t>
-            </a:r>
-          </a:p>
-        </p:txBody>
-      </p:sp>
-      <p:sp>
-        <p:nvSpPr>
-          <p:cNvPr id="41" name="Down Arrow 40"/>
+              <a:t>임베딩(선택)</a:t>
+            </a:r>
+          </a:p>
+        </p:txBody>
+      </p:sp>
+      <p:sp>
+        <p:nvSpPr>
+          <p:cNvPr id="46" name="TextBox 45"/>
+          <p:cNvSpPr txBox="1"/>
+          <p:nvPr/>
+        </p:nvSpPr>
+        <p:spPr>
+          <a:xfrm>
+            <a:off x="6035040" y="3438143"/>
+            <a:ext cx="5486400" cy="201168"/>
+          </a:xfrm>
+          <a:prstGeom prst="rect">
+            <a:avLst/>
+          </a:prstGeom>
+          <a:noFill/>
+        </p:spPr>
+        <p:txBody>
+          <a:bodyPr wrap="square" anchor="t" lIns="0" rIns="0" tIns="9144" bIns="9144">
+            <a:spAutoFit/>
+          </a:bodyPr>
+          <a:lstStyle/>
+          <a:p>
+            <a:pPr algn="l">
+              <a:lnSpc>
+                <a:spcPct val="100000"/>
+              </a:lnSpc>
+              <a:spcBef>
+                <a:spcPts val="0"/>
+              </a:spcBef>
+              <a:spcAft>
+                <a:spcPts val="0"/>
+              </a:spcAft>
+            </a:pPr>
+            <a:r>
+              <a:rPr sz="800" b="0">
+                <a:solidFill>
+                  <a:srgbClr val="5B6470"/>
+                </a:solidFill>
+                <a:latin typeface="맑은 고딕"/>
+              </a:rPr>
+              <a:t>인용은 검색된 조항으로 제한 · 룰엔진=결정적 등급 권위 · LLM=보조</a:t>
+            </a:r>
+          </a:p>
+        </p:txBody>
+      </p:sp>
+      <p:sp>
+        <p:nvSpPr>
+          <p:cNvPr id="47" name="Down Arrow 46"/>
           <p:cNvSpPr/>
           <p:nvPr/>
         </p:nvSpPr>
         <p:spPr>
           <a:xfrm>
-            <a:off x="7022592" y="5321808"/>
-            <a:ext cx="219456" cy="146304"/>
+            <a:off x="6830568" y="4663440"/>
+            <a:ext cx="237744" cy="365760"/>
           </a:xfrm>
           <a:prstGeom prst="downArrow">
             <a:avLst/>
           </a:prstGeom>
           <a:solidFill>
-            <a:srgbClr val="AAB4C0"/>
+            <a:srgbClr val="8AA0B5"/>
           </a:solidFill>
           <a:ln>
             <a:noFill/>
@@ -5515,14 +5761,14 @@
       </p:sp>
       <p:sp>
         <p:nvSpPr>
-          <p:cNvPr id="42" name="TextBox 41"/>
+          <p:cNvPr id="48" name="TextBox 47"/>
           <p:cNvSpPr txBox="1"/>
           <p:nvPr/>
         </p:nvSpPr>
         <p:spPr>
           <a:xfrm>
-            <a:off x="7315200" y="5303520"/>
-            <a:ext cx="2743200" cy="146304"/>
+            <a:off x="7114032" y="4663440"/>
+            <a:ext cx="2286000" cy="365760"/>
           </a:xfrm>
           <a:prstGeom prst="rect">
             <a:avLst/>
@@ -5547,29 +5793,118 @@
               </a:spcAft>
             </a:pPr>
             <a:r>
-              <a:rPr sz="850" b="0">
+              <a:rPr sz="850" b="1">
                 <a:solidFill>
                   <a:srgbClr val="5B6470"/>
                 </a:solidFill>
                 <a:latin typeface="맑은 고딕"/>
               </a:rPr>
-              <a:t>조회 · 기록</a:t>
-            </a:r>
-          </a:p>
-        </p:txBody>
-      </p:sp>
-      <p:sp>
-        <p:nvSpPr>
-          <p:cNvPr id="43" name="Rounded Rectangle 42"/>
+              <a:t>조회·기록</a:t>
+            </a:r>
+          </a:p>
+        </p:txBody>
+      </p:sp>
+      <p:sp>
+        <p:nvSpPr>
+          <p:cNvPr id="49" name="Down Arrow 48"/>
           <p:cNvSpPr/>
           <p:nvPr/>
         </p:nvSpPr>
         <p:spPr>
           <a:xfrm>
-            <a:off x="457200" y="5486400"/>
-            <a:ext cx="1965960" cy="859536"/>
-          </a:xfrm>
-          <a:prstGeom prst="roundRect">
+            <a:off x="10213848" y="4663440"/>
+            <a:ext cx="237744" cy="365760"/>
+          </a:xfrm>
+          <a:prstGeom prst="downArrow">
+            <a:avLst/>
+          </a:prstGeom>
+          <a:solidFill>
+            <a:srgbClr val="8AA0B5"/>
+          </a:solidFill>
+          <a:ln>
+            <a:noFill/>
+          </a:ln>
+          <a:effectLst/>
+        </p:spPr>
+        <p:style>
+          <a:lnRef idx="1">
+            <a:schemeClr val="accent1"/>
+          </a:lnRef>
+          <a:fillRef idx="3">
+            <a:schemeClr val="accent1"/>
+          </a:fillRef>
+          <a:effectRef idx="2">
+            <a:schemeClr val="accent1"/>
+          </a:effectRef>
+          <a:fontRef idx="minor">
+            <a:schemeClr val="lt1"/>
+          </a:fontRef>
+        </p:style>
+        <p:txBody>
+          <a:bodyPr rtlCol="0" anchor="ctr"/>
+          <a:lstStyle/>
+          <a:p>
+            <a:pPr algn="ctr"/>
+          </a:p>
+        </p:txBody>
+      </p:sp>
+      <p:sp>
+        <p:nvSpPr>
+          <p:cNvPr id="50" name="TextBox 49"/>
+          <p:cNvSpPr txBox="1"/>
+          <p:nvPr/>
+        </p:nvSpPr>
+        <p:spPr>
+          <a:xfrm>
+            <a:off x="10497312" y="4663440"/>
+            <a:ext cx="2286000" cy="365760"/>
+          </a:xfrm>
+          <a:prstGeom prst="rect">
+            <a:avLst/>
+          </a:prstGeom>
+          <a:noFill/>
+        </p:spPr>
+        <p:txBody>
+          <a:bodyPr wrap="square" anchor="ctr" lIns="0" rIns="0" tIns="9144" bIns="9144">
+            <a:spAutoFit/>
+          </a:bodyPr>
+          <a:lstStyle/>
+          <a:p>
+            <a:pPr algn="l">
+              <a:lnSpc>
+                <a:spcPct val="100000"/>
+              </a:lnSpc>
+              <a:spcBef>
+                <a:spcPts val="0"/>
+              </a:spcBef>
+              <a:spcAft>
+                <a:spcPts val="0"/>
+              </a:spcAft>
+            </a:pPr>
+            <a:r>
+              <a:rPr sz="850" b="1">
+                <a:solidFill>
+                  <a:srgbClr val="5B6470"/>
+                </a:solidFill>
+                <a:latin typeface="맑은 고딕"/>
+              </a:rPr>
+              <a:t>연동</a:t>
+            </a:r>
+          </a:p>
+        </p:txBody>
+      </p:sp>
+      <p:sp>
+        <p:nvSpPr>
+          <p:cNvPr id="51" name="Can 50"/>
+          <p:cNvSpPr/>
+          <p:nvPr/>
+        </p:nvSpPr>
+        <p:spPr>
+          <a:xfrm>
+            <a:off x="5806440" y="5120640"/>
+            <a:ext cx="1554480" cy="1188720"/>
+          </a:xfrm>
+          <a:prstGeom prst="can">
             <a:avLst/>
           </a:prstGeom>
           <a:solidFill>
@@ -5610,38 +5945,80 @@
               </a:spcAft>
             </a:pPr>
             <a:r>
-              <a:rPr sz="1250" b="1">
+              <a:rPr sz="950" b="1">
                 <a:solidFill>
                   <a:srgbClr val="FFFFFF"/>
                 </a:solidFill>
                 <a:latin typeface="맑은 고딕"/>
               </a:rPr>
-              <a:t>🗄 DB/외부연동</a:t>
-            </a:r>
-          </a:p>
-        </p:txBody>
-      </p:sp>
-      <p:sp>
-        <p:nvSpPr>
-          <p:cNvPr id="44" name="Rounded Rectangle 43"/>
+              <a:t>🗄 SQLite</a:t>
+            </a:r>
+          </a:p>
+          <a:p>
+            <a:pPr algn="ctr">
+              <a:lnSpc>
+                <a:spcPct val="100000"/>
+              </a:lnSpc>
+              <a:spcBef>
+                <a:spcPts val="0"/>
+              </a:spcBef>
+              <a:spcAft>
+                <a:spcPts val="0"/>
+              </a:spcAft>
+            </a:pPr>
+            <a:r>
+              <a:rPr sz="750" b="0">
+                <a:solidFill>
+                  <a:srgbClr val="DFE6F0"/>
+                </a:solidFill>
+                <a:latin typeface="맑은 고딕"/>
+              </a:rPr>
+              <a:t>승인·감사로그</a:t>
+            </a:r>
+          </a:p>
+          <a:p>
+            <a:pPr algn="ctr">
+              <a:lnSpc>
+                <a:spcPct val="100000"/>
+              </a:lnSpc>
+              <a:spcBef>
+                <a:spcPts val="0"/>
+              </a:spcBef>
+              <a:spcAft>
+                <a:spcPts val="0"/>
+              </a:spcAft>
+            </a:pPr>
+            <a:r>
+              <a:rPr sz="750" b="0">
+                <a:solidFill>
+                  <a:srgbClr val="DFE6F0"/>
+                </a:solidFill>
+                <a:latin typeface="맑은 고딕"/>
+              </a:rPr>
+              <a:t>내규·배포</a:t>
+            </a:r>
+          </a:p>
+        </p:txBody>
+      </p:sp>
+      <p:sp>
+        <p:nvSpPr>
+          <p:cNvPr id="52" name="Can 51"/>
           <p:cNvSpPr/>
           <p:nvPr/>
         </p:nvSpPr>
         <p:spPr>
           <a:xfrm>
-            <a:off x="2560320" y="5486400"/>
-            <a:ext cx="4480560" cy="384048"/>
-          </a:xfrm>
-          <a:prstGeom prst="roundRect">
+            <a:off x="7498079" y="5120640"/>
+            <a:ext cx="1554480" cy="1188720"/>
+          </a:xfrm>
+          <a:prstGeom prst="can">
             <a:avLst/>
           </a:prstGeom>
           <a:solidFill>
-            <a:srgbClr val="EEF2F8"/>
+            <a:srgbClr val="2A6099"/>
           </a:solidFill>
-          <a:ln w="9525">
-            <a:solidFill>
-              <a:srgbClr val="D8DEE6"/>
-            </a:solidFill>
+          <a:ln>
+            <a:noFill/>
           </a:ln>
           <a:effectLst/>
         </p:spPr>
@@ -5660,7 +6037,349 @@
           </a:fontRef>
         </p:style>
         <p:txBody>
-          <a:bodyPr rtlCol="0" anchor="ctr" wrap="square" lIns="109728" rIns="109728" tIns="9144" bIns="9144"/>
+          <a:bodyPr rtlCol="0" anchor="ctr" wrap="square" lIns="64008" rIns="64008" tIns="9144" bIns="9144"/>
+          <a:lstStyle/>
+          <a:p>
+            <a:pPr algn="ctr">
+              <a:lnSpc>
+                <a:spcPct val="100000"/>
+              </a:lnSpc>
+              <a:spcBef>
+                <a:spcPts val="0"/>
+              </a:spcBef>
+              <a:spcAft>
+                <a:spcPts val="0"/>
+              </a:spcAft>
+            </a:pPr>
+            <a:r>
+              <a:rPr sz="950" b="1">
+                <a:solidFill>
+                  <a:srgbClr val="FFFFFF"/>
+                </a:solidFill>
+                <a:latin typeface="맑은 고딕"/>
+              </a:rPr>
+              <a:t>📚 규제 KB</a:t>
+            </a:r>
+          </a:p>
+          <a:p>
+            <a:pPr algn="ctr">
+              <a:lnSpc>
+                <a:spcPct val="100000"/>
+              </a:lnSpc>
+              <a:spcBef>
+                <a:spcPts val="0"/>
+              </a:spcBef>
+              <a:spcAft>
+                <a:spcPts val="0"/>
+              </a:spcAft>
+            </a:pPr>
+            <a:r>
+              <a:rPr sz="700" b="0">
+                <a:solidFill>
+                  <a:srgbClr val="DFE6F0"/>
+                </a:solidFill>
+                <a:latin typeface="맑은 고딕"/>
+              </a:rPr>
+              <a:t>regulations.json</a:t>
+            </a:r>
+          </a:p>
+          <a:p>
+            <a:pPr algn="ctr">
+              <a:lnSpc>
+                <a:spcPct val="100000"/>
+              </a:lnSpc>
+              <a:spcBef>
+                <a:spcPts val="0"/>
+              </a:spcBef>
+              <a:spcAft>
+                <a:spcPts val="0"/>
+              </a:spcAft>
+            </a:pPr>
+            <a:r>
+              <a:rPr sz="700" b="0">
+                <a:solidFill>
+                  <a:srgbClr val="DFE6F0"/>
+                </a:solidFill>
+                <a:latin typeface="맑은 고딕"/>
+              </a:rPr>
+              <a:t>rules.yaml</a:t>
+            </a:r>
+          </a:p>
+        </p:txBody>
+      </p:sp>
+      <p:sp>
+        <p:nvSpPr>
+          <p:cNvPr id="53" name="Cloud 52"/>
+          <p:cNvSpPr/>
+          <p:nvPr/>
+        </p:nvSpPr>
+        <p:spPr>
+          <a:xfrm>
+            <a:off x="9189720" y="4983480"/>
+            <a:ext cx="2560320" cy="1508760"/>
+          </a:xfrm>
+          <a:prstGeom prst="cloud">
+            <a:avLst/>
+          </a:prstGeom>
+          <a:solidFill>
+            <a:srgbClr val="FFF7E6"/>
+          </a:solidFill>
+          <a:ln w="15875">
+            <a:solidFill>
+              <a:srgbClr val="C78A06"/>
+            </a:solidFill>
+          </a:ln>
+          <a:effectLst/>
+        </p:spPr>
+        <p:style>
+          <a:lnRef idx="1">
+            <a:schemeClr val="accent1"/>
+          </a:lnRef>
+          <a:fillRef idx="3">
+            <a:schemeClr val="accent1"/>
+          </a:fillRef>
+          <a:effectRef idx="2">
+            <a:schemeClr val="accent1"/>
+          </a:effectRef>
+          <a:fontRef idx="minor">
+            <a:schemeClr val="lt1"/>
+          </a:fontRef>
+        </p:style>
+        <p:txBody>
+          <a:bodyPr rtlCol="0" anchor="ctr"/>
+          <a:lstStyle/>
+          <a:p>
+            <a:pPr algn="ctr"/>
+          </a:p>
+        </p:txBody>
+      </p:sp>
+      <p:sp>
+        <p:nvSpPr>
+          <p:cNvPr id="54" name="TextBox 53"/>
+          <p:cNvSpPr txBox="1"/>
+          <p:nvPr/>
+        </p:nvSpPr>
+        <p:spPr>
+          <a:xfrm>
+            <a:off x="9189720" y="5138928"/>
+            <a:ext cx="2560320" cy="219456"/>
+          </a:xfrm>
+          <a:prstGeom prst="rect">
+            <a:avLst/>
+          </a:prstGeom>
+          <a:noFill/>
+        </p:spPr>
+        <p:txBody>
+          <a:bodyPr wrap="square" anchor="t" lIns="0" rIns="0" tIns="9144" bIns="9144">
+            <a:spAutoFit/>
+          </a:bodyPr>
+          <a:lstStyle/>
+          <a:p>
+            <a:pPr algn="ctr">
+              <a:lnSpc>
+                <a:spcPct val="100000"/>
+              </a:lnSpc>
+              <a:spcBef>
+                <a:spcPts val="0"/>
+              </a:spcBef>
+              <a:spcAft>
+                <a:spcPts val="0"/>
+              </a:spcAft>
+            </a:pPr>
+            <a:r>
+              <a:rPr sz="950" b="1">
+                <a:solidFill>
+                  <a:srgbClr val="8A6200"/>
+                </a:solidFill>
+                <a:latin typeface="맑은 고딕"/>
+              </a:rPr>
+              <a:t>☁ 외부 연동 (어댑터)</a:t>
+            </a:r>
+          </a:p>
+        </p:txBody>
+      </p:sp>
+      <p:sp>
+        <p:nvSpPr>
+          <p:cNvPr id="55" name="TextBox 54"/>
+          <p:cNvSpPr txBox="1"/>
+          <p:nvPr/>
+        </p:nvSpPr>
+        <p:spPr>
+          <a:xfrm>
+            <a:off x="9326880" y="5394960"/>
+            <a:ext cx="2286000" cy="237744"/>
+          </a:xfrm>
+          <a:prstGeom prst="rect">
+            <a:avLst/>
+          </a:prstGeom>
+          <a:noFill/>
+        </p:spPr>
+        <p:txBody>
+          <a:bodyPr wrap="square" anchor="t" lIns="0" rIns="0" tIns="9144" bIns="9144">
+            <a:spAutoFit/>
+          </a:bodyPr>
+          <a:lstStyle/>
+          <a:p>
+            <a:pPr algn="ctr">
+              <a:lnSpc>
+                <a:spcPct val="100000"/>
+              </a:lnSpc>
+              <a:spcBef>
+                <a:spcPts val="0"/>
+              </a:spcBef>
+              <a:spcAft>
+                <a:spcPts val="0"/>
+              </a:spcAft>
+            </a:pPr>
+            <a:r>
+              <a:rPr sz="800" b="1">
+                <a:solidFill>
+                  <a:srgbClr val="6B4E00"/>
+                </a:solidFill>
+                <a:latin typeface="맑은 고딕"/>
+              </a:rPr>
+              <a:t>법제처 OpenAPI  </a:t>
+            </a:r>
+            <a:r>
+              <a:rPr sz="750" b="1">
+                <a:solidFill>
+                  <a:srgbClr val="C78A06"/>
+                </a:solidFill>
+                <a:latin typeface="맑은 고딕"/>
+              </a:rPr>
+              <a:t>F14</a:t>
+            </a:r>
+          </a:p>
+        </p:txBody>
+      </p:sp>
+      <p:sp>
+        <p:nvSpPr>
+          <p:cNvPr id="56" name="TextBox 55"/>
+          <p:cNvSpPr txBox="1"/>
+          <p:nvPr/>
+        </p:nvSpPr>
+        <p:spPr>
+          <a:xfrm>
+            <a:off x="9326880" y="5669280"/>
+            <a:ext cx="2286000" cy="237744"/>
+          </a:xfrm>
+          <a:prstGeom prst="rect">
+            <a:avLst/>
+          </a:prstGeom>
+          <a:noFill/>
+        </p:spPr>
+        <p:txBody>
+          <a:bodyPr wrap="square" anchor="t" lIns="0" rIns="0" tIns="9144" bIns="9144">
+            <a:spAutoFit/>
+          </a:bodyPr>
+          <a:lstStyle/>
+          <a:p>
+            <a:pPr algn="ctr">
+              <a:lnSpc>
+                <a:spcPct val="100000"/>
+              </a:lnSpc>
+              <a:spcBef>
+                <a:spcPts val="0"/>
+              </a:spcBef>
+              <a:spcAft>
+                <a:spcPts val="0"/>
+              </a:spcAft>
+            </a:pPr>
+            <a:r>
+              <a:rPr sz="800" b="1">
+                <a:solidFill>
+                  <a:srgbClr val="6B4E00"/>
+                </a:solidFill>
+                <a:latin typeface="맑은 고딕"/>
+              </a:rPr>
+              <a:t>FCM·SNS·알림톡  </a:t>
+            </a:r>
+            <a:r>
+              <a:rPr sz="750" b="1">
+                <a:solidFill>
+                  <a:srgbClr val="C78A06"/>
+                </a:solidFill>
+                <a:latin typeface="맑은 고딕"/>
+              </a:rPr>
+              <a:t>F15</a:t>
+            </a:r>
+          </a:p>
+        </p:txBody>
+      </p:sp>
+      <p:sp>
+        <p:nvSpPr>
+          <p:cNvPr id="57" name="TextBox 56"/>
+          <p:cNvSpPr txBox="1"/>
+          <p:nvPr/>
+        </p:nvSpPr>
+        <p:spPr>
+          <a:xfrm>
+            <a:off x="9326880" y="5943600"/>
+            <a:ext cx="2286000" cy="237744"/>
+          </a:xfrm>
+          <a:prstGeom prst="rect">
+            <a:avLst/>
+          </a:prstGeom>
+          <a:noFill/>
+        </p:spPr>
+        <p:txBody>
+          <a:bodyPr wrap="square" anchor="t" lIns="0" rIns="0" tIns="9144" bIns="9144">
+            <a:spAutoFit/>
+          </a:bodyPr>
+          <a:lstStyle/>
+          <a:p>
+            <a:pPr algn="ctr">
+              <a:lnSpc>
+                <a:spcPct val="100000"/>
+              </a:lnSpc>
+              <a:spcBef>
+                <a:spcPts val="0"/>
+              </a:spcBef>
+              <a:spcAft>
+                <a:spcPts val="0"/>
+              </a:spcAft>
+            </a:pPr>
+            <a:r>
+              <a:rPr sz="800" b="1">
+                <a:solidFill>
+                  <a:srgbClr val="6B4E00"/>
+                </a:solidFill>
+                <a:latin typeface="맑은 고딕"/>
+              </a:rPr>
+              <a:t>코어뱅킹 API  </a:t>
+            </a:r>
+            <a:r>
+              <a:rPr sz="750" b="1">
+                <a:solidFill>
+                  <a:srgbClr val="C78A06"/>
+                </a:solidFill>
+                <a:latin typeface="맑은 고딕"/>
+              </a:rPr>
+              <a:t>F16</a:t>
+            </a:r>
+          </a:p>
+        </p:txBody>
+      </p:sp>
+      <p:sp>
+        <p:nvSpPr>
+          <p:cNvPr id="58" name="TextBox 57"/>
+          <p:cNvSpPr txBox="1"/>
+          <p:nvPr/>
+        </p:nvSpPr>
+        <p:spPr>
+          <a:xfrm>
+            <a:off x="411480" y="6492240"/>
+            <a:ext cx="11338560" cy="274320"/>
+          </a:xfrm>
+          <a:prstGeom prst="rect">
+            <a:avLst/>
+          </a:prstGeom>
+          <a:noFill/>
+        </p:spPr>
+        <p:txBody>
+          <a:bodyPr wrap="square" anchor="t" lIns="0" rIns="0" tIns="9144" bIns="9144">
+            <a:spAutoFit/>
+          </a:bodyPr>
           <a:lstStyle/>
           <a:p>
             <a:pPr algn="l">
@@ -5675,552 +6394,13 @@
               </a:spcAft>
             </a:pPr>
             <a:r>
-              <a:rPr sz="950" b="1">
-                <a:solidFill>
-                  <a:srgbClr val="1A1D21"/>
+              <a:rPr sz="850" b="0">
+                <a:solidFill>
+                  <a:srgbClr val="5B6470"/>
                 </a:solidFill>
                 <a:latin typeface="맑은 고딕"/>
               </a:rPr>
-              <a:t>SQLite (store.py)</a:t>
-            </a:r>
-            <a:r>
-              <a:rPr sz="850" b="0">
-                <a:solidFill>
-                  <a:srgbClr val="5B6470"/>
-                </a:solidFill>
-                <a:latin typeface="맑은 고딕"/>
-              </a:rPr>
-              <a:t>  승인·감사로그·내규·배포 로그</a:t>
-            </a:r>
-          </a:p>
-        </p:txBody>
-      </p:sp>
-      <p:sp>
-        <p:nvSpPr>
-          <p:cNvPr id="45" name="Rounded Rectangle 44"/>
-          <p:cNvSpPr/>
-          <p:nvPr/>
-        </p:nvSpPr>
-        <p:spPr>
-          <a:xfrm>
-            <a:off x="7178040" y="5486400"/>
-            <a:ext cx="4553712" cy="384048"/>
-          </a:xfrm>
-          <a:prstGeom prst="roundRect">
-            <a:avLst/>
-          </a:prstGeom>
-          <a:solidFill>
-            <a:srgbClr val="EEF2F8"/>
-          </a:solidFill>
-          <a:ln w="9525">
-            <a:solidFill>
-              <a:srgbClr val="D8DEE6"/>
-            </a:solidFill>
-          </a:ln>
-          <a:effectLst/>
-        </p:spPr>
-        <p:style>
-          <a:lnRef idx="1">
-            <a:schemeClr val="accent1"/>
-          </a:lnRef>
-          <a:fillRef idx="3">
-            <a:schemeClr val="accent1"/>
-          </a:fillRef>
-          <a:effectRef idx="2">
-            <a:schemeClr val="accent1"/>
-          </a:effectRef>
-          <a:fontRef idx="minor">
-            <a:schemeClr val="lt1"/>
-          </a:fontRef>
-        </p:style>
-        <p:txBody>
-          <a:bodyPr rtlCol="0" anchor="ctr" wrap="square" lIns="109728" rIns="109728" tIns="9144" bIns="9144"/>
-          <a:lstStyle/>
-          <a:p>
-            <a:pPr algn="l">
-              <a:lnSpc>
-                <a:spcPct val="100000"/>
-              </a:lnSpc>
-              <a:spcBef>
-                <a:spcPts val="0"/>
-              </a:spcBef>
-              <a:spcAft>
-                <a:spcPts val="0"/>
-              </a:spcAft>
-            </a:pPr>
-            <a:r>
-              <a:rPr sz="950" b="1">
-                <a:solidFill>
-                  <a:srgbClr val="1A1D21"/>
-                </a:solidFill>
-                <a:latin typeface="맑은 고딕"/>
-              </a:rPr>
-              <a:t>규제 지식베이스</a:t>
-            </a:r>
-            <a:r>
-              <a:rPr sz="850" b="0">
-                <a:solidFill>
-                  <a:srgbClr val="5B6470"/>
-                </a:solidFill>
-                <a:latin typeface="맑은 고딕"/>
-              </a:rPr>
-              <a:t>  regulations.json · rules.yaml</a:t>
-            </a:r>
-          </a:p>
-        </p:txBody>
-      </p:sp>
-      <p:sp>
-        <p:nvSpPr>
-          <p:cNvPr id="46" name="Rounded Rectangle 45"/>
-          <p:cNvSpPr/>
-          <p:nvPr/>
-        </p:nvSpPr>
-        <p:spPr>
-          <a:xfrm>
-            <a:off x="2560320" y="5925312"/>
-            <a:ext cx="2959608" cy="384048"/>
-          </a:xfrm>
-          <a:prstGeom prst="roundRect">
-            <a:avLst/>
-          </a:prstGeom>
-          <a:solidFill>
-            <a:srgbClr val="FFF7E6"/>
-          </a:solidFill>
-          <a:ln w="9525">
-            <a:solidFill>
-              <a:srgbClr val="F0D99A"/>
-            </a:solidFill>
-          </a:ln>
-          <a:effectLst/>
-        </p:spPr>
-        <p:style>
-          <a:lnRef idx="1">
-            <a:schemeClr val="accent1"/>
-          </a:lnRef>
-          <a:fillRef idx="3">
-            <a:schemeClr val="accent1"/>
-          </a:fillRef>
-          <a:effectRef idx="2">
-            <a:schemeClr val="accent1"/>
-          </a:effectRef>
-          <a:fontRef idx="minor">
-            <a:schemeClr val="lt1"/>
-          </a:fontRef>
-        </p:style>
-        <p:txBody>
-          <a:bodyPr rtlCol="0" anchor="ctr" wrap="square" tIns="9144" bIns="9144"/>
-          <a:lstStyle/>
-          <a:p>
-            <a:pPr algn="l">
-              <a:lnSpc>
-                <a:spcPct val="100000"/>
-              </a:lnSpc>
-              <a:spcBef>
-                <a:spcPts val="0"/>
-              </a:spcBef>
-              <a:spcAft>
-                <a:spcPts val="0"/>
-              </a:spcAft>
-            </a:pPr>
-            <a:r>
-              <a:rPr sz="900" b="1">
-                <a:solidFill>
-                  <a:srgbClr val="003A6E"/>
-                </a:solidFill>
-                <a:latin typeface="맑은 고딕"/>
-              </a:rPr>
-              <a:t>🔌 법제처 OpenAPI</a:t>
-            </a:r>
-            <a:r>
-              <a:rPr sz="800" b="0">
-                <a:solidFill>
-                  <a:srgbClr val="5B6470"/>
-                </a:solidFill>
-                <a:latin typeface="맑은 고딕"/>
-              </a:rPr>
-              <a:t>  규제 피드</a:t>
-            </a:r>
-          </a:p>
-        </p:txBody>
-      </p:sp>
-      <p:sp>
-        <p:nvSpPr>
-          <p:cNvPr id="47" name="Rounded Rectangle 46"/>
-          <p:cNvSpPr/>
-          <p:nvPr/>
-        </p:nvSpPr>
-        <p:spPr>
-          <a:xfrm>
-            <a:off x="5062728" y="5989320"/>
-            <a:ext cx="384048" cy="256032"/>
-          </a:xfrm>
-          <a:prstGeom prst="roundRect">
-            <a:avLst/>
-          </a:prstGeom>
-          <a:solidFill>
-            <a:srgbClr val="00529B"/>
-          </a:solidFill>
-          <a:ln>
-            <a:noFill/>
-          </a:ln>
-          <a:effectLst/>
-        </p:spPr>
-        <p:style>
-          <a:lnRef idx="1">
-            <a:schemeClr val="accent1"/>
-          </a:lnRef>
-          <a:fillRef idx="3">
-            <a:schemeClr val="accent1"/>
-          </a:fillRef>
-          <a:effectRef idx="2">
-            <a:schemeClr val="accent1"/>
-          </a:effectRef>
-          <a:fontRef idx="minor">
-            <a:schemeClr val="lt1"/>
-          </a:fontRef>
-        </p:style>
-        <p:txBody>
-          <a:bodyPr rtlCol="0" anchor="ctr" wrap="square" lIns="18288" rIns="18288" tIns="9144" bIns="9144"/>
-          <a:lstStyle/>
-          <a:p>
-            <a:pPr algn="ctr">
-              <a:lnSpc>
-                <a:spcPct val="100000"/>
-              </a:lnSpc>
-              <a:spcBef>
-                <a:spcPts val="0"/>
-              </a:spcBef>
-              <a:spcAft>
-                <a:spcPts val="0"/>
-              </a:spcAft>
-            </a:pPr>
-            <a:r>
-              <a:rPr sz="800" b="1">
-                <a:solidFill>
-                  <a:srgbClr val="FFFFFF"/>
-                </a:solidFill>
-                <a:latin typeface="맑은 고딕"/>
-              </a:rPr>
-              <a:t>F14</a:t>
-            </a:r>
-          </a:p>
-        </p:txBody>
-      </p:sp>
-      <p:sp>
-        <p:nvSpPr>
-          <p:cNvPr id="48" name="Rounded Rectangle 47"/>
-          <p:cNvSpPr/>
-          <p:nvPr/>
-        </p:nvSpPr>
-        <p:spPr>
-          <a:xfrm>
-            <a:off x="5666232" y="5925312"/>
-            <a:ext cx="2959608" cy="384048"/>
-          </a:xfrm>
-          <a:prstGeom prst="roundRect">
-            <a:avLst/>
-          </a:prstGeom>
-          <a:solidFill>
-            <a:srgbClr val="FFF7E6"/>
-          </a:solidFill>
-          <a:ln w="9525">
-            <a:solidFill>
-              <a:srgbClr val="F0D99A"/>
-            </a:solidFill>
-          </a:ln>
-          <a:effectLst/>
-        </p:spPr>
-        <p:style>
-          <a:lnRef idx="1">
-            <a:schemeClr val="accent1"/>
-          </a:lnRef>
-          <a:fillRef idx="3">
-            <a:schemeClr val="accent1"/>
-          </a:fillRef>
-          <a:effectRef idx="2">
-            <a:schemeClr val="accent1"/>
-          </a:effectRef>
-          <a:fontRef idx="minor">
-            <a:schemeClr val="lt1"/>
-          </a:fontRef>
-        </p:style>
-        <p:txBody>
-          <a:bodyPr rtlCol="0" anchor="ctr" wrap="square" tIns="9144" bIns="9144"/>
-          <a:lstStyle/>
-          <a:p>
-            <a:pPr algn="l">
-              <a:lnSpc>
-                <a:spcPct val="100000"/>
-              </a:lnSpc>
-              <a:spcBef>
-                <a:spcPts val="0"/>
-              </a:spcBef>
-              <a:spcAft>
-                <a:spcPts val="0"/>
-              </a:spcAft>
-            </a:pPr>
-            <a:r>
-              <a:rPr sz="900" b="1">
-                <a:solidFill>
-                  <a:srgbClr val="003A6E"/>
-                </a:solidFill>
-                <a:latin typeface="맑은 고딕"/>
-              </a:rPr>
-              <a:t>🔌 FCM·SNS·알림톡</a:t>
-            </a:r>
-            <a:r>
-              <a:rPr sz="800" b="0">
-                <a:solidFill>
-                  <a:srgbClr val="5B6470"/>
-                </a:solidFill>
-                <a:latin typeface="맑은 고딕"/>
-              </a:rPr>
-              <a:t>  승인본 발송</a:t>
-            </a:r>
-          </a:p>
-        </p:txBody>
-      </p:sp>
-      <p:sp>
-        <p:nvSpPr>
-          <p:cNvPr id="49" name="Rounded Rectangle 48"/>
-          <p:cNvSpPr/>
-          <p:nvPr/>
-        </p:nvSpPr>
-        <p:spPr>
-          <a:xfrm>
-            <a:off x="8168640" y="5989320"/>
-            <a:ext cx="384048" cy="256032"/>
-          </a:xfrm>
-          <a:prstGeom prst="roundRect">
-            <a:avLst/>
-          </a:prstGeom>
-          <a:solidFill>
-            <a:srgbClr val="00529B"/>
-          </a:solidFill>
-          <a:ln>
-            <a:noFill/>
-          </a:ln>
-          <a:effectLst/>
-        </p:spPr>
-        <p:style>
-          <a:lnRef idx="1">
-            <a:schemeClr val="accent1"/>
-          </a:lnRef>
-          <a:fillRef idx="3">
-            <a:schemeClr val="accent1"/>
-          </a:fillRef>
-          <a:effectRef idx="2">
-            <a:schemeClr val="accent1"/>
-          </a:effectRef>
-          <a:fontRef idx="minor">
-            <a:schemeClr val="lt1"/>
-          </a:fontRef>
-        </p:style>
-        <p:txBody>
-          <a:bodyPr rtlCol="0" anchor="ctr" wrap="square" lIns="18288" rIns="18288" tIns="9144" bIns="9144"/>
-          <a:lstStyle/>
-          <a:p>
-            <a:pPr algn="ctr">
-              <a:lnSpc>
-                <a:spcPct val="100000"/>
-              </a:lnSpc>
-              <a:spcBef>
-                <a:spcPts val="0"/>
-              </a:spcBef>
-              <a:spcAft>
-                <a:spcPts val="0"/>
-              </a:spcAft>
-            </a:pPr>
-            <a:r>
-              <a:rPr sz="800" b="1">
-                <a:solidFill>
-                  <a:srgbClr val="FFFFFF"/>
-                </a:solidFill>
-                <a:latin typeface="맑은 고딕"/>
-              </a:rPr>
-              <a:t>F15</a:t>
-            </a:r>
-          </a:p>
-        </p:txBody>
-      </p:sp>
-      <p:sp>
-        <p:nvSpPr>
-          <p:cNvPr id="50" name="Rounded Rectangle 49"/>
-          <p:cNvSpPr/>
-          <p:nvPr/>
-        </p:nvSpPr>
-        <p:spPr>
-          <a:xfrm>
-            <a:off x="8772144" y="5925312"/>
-            <a:ext cx="2959608" cy="384048"/>
-          </a:xfrm>
-          <a:prstGeom prst="roundRect">
-            <a:avLst/>
-          </a:prstGeom>
-          <a:solidFill>
-            <a:srgbClr val="FFF7E6"/>
-          </a:solidFill>
-          <a:ln w="9525">
-            <a:solidFill>
-              <a:srgbClr val="F0D99A"/>
-            </a:solidFill>
-          </a:ln>
-          <a:effectLst/>
-        </p:spPr>
-        <p:style>
-          <a:lnRef idx="1">
-            <a:schemeClr val="accent1"/>
-          </a:lnRef>
-          <a:fillRef idx="3">
-            <a:schemeClr val="accent1"/>
-          </a:fillRef>
-          <a:effectRef idx="2">
-            <a:schemeClr val="accent1"/>
-          </a:effectRef>
-          <a:fontRef idx="minor">
-            <a:schemeClr val="lt1"/>
-          </a:fontRef>
-        </p:style>
-        <p:txBody>
-          <a:bodyPr rtlCol="0" anchor="ctr" wrap="square" tIns="9144" bIns="9144"/>
-          <a:lstStyle/>
-          <a:p>
-            <a:pPr algn="l">
-              <a:lnSpc>
-                <a:spcPct val="100000"/>
-              </a:lnSpc>
-              <a:spcBef>
-                <a:spcPts val="0"/>
-              </a:spcBef>
-              <a:spcAft>
-                <a:spcPts val="0"/>
-              </a:spcAft>
-            </a:pPr>
-            <a:r>
-              <a:rPr sz="900" b="1">
-                <a:solidFill>
-                  <a:srgbClr val="003A6E"/>
-                </a:solidFill>
-                <a:latin typeface="맑은 고딕"/>
-              </a:rPr>
-              <a:t>🔌 코어뱅킹 API</a:t>
-            </a:r>
-            <a:r>
-              <a:rPr sz="800" b="0">
-                <a:solidFill>
-                  <a:srgbClr val="5B6470"/>
-                </a:solidFill>
-                <a:latin typeface="맑은 고딕"/>
-              </a:rPr>
-              <a:t>  상품조건</a:t>
-            </a:r>
-          </a:p>
-        </p:txBody>
-      </p:sp>
-      <p:sp>
-        <p:nvSpPr>
-          <p:cNvPr id="51" name="Rounded Rectangle 50"/>
-          <p:cNvSpPr/>
-          <p:nvPr/>
-        </p:nvSpPr>
-        <p:spPr>
-          <a:xfrm>
-            <a:off x="11274552" y="5989320"/>
-            <a:ext cx="384048" cy="256032"/>
-          </a:xfrm>
-          <a:prstGeom prst="roundRect">
-            <a:avLst/>
-          </a:prstGeom>
-          <a:solidFill>
-            <a:srgbClr val="00529B"/>
-          </a:solidFill>
-          <a:ln>
-            <a:noFill/>
-          </a:ln>
-          <a:effectLst/>
-        </p:spPr>
-        <p:style>
-          <a:lnRef idx="1">
-            <a:schemeClr val="accent1"/>
-          </a:lnRef>
-          <a:fillRef idx="3">
-            <a:schemeClr val="accent1"/>
-          </a:fillRef>
-          <a:effectRef idx="2">
-            <a:schemeClr val="accent1"/>
-          </a:effectRef>
-          <a:fontRef idx="minor">
-            <a:schemeClr val="lt1"/>
-          </a:fontRef>
-        </p:style>
-        <p:txBody>
-          <a:bodyPr rtlCol="0" anchor="ctr" wrap="square" lIns="18288" rIns="18288" tIns="9144" bIns="9144"/>
-          <a:lstStyle/>
-          <a:p>
-            <a:pPr algn="ctr">
-              <a:lnSpc>
-                <a:spcPct val="100000"/>
-              </a:lnSpc>
-              <a:spcBef>
-                <a:spcPts val="0"/>
-              </a:spcBef>
-              <a:spcAft>
-                <a:spcPts val="0"/>
-              </a:spcAft>
-            </a:pPr>
-            <a:r>
-              <a:rPr sz="800" b="1">
-                <a:solidFill>
-                  <a:srgbClr val="FFFFFF"/>
-                </a:solidFill>
-                <a:latin typeface="맑은 고딕"/>
-              </a:rPr>
-              <a:t>F16</a:t>
-            </a:r>
-          </a:p>
-        </p:txBody>
-      </p:sp>
-      <p:sp>
-        <p:nvSpPr>
-          <p:cNvPr id="52" name="TextBox 51"/>
-          <p:cNvSpPr txBox="1"/>
-          <p:nvPr/>
-        </p:nvSpPr>
-        <p:spPr>
-          <a:xfrm>
-            <a:off x="457200" y="6473952"/>
-            <a:ext cx="11338560" cy="274320"/>
-          </a:xfrm>
-          <a:prstGeom prst="rect">
-            <a:avLst/>
-          </a:prstGeom>
-          <a:noFill/>
-        </p:spPr>
-        <p:txBody>
-          <a:bodyPr wrap="square" anchor="t" lIns="0" rIns="0" tIns="9144" bIns="9144">
-            <a:spAutoFit/>
-          </a:bodyPr>
-          <a:lstStyle/>
-          <a:p>
-            <a:pPr algn="l">
-              <a:lnSpc>
-                <a:spcPct val="100000"/>
-              </a:lnSpc>
-              <a:spcBef>
-                <a:spcPts val="0"/>
-              </a:spcBef>
-              <a:spcAft>
-                <a:spcPts val="0"/>
-              </a:spcAft>
-            </a:pPr>
-            <a:r>
-              <a:rPr sz="850" b="0">
-                <a:solidFill>
-                  <a:srgbClr val="5B6470"/>
-                </a:solidFill>
-                <a:latin typeface="맑은 고딕"/>
-              </a:rPr>
-              <a:t>외부 연동(법제처·발송채널·코어뱅킹)은 어댑터로 분리 — 데모는 목/피드, 운영 시 실제 API로 교체 · 전 과정 온프레미스</a:t>
+              <a:t>외부 연동은 어댑터로 분리 — 데모는 목/피드, 운영 시 법제처 OpenAPI·FCM/SNS/알림톡·코어뱅킹 API로 교체 · 전 과정 온프레미스</a:t>
             </a:r>
           </a:p>
         </p:txBody>

</xml_diff>

<commit_message>
docs: clarify engine-to-stage mapping in architecture, bigger fonts, drop endpoints
- 백엔드 박스에서 엔드포인트 칩 제거 → '전체 백엔드 아키텍처'로 단순화(요청).
- 파이프라인 각 단계를 엔진별 색상·태그로 구분(결정적/BGE-m3/Ollama)하고,
  하단에 '엔진-기능 매핑' 범례 추가 → 어느 모델이 어느 단계에 쓰이는지 명확화.
- 빈 하단 공간을 범례로 채우고 폰트 전반 확대(가독성).
- 빌드 스크립트(scripts/build_arch_pptx.py) 추가로 재생성 가능.

Co-Authored-By: Claude Opus 4.8 (1M context) <noreply@anthropic.com>
</commit_message>
<xml_diff>
--- a/docs/submission/JB준법코파일럿_시스템아키텍처.pptx
+++ b/docs/submission/JB준법코파일럿_시스템아키텍처.pptx
@@ -3096,7 +3096,7 @@
         </p:nvSpPr>
         <p:spPr>
           <a:xfrm>
-            <a:off x="411480" y="201168"/>
+            <a:off x="411480" y="182880"/>
             <a:ext cx="10058400" cy="457200"/>
           </a:xfrm>
           <a:prstGeom prst="rect">
@@ -3122,13 +3122,13 @@
               </a:spcAft>
             </a:pPr>
             <a:r>
-              <a:rPr sz="2200" b="1">
+              <a:rPr sz="2500" b="1">
                 <a:solidFill>
                   <a:srgbClr val="003A6E"/>
                 </a:solidFill>
-                <a:latin typeface="맑은 고딕"/>
-              </a:rPr>
-              <a:t>JB 준법 코파일럿 — 시스템 아키텍처</a:t>
+                <a:latin typeface="Malgun Gothic"/>
+              </a:rPr>
+              <a:t>JB 준법 코파일럿 - 시스템 아키텍처</a:t>
             </a:r>
           </a:p>
         </p:txBody>
@@ -3141,8 +3141,8 @@
         </p:nvSpPr>
         <p:spPr>
           <a:xfrm>
-            <a:off x="429768" y="676656"/>
-            <a:ext cx="10972800" cy="274320"/>
+            <a:off x="429768" y="694944"/>
+            <a:ext cx="11338560" cy="274320"/>
           </a:xfrm>
           <a:prstGeom prst="rect">
             <a:avLst/>
@@ -3167,13 +3167,13 @@
               </a:spcAft>
             </a:pPr>
             <a:r>
-              <a:rPr sz="1100" b="0">
+              <a:rPr sz="1200" b="0">
                 <a:solidFill>
                   <a:srgbClr val="5B6470"/>
                 </a:solidFill>
-                <a:latin typeface="맑은 고딕"/>
-              </a:rPr>
-              <a:t>사용자 · 프론트엔드 · 백엔드 API · AI Agent/모델 · DB/외부연동 — 전 과정 온프레미스 · 휴먼인더루프</a:t>
+                <a:latin typeface="Malgun Gothic"/>
+              </a:rPr>
+              <a:t>사용자 · 프론트엔드 · 백엔드 API · AI Agent/모델 · DB/외부연동 - 전 과정 온프레미스 · 휴먼인더루프</a:t>
             </a:r>
           </a:p>
         </p:txBody>
@@ -3186,7 +3186,7 @@
         </p:nvSpPr>
         <p:spPr>
           <a:xfrm>
-            <a:off x="411480" y="1005840"/>
+            <a:off x="411480" y="1024128"/>
             <a:ext cx="11365992" cy="31750"/>
           </a:xfrm>
           <a:prstGeom prst="rect">
@@ -3230,8 +3230,8 @@
         </p:nvSpPr>
         <p:spPr>
           <a:xfrm>
-            <a:off x="411480" y="1600200"/>
-            <a:ext cx="1874519" cy="2194560"/>
+            <a:off x="411480" y="1627632"/>
+            <a:ext cx="1920240" cy="2240280"/>
           </a:xfrm>
           <a:prstGeom prst="roundRect">
             <a:avLst/>
@@ -3276,8 +3276,8 @@
         </p:nvSpPr>
         <p:spPr>
           <a:xfrm>
-            <a:off x="411480" y="1691640"/>
-            <a:ext cx="1874519" cy="274320"/>
+            <a:off x="411480" y="1737360"/>
+            <a:ext cx="1920240" cy="292608"/>
           </a:xfrm>
           <a:prstGeom prst="rect">
             <a:avLst/>
@@ -3302,13 +3302,13 @@
               </a:spcAft>
             </a:pPr>
             <a:r>
-              <a:rPr sz="1250" b="1">
+              <a:rPr sz="1400" b="1">
                 <a:solidFill>
                   <a:srgbClr val="5B6470"/>
                 </a:solidFill>
-                <a:latin typeface="맑은 고딕"/>
-              </a:rPr>
-              <a:t>👤 사용자</a:t>
+                <a:latin typeface="Malgun Gothic"/>
+              </a:rPr>
+              <a:t>[사용자]</a:t>
             </a:r>
           </a:p>
         </p:txBody>
@@ -3321,8 +3321,8 @@
         </p:nvSpPr>
         <p:spPr>
           <a:xfrm>
-            <a:off x="548640" y="2057400"/>
-            <a:ext cx="1600199" cy="749808"/>
+            <a:off x="557784" y="2139696"/>
+            <a:ext cx="1627632" cy="749808"/>
           </a:xfrm>
           <a:prstGeom prst="roundRect">
             <a:avLst/>
@@ -3367,11 +3367,11 @@
               </a:spcAft>
             </a:pPr>
             <a:r>
-              <a:rPr sz="1000" b="1">
+              <a:rPr sz="1100" b="1">
                 <a:solidFill>
                   <a:srgbClr val="1A1D21"/>
                 </a:solidFill>
-                <a:latin typeface="맑은 고딕"/>
+                <a:latin typeface="Malgun Gothic"/>
               </a:rPr>
               <a:t>마케팅·지점 담당자</a:t>
             </a:r>
@@ -3389,13 +3389,13 @@
               </a:spcAft>
             </a:pPr>
             <a:r>
-              <a:rPr sz="850" b="0">
+              <a:rPr sz="900" b="0">
                 <a:solidFill>
                   <a:srgbClr val="5B6470"/>
                 </a:solidFill>
-                <a:latin typeface="맑은 고딕"/>
-              </a:rPr>
-              <a:t>금융 콘텐츠</a:t>
+                <a:latin typeface="Malgun Gothic"/>
+              </a:rPr>
+              <a:t>금융 콘텐츠 초안</a:t>
             </a:r>
           </a:p>
           <a:p>
@@ -3411,13 +3411,13 @@
               </a:spcAft>
             </a:pPr>
             <a:r>
-              <a:rPr sz="850" b="0">
+              <a:rPr sz="900" b="0">
                 <a:solidFill>
                   <a:srgbClr val="5B6470"/>
                 </a:solidFill>
-                <a:latin typeface="맑은 고딕"/>
-              </a:rPr>
-              <a:t>초안 작성(실시간)</a:t>
+                <a:latin typeface="Malgun Gothic"/>
+              </a:rPr>
+              <a:t>작성(실시간)</a:t>
             </a:r>
           </a:p>
         </p:txBody>
@@ -3430,8 +3430,8 @@
         </p:nvSpPr>
         <p:spPr>
           <a:xfrm>
-            <a:off x="548640" y="2898648"/>
-            <a:ext cx="1600199" cy="749808"/>
+            <a:off x="557784" y="2980944"/>
+            <a:ext cx="1627632" cy="749808"/>
           </a:xfrm>
           <a:prstGeom prst="roundRect">
             <a:avLst/>
@@ -3476,11 +3476,11 @@
               </a:spcAft>
             </a:pPr>
             <a:r>
-              <a:rPr sz="1000" b="1">
+              <a:rPr sz="1100" b="1">
                 <a:solidFill>
                   <a:srgbClr val="1A1D21"/>
                 </a:solidFill>
-                <a:latin typeface="맑은 고딕"/>
+                <a:latin typeface="Malgun Gothic"/>
               </a:rPr>
               <a:t>준법관리자</a:t>
             </a:r>
@@ -3498,11 +3498,11 @@
               </a:spcAft>
             </a:pPr>
             <a:r>
-              <a:rPr sz="850" b="0">
+              <a:rPr sz="900" b="0">
                 <a:solidFill>
                   <a:srgbClr val="5B6470"/>
                 </a:solidFill>
-                <a:latin typeface="맑은 고딕"/>
+                <a:latin typeface="Malgun Gothic"/>
               </a:rPr>
               <a:t>준법감시부</a:t>
             </a:r>
@@ -3520,11 +3520,11 @@
               </a:spcAft>
             </a:pPr>
             <a:r>
-              <a:rPr sz="850" b="0">
+              <a:rPr sz="900" b="0">
                 <a:solidFill>
                   <a:srgbClr val="5B6470"/>
                 </a:solidFill>
-                <a:latin typeface="맑은 고딕"/>
+                <a:latin typeface="Malgun Gothic"/>
               </a:rPr>
               <a:t>검토·승인(HITL)</a:t>
             </a:r>
@@ -3539,8 +3539,8 @@
         </p:nvSpPr>
         <p:spPr>
           <a:xfrm>
-            <a:off x="2377440" y="2514600"/>
-            <a:ext cx="411480" cy="365760"/>
+            <a:off x="2432304" y="2560320"/>
+            <a:ext cx="420624" cy="384048"/>
           </a:xfrm>
           <a:prstGeom prst="rightArrow">
             <a:avLst/>
@@ -3583,8 +3583,8 @@
         </p:nvSpPr>
         <p:spPr>
           <a:xfrm>
-            <a:off x="2880360" y="1600200"/>
-            <a:ext cx="2331720" cy="2194560"/>
+            <a:off x="2926080" y="1627632"/>
+            <a:ext cx="2377440" cy="2240280"/>
           </a:xfrm>
           <a:prstGeom prst="roundRect">
             <a:avLst/>
@@ -3594,7 +3594,7 @@
           </a:solidFill>
           <a:ln w="15875">
             <a:solidFill>
-              <a:srgbClr val="1F9D55"/>
+              <a:srgbClr val="0F9D58"/>
             </a:solidFill>
           </a:ln>
           <a:effectLst/>
@@ -3629,8 +3629,8 @@
         </p:nvSpPr>
         <p:spPr>
           <a:xfrm>
-            <a:off x="2880360" y="1691640"/>
-            <a:ext cx="2331720" cy="274320"/>
+            <a:off x="2926080" y="1737360"/>
+            <a:ext cx="2377440" cy="292608"/>
           </a:xfrm>
           <a:prstGeom prst="rect">
             <a:avLst/>
@@ -3655,13 +3655,13 @@
               </a:spcAft>
             </a:pPr>
             <a:r>
-              <a:rPr sz="1200" b="1">
-                <a:solidFill>
-                  <a:srgbClr val="1F9D55"/>
-                </a:solidFill>
-                <a:latin typeface="맑은 고딕"/>
-              </a:rPr>
-              <a:t>🖥 프론트엔드 / UI</a:t>
+              <a:rPr sz="1350" b="1">
+                <a:solidFill>
+                  <a:srgbClr val="0F9D58"/>
+                </a:solidFill>
+                <a:latin typeface="Malgun Gothic"/>
+              </a:rPr>
+              <a:t>[프론트엔드 / UI]</a:t>
             </a:r>
           </a:p>
         </p:txBody>
@@ -3674,8 +3674,8 @@
         </p:nvSpPr>
         <p:spPr>
           <a:xfrm>
-            <a:off x="2880360" y="1984248"/>
-            <a:ext cx="2331720" cy="219456"/>
+            <a:off x="2926080" y="2048256"/>
+            <a:ext cx="2377440" cy="219456"/>
           </a:xfrm>
           <a:prstGeom prst="rect">
             <a:avLst/>
@@ -3700,11 +3700,11 @@
               </a:spcAft>
             </a:pPr>
             <a:r>
-              <a:rPr sz="850" b="0">
+              <a:rPr sz="900" b="0">
                 <a:solidFill>
                   <a:srgbClr val="5B6470"/>
                 </a:solidFill>
-                <a:latin typeface="맑은 고딕"/>
+                <a:latin typeface="Malgun Gothic"/>
               </a:rPr>
               <a:t>정적 SPA · 바닐라 JS (FastAPI 서빙)</a:t>
             </a:r>
@@ -3719,8 +3719,8 @@
         </p:nvSpPr>
         <p:spPr>
           <a:xfrm>
-            <a:off x="3017520" y="2258568"/>
-            <a:ext cx="2057400" cy="310896"/>
+            <a:off x="3072384" y="2322576"/>
+            <a:ext cx="2084832" cy="310896"/>
           </a:xfrm>
           <a:prstGeom prst="roundRect">
             <a:avLst/>
@@ -3765,11 +3765,11 @@
               </a:spcAft>
             </a:pPr>
             <a:r>
-              <a:rPr sz="950" b="0">
+              <a:rPr sz="1050" b="0">
                 <a:solidFill>
                   <a:srgbClr val="1A1D21"/>
                 </a:solidFill>
-                <a:latin typeface="맑은 고딕"/>
+                <a:latin typeface="Malgun Gothic"/>
               </a:rPr>
               <a:t>심의 워크스페이스</a:t>
             </a:r>
@@ -3784,8 +3784,8 @@
         </p:nvSpPr>
         <p:spPr>
           <a:xfrm>
-            <a:off x="3017520" y="2624328"/>
-            <a:ext cx="2057400" cy="310896"/>
+            <a:off x="3072384" y="2688336"/>
+            <a:ext cx="2084832" cy="310896"/>
           </a:xfrm>
           <a:prstGeom prst="roundRect">
             <a:avLst/>
@@ -3830,13 +3830,13 @@
               </a:spcAft>
             </a:pPr>
             <a:r>
-              <a:rPr sz="950" b="1">
+              <a:rPr sz="1050" b="1">
                 <a:solidFill>
                   <a:srgbClr val="1A1D21"/>
                 </a:solidFill>
-                <a:latin typeface="맑은 고딕"/>
-              </a:rPr>
-              <a:t>오인 시뮬레이터 ★</a:t>
+                <a:latin typeface="Malgun Gothic"/>
+              </a:rPr>
+              <a:t>오인 시뮬레이터 *</a:t>
             </a:r>
           </a:p>
         </p:txBody>
@@ -3849,8 +3849,8 @@
         </p:nvSpPr>
         <p:spPr>
           <a:xfrm>
-            <a:off x="3017520" y="2990088"/>
-            <a:ext cx="2057400" cy="310896"/>
+            <a:off x="3072384" y="3054096"/>
+            <a:ext cx="2084832" cy="310896"/>
           </a:xfrm>
           <a:prstGeom prst="roundRect">
             <a:avLst/>
@@ -3895,11 +3895,11 @@
               </a:spcAft>
             </a:pPr>
             <a:r>
-              <a:rPr sz="950" b="0">
+              <a:rPr sz="1050" b="0">
                 <a:solidFill>
                   <a:srgbClr val="1A1D21"/>
                 </a:solidFill>
-                <a:latin typeface="맑은 고딕"/>
+                <a:latin typeface="Malgun Gothic"/>
               </a:rPr>
               <a:t>준법관리자 승인 뷰</a:t>
             </a:r>
@@ -3914,8 +3914,8 @@
         </p:nvSpPr>
         <p:spPr>
           <a:xfrm>
-            <a:off x="3017520" y="3355848"/>
-            <a:ext cx="2057400" cy="310896"/>
+            <a:off x="3072384" y="3419856"/>
+            <a:ext cx="2084832" cy="310896"/>
           </a:xfrm>
           <a:prstGeom prst="roundRect">
             <a:avLst/>
@@ -3960,11 +3960,11 @@
               </a:spcAft>
             </a:pPr>
             <a:r>
-              <a:rPr sz="950" b="0">
+              <a:rPr sz="1050" b="0">
                 <a:solidFill>
                   <a:srgbClr val="1A1D21"/>
                 </a:solidFill>
-                <a:latin typeface="맑은 고딕"/>
+                <a:latin typeface="Malgun Gothic"/>
               </a:rPr>
               <a:t>감사로그 뷰</a:t>
             </a:r>
@@ -3979,8 +3979,8 @@
         </p:nvSpPr>
         <p:spPr>
           <a:xfrm>
-            <a:off x="5303520" y="2514600"/>
-            <a:ext cx="411480" cy="365760"/>
+            <a:off x="5394960" y="2560320"/>
+            <a:ext cx="420624" cy="384048"/>
           </a:xfrm>
           <a:prstGeom prst="rightArrow">
             <a:avLst/>
@@ -4023,8 +4023,8 @@
         </p:nvSpPr>
         <p:spPr>
           <a:xfrm>
-            <a:off x="5029200" y="2240280"/>
-            <a:ext cx="960120" cy="228600"/>
+            <a:off x="5074920" y="2267712"/>
+            <a:ext cx="1060704" cy="237744"/>
           </a:xfrm>
           <a:prstGeom prst="rect">
             <a:avLst/>
@@ -4049,11 +4049,11 @@
               </a:spcAft>
             </a:pPr>
             <a:r>
-              <a:rPr sz="850" b="1">
+              <a:rPr sz="950" b="1">
                 <a:solidFill>
                   <a:srgbClr val="5B6470"/>
                 </a:solidFill>
-                <a:latin typeface="맑은 고딕"/>
+                <a:latin typeface="Malgun Gothic"/>
               </a:rPr>
               <a:t>REST(JSON)</a:t>
             </a:r>
@@ -4068,8 +4068,8 @@
         </p:nvSpPr>
         <p:spPr>
           <a:xfrm>
-            <a:off x="5806440" y="1371600"/>
-            <a:ext cx="5943600" cy="3246120"/>
+            <a:off x="5852160" y="1371600"/>
+            <a:ext cx="5925312" cy="3657600"/>
           </a:xfrm>
           <a:prstGeom prst="roundRect">
             <a:avLst/>
@@ -4108,24 +4108,114 @@
       </p:sp>
       <p:sp>
         <p:nvSpPr>
-          <p:cNvPr id="20" name="Rounded Rectangle 19"/>
+          <p:cNvPr id="20" name="TextBox 19"/>
+          <p:cNvSpPr txBox="1"/>
+          <p:nvPr/>
+        </p:nvSpPr>
+        <p:spPr>
+          <a:xfrm>
+            <a:off x="6016752" y="1490472"/>
+            <a:ext cx="5596128" cy="274320"/>
+          </a:xfrm>
+          <a:prstGeom prst="rect">
+            <a:avLst/>
+          </a:prstGeom>
+          <a:noFill/>
+        </p:spPr>
+        <p:txBody>
+          <a:bodyPr wrap="square" anchor="t" lIns="0" rIns="0" tIns="9144" bIns="9144">
+            <a:spAutoFit/>
+          </a:bodyPr>
+          <a:lstStyle/>
+          <a:p>
+            <a:pPr algn="l">
+              <a:lnSpc>
+                <a:spcPct val="100000"/>
+              </a:lnSpc>
+              <a:spcBef>
+                <a:spcPts val="0"/>
+              </a:spcBef>
+              <a:spcAft>
+                <a:spcPts val="0"/>
+              </a:spcAft>
+            </a:pPr>
+            <a:r>
+              <a:rPr sz="1300" b="1">
+                <a:solidFill>
+                  <a:srgbClr val="00529B"/>
+                </a:solidFill>
+                <a:latin typeface="Malgun Gothic"/>
+              </a:rPr>
+              <a:t>[백엔드 / Backend]  FastAPI (app/main.py) · 온프레미스</a:t>
+            </a:r>
+          </a:p>
+        </p:txBody>
+      </p:sp>
+      <p:sp>
+        <p:nvSpPr>
+          <p:cNvPr id="21" name="TextBox 20"/>
+          <p:cNvSpPr txBox="1"/>
+          <p:nvPr/>
+        </p:nvSpPr>
+        <p:spPr>
+          <a:xfrm>
+            <a:off x="6016752" y="1828800"/>
+            <a:ext cx="5596128" cy="256032"/>
+          </a:xfrm>
+          <a:prstGeom prst="rect">
+            <a:avLst/>
+          </a:prstGeom>
+          <a:noFill/>
+        </p:spPr>
+        <p:txBody>
+          <a:bodyPr wrap="square" anchor="t" lIns="0" rIns="0" tIns="9144" bIns="9144">
+            <a:spAutoFit/>
+          </a:bodyPr>
+          <a:lstStyle/>
+          <a:p>
+            <a:pPr algn="l">
+              <a:lnSpc>
+                <a:spcPct val="100000"/>
+              </a:lnSpc>
+              <a:spcBef>
+                <a:spcPts val="0"/>
+              </a:spcBef>
+              <a:spcAft>
+                <a:spcPts val="0"/>
+              </a:spcAft>
+            </a:pPr>
+            <a:r>
+              <a:rPr sz="1200" b="1">
+                <a:solidFill>
+                  <a:srgbClr val="5B3BBF"/>
+                </a:solidFill>
+                <a:latin typeface="Malgun Gothic"/>
+              </a:rPr>
+              <a:t>AI Agent · Orchestrator - 명시적 파이썬 파이프라인</a:t>
+            </a:r>
+          </a:p>
+        </p:txBody>
+      </p:sp>
+      <p:sp>
+        <p:nvSpPr>
+          <p:cNvPr id="22" name="Rounded Rectangle 21"/>
           <p:cNvSpPr/>
           <p:nvPr/>
         </p:nvSpPr>
         <p:spPr>
           <a:xfrm>
-            <a:off x="5952744" y="1499616"/>
-            <a:ext cx="5650992" cy="566928"/>
+            <a:off x="6016752" y="2139696"/>
+            <a:ext cx="760258" cy="841248"/>
           </a:xfrm>
           <a:prstGeom prst="roundRect">
             <a:avLst/>
           </a:prstGeom>
           <a:solidFill>
-            <a:srgbClr val="EEF4FC"/>
+            <a:srgbClr val="EEF1F5"/>
           </a:solidFill>
           <a:ln w="9525">
             <a:solidFill>
-              <a:srgbClr val="BCD6F2"/>
+              <a:srgbClr val="6B7480"/>
             </a:solidFill>
           </a:ln>
           <a:effectLst/>
@@ -4145,23 +4235,86 @@
           </a:fontRef>
         </p:style>
         <p:txBody>
-          <a:bodyPr rtlCol="0" anchor="ctr"/>
-          <a:lstStyle/>
-          <a:p>
-            <a:pPr algn="ctr"/>
-          </a:p>
-        </p:txBody>
-      </p:sp>
-      <p:sp>
-        <p:nvSpPr>
-          <p:cNvPr id="21" name="TextBox 20"/>
+          <a:bodyPr rtlCol="0" anchor="ctr" wrap="square" lIns="27432" rIns="27432" tIns="9144" bIns="9144"/>
+          <a:lstStyle/>
+          <a:p>
+            <a:pPr algn="ctr">
+              <a:lnSpc>
+                <a:spcPct val="100000"/>
+              </a:lnSpc>
+              <a:spcBef>
+                <a:spcPts val="0"/>
+              </a:spcBef>
+              <a:spcAft>
+                <a:spcPts val="0"/>
+              </a:spcAft>
+            </a:pPr>
+            <a:r>
+              <a:rPr sz="1050" b="1">
+                <a:solidFill>
+                  <a:srgbClr val="1A1D21"/>
+                </a:solidFill>
+                <a:latin typeface="Malgun Gothic"/>
+              </a:rPr>
+              <a:t>(1)분류</a:t>
+            </a:r>
+          </a:p>
+          <a:p>
+            <a:pPr algn="ctr">
+              <a:lnSpc>
+                <a:spcPct val="100000"/>
+              </a:lnSpc>
+              <a:spcBef>
+                <a:spcPts val="0"/>
+              </a:spcBef>
+              <a:spcAft>
+                <a:spcPts val="0"/>
+              </a:spcAft>
+            </a:pPr>
+            <a:r>
+              <a:rPr sz="400" b="0">
+                <a:solidFill>
+                  <a:srgbClr val="1A1D21"/>
+                </a:solidFill>
+                <a:latin typeface="Malgun Gothic"/>
+              </a:rPr>
+              <a:t> </a:t>
+            </a:r>
+          </a:p>
+          <a:p>
+            <a:pPr algn="ctr">
+              <a:lnSpc>
+                <a:spcPct val="100000"/>
+              </a:lnSpc>
+              <a:spcBef>
+                <a:spcPts val="0"/>
+              </a:spcBef>
+              <a:spcAft>
+                <a:spcPts val="0"/>
+              </a:spcAft>
+            </a:pPr>
+            <a:r>
+              <a:rPr sz="950" b="1">
+                <a:solidFill>
+                  <a:srgbClr val="6B7480"/>
+                </a:solidFill>
+                <a:latin typeface="Malgun Gothic"/>
+              </a:rPr>
+              <a:t>결정적</a:t>
+            </a:r>
+          </a:p>
+        </p:txBody>
+      </p:sp>
+      <p:sp>
+        <p:nvSpPr>
+          <p:cNvPr id="23" name="TextBox 22"/>
           <p:cNvSpPr txBox="1"/>
           <p:nvPr/>
         </p:nvSpPr>
         <p:spPr>
           <a:xfrm>
-            <a:off x="6080760" y="1536192"/>
-            <a:ext cx="5486400" cy="201168"/>
+            <a:off x="6758722" y="2139696"/>
+            <a:ext cx="91440" cy="841248"/>
           </a:xfrm>
           <a:prstGeom prst="rect">
             <a:avLst/>
@@ -4169,9 +4322,953 @@
           <a:noFill/>
         </p:spPr>
         <p:txBody>
-          <a:bodyPr wrap="square" anchor="t" lIns="0" rIns="0" tIns="9144" bIns="9144">
+          <a:bodyPr wrap="square" anchor="ctr" lIns="0" rIns="0" tIns="9144" bIns="9144">
             <a:spAutoFit/>
           </a:bodyPr>
+          <a:lstStyle/>
+          <a:p>
+            <a:pPr algn="ctr">
+              <a:lnSpc>
+                <a:spcPct val="100000"/>
+              </a:lnSpc>
+              <a:spcBef>
+                <a:spcPts val="0"/>
+              </a:spcBef>
+              <a:spcAft>
+                <a:spcPts val="0"/>
+              </a:spcAft>
+            </a:pPr>
+            <a:r>
+              <a:rPr sz="1100" b="1">
+                <a:solidFill>
+                  <a:srgbClr val="5B6470"/>
+                </a:solidFill>
+                <a:latin typeface="Malgun Gothic"/>
+              </a:rPr>
+              <a:t>&gt;</a:t>
+            </a:r>
+          </a:p>
+        </p:txBody>
+      </p:sp>
+      <p:sp>
+        <p:nvSpPr>
+          <p:cNvPr id="24" name="Rounded Rectangle 23"/>
+          <p:cNvSpPr/>
+          <p:nvPr/>
+        </p:nvSpPr>
+        <p:spPr>
+          <a:xfrm>
+            <a:off x="6822730" y="2139696"/>
+            <a:ext cx="760258" cy="841248"/>
+          </a:xfrm>
+          <a:prstGeom prst="roundRect">
+            <a:avLst/>
+          </a:prstGeom>
+          <a:solidFill>
+            <a:srgbClr val="E7F6EE"/>
+          </a:solidFill>
+          <a:ln w="9525">
+            <a:solidFill>
+              <a:srgbClr val="0F9D58"/>
+            </a:solidFill>
+          </a:ln>
+          <a:effectLst/>
+        </p:spPr>
+        <p:style>
+          <a:lnRef idx="1">
+            <a:schemeClr val="accent1"/>
+          </a:lnRef>
+          <a:fillRef idx="3">
+            <a:schemeClr val="accent1"/>
+          </a:fillRef>
+          <a:effectRef idx="2">
+            <a:schemeClr val="accent1"/>
+          </a:effectRef>
+          <a:fontRef idx="minor">
+            <a:schemeClr val="lt1"/>
+          </a:fontRef>
+        </p:style>
+        <p:txBody>
+          <a:bodyPr rtlCol="0" anchor="ctr" wrap="square" lIns="27432" rIns="27432" tIns="9144" bIns="9144"/>
+          <a:lstStyle/>
+          <a:p>
+            <a:pPr algn="ctr">
+              <a:lnSpc>
+                <a:spcPct val="100000"/>
+              </a:lnSpc>
+              <a:spcBef>
+                <a:spcPts val="0"/>
+              </a:spcBef>
+              <a:spcAft>
+                <a:spcPts val="0"/>
+              </a:spcAft>
+            </a:pPr>
+            <a:r>
+              <a:rPr sz="1050" b="1">
+                <a:solidFill>
+                  <a:srgbClr val="1A1D21"/>
+                </a:solidFill>
+                <a:latin typeface="Malgun Gothic"/>
+              </a:rPr>
+              <a:t>(2)RAG</a:t>
+            </a:r>
+          </a:p>
+          <a:p>
+            <a:pPr algn="ctr">
+              <a:lnSpc>
+                <a:spcPct val="100000"/>
+              </a:lnSpc>
+              <a:spcBef>
+                <a:spcPts val="0"/>
+              </a:spcBef>
+              <a:spcAft>
+                <a:spcPts val="0"/>
+              </a:spcAft>
+            </a:pPr>
+            <a:r>
+              <a:rPr sz="400" b="0">
+                <a:solidFill>
+                  <a:srgbClr val="1A1D21"/>
+                </a:solidFill>
+                <a:latin typeface="Malgun Gothic"/>
+              </a:rPr>
+              <a:t> </a:t>
+            </a:r>
+          </a:p>
+          <a:p>
+            <a:pPr algn="ctr">
+              <a:lnSpc>
+                <a:spcPct val="100000"/>
+              </a:lnSpc>
+              <a:spcBef>
+                <a:spcPts val="0"/>
+              </a:spcBef>
+              <a:spcAft>
+                <a:spcPts val="0"/>
+              </a:spcAft>
+            </a:pPr>
+            <a:r>
+              <a:rPr sz="950" b="1">
+                <a:solidFill>
+                  <a:srgbClr val="0F9D58"/>
+                </a:solidFill>
+                <a:latin typeface="Malgun Gothic"/>
+              </a:rPr>
+              <a:t>BGE-m3</a:t>
+            </a:r>
+          </a:p>
+        </p:txBody>
+      </p:sp>
+      <p:sp>
+        <p:nvSpPr>
+          <p:cNvPr id="25" name="TextBox 24"/>
+          <p:cNvSpPr txBox="1"/>
+          <p:nvPr/>
+        </p:nvSpPr>
+        <p:spPr>
+          <a:xfrm>
+            <a:off x="7564700" y="2139696"/>
+            <a:ext cx="91440" cy="841248"/>
+          </a:xfrm>
+          <a:prstGeom prst="rect">
+            <a:avLst/>
+          </a:prstGeom>
+          <a:noFill/>
+        </p:spPr>
+        <p:txBody>
+          <a:bodyPr wrap="square" anchor="ctr" lIns="0" rIns="0" tIns="9144" bIns="9144">
+            <a:spAutoFit/>
+          </a:bodyPr>
+          <a:lstStyle/>
+          <a:p>
+            <a:pPr algn="ctr">
+              <a:lnSpc>
+                <a:spcPct val="100000"/>
+              </a:lnSpc>
+              <a:spcBef>
+                <a:spcPts val="0"/>
+              </a:spcBef>
+              <a:spcAft>
+                <a:spcPts val="0"/>
+              </a:spcAft>
+            </a:pPr>
+            <a:r>
+              <a:rPr sz="1100" b="1">
+                <a:solidFill>
+                  <a:srgbClr val="5B6470"/>
+                </a:solidFill>
+                <a:latin typeface="Malgun Gothic"/>
+              </a:rPr>
+              <a:t>&gt;</a:t>
+            </a:r>
+          </a:p>
+        </p:txBody>
+      </p:sp>
+      <p:sp>
+        <p:nvSpPr>
+          <p:cNvPr id="26" name="Rounded Rectangle 25"/>
+          <p:cNvSpPr/>
+          <p:nvPr/>
+        </p:nvSpPr>
+        <p:spPr>
+          <a:xfrm>
+            <a:off x="7628708" y="2139696"/>
+            <a:ext cx="760258" cy="841248"/>
+          </a:xfrm>
+          <a:prstGeom prst="roundRect">
+            <a:avLst/>
+          </a:prstGeom>
+          <a:solidFill>
+            <a:srgbClr val="EEF1F5"/>
+          </a:solidFill>
+          <a:ln w="9525">
+            <a:solidFill>
+              <a:srgbClr val="6B7480"/>
+            </a:solidFill>
+          </a:ln>
+          <a:effectLst/>
+        </p:spPr>
+        <p:style>
+          <a:lnRef idx="1">
+            <a:schemeClr val="accent1"/>
+          </a:lnRef>
+          <a:fillRef idx="3">
+            <a:schemeClr val="accent1"/>
+          </a:fillRef>
+          <a:effectRef idx="2">
+            <a:schemeClr val="accent1"/>
+          </a:effectRef>
+          <a:fontRef idx="minor">
+            <a:schemeClr val="lt1"/>
+          </a:fontRef>
+        </p:style>
+        <p:txBody>
+          <a:bodyPr rtlCol="0" anchor="ctr" wrap="square" lIns="27432" rIns="27432" tIns="9144" bIns="9144"/>
+          <a:lstStyle/>
+          <a:p>
+            <a:pPr algn="ctr">
+              <a:lnSpc>
+                <a:spcPct val="100000"/>
+              </a:lnSpc>
+              <a:spcBef>
+                <a:spcPts val="0"/>
+              </a:spcBef>
+              <a:spcAft>
+                <a:spcPts val="0"/>
+              </a:spcAft>
+            </a:pPr>
+            <a:r>
+              <a:rPr sz="1050" b="1">
+                <a:solidFill>
+                  <a:srgbClr val="1A1D21"/>
+                </a:solidFill>
+                <a:latin typeface="Malgun Gothic"/>
+              </a:rPr>
+              <a:t>(3)룰엔진</a:t>
+            </a:r>
+          </a:p>
+          <a:p>
+            <a:pPr algn="ctr">
+              <a:lnSpc>
+                <a:spcPct val="100000"/>
+              </a:lnSpc>
+              <a:spcBef>
+                <a:spcPts val="0"/>
+              </a:spcBef>
+              <a:spcAft>
+                <a:spcPts val="0"/>
+              </a:spcAft>
+            </a:pPr>
+            <a:r>
+              <a:rPr sz="400" b="0">
+                <a:solidFill>
+                  <a:srgbClr val="1A1D21"/>
+                </a:solidFill>
+                <a:latin typeface="Malgun Gothic"/>
+              </a:rPr>
+              <a:t> </a:t>
+            </a:r>
+          </a:p>
+          <a:p>
+            <a:pPr algn="ctr">
+              <a:lnSpc>
+                <a:spcPct val="100000"/>
+              </a:lnSpc>
+              <a:spcBef>
+                <a:spcPts val="0"/>
+              </a:spcBef>
+              <a:spcAft>
+                <a:spcPts val="0"/>
+              </a:spcAft>
+            </a:pPr>
+            <a:r>
+              <a:rPr sz="950" b="1">
+                <a:solidFill>
+                  <a:srgbClr val="6B7480"/>
+                </a:solidFill>
+                <a:latin typeface="Malgun Gothic"/>
+              </a:rPr>
+              <a:t>결정적</a:t>
+            </a:r>
+          </a:p>
+        </p:txBody>
+      </p:sp>
+      <p:sp>
+        <p:nvSpPr>
+          <p:cNvPr id="27" name="TextBox 26"/>
+          <p:cNvSpPr txBox="1"/>
+          <p:nvPr/>
+        </p:nvSpPr>
+        <p:spPr>
+          <a:xfrm>
+            <a:off x="8370678" y="2139696"/>
+            <a:ext cx="91440" cy="841248"/>
+          </a:xfrm>
+          <a:prstGeom prst="rect">
+            <a:avLst/>
+          </a:prstGeom>
+          <a:noFill/>
+        </p:spPr>
+        <p:txBody>
+          <a:bodyPr wrap="square" anchor="ctr" lIns="0" rIns="0" tIns="9144" bIns="9144">
+            <a:spAutoFit/>
+          </a:bodyPr>
+          <a:lstStyle/>
+          <a:p>
+            <a:pPr algn="ctr">
+              <a:lnSpc>
+                <a:spcPct val="100000"/>
+              </a:lnSpc>
+              <a:spcBef>
+                <a:spcPts val="0"/>
+              </a:spcBef>
+              <a:spcAft>
+                <a:spcPts val="0"/>
+              </a:spcAft>
+            </a:pPr>
+            <a:r>
+              <a:rPr sz="1100" b="1">
+                <a:solidFill>
+                  <a:srgbClr val="5B6470"/>
+                </a:solidFill>
+                <a:latin typeface="Malgun Gothic"/>
+              </a:rPr>
+              <a:t>&gt;</a:t>
+            </a:r>
+          </a:p>
+        </p:txBody>
+      </p:sp>
+      <p:sp>
+        <p:nvSpPr>
+          <p:cNvPr id="28" name="Rounded Rectangle 27"/>
+          <p:cNvSpPr/>
+          <p:nvPr/>
+        </p:nvSpPr>
+        <p:spPr>
+          <a:xfrm>
+            <a:off x="8434686" y="2139696"/>
+            <a:ext cx="760258" cy="841248"/>
+          </a:xfrm>
+          <a:prstGeom prst="roundRect">
+            <a:avLst/>
+          </a:prstGeom>
+          <a:solidFill>
+            <a:srgbClr val="EFEAFF"/>
+          </a:solidFill>
+          <a:ln w="9525">
+            <a:solidFill>
+              <a:srgbClr val="5B3BBF"/>
+            </a:solidFill>
+          </a:ln>
+          <a:effectLst/>
+        </p:spPr>
+        <p:style>
+          <a:lnRef idx="1">
+            <a:schemeClr val="accent1"/>
+          </a:lnRef>
+          <a:fillRef idx="3">
+            <a:schemeClr val="accent1"/>
+          </a:fillRef>
+          <a:effectRef idx="2">
+            <a:schemeClr val="accent1"/>
+          </a:effectRef>
+          <a:fontRef idx="minor">
+            <a:schemeClr val="lt1"/>
+          </a:fontRef>
+        </p:style>
+        <p:txBody>
+          <a:bodyPr rtlCol="0" anchor="ctr" wrap="square" lIns="27432" rIns="27432" tIns="9144" bIns="9144"/>
+          <a:lstStyle/>
+          <a:p>
+            <a:pPr algn="ctr">
+              <a:lnSpc>
+                <a:spcPct val="100000"/>
+              </a:lnSpc>
+              <a:spcBef>
+                <a:spcPts val="0"/>
+              </a:spcBef>
+              <a:spcAft>
+                <a:spcPts val="0"/>
+              </a:spcAft>
+            </a:pPr>
+            <a:r>
+              <a:rPr sz="1050" b="1">
+                <a:solidFill>
+                  <a:srgbClr val="1A1D21"/>
+                </a:solidFill>
+                <a:latin typeface="Malgun Gothic"/>
+              </a:rPr>
+              <a:t>(4)LLM심의</a:t>
+            </a:r>
+          </a:p>
+          <a:p>
+            <a:pPr algn="ctr">
+              <a:lnSpc>
+                <a:spcPct val="100000"/>
+              </a:lnSpc>
+              <a:spcBef>
+                <a:spcPts val="0"/>
+              </a:spcBef>
+              <a:spcAft>
+                <a:spcPts val="0"/>
+              </a:spcAft>
+            </a:pPr>
+            <a:r>
+              <a:rPr sz="400" b="0">
+                <a:solidFill>
+                  <a:srgbClr val="1A1D21"/>
+                </a:solidFill>
+                <a:latin typeface="Malgun Gothic"/>
+              </a:rPr>
+              <a:t> </a:t>
+            </a:r>
+          </a:p>
+          <a:p>
+            <a:pPr algn="ctr">
+              <a:lnSpc>
+                <a:spcPct val="100000"/>
+              </a:lnSpc>
+              <a:spcBef>
+                <a:spcPts val="0"/>
+              </a:spcBef>
+              <a:spcAft>
+                <a:spcPts val="0"/>
+              </a:spcAft>
+            </a:pPr>
+            <a:r>
+              <a:rPr sz="950" b="1">
+                <a:solidFill>
+                  <a:srgbClr val="5B3BBF"/>
+                </a:solidFill>
+                <a:latin typeface="Malgun Gothic"/>
+              </a:rPr>
+              <a:t>Ollama</a:t>
+            </a:r>
+          </a:p>
+        </p:txBody>
+      </p:sp>
+      <p:sp>
+        <p:nvSpPr>
+          <p:cNvPr id="29" name="TextBox 28"/>
+          <p:cNvSpPr txBox="1"/>
+          <p:nvPr/>
+        </p:nvSpPr>
+        <p:spPr>
+          <a:xfrm>
+            <a:off x="9176656" y="2139696"/>
+            <a:ext cx="91440" cy="841248"/>
+          </a:xfrm>
+          <a:prstGeom prst="rect">
+            <a:avLst/>
+          </a:prstGeom>
+          <a:noFill/>
+        </p:spPr>
+        <p:txBody>
+          <a:bodyPr wrap="square" anchor="ctr" lIns="0" rIns="0" tIns="9144" bIns="9144">
+            <a:spAutoFit/>
+          </a:bodyPr>
+          <a:lstStyle/>
+          <a:p>
+            <a:pPr algn="ctr">
+              <a:lnSpc>
+                <a:spcPct val="100000"/>
+              </a:lnSpc>
+              <a:spcBef>
+                <a:spcPts val="0"/>
+              </a:spcBef>
+              <a:spcAft>
+                <a:spcPts val="0"/>
+              </a:spcAft>
+            </a:pPr>
+            <a:r>
+              <a:rPr sz="1100" b="1">
+                <a:solidFill>
+                  <a:srgbClr val="5B6470"/>
+                </a:solidFill>
+                <a:latin typeface="Malgun Gothic"/>
+              </a:rPr>
+              <a:t>&gt;</a:t>
+            </a:r>
+          </a:p>
+        </p:txBody>
+      </p:sp>
+      <p:sp>
+        <p:nvSpPr>
+          <p:cNvPr id="30" name="Rounded Rectangle 29"/>
+          <p:cNvSpPr/>
+          <p:nvPr/>
+        </p:nvSpPr>
+        <p:spPr>
+          <a:xfrm>
+            <a:off x="9240664" y="2139696"/>
+            <a:ext cx="760258" cy="841248"/>
+          </a:xfrm>
+          <a:prstGeom prst="roundRect">
+            <a:avLst/>
+          </a:prstGeom>
+          <a:solidFill>
+            <a:srgbClr val="EFEAFF"/>
+          </a:solidFill>
+          <a:ln w="9525">
+            <a:solidFill>
+              <a:srgbClr val="5B3BBF"/>
+            </a:solidFill>
+          </a:ln>
+          <a:effectLst/>
+        </p:spPr>
+        <p:style>
+          <a:lnRef idx="1">
+            <a:schemeClr val="accent1"/>
+          </a:lnRef>
+          <a:fillRef idx="3">
+            <a:schemeClr val="accent1"/>
+          </a:fillRef>
+          <a:effectRef idx="2">
+            <a:schemeClr val="accent1"/>
+          </a:effectRef>
+          <a:fontRef idx="minor">
+            <a:schemeClr val="lt1"/>
+          </a:fontRef>
+        </p:style>
+        <p:txBody>
+          <a:bodyPr rtlCol="0" anchor="ctr" wrap="square" lIns="27432" rIns="27432" tIns="9144" bIns="9144"/>
+          <a:lstStyle/>
+          <a:p>
+            <a:pPr algn="ctr">
+              <a:lnSpc>
+                <a:spcPct val="100000"/>
+              </a:lnSpc>
+              <a:spcBef>
+                <a:spcPts val="0"/>
+              </a:spcBef>
+              <a:spcAft>
+                <a:spcPts val="0"/>
+              </a:spcAft>
+            </a:pPr>
+            <a:r>
+              <a:rPr sz="1050" b="1">
+                <a:solidFill>
+                  <a:srgbClr val="1A1D21"/>
+                </a:solidFill>
+                <a:latin typeface="Malgun Gothic"/>
+              </a:rPr>
+              <a:t>(5)시뮬레이터</a:t>
+            </a:r>
+          </a:p>
+          <a:p>
+            <a:pPr algn="ctr">
+              <a:lnSpc>
+                <a:spcPct val="100000"/>
+              </a:lnSpc>
+              <a:spcBef>
+                <a:spcPts val="0"/>
+              </a:spcBef>
+              <a:spcAft>
+                <a:spcPts val="0"/>
+              </a:spcAft>
+            </a:pPr>
+            <a:r>
+              <a:rPr sz="400" b="0">
+                <a:solidFill>
+                  <a:srgbClr val="1A1D21"/>
+                </a:solidFill>
+                <a:latin typeface="Malgun Gothic"/>
+              </a:rPr>
+              <a:t> </a:t>
+            </a:r>
+          </a:p>
+          <a:p>
+            <a:pPr algn="ctr">
+              <a:lnSpc>
+                <a:spcPct val="100000"/>
+              </a:lnSpc>
+              <a:spcBef>
+                <a:spcPts val="0"/>
+              </a:spcBef>
+              <a:spcAft>
+                <a:spcPts val="0"/>
+              </a:spcAft>
+            </a:pPr>
+            <a:r>
+              <a:rPr sz="950" b="1">
+                <a:solidFill>
+                  <a:srgbClr val="5B3BBF"/>
+                </a:solidFill>
+                <a:latin typeface="Malgun Gothic"/>
+              </a:rPr>
+              <a:t>Ollama</a:t>
+            </a:r>
+          </a:p>
+        </p:txBody>
+      </p:sp>
+      <p:sp>
+        <p:nvSpPr>
+          <p:cNvPr id="31" name="TextBox 30"/>
+          <p:cNvSpPr txBox="1"/>
+          <p:nvPr/>
+        </p:nvSpPr>
+        <p:spPr>
+          <a:xfrm>
+            <a:off x="9982634" y="2139696"/>
+            <a:ext cx="91440" cy="841248"/>
+          </a:xfrm>
+          <a:prstGeom prst="rect">
+            <a:avLst/>
+          </a:prstGeom>
+          <a:noFill/>
+        </p:spPr>
+        <p:txBody>
+          <a:bodyPr wrap="square" anchor="ctr" lIns="0" rIns="0" tIns="9144" bIns="9144">
+            <a:spAutoFit/>
+          </a:bodyPr>
+          <a:lstStyle/>
+          <a:p>
+            <a:pPr algn="ctr">
+              <a:lnSpc>
+                <a:spcPct val="100000"/>
+              </a:lnSpc>
+              <a:spcBef>
+                <a:spcPts val="0"/>
+              </a:spcBef>
+              <a:spcAft>
+                <a:spcPts val="0"/>
+              </a:spcAft>
+            </a:pPr>
+            <a:r>
+              <a:rPr sz="1100" b="1">
+                <a:solidFill>
+                  <a:srgbClr val="5B6470"/>
+                </a:solidFill>
+                <a:latin typeface="Malgun Gothic"/>
+              </a:rPr>
+              <a:t>&gt;</a:t>
+            </a:r>
+          </a:p>
+        </p:txBody>
+      </p:sp>
+      <p:sp>
+        <p:nvSpPr>
+          <p:cNvPr id="32" name="Rounded Rectangle 31"/>
+          <p:cNvSpPr/>
+          <p:nvPr/>
+        </p:nvSpPr>
+        <p:spPr>
+          <a:xfrm>
+            <a:off x="10046642" y="2139696"/>
+            <a:ext cx="760258" cy="841248"/>
+          </a:xfrm>
+          <a:prstGeom prst="roundRect">
+            <a:avLst/>
+          </a:prstGeom>
+          <a:solidFill>
+            <a:srgbClr val="EEF1F5"/>
+          </a:solidFill>
+          <a:ln w="9525">
+            <a:solidFill>
+              <a:srgbClr val="6B7480"/>
+            </a:solidFill>
+          </a:ln>
+          <a:effectLst/>
+        </p:spPr>
+        <p:style>
+          <a:lnRef idx="1">
+            <a:schemeClr val="accent1"/>
+          </a:lnRef>
+          <a:fillRef idx="3">
+            <a:schemeClr val="accent1"/>
+          </a:fillRef>
+          <a:effectRef idx="2">
+            <a:schemeClr val="accent1"/>
+          </a:effectRef>
+          <a:fontRef idx="minor">
+            <a:schemeClr val="lt1"/>
+          </a:fontRef>
+        </p:style>
+        <p:txBody>
+          <a:bodyPr rtlCol="0" anchor="ctr" wrap="square" lIns="27432" rIns="27432" tIns="9144" bIns="9144"/>
+          <a:lstStyle/>
+          <a:p>
+            <a:pPr algn="ctr">
+              <a:lnSpc>
+                <a:spcPct val="100000"/>
+              </a:lnSpc>
+              <a:spcBef>
+                <a:spcPts val="0"/>
+              </a:spcBef>
+              <a:spcAft>
+                <a:spcPts val="0"/>
+              </a:spcAft>
+            </a:pPr>
+            <a:r>
+              <a:rPr sz="1050" b="1">
+                <a:solidFill>
+                  <a:srgbClr val="1A1D21"/>
+                </a:solidFill>
+                <a:latin typeface="Malgun Gothic"/>
+              </a:rPr>
+              <a:t>(6)리포트</a:t>
+            </a:r>
+          </a:p>
+          <a:p>
+            <a:pPr algn="ctr">
+              <a:lnSpc>
+                <a:spcPct val="100000"/>
+              </a:lnSpc>
+              <a:spcBef>
+                <a:spcPts val="0"/>
+              </a:spcBef>
+              <a:spcAft>
+                <a:spcPts val="0"/>
+              </a:spcAft>
+            </a:pPr>
+            <a:r>
+              <a:rPr sz="400" b="0">
+                <a:solidFill>
+                  <a:srgbClr val="1A1D21"/>
+                </a:solidFill>
+                <a:latin typeface="Malgun Gothic"/>
+              </a:rPr>
+              <a:t> </a:t>
+            </a:r>
+          </a:p>
+          <a:p>
+            <a:pPr algn="ctr">
+              <a:lnSpc>
+                <a:spcPct val="100000"/>
+              </a:lnSpc>
+              <a:spcBef>
+                <a:spcPts val="0"/>
+              </a:spcBef>
+              <a:spcAft>
+                <a:spcPts val="0"/>
+              </a:spcAft>
+            </a:pPr>
+            <a:r>
+              <a:rPr sz="950" b="1">
+                <a:solidFill>
+                  <a:srgbClr val="6B7480"/>
+                </a:solidFill>
+                <a:latin typeface="Malgun Gothic"/>
+              </a:rPr>
+              <a:t>결정적</a:t>
+            </a:r>
+          </a:p>
+        </p:txBody>
+      </p:sp>
+      <p:sp>
+        <p:nvSpPr>
+          <p:cNvPr id="33" name="TextBox 32"/>
+          <p:cNvSpPr txBox="1"/>
+          <p:nvPr/>
+        </p:nvSpPr>
+        <p:spPr>
+          <a:xfrm>
+            <a:off x="10788612" y="2139696"/>
+            <a:ext cx="91440" cy="841248"/>
+          </a:xfrm>
+          <a:prstGeom prst="rect">
+            <a:avLst/>
+          </a:prstGeom>
+          <a:noFill/>
+        </p:spPr>
+        <p:txBody>
+          <a:bodyPr wrap="square" anchor="ctr" lIns="0" rIns="0" tIns="9144" bIns="9144">
+            <a:spAutoFit/>
+          </a:bodyPr>
+          <a:lstStyle/>
+          <a:p>
+            <a:pPr algn="ctr">
+              <a:lnSpc>
+                <a:spcPct val="100000"/>
+              </a:lnSpc>
+              <a:spcBef>
+                <a:spcPts val="0"/>
+              </a:spcBef>
+              <a:spcAft>
+                <a:spcPts val="0"/>
+              </a:spcAft>
+            </a:pPr>
+            <a:r>
+              <a:rPr sz="1100" b="1">
+                <a:solidFill>
+                  <a:srgbClr val="5B6470"/>
+                </a:solidFill>
+                <a:latin typeface="Malgun Gothic"/>
+              </a:rPr>
+              <a:t>&gt;</a:t>
+            </a:r>
+          </a:p>
+        </p:txBody>
+      </p:sp>
+      <p:sp>
+        <p:nvSpPr>
+          <p:cNvPr id="34" name="Rounded Rectangle 33"/>
+          <p:cNvSpPr/>
+          <p:nvPr/>
+        </p:nvSpPr>
+        <p:spPr>
+          <a:xfrm>
+            <a:off x="10852620" y="2139696"/>
+            <a:ext cx="760258" cy="841248"/>
+          </a:xfrm>
+          <a:prstGeom prst="roundRect">
+            <a:avLst/>
+          </a:prstGeom>
+          <a:solidFill>
+            <a:srgbClr val="EEF1F5"/>
+          </a:solidFill>
+          <a:ln w="9525">
+            <a:solidFill>
+              <a:srgbClr val="6B7480"/>
+            </a:solidFill>
+          </a:ln>
+          <a:effectLst/>
+        </p:spPr>
+        <p:style>
+          <a:lnRef idx="1">
+            <a:schemeClr val="accent1"/>
+          </a:lnRef>
+          <a:fillRef idx="3">
+            <a:schemeClr val="accent1"/>
+          </a:fillRef>
+          <a:effectRef idx="2">
+            <a:schemeClr val="accent1"/>
+          </a:effectRef>
+          <a:fontRef idx="minor">
+            <a:schemeClr val="lt1"/>
+          </a:fontRef>
+        </p:style>
+        <p:txBody>
+          <a:bodyPr rtlCol="0" anchor="ctr" wrap="square" lIns="27432" rIns="27432" tIns="9144" bIns="9144"/>
+          <a:lstStyle/>
+          <a:p>
+            <a:pPr algn="ctr">
+              <a:lnSpc>
+                <a:spcPct val="100000"/>
+              </a:lnSpc>
+              <a:spcBef>
+                <a:spcPts val="0"/>
+              </a:spcBef>
+              <a:spcAft>
+                <a:spcPts val="0"/>
+              </a:spcAft>
+            </a:pPr>
+            <a:r>
+              <a:rPr sz="1050" b="1">
+                <a:solidFill>
+                  <a:srgbClr val="1A1D21"/>
+                </a:solidFill>
+                <a:latin typeface="Malgun Gothic"/>
+              </a:rPr>
+              <a:t>(7,8)승인·감사</a:t>
+            </a:r>
+          </a:p>
+          <a:p>
+            <a:pPr algn="ctr">
+              <a:lnSpc>
+                <a:spcPct val="100000"/>
+              </a:lnSpc>
+              <a:spcBef>
+                <a:spcPts val="0"/>
+              </a:spcBef>
+              <a:spcAft>
+                <a:spcPts val="0"/>
+              </a:spcAft>
+            </a:pPr>
+            <a:r>
+              <a:rPr sz="400" b="0">
+                <a:solidFill>
+                  <a:srgbClr val="1A1D21"/>
+                </a:solidFill>
+                <a:latin typeface="Malgun Gothic"/>
+              </a:rPr>
+              <a:t> </a:t>
+            </a:r>
+          </a:p>
+          <a:p>
+            <a:pPr algn="ctr">
+              <a:lnSpc>
+                <a:spcPct val="100000"/>
+              </a:lnSpc>
+              <a:spcBef>
+                <a:spcPts val="0"/>
+              </a:spcBef>
+              <a:spcAft>
+                <a:spcPts val="0"/>
+              </a:spcAft>
+            </a:pPr>
+            <a:r>
+              <a:rPr sz="950" b="1">
+                <a:solidFill>
+                  <a:srgbClr val="6B7480"/>
+                </a:solidFill>
+                <a:latin typeface="Malgun Gothic"/>
+              </a:rPr>
+              <a:t>결정적</a:t>
+            </a:r>
+          </a:p>
+        </p:txBody>
+      </p:sp>
+      <p:sp>
+        <p:nvSpPr>
+          <p:cNvPr id="35" name="Rounded Rectangle 34"/>
+          <p:cNvSpPr/>
+          <p:nvPr/>
+        </p:nvSpPr>
+        <p:spPr>
+          <a:xfrm>
+            <a:off x="6016752" y="3072384"/>
+            <a:ext cx="5596128" cy="438912"/>
+          </a:xfrm>
+          <a:prstGeom prst="roundRect">
+            <a:avLst/>
+          </a:prstGeom>
+          <a:solidFill>
+            <a:srgbClr val="EFEAFF"/>
+          </a:solidFill>
+          <a:ln w="9525">
+            <a:solidFill>
+              <a:srgbClr val="5B3BBF"/>
+            </a:solidFill>
+          </a:ln>
+          <a:effectLst/>
+        </p:spPr>
+        <p:style>
+          <a:lnRef idx="1">
+            <a:schemeClr val="accent1"/>
+          </a:lnRef>
+          <a:fillRef idx="3">
+            <a:schemeClr val="accent1"/>
+          </a:fillRef>
+          <a:effectRef idx="2">
+            <a:schemeClr val="accent1"/>
+          </a:effectRef>
+          <a:fontRef idx="minor">
+            <a:schemeClr val="lt1"/>
+          </a:fontRef>
+        </p:style>
+        <p:txBody>
+          <a:bodyPr rtlCol="0" anchor="ctr" wrap="square" lIns="128016" rIns="128016" tIns="9144" bIns="9144"/>
           <a:lstStyle/>
           <a:p>
             <a:pPr algn="l">
@@ -4186,37 +5283,91 @@
               </a:spcAft>
             </a:pPr>
             <a:r>
-              <a:rPr sz="950" b="1">
-                <a:solidFill>
-                  <a:srgbClr val="00529B"/>
-                </a:solidFill>
-                <a:latin typeface="맑은 고딕"/>
-              </a:rPr>
-              <a:t>⚙ 백엔드 / API — FastAPI (app/main.py) · REST 엔드포인트</a:t>
-            </a:r>
-          </a:p>
-        </p:txBody>
-      </p:sp>
-      <p:sp>
-        <p:nvSpPr>
-          <p:cNvPr id="22" name="Rounded Rectangle 21"/>
+              <a:rPr sz="1150" b="1">
+                <a:solidFill>
+                  <a:srgbClr val="5B3BBF"/>
+                </a:solidFill>
+                <a:latin typeface="Malgun Gothic"/>
+              </a:rPr>
+              <a:t>* 준법 오토파일럿</a:t>
+            </a:r>
+            <a:r>
+              <a:rPr sz="1000" b="0">
+                <a:solidFill>
+                  <a:srgbClr val="5B6470"/>
+                </a:solidFill>
+                <a:latin typeface="Malgun Gothic"/>
+              </a:rPr>
+              <a:t>  판단-&gt;고쳐쓰기-&gt;재심의 자율 개선 루프 (Ollama)</a:t>
+            </a:r>
+          </a:p>
+        </p:txBody>
+      </p:sp>
+      <p:sp>
+        <p:nvSpPr>
+          <p:cNvPr id="36" name="TextBox 35"/>
+          <p:cNvSpPr txBox="1"/>
+          <p:nvPr/>
+        </p:nvSpPr>
+        <p:spPr>
+          <a:xfrm>
+            <a:off x="6016752" y="3602736"/>
+            <a:ext cx="5596128" cy="237744"/>
+          </a:xfrm>
+          <a:prstGeom prst="rect">
+            <a:avLst/>
+          </a:prstGeom>
+          <a:noFill/>
+        </p:spPr>
+        <p:txBody>
+          <a:bodyPr wrap="square" anchor="t" lIns="0" rIns="0" tIns="9144" bIns="9144">
+            <a:spAutoFit/>
+          </a:bodyPr>
+          <a:lstStyle/>
+          <a:p>
+            <a:pPr algn="l">
+              <a:lnSpc>
+                <a:spcPct val="100000"/>
+              </a:lnSpc>
+              <a:spcBef>
+                <a:spcPts val="0"/>
+              </a:spcBef>
+              <a:spcAft>
+                <a:spcPts val="0"/>
+              </a:spcAft>
+            </a:pPr>
+            <a:r>
+              <a:rPr sz="1150" b="1">
+                <a:solidFill>
+                  <a:srgbClr val="003A6E"/>
+                </a:solidFill>
+                <a:latin typeface="Malgun Gothic"/>
+              </a:rPr>
+              <a:t>[엔진] 어느 모델이 어느 단계에 쓰이나</a:t>
+            </a:r>
+          </a:p>
+        </p:txBody>
+      </p:sp>
+      <p:sp>
+        <p:nvSpPr>
+          <p:cNvPr id="37" name="Rounded Rectangle 36"/>
           <p:cNvSpPr/>
           <p:nvPr/>
         </p:nvSpPr>
         <p:spPr>
           <a:xfrm>
-            <a:off x="6035040" y="1773936"/>
-            <a:ext cx="728907" cy="237744"/>
+            <a:off x="6016752" y="3877056"/>
+            <a:ext cx="2606040" cy="338328"/>
           </a:xfrm>
           <a:prstGeom prst="roundRect">
             <a:avLst/>
           </a:prstGeom>
           <a:solidFill>
-            <a:srgbClr val="FFFFFF"/>
+            <a:srgbClr val="EFEAFF"/>
           </a:solidFill>
           <a:ln w="9525">
             <a:solidFill>
-              <a:srgbClr val="BCD6F2"/>
+              <a:srgbClr val="5B3BBF"/>
             </a:solidFill>
           </a:ln>
           <a:effectLst/>
@@ -4236,10 +5387,10 @@
           </a:fontRef>
         </p:style>
         <p:txBody>
-          <a:bodyPr rtlCol="0" anchor="ctr" wrap="square" lIns="18288" rIns="18288" tIns="9144" bIns="9144"/>
-          <a:lstStyle/>
-          <a:p>
-            <a:pPr algn="ctr">
+          <a:bodyPr rtlCol="0" anchor="ctr" wrap="square" tIns="9144" bIns="9144"/>
+          <a:lstStyle/>
+          <a:p>
+            <a:pPr algn="l">
               <a:lnSpc>
                 <a:spcPct val="100000"/>
               </a:lnSpc>
@@ -4251,37 +5402,82 @@
               </a:spcAft>
             </a:pPr>
             <a:r>
-              <a:rPr sz="780" b="0">
-                <a:solidFill>
-                  <a:srgbClr val="003A6E"/>
-                </a:solidFill>
-                <a:latin typeface="맑은 고딕"/>
-              </a:rPr>
-              <a:t>/review</a:t>
-            </a:r>
-          </a:p>
-        </p:txBody>
-      </p:sp>
-      <p:sp>
-        <p:nvSpPr>
-          <p:cNvPr id="23" name="Rounded Rectangle 22"/>
+              <a:rPr sz="1000" b="1">
+                <a:solidFill>
+                  <a:srgbClr val="5B3BBF"/>
+                </a:solidFill>
+                <a:latin typeface="Malgun Gothic"/>
+              </a:rPr>
+              <a:t>Ollama · Qwen2.5-7B (LLM 추론)</a:t>
+            </a:r>
+          </a:p>
+        </p:txBody>
+      </p:sp>
+      <p:sp>
+        <p:nvSpPr>
+          <p:cNvPr id="38" name="TextBox 37"/>
+          <p:cNvSpPr txBox="1"/>
+          <p:nvPr/>
+        </p:nvSpPr>
+        <p:spPr>
+          <a:xfrm>
+            <a:off x="8741664" y="3877056"/>
+            <a:ext cx="2871216" cy="338328"/>
+          </a:xfrm>
+          <a:prstGeom prst="rect">
+            <a:avLst/>
+          </a:prstGeom>
+          <a:noFill/>
+        </p:spPr>
+        <p:txBody>
+          <a:bodyPr wrap="square" anchor="ctr" lIns="0" rIns="0" tIns="9144" bIns="9144">
+            <a:spAutoFit/>
+          </a:bodyPr>
+          <a:lstStyle/>
+          <a:p>
+            <a:pPr algn="l">
+              <a:lnSpc>
+                <a:spcPct val="100000"/>
+              </a:lnSpc>
+              <a:spcBef>
+                <a:spcPts val="0"/>
+              </a:spcBef>
+              <a:spcAft>
+                <a:spcPts val="0"/>
+              </a:spcAft>
+            </a:pPr>
+            <a:r>
+              <a:rPr sz="969" b="0">
+                <a:solidFill>
+                  <a:srgbClr val="1A1D21"/>
+                </a:solidFill>
+                <a:latin typeface="Malgun Gothic"/>
+              </a:rPr>
+              <a:t>-&gt; (4)LLM 심의 · (5)오인 시뮬레이터 · *오토파일럿 · 내규 변환 · 다국어 재심의</a:t>
+            </a:r>
+          </a:p>
+        </p:txBody>
+      </p:sp>
+      <p:sp>
+        <p:nvSpPr>
+          <p:cNvPr id="39" name="Rounded Rectangle 38"/>
           <p:cNvSpPr/>
           <p:nvPr/>
         </p:nvSpPr>
         <p:spPr>
           <a:xfrm>
-            <a:off x="6827955" y="1773936"/>
-            <a:ext cx="728907" cy="237744"/>
+            <a:off x="6016752" y="4242816"/>
+            <a:ext cx="2606040" cy="338328"/>
           </a:xfrm>
           <a:prstGeom prst="roundRect">
             <a:avLst/>
           </a:prstGeom>
           <a:solidFill>
-            <a:srgbClr val="FFFFFF"/>
+            <a:srgbClr val="E7F6EE"/>
           </a:solidFill>
           <a:ln w="9525">
             <a:solidFill>
-              <a:srgbClr val="BCD6F2"/>
+              <a:srgbClr val="0F9D58"/>
             </a:solidFill>
           </a:ln>
           <a:effectLst/>
@@ -4301,10 +5497,10 @@
           </a:fontRef>
         </p:style>
         <p:txBody>
-          <a:bodyPr rtlCol="0" anchor="ctr" wrap="square" lIns="18288" rIns="18288" tIns="9144" bIns="9144"/>
-          <a:lstStyle/>
-          <a:p>
-            <a:pPr algn="ctr">
+          <a:bodyPr rtlCol="0" anchor="ctr" wrap="square" tIns="9144" bIns="9144"/>
+          <a:lstStyle/>
+          <a:p>
+            <a:pPr algn="l">
               <a:lnSpc>
                 <a:spcPct val="100000"/>
               </a:lnSpc>
@@ -4316,37 +5512,82 @@
               </a:spcAft>
             </a:pPr>
             <a:r>
-              <a:rPr sz="780" b="0">
-                <a:solidFill>
-                  <a:srgbClr val="003A6E"/>
-                </a:solidFill>
-                <a:latin typeface="맑은 고딕"/>
-              </a:rPr>
-              <a:t>/autopilot</a:t>
-            </a:r>
-          </a:p>
-        </p:txBody>
-      </p:sp>
-      <p:sp>
-        <p:nvSpPr>
-          <p:cNvPr id="24" name="Rounded Rectangle 23"/>
+              <a:rPr sz="1000" b="1">
+                <a:solidFill>
+                  <a:srgbClr val="0F9D58"/>
+                </a:solidFill>
+                <a:latin typeface="Malgun Gothic"/>
+              </a:rPr>
+              <a:t>BGE-m3 (임베딩, 선택)</a:t>
+            </a:r>
+          </a:p>
+        </p:txBody>
+      </p:sp>
+      <p:sp>
+        <p:nvSpPr>
+          <p:cNvPr id="40" name="TextBox 39"/>
+          <p:cNvSpPr txBox="1"/>
+          <p:nvPr/>
+        </p:nvSpPr>
+        <p:spPr>
+          <a:xfrm>
+            <a:off x="8741664" y="4242816"/>
+            <a:ext cx="2871216" cy="338328"/>
+          </a:xfrm>
+          <a:prstGeom prst="rect">
+            <a:avLst/>
+          </a:prstGeom>
+          <a:noFill/>
+        </p:spPr>
+        <p:txBody>
+          <a:bodyPr wrap="square" anchor="ctr" lIns="0" rIns="0" tIns="9144" bIns="9144">
+            <a:spAutoFit/>
+          </a:bodyPr>
+          <a:lstStyle/>
+          <a:p>
+            <a:pPr algn="l">
+              <a:lnSpc>
+                <a:spcPct val="100000"/>
+              </a:lnSpc>
+              <a:spcBef>
+                <a:spcPts val="0"/>
+              </a:spcBef>
+              <a:spcAft>
+                <a:spcPts val="0"/>
+              </a:spcAft>
+            </a:pPr>
+            <a:r>
+              <a:rPr sz="969" b="0">
+                <a:solidFill>
+                  <a:srgbClr val="1A1D21"/>
+                </a:solidFill>
+                <a:latin typeface="Malgun Gothic"/>
+              </a:rPr>
+              <a:t>-&gt; (2) RAG 근거검색 - 미설치 시 어휘검색으로 자동 폴백</a:t>
+            </a:r>
+          </a:p>
+        </p:txBody>
+      </p:sp>
+      <p:sp>
+        <p:nvSpPr>
+          <p:cNvPr id="41" name="Rounded Rectangle 40"/>
           <p:cNvSpPr/>
           <p:nvPr/>
         </p:nvSpPr>
         <p:spPr>
           <a:xfrm>
-            <a:off x="7620870" y="1773936"/>
-            <a:ext cx="728907" cy="237744"/>
+            <a:off x="6016752" y="4608576"/>
+            <a:ext cx="2606040" cy="338328"/>
           </a:xfrm>
           <a:prstGeom prst="roundRect">
             <a:avLst/>
           </a:prstGeom>
           <a:solidFill>
-            <a:srgbClr val="FFFFFF"/>
+            <a:srgbClr val="EEF1F5"/>
           </a:solidFill>
           <a:ln w="9525">
             <a:solidFill>
-              <a:srgbClr val="BCD6F2"/>
+              <a:srgbClr val="6B7480"/>
             </a:solidFill>
           </a:ln>
           <a:effectLst/>
@@ -4366,312 +5607,7 @@
           </a:fontRef>
         </p:style>
         <p:txBody>
-          <a:bodyPr rtlCol="0" anchor="ctr" wrap="square" lIns="18288" rIns="18288" tIns="9144" bIns="9144"/>
-          <a:lstStyle/>
-          <a:p>
-            <a:pPr algn="ctr">
-              <a:lnSpc>
-                <a:spcPct val="100000"/>
-              </a:lnSpc>
-              <a:spcBef>
-                <a:spcPts val="0"/>
-              </a:spcBef>
-              <a:spcAft>
-                <a:spcPts val="0"/>
-              </a:spcAft>
-            </a:pPr>
-            <a:r>
-              <a:rPr sz="780" b="0">
-                <a:solidFill>
-                  <a:srgbClr val="003A6E"/>
-                </a:solidFill>
-                <a:latin typeface="맑은 고딕"/>
-              </a:rPr>
-              <a:t>/submissions</a:t>
-            </a:r>
-          </a:p>
-        </p:txBody>
-      </p:sp>
-      <p:sp>
-        <p:nvSpPr>
-          <p:cNvPr id="25" name="Rounded Rectangle 24"/>
-          <p:cNvSpPr/>
-          <p:nvPr/>
-        </p:nvSpPr>
-        <p:spPr>
-          <a:xfrm>
-            <a:off x="8413785" y="1773936"/>
-            <a:ext cx="728907" cy="237744"/>
-          </a:xfrm>
-          <a:prstGeom prst="roundRect">
-            <a:avLst/>
-          </a:prstGeom>
-          <a:solidFill>
-            <a:srgbClr val="FFFFFF"/>
-          </a:solidFill>
-          <a:ln w="9525">
-            <a:solidFill>
-              <a:srgbClr val="BCD6F2"/>
-            </a:solidFill>
-          </a:ln>
-          <a:effectLst/>
-        </p:spPr>
-        <p:style>
-          <a:lnRef idx="1">
-            <a:schemeClr val="accent1"/>
-          </a:lnRef>
-          <a:fillRef idx="3">
-            <a:schemeClr val="accent1"/>
-          </a:fillRef>
-          <a:effectRef idx="2">
-            <a:schemeClr val="accent1"/>
-          </a:effectRef>
-          <a:fontRef idx="minor">
-            <a:schemeClr val="lt1"/>
-          </a:fontRef>
-        </p:style>
-        <p:txBody>
-          <a:bodyPr rtlCol="0" anchor="ctr" wrap="square" lIns="18288" rIns="18288" tIns="9144" bIns="9144"/>
-          <a:lstStyle/>
-          <a:p>
-            <a:pPr algn="ctr">
-              <a:lnSpc>
-                <a:spcPct val="100000"/>
-              </a:lnSpc>
-              <a:spcBef>
-                <a:spcPts val="0"/>
-              </a:spcBef>
-              <a:spcAft>
-                <a:spcPts val="0"/>
-              </a:spcAft>
-            </a:pPr>
-            <a:r>
-              <a:rPr sz="780" b="0">
-                <a:solidFill>
-                  <a:srgbClr val="003A6E"/>
-                </a:solidFill>
-                <a:latin typeface="맑은 고딕"/>
-              </a:rPr>
-              <a:t>/internal-rules</a:t>
-            </a:r>
-          </a:p>
-        </p:txBody>
-      </p:sp>
-      <p:sp>
-        <p:nvSpPr>
-          <p:cNvPr id="26" name="Rounded Rectangle 25"/>
-          <p:cNvSpPr/>
-          <p:nvPr/>
-        </p:nvSpPr>
-        <p:spPr>
-          <a:xfrm>
-            <a:off x="9206700" y="1773936"/>
-            <a:ext cx="728907" cy="237744"/>
-          </a:xfrm>
-          <a:prstGeom prst="roundRect">
-            <a:avLst/>
-          </a:prstGeom>
-          <a:solidFill>
-            <a:srgbClr val="FFFFFF"/>
-          </a:solidFill>
-          <a:ln w="9525">
-            <a:solidFill>
-              <a:srgbClr val="BCD6F2"/>
-            </a:solidFill>
-          </a:ln>
-          <a:effectLst/>
-        </p:spPr>
-        <p:style>
-          <a:lnRef idx="1">
-            <a:schemeClr val="accent1"/>
-          </a:lnRef>
-          <a:fillRef idx="3">
-            <a:schemeClr val="accent1"/>
-          </a:fillRef>
-          <a:effectRef idx="2">
-            <a:schemeClr val="accent1"/>
-          </a:effectRef>
-          <a:fontRef idx="minor">
-            <a:schemeClr val="lt1"/>
-          </a:fontRef>
-        </p:style>
-        <p:txBody>
-          <a:bodyPr rtlCol="0" anchor="ctr" wrap="square" lIns="18288" rIns="18288" tIns="9144" bIns="9144"/>
-          <a:lstStyle/>
-          <a:p>
-            <a:pPr algn="ctr">
-              <a:lnSpc>
-                <a:spcPct val="100000"/>
-              </a:lnSpc>
-              <a:spcBef>
-                <a:spcPts val="0"/>
-              </a:spcBef>
-              <a:spcAft>
-                <a:spcPts val="0"/>
-              </a:spcAft>
-            </a:pPr>
-            <a:r>
-              <a:rPr sz="780" b="0">
-                <a:solidFill>
-                  <a:srgbClr val="003A6E"/>
-                </a:solidFill>
-                <a:latin typeface="맑은 고딕"/>
-              </a:rPr>
-              <a:t>/regwatch</a:t>
-            </a:r>
-          </a:p>
-        </p:txBody>
-      </p:sp>
-      <p:sp>
-        <p:nvSpPr>
-          <p:cNvPr id="27" name="Rounded Rectangle 26"/>
-          <p:cNvSpPr/>
-          <p:nvPr/>
-        </p:nvSpPr>
-        <p:spPr>
-          <a:xfrm>
-            <a:off x="9999615" y="1773936"/>
-            <a:ext cx="728907" cy="237744"/>
-          </a:xfrm>
-          <a:prstGeom prst="roundRect">
-            <a:avLst/>
-          </a:prstGeom>
-          <a:solidFill>
-            <a:srgbClr val="FFFFFF"/>
-          </a:solidFill>
-          <a:ln w="9525">
-            <a:solidFill>
-              <a:srgbClr val="BCD6F2"/>
-            </a:solidFill>
-          </a:ln>
-          <a:effectLst/>
-        </p:spPr>
-        <p:style>
-          <a:lnRef idx="1">
-            <a:schemeClr val="accent1"/>
-          </a:lnRef>
-          <a:fillRef idx="3">
-            <a:schemeClr val="accent1"/>
-          </a:fillRef>
-          <a:effectRef idx="2">
-            <a:schemeClr val="accent1"/>
-          </a:effectRef>
-          <a:fontRef idx="minor">
-            <a:schemeClr val="lt1"/>
-          </a:fontRef>
-        </p:style>
-        <p:txBody>
-          <a:bodyPr rtlCol="0" anchor="ctr" wrap="square" lIns="18288" rIns="18288" tIns="9144" bIns="9144"/>
-          <a:lstStyle/>
-          <a:p>
-            <a:pPr algn="ctr">
-              <a:lnSpc>
-                <a:spcPct val="100000"/>
-              </a:lnSpc>
-              <a:spcBef>
-                <a:spcPts val="0"/>
-              </a:spcBef>
-              <a:spcAft>
-                <a:spcPts val="0"/>
-              </a:spcAft>
-            </a:pPr>
-            <a:r>
-              <a:rPr sz="780" b="0">
-                <a:solidFill>
-                  <a:srgbClr val="003A6E"/>
-                </a:solidFill>
-                <a:latin typeface="맑은 고딕"/>
-              </a:rPr>
-              <a:t>/dist</a:t>
-            </a:r>
-          </a:p>
-        </p:txBody>
-      </p:sp>
-      <p:sp>
-        <p:nvSpPr>
-          <p:cNvPr id="28" name="Rounded Rectangle 27"/>
-          <p:cNvSpPr/>
-          <p:nvPr/>
-        </p:nvSpPr>
-        <p:spPr>
-          <a:xfrm>
-            <a:off x="10792530" y="1773936"/>
-            <a:ext cx="728907" cy="237744"/>
-          </a:xfrm>
-          <a:prstGeom prst="roundRect">
-            <a:avLst/>
-          </a:prstGeom>
-          <a:solidFill>
-            <a:srgbClr val="FFFFFF"/>
-          </a:solidFill>
-          <a:ln w="9525">
-            <a:solidFill>
-              <a:srgbClr val="BCD6F2"/>
-            </a:solidFill>
-          </a:ln>
-          <a:effectLst/>
-        </p:spPr>
-        <p:style>
-          <a:lnRef idx="1">
-            <a:schemeClr val="accent1"/>
-          </a:lnRef>
-          <a:fillRef idx="3">
-            <a:schemeClr val="accent1"/>
-          </a:fillRef>
-          <a:effectRef idx="2">
-            <a:schemeClr val="accent1"/>
-          </a:effectRef>
-          <a:fontRef idx="minor">
-            <a:schemeClr val="lt1"/>
-          </a:fontRef>
-        </p:style>
-        <p:txBody>
-          <a:bodyPr rtlCol="0" anchor="ctr" wrap="square" lIns="18288" rIns="18288" tIns="9144" bIns="9144"/>
-          <a:lstStyle/>
-          <a:p>
-            <a:pPr algn="ctr">
-              <a:lnSpc>
-                <a:spcPct val="100000"/>
-              </a:lnSpc>
-              <a:spcBef>
-                <a:spcPts val="0"/>
-              </a:spcBef>
-              <a:spcAft>
-                <a:spcPts val="0"/>
-              </a:spcAft>
-            </a:pPr>
-            <a:r>
-              <a:rPr sz="780" b="0">
-                <a:solidFill>
-                  <a:srgbClr val="003A6E"/>
-                </a:solidFill>
-                <a:latin typeface="맑은 고딕"/>
-              </a:rPr>
-              <a:t>/products</a:t>
-            </a:r>
-          </a:p>
-        </p:txBody>
-      </p:sp>
-      <p:sp>
-        <p:nvSpPr>
-          <p:cNvPr id="29" name="TextBox 28"/>
-          <p:cNvSpPr txBox="1"/>
-          <p:nvPr/>
-        </p:nvSpPr>
-        <p:spPr>
-          <a:xfrm>
-            <a:off x="6080760" y="2157984"/>
-            <a:ext cx="5486400" cy="219456"/>
-          </a:xfrm>
-          <a:prstGeom prst="rect">
-            <a:avLst/>
-          </a:prstGeom>
-          <a:noFill/>
-        </p:spPr>
-        <p:txBody>
-          <a:bodyPr wrap="square" anchor="t" lIns="0" rIns="0" tIns="9144" bIns="9144">
-            <a:spAutoFit/>
-          </a:bodyPr>
+          <a:bodyPr rtlCol="0" anchor="ctr" wrap="square" tIns="9144" bIns="9144"/>
           <a:lstStyle/>
           <a:p>
             <a:pPr algn="l">
@@ -4686,92 +5622,27 @@
               </a:spcAft>
             </a:pPr>
             <a:r>
-              <a:rPr sz="950" b="1">
-                <a:solidFill>
-                  <a:srgbClr val="5B3BBF"/>
-                </a:solidFill>
-                <a:latin typeface="맑은 고딕"/>
-              </a:rPr>
-              <a:t>🧠 AI Agent · Orchestrator (명시적 파이썬 파이프라인)</a:t>
-            </a:r>
-          </a:p>
-        </p:txBody>
-      </p:sp>
-      <p:sp>
-        <p:nvSpPr>
-          <p:cNvPr id="30" name="Rounded Rectangle 29"/>
-          <p:cNvSpPr/>
-          <p:nvPr/>
-        </p:nvSpPr>
-        <p:spPr>
-          <a:xfrm>
-            <a:off x="6035040" y="2395728"/>
-            <a:ext cx="728907" cy="457200"/>
-          </a:xfrm>
-          <a:prstGeom prst="roundRect">
-            <a:avLst/>
-          </a:prstGeom>
-          <a:solidFill>
-            <a:srgbClr val="FFFFFF"/>
-          </a:solidFill>
-          <a:ln w="9525">
-            <a:solidFill>
-              <a:srgbClr val="CDBFF0"/>
-            </a:solidFill>
-          </a:ln>
-          <a:effectLst/>
-        </p:spPr>
-        <p:style>
-          <a:lnRef idx="1">
-            <a:schemeClr val="accent1"/>
-          </a:lnRef>
-          <a:fillRef idx="3">
-            <a:schemeClr val="accent1"/>
-          </a:fillRef>
-          <a:effectRef idx="2">
-            <a:schemeClr val="accent1"/>
-          </a:effectRef>
-          <a:fontRef idx="minor">
-            <a:schemeClr val="lt1"/>
-          </a:fontRef>
-        </p:style>
-        <p:txBody>
-          <a:bodyPr rtlCol="0" anchor="ctr" wrap="square" lIns="27432" rIns="27432" tIns="9144" bIns="9144"/>
-          <a:lstStyle/>
-          <a:p>
-            <a:pPr algn="ctr">
-              <a:lnSpc>
-                <a:spcPct val="100000"/>
-              </a:lnSpc>
-              <a:spcBef>
-                <a:spcPts val="0"/>
-              </a:spcBef>
-              <a:spcAft>
-                <a:spcPts val="0"/>
-              </a:spcAft>
-            </a:pPr>
-            <a:r>
-              <a:rPr sz="830" b="0">
-                <a:solidFill>
-                  <a:srgbClr val="1A1D21"/>
-                </a:solidFill>
-                <a:latin typeface="맑은 고딕"/>
-              </a:rPr>
-              <a:t>①유형분류</a:t>
-            </a:r>
-          </a:p>
-        </p:txBody>
-      </p:sp>
-      <p:sp>
-        <p:nvSpPr>
-          <p:cNvPr id="31" name="TextBox 30"/>
+              <a:rPr sz="1000" b="1">
+                <a:solidFill>
+                  <a:srgbClr val="6B7480"/>
+                </a:solidFill>
+                <a:latin typeface="Malgun Gothic"/>
+              </a:rPr>
+              <a:t>결정적 엔진 (모델 없음)</a:t>
+            </a:r>
+          </a:p>
+        </p:txBody>
+      </p:sp>
+      <p:sp>
+        <p:nvSpPr>
+          <p:cNvPr id="42" name="TextBox 41"/>
           <p:cNvSpPr txBox="1"/>
           <p:nvPr/>
         </p:nvSpPr>
         <p:spPr>
           <a:xfrm>
-            <a:off x="6727371" y="2395728"/>
-            <a:ext cx="109728" cy="457200"/>
+            <a:off x="8741664" y="4608576"/>
+            <a:ext cx="2871216" cy="338328"/>
           </a:xfrm>
           <a:prstGeom prst="rect">
             <a:avLst/>
@@ -4782,686 +5653,6 @@
           <a:bodyPr wrap="square" anchor="ctr" lIns="0" rIns="0" tIns="9144" bIns="9144">
             <a:spAutoFit/>
           </a:bodyPr>
-          <a:lstStyle/>
-          <a:p>
-            <a:pPr algn="ctr">
-              <a:lnSpc>
-                <a:spcPct val="100000"/>
-              </a:lnSpc>
-              <a:spcBef>
-                <a:spcPts val="0"/>
-              </a:spcBef>
-              <a:spcAft>
-                <a:spcPts val="0"/>
-              </a:spcAft>
-            </a:pPr>
-            <a:r>
-              <a:rPr sz="800" b="1">
-                <a:solidFill>
-                  <a:srgbClr val="5B6470"/>
-                </a:solidFill>
-                <a:latin typeface="맑은 고딕"/>
-              </a:rPr>
-              <a:t>▸</a:t>
-            </a:r>
-          </a:p>
-        </p:txBody>
-      </p:sp>
-      <p:sp>
-        <p:nvSpPr>
-          <p:cNvPr id="32" name="Rounded Rectangle 31"/>
-          <p:cNvSpPr/>
-          <p:nvPr/>
-        </p:nvSpPr>
-        <p:spPr>
-          <a:xfrm>
-            <a:off x="6827955" y="2395728"/>
-            <a:ext cx="728907" cy="457200"/>
-          </a:xfrm>
-          <a:prstGeom prst="roundRect">
-            <a:avLst/>
-          </a:prstGeom>
-          <a:solidFill>
-            <a:srgbClr val="FFFFFF"/>
-          </a:solidFill>
-          <a:ln w="9525">
-            <a:solidFill>
-              <a:srgbClr val="CDBFF0"/>
-            </a:solidFill>
-          </a:ln>
-          <a:effectLst/>
-        </p:spPr>
-        <p:style>
-          <a:lnRef idx="1">
-            <a:schemeClr val="accent1"/>
-          </a:lnRef>
-          <a:fillRef idx="3">
-            <a:schemeClr val="accent1"/>
-          </a:fillRef>
-          <a:effectRef idx="2">
-            <a:schemeClr val="accent1"/>
-          </a:effectRef>
-          <a:fontRef idx="minor">
-            <a:schemeClr val="lt1"/>
-          </a:fontRef>
-        </p:style>
-        <p:txBody>
-          <a:bodyPr rtlCol="0" anchor="ctr" wrap="square" lIns="27432" rIns="27432" tIns="9144" bIns="9144"/>
-          <a:lstStyle/>
-          <a:p>
-            <a:pPr algn="ctr">
-              <a:lnSpc>
-                <a:spcPct val="100000"/>
-              </a:lnSpc>
-              <a:spcBef>
-                <a:spcPts val="0"/>
-              </a:spcBef>
-              <a:spcAft>
-                <a:spcPts val="0"/>
-              </a:spcAft>
-            </a:pPr>
-            <a:r>
-              <a:rPr sz="830" b="0">
-                <a:solidFill>
-                  <a:srgbClr val="1A1D21"/>
-                </a:solidFill>
-                <a:latin typeface="맑은 고딕"/>
-              </a:rPr>
-              <a:t>②RAG 검색</a:t>
-            </a:r>
-          </a:p>
-        </p:txBody>
-      </p:sp>
-      <p:sp>
-        <p:nvSpPr>
-          <p:cNvPr id="33" name="TextBox 32"/>
-          <p:cNvSpPr txBox="1"/>
-          <p:nvPr/>
-        </p:nvSpPr>
-        <p:spPr>
-          <a:xfrm>
-            <a:off x="7520286" y="2395728"/>
-            <a:ext cx="109728" cy="457200"/>
-          </a:xfrm>
-          <a:prstGeom prst="rect">
-            <a:avLst/>
-          </a:prstGeom>
-          <a:noFill/>
-        </p:spPr>
-        <p:txBody>
-          <a:bodyPr wrap="square" anchor="ctr" lIns="0" rIns="0" tIns="9144" bIns="9144">
-            <a:spAutoFit/>
-          </a:bodyPr>
-          <a:lstStyle/>
-          <a:p>
-            <a:pPr algn="ctr">
-              <a:lnSpc>
-                <a:spcPct val="100000"/>
-              </a:lnSpc>
-              <a:spcBef>
-                <a:spcPts val="0"/>
-              </a:spcBef>
-              <a:spcAft>
-                <a:spcPts val="0"/>
-              </a:spcAft>
-            </a:pPr>
-            <a:r>
-              <a:rPr sz="800" b="1">
-                <a:solidFill>
-                  <a:srgbClr val="5B6470"/>
-                </a:solidFill>
-                <a:latin typeface="맑은 고딕"/>
-              </a:rPr>
-              <a:t>▸</a:t>
-            </a:r>
-          </a:p>
-        </p:txBody>
-      </p:sp>
-      <p:sp>
-        <p:nvSpPr>
-          <p:cNvPr id="34" name="Rounded Rectangle 33"/>
-          <p:cNvSpPr/>
-          <p:nvPr/>
-        </p:nvSpPr>
-        <p:spPr>
-          <a:xfrm>
-            <a:off x="7620870" y="2395728"/>
-            <a:ext cx="728907" cy="457200"/>
-          </a:xfrm>
-          <a:prstGeom prst="roundRect">
-            <a:avLst/>
-          </a:prstGeom>
-          <a:solidFill>
-            <a:srgbClr val="F0ECFF"/>
-          </a:solidFill>
-          <a:ln w="9525">
-            <a:solidFill>
-              <a:srgbClr val="CDBFF0"/>
-            </a:solidFill>
-          </a:ln>
-          <a:effectLst/>
-        </p:spPr>
-        <p:style>
-          <a:lnRef idx="1">
-            <a:schemeClr val="accent1"/>
-          </a:lnRef>
-          <a:fillRef idx="3">
-            <a:schemeClr val="accent1"/>
-          </a:fillRef>
-          <a:effectRef idx="2">
-            <a:schemeClr val="accent1"/>
-          </a:effectRef>
-          <a:fontRef idx="minor">
-            <a:schemeClr val="lt1"/>
-          </a:fontRef>
-        </p:style>
-        <p:txBody>
-          <a:bodyPr rtlCol="0" anchor="ctr" wrap="square" lIns="27432" rIns="27432" tIns="9144" bIns="9144"/>
-          <a:lstStyle/>
-          <a:p>
-            <a:pPr algn="ctr">
-              <a:lnSpc>
-                <a:spcPct val="100000"/>
-              </a:lnSpc>
-              <a:spcBef>
-                <a:spcPts val="0"/>
-              </a:spcBef>
-              <a:spcAft>
-                <a:spcPts val="0"/>
-              </a:spcAft>
-            </a:pPr>
-            <a:r>
-              <a:rPr sz="830" b="1">
-                <a:solidFill>
-                  <a:srgbClr val="5B3BBF"/>
-                </a:solidFill>
-                <a:latin typeface="맑은 고딕"/>
-              </a:rPr>
-              <a:t>③룰엔진</a:t>
-            </a:r>
-          </a:p>
-        </p:txBody>
-      </p:sp>
-      <p:sp>
-        <p:nvSpPr>
-          <p:cNvPr id="35" name="TextBox 34"/>
-          <p:cNvSpPr txBox="1"/>
-          <p:nvPr/>
-        </p:nvSpPr>
-        <p:spPr>
-          <a:xfrm>
-            <a:off x="8313201" y="2395728"/>
-            <a:ext cx="109728" cy="457200"/>
-          </a:xfrm>
-          <a:prstGeom prst="rect">
-            <a:avLst/>
-          </a:prstGeom>
-          <a:noFill/>
-        </p:spPr>
-        <p:txBody>
-          <a:bodyPr wrap="square" anchor="ctr" lIns="0" rIns="0" tIns="9144" bIns="9144">
-            <a:spAutoFit/>
-          </a:bodyPr>
-          <a:lstStyle/>
-          <a:p>
-            <a:pPr algn="ctr">
-              <a:lnSpc>
-                <a:spcPct val="100000"/>
-              </a:lnSpc>
-              <a:spcBef>
-                <a:spcPts val="0"/>
-              </a:spcBef>
-              <a:spcAft>
-                <a:spcPts val="0"/>
-              </a:spcAft>
-            </a:pPr>
-            <a:r>
-              <a:rPr sz="800" b="1">
-                <a:solidFill>
-                  <a:srgbClr val="5B6470"/>
-                </a:solidFill>
-                <a:latin typeface="맑은 고딕"/>
-              </a:rPr>
-              <a:t>▸</a:t>
-            </a:r>
-          </a:p>
-        </p:txBody>
-      </p:sp>
-      <p:sp>
-        <p:nvSpPr>
-          <p:cNvPr id="36" name="Rounded Rectangle 35"/>
-          <p:cNvSpPr/>
-          <p:nvPr/>
-        </p:nvSpPr>
-        <p:spPr>
-          <a:xfrm>
-            <a:off x="8413785" y="2395728"/>
-            <a:ext cx="728907" cy="457200"/>
-          </a:xfrm>
-          <a:prstGeom prst="roundRect">
-            <a:avLst/>
-          </a:prstGeom>
-          <a:solidFill>
-            <a:srgbClr val="FFFFFF"/>
-          </a:solidFill>
-          <a:ln w="9525">
-            <a:solidFill>
-              <a:srgbClr val="CDBFF0"/>
-            </a:solidFill>
-          </a:ln>
-          <a:effectLst/>
-        </p:spPr>
-        <p:style>
-          <a:lnRef idx="1">
-            <a:schemeClr val="accent1"/>
-          </a:lnRef>
-          <a:fillRef idx="3">
-            <a:schemeClr val="accent1"/>
-          </a:fillRef>
-          <a:effectRef idx="2">
-            <a:schemeClr val="accent1"/>
-          </a:effectRef>
-          <a:fontRef idx="minor">
-            <a:schemeClr val="lt1"/>
-          </a:fontRef>
-        </p:style>
-        <p:txBody>
-          <a:bodyPr rtlCol="0" anchor="ctr" wrap="square" lIns="27432" rIns="27432" tIns="9144" bIns="9144"/>
-          <a:lstStyle/>
-          <a:p>
-            <a:pPr algn="ctr">
-              <a:lnSpc>
-                <a:spcPct val="100000"/>
-              </a:lnSpc>
-              <a:spcBef>
-                <a:spcPts val="0"/>
-              </a:spcBef>
-              <a:spcAft>
-                <a:spcPts val="0"/>
-              </a:spcAft>
-            </a:pPr>
-            <a:r>
-              <a:rPr sz="830" b="0">
-                <a:solidFill>
-                  <a:srgbClr val="1A1D21"/>
-                </a:solidFill>
-                <a:latin typeface="맑은 고딕"/>
-              </a:rPr>
-              <a:t>④LLM 심의</a:t>
-            </a:r>
-          </a:p>
-        </p:txBody>
-      </p:sp>
-      <p:sp>
-        <p:nvSpPr>
-          <p:cNvPr id="37" name="TextBox 36"/>
-          <p:cNvSpPr txBox="1"/>
-          <p:nvPr/>
-        </p:nvSpPr>
-        <p:spPr>
-          <a:xfrm>
-            <a:off x="9106116" y="2395728"/>
-            <a:ext cx="109728" cy="457200"/>
-          </a:xfrm>
-          <a:prstGeom prst="rect">
-            <a:avLst/>
-          </a:prstGeom>
-          <a:noFill/>
-        </p:spPr>
-        <p:txBody>
-          <a:bodyPr wrap="square" anchor="ctr" lIns="0" rIns="0" tIns="9144" bIns="9144">
-            <a:spAutoFit/>
-          </a:bodyPr>
-          <a:lstStyle/>
-          <a:p>
-            <a:pPr algn="ctr">
-              <a:lnSpc>
-                <a:spcPct val="100000"/>
-              </a:lnSpc>
-              <a:spcBef>
-                <a:spcPts val="0"/>
-              </a:spcBef>
-              <a:spcAft>
-                <a:spcPts val="0"/>
-              </a:spcAft>
-            </a:pPr>
-            <a:r>
-              <a:rPr sz="800" b="1">
-                <a:solidFill>
-                  <a:srgbClr val="5B6470"/>
-                </a:solidFill>
-                <a:latin typeface="맑은 고딕"/>
-              </a:rPr>
-              <a:t>▸</a:t>
-            </a:r>
-          </a:p>
-        </p:txBody>
-      </p:sp>
-      <p:sp>
-        <p:nvSpPr>
-          <p:cNvPr id="38" name="Rounded Rectangle 37"/>
-          <p:cNvSpPr/>
-          <p:nvPr/>
-        </p:nvSpPr>
-        <p:spPr>
-          <a:xfrm>
-            <a:off x="9206700" y="2395728"/>
-            <a:ext cx="728907" cy="457200"/>
-          </a:xfrm>
-          <a:prstGeom prst="roundRect">
-            <a:avLst/>
-          </a:prstGeom>
-          <a:solidFill>
-            <a:srgbClr val="F0ECFF"/>
-          </a:solidFill>
-          <a:ln w="9525">
-            <a:solidFill>
-              <a:srgbClr val="CDBFF0"/>
-            </a:solidFill>
-          </a:ln>
-          <a:effectLst/>
-        </p:spPr>
-        <p:style>
-          <a:lnRef idx="1">
-            <a:schemeClr val="accent1"/>
-          </a:lnRef>
-          <a:fillRef idx="3">
-            <a:schemeClr val="accent1"/>
-          </a:fillRef>
-          <a:effectRef idx="2">
-            <a:schemeClr val="accent1"/>
-          </a:effectRef>
-          <a:fontRef idx="minor">
-            <a:schemeClr val="lt1"/>
-          </a:fontRef>
-        </p:style>
-        <p:txBody>
-          <a:bodyPr rtlCol="0" anchor="ctr" wrap="square" lIns="27432" rIns="27432" tIns="9144" bIns="9144"/>
-          <a:lstStyle/>
-          <a:p>
-            <a:pPr algn="ctr">
-              <a:lnSpc>
-                <a:spcPct val="100000"/>
-              </a:lnSpc>
-              <a:spcBef>
-                <a:spcPts val="0"/>
-              </a:spcBef>
-              <a:spcAft>
-                <a:spcPts val="0"/>
-              </a:spcAft>
-            </a:pPr>
-            <a:r>
-              <a:rPr sz="830" b="1">
-                <a:solidFill>
-                  <a:srgbClr val="5B3BBF"/>
-                </a:solidFill>
-                <a:latin typeface="맑은 고딕"/>
-              </a:rPr>
-              <a:t>⑤시뮬레이터</a:t>
-            </a:r>
-          </a:p>
-        </p:txBody>
-      </p:sp>
-      <p:sp>
-        <p:nvSpPr>
-          <p:cNvPr id="39" name="TextBox 38"/>
-          <p:cNvSpPr txBox="1"/>
-          <p:nvPr/>
-        </p:nvSpPr>
-        <p:spPr>
-          <a:xfrm>
-            <a:off x="9899031" y="2395728"/>
-            <a:ext cx="109728" cy="457200"/>
-          </a:xfrm>
-          <a:prstGeom prst="rect">
-            <a:avLst/>
-          </a:prstGeom>
-          <a:noFill/>
-        </p:spPr>
-        <p:txBody>
-          <a:bodyPr wrap="square" anchor="ctr" lIns="0" rIns="0" tIns="9144" bIns="9144">
-            <a:spAutoFit/>
-          </a:bodyPr>
-          <a:lstStyle/>
-          <a:p>
-            <a:pPr algn="ctr">
-              <a:lnSpc>
-                <a:spcPct val="100000"/>
-              </a:lnSpc>
-              <a:spcBef>
-                <a:spcPts val="0"/>
-              </a:spcBef>
-              <a:spcAft>
-                <a:spcPts val="0"/>
-              </a:spcAft>
-            </a:pPr>
-            <a:r>
-              <a:rPr sz="800" b="1">
-                <a:solidFill>
-                  <a:srgbClr val="5B6470"/>
-                </a:solidFill>
-                <a:latin typeface="맑은 고딕"/>
-              </a:rPr>
-              <a:t>▸</a:t>
-            </a:r>
-          </a:p>
-        </p:txBody>
-      </p:sp>
-      <p:sp>
-        <p:nvSpPr>
-          <p:cNvPr id="40" name="Rounded Rectangle 39"/>
-          <p:cNvSpPr/>
-          <p:nvPr/>
-        </p:nvSpPr>
-        <p:spPr>
-          <a:xfrm>
-            <a:off x="9999615" y="2395728"/>
-            <a:ext cx="728907" cy="457200"/>
-          </a:xfrm>
-          <a:prstGeom prst="roundRect">
-            <a:avLst/>
-          </a:prstGeom>
-          <a:solidFill>
-            <a:srgbClr val="FFFFFF"/>
-          </a:solidFill>
-          <a:ln w="9525">
-            <a:solidFill>
-              <a:srgbClr val="CDBFF0"/>
-            </a:solidFill>
-          </a:ln>
-          <a:effectLst/>
-        </p:spPr>
-        <p:style>
-          <a:lnRef idx="1">
-            <a:schemeClr val="accent1"/>
-          </a:lnRef>
-          <a:fillRef idx="3">
-            <a:schemeClr val="accent1"/>
-          </a:fillRef>
-          <a:effectRef idx="2">
-            <a:schemeClr val="accent1"/>
-          </a:effectRef>
-          <a:fontRef idx="minor">
-            <a:schemeClr val="lt1"/>
-          </a:fontRef>
-        </p:style>
-        <p:txBody>
-          <a:bodyPr rtlCol="0" anchor="ctr" wrap="square" lIns="27432" rIns="27432" tIns="9144" bIns="9144"/>
-          <a:lstStyle/>
-          <a:p>
-            <a:pPr algn="ctr">
-              <a:lnSpc>
-                <a:spcPct val="100000"/>
-              </a:lnSpc>
-              <a:spcBef>
-                <a:spcPts val="0"/>
-              </a:spcBef>
-              <a:spcAft>
-                <a:spcPts val="0"/>
-              </a:spcAft>
-            </a:pPr>
-            <a:r>
-              <a:rPr sz="830" b="0">
-                <a:solidFill>
-                  <a:srgbClr val="1A1D21"/>
-                </a:solidFill>
-                <a:latin typeface="맑은 고딕"/>
-              </a:rPr>
-              <a:t>⑥리포트</a:t>
-            </a:r>
-          </a:p>
-        </p:txBody>
-      </p:sp>
-      <p:sp>
-        <p:nvSpPr>
-          <p:cNvPr id="41" name="TextBox 40"/>
-          <p:cNvSpPr txBox="1"/>
-          <p:nvPr/>
-        </p:nvSpPr>
-        <p:spPr>
-          <a:xfrm>
-            <a:off x="10691946" y="2395728"/>
-            <a:ext cx="109728" cy="457200"/>
-          </a:xfrm>
-          <a:prstGeom prst="rect">
-            <a:avLst/>
-          </a:prstGeom>
-          <a:noFill/>
-        </p:spPr>
-        <p:txBody>
-          <a:bodyPr wrap="square" anchor="ctr" lIns="0" rIns="0" tIns="9144" bIns="9144">
-            <a:spAutoFit/>
-          </a:bodyPr>
-          <a:lstStyle/>
-          <a:p>
-            <a:pPr algn="ctr">
-              <a:lnSpc>
-                <a:spcPct val="100000"/>
-              </a:lnSpc>
-              <a:spcBef>
-                <a:spcPts val="0"/>
-              </a:spcBef>
-              <a:spcAft>
-                <a:spcPts val="0"/>
-              </a:spcAft>
-            </a:pPr>
-            <a:r>
-              <a:rPr sz="800" b="1">
-                <a:solidFill>
-                  <a:srgbClr val="5B6470"/>
-                </a:solidFill>
-                <a:latin typeface="맑은 고딕"/>
-              </a:rPr>
-              <a:t>▸</a:t>
-            </a:r>
-          </a:p>
-        </p:txBody>
-      </p:sp>
-      <p:sp>
-        <p:nvSpPr>
-          <p:cNvPr id="42" name="Rounded Rectangle 41"/>
-          <p:cNvSpPr/>
-          <p:nvPr/>
-        </p:nvSpPr>
-        <p:spPr>
-          <a:xfrm>
-            <a:off x="10792530" y="2395728"/>
-            <a:ext cx="728907" cy="457200"/>
-          </a:xfrm>
-          <a:prstGeom prst="roundRect">
-            <a:avLst/>
-          </a:prstGeom>
-          <a:solidFill>
-            <a:srgbClr val="FFFFFF"/>
-          </a:solidFill>
-          <a:ln w="9525">
-            <a:solidFill>
-              <a:srgbClr val="CDBFF0"/>
-            </a:solidFill>
-          </a:ln>
-          <a:effectLst/>
-        </p:spPr>
-        <p:style>
-          <a:lnRef idx="1">
-            <a:schemeClr val="accent1"/>
-          </a:lnRef>
-          <a:fillRef idx="3">
-            <a:schemeClr val="accent1"/>
-          </a:fillRef>
-          <a:effectRef idx="2">
-            <a:schemeClr val="accent1"/>
-          </a:effectRef>
-          <a:fontRef idx="minor">
-            <a:schemeClr val="lt1"/>
-          </a:fontRef>
-        </p:style>
-        <p:txBody>
-          <a:bodyPr rtlCol="0" anchor="ctr" wrap="square" lIns="27432" rIns="27432" tIns="9144" bIns="9144"/>
-          <a:lstStyle/>
-          <a:p>
-            <a:pPr algn="ctr">
-              <a:lnSpc>
-                <a:spcPct val="100000"/>
-              </a:lnSpc>
-              <a:spcBef>
-                <a:spcPts val="0"/>
-              </a:spcBef>
-              <a:spcAft>
-                <a:spcPts val="0"/>
-              </a:spcAft>
-            </a:pPr>
-            <a:r>
-              <a:rPr sz="830" b="0">
-                <a:solidFill>
-                  <a:srgbClr val="1A1D21"/>
-                </a:solidFill>
-                <a:latin typeface="맑은 고딕"/>
-              </a:rPr>
-              <a:t>⑦⑧승인·감사</a:t>
-            </a:r>
-          </a:p>
-        </p:txBody>
-      </p:sp>
-      <p:sp>
-        <p:nvSpPr>
-          <p:cNvPr id="43" name="Rounded Rectangle 42"/>
-          <p:cNvSpPr/>
-          <p:nvPr/>
-        </p:nvSpPr>
-        <p:spPr>
-          <a:xfrm>
-            <a:off x="6035040" y="2962656"/>
-            <a:ext cx="3017520" cy="402336"/>
-          </a:xfrm>
-          <a:prstGeom prst="roundRect">
-            <a:avLst/>
-          </a:prstGeom>
-          <a:solidFill>
-            <a:srgbClr val="F0ECFF"/>
-          </a:solidFill>
-          <a:ln w="9525">
-            <a:solidFill>
-              <a:srgbClr val="CDBFF0"/>
-            </a:solidFill>
-          </a:ln>
-          <a:effectLst/>
-        </p:spPr>
-        <p:style>
-          <a:lnRef idx="1">
-            <a:schemeClr val="accent1"/>
-          </a:lnRef>
-          <a:fillRef idx="3">
-            <a:schemeClr val="accent1"/>
-          </a:fillRef>
-          <a:effectRef idx="2">
-            <a:schemeClr val="accent1"/>
-          </a:effectRef>
-          <a:fontRef idx="minor">
-            <a:schemeClr val="lt1"/>
-          </a:fontRef>
-        </p:style>
-        <p:txBody>
-          <a:bodyPr rtlCol="0" anchor="ctr" wrap="square" tIns="9144" bIns="9144"/>
           <a:lstStyle/>
           <a:p>
             <a:pPr algn="l">
@@ -5476,255 +5667,27 @@
               </a:spcAft>
             </a:pPr>
             <a:r>
-              <a:rPr sz="900" b="1">
-                <a:solidFill>
-                  <a:srgbClr val="5B3BBF"/>
-                </a:solidFill>
-                <a:latin typeface="맑은 고딕"/>
-              </a:rPr>
-              <a:t>★준법 오토파일럿</a:t>
-            </a:r>
-            <a:r>
-              <a:rPr sz="800" b="0">
-                <a:solidFill>
-                  <a:srgbClr val="5B6470"/>
-                </a:solidFill>
-                <a:latin typeface="맑은 고딕"/>
-              </a:rPr>
-              <a:t> 자율 개선 루프</a:t>
-            </a:r>
-          </a:p>
-        </p:txBody>
-      </p:sp>
-      <p:sp>
-        <p:nvSpPr>
-          <p:cNvPr id="44" name="Rounded Rectangle 43"/>
+              <a:rPr sz="969" b="0">
+                <a:solidFill>
+                  <a:srgbClr val="1A1D21"/>
+                </a:solidFill>
+                <a:latin typeface="Malgun Gothic"/>
+              </a:rPr>
+              <a:t>-&gt; (1) 유형분류 · (3) 룰엔진 · (6) 리포트 · (7,8) 승인·감사 (규칙·집계)</a:t>
+            </a:r>
+          </a:p>
+        </p:txBody>
+      </p:sp>
+      <p:sp>
+        <p:nvSpPr>
+          <p:cNvPr id="43" name="Down Arrow 42"/>
           <p:cNvSpPr/>
           <p:nvPr/>
         </p:nvSpPr>
         <p:spPr>
           <a:xfrm>
-            <a:off x="9144000" y="2962656"/>
-            <a:ext cx="1325880" cy="402336"/>
-          </a:xfrm>
-          <a:prstGeom prst="roundRect">
-            <a:avLst/>
-          </a:prstGeom>
-          <a:solidFill>
-            <a:srgbClr val="E7ECF5"/>
-          </a:solidFill>
-          <a:ln w="9525">
-            <a:solidFill>
-              <a:srgbClr val="BCD6F2"/>
-            </a:solidFill>
-          </a:ln>
-          <a:effectLst/>
-        </p:spPr>
-        <p:style>
-          <a:lnRef idx="1">
-            <a:schemeClr val="accent1"/>
-          </a:lnRef>
-          <a:fillRef idx="3">
-            <a:schemeClr val="accent1"/>
-          </a:fillRef>
-          <a:effectRef idx="2">
-            <a:schemeClr val="accent1"/>
-          </a:effectRef>
-          <a:fontRef idx="minor">
-            <a:schemeClr val="lt1"/>
-          </a:fontRef>
-        </p:style>
-        <p:txBody>
-          <a:bodyPr rtlCol="0" anchor="ctr" wrap="square" lIns="27432" rIns="27432" tIns="9144" bIns="9144"/>
-          <a:lstStyle/>
-          <a:p>
-            <a:pPr algn="ctr">
-              <a:lnSpc>
-                <a:spcPct val="100000"/>
-              </a:lnSpc>
-              <a:spcBef>
-                <a:spcPts val="0"/>
-              </a:spcBef>
-              <a:spcAft>
-                <a:spcPts val="0"/>
-              </a:spcAft>
-            </a:pPr>
-            <a:r>
-              <a:rPr sz="850" b="1">
-                <a:solidFill>
-                  <a:srgbClr val="003A6E"/>
-                </a:solidFill>
-                <a:latin typeface="맑은 고딕"/>
-              </a:rPr>
-              <a:t>🤖 Ollama</a:t>
-            </a:r>
-          </a:p>
-          <a:p>
-            <a:pPr algn="ctr">
-              <a:lnSpc>
-                <a:spcPct val="100000"/>
-              </a:lnSpc>
-              <a:spcBef>
-                <a:spcPts val="0"/>
-              </a:spcBef>
-              <a:spcAft>
-                <a:spcPts val="0"/>
-              </a:spcAft>
-            </a:pPr>
-            <a:r>
-              <a:rPr sz="750" b="0">
-                <a:solidFill>
-                  <a:srgbClr val="5B6470"/>
-                </a:solidFill>
-                <a:latin typeface="맑은 고딕"/>
-              </a:rPr>
-              <a:t>Qwen2.5-7B</a:t>
-            </a:r>
-          </a:p>
-        </p:txBody>
-      </p:sp>
-      <p:sp>
-        <p:nvSpPr>
-          <p:cNvPr id="45" name="Rounded Rectangle 44"/>
-          <p:cNvSpPr/>
-          <p:nvPr/>
-        </p:nvSpPr>
-        <p:spPr>
-          <a:xfrm>
-            <a:off x="10561320" y="2962656"/>
-            <a:ext cx="960120" cy="402336"/>
-          </a:xfrm>
-          <a:prstGeom prst="roundRect">
-            <a:avLst/>
-          </a:prstGeom>
-          <a:solidFill>
-            <a:srgbClr val="E7ECF5"/>
-          </a:solidFill>
-          <a:ln w="9525">
-            <a:solidFill>
-              <a:srgbClr val="BCD6F2"/>
-            </a:solidFill>
-          </a:ln>
-          <a:effectLst/>
-        </p:spPr>
-        <p:style>
-          <a:lnRef idx="1">
-            <a:schemeClr val="accent1"/>
-          </a:lnRef>
-          <a:fillRef idx="3">
-            <a:schemeClr val="accent1"/>
-          </a:fillRef>
-          <a:effectRef idx="2">
-            <a:schemeClr val="accent1"/>
-          </a:effectRef>
-          <a:fontRef idx="minor">
-            <a:schemeClr val="lt1"/>
-          </a:fontRef>
-        </p:style>
-        <p:txBody>
-          <a:bodyPr rtlCol="0" anchor="ctr" wrap="square" lIns="27432" rIns="27432" tIns="9144" bIns="9144"/>
-          <a:lstStyle/>
-          <a:p>
-            <a:pPr algn="ctr">
-              <a:lnSpc>
-                <a:spcPct val="100000"/>
-              </a:lnSpc>
-              <a:spcBef>
-                <a:spcPts val="0"/>
-              </a:spcBef>
-              <a:spcAft>
-                <a:spcPts val="0"/>
-              </a:spcAft>
-            </a:pPr>
-            <a:r>
-              <a:rPr sz="850" b="1">
-                <a:solidFill>
-                  <a:srgbClr val="003A6E"/>
-                </a:solidFill>
-                <a:latin typeface="맑은 고딕"/>
-              </a:rPr>
-              <a:t>🔎 BGE-m3</a:t>
-            </a:r>
-          </a:p>
-          <a:p>
-            <a:pPr algn="ctr">
-              <a:lnSpc>
-                <a:spcPct val="100000"/>
-              </a:lnSpc>
-              <a:spcBef>
-                <a:spcPts val="0"/>
-              </a:spcBef>
-              <a:spcAft>
-                <a:spcPts val="0"/>
-              </a:spcAft>
-            </a:pPr>
-            <a:r>
-              <a:rPr sz="750" b="0">
-                <a:solidFill>
-                  <a:srgbClr val="5B6470"/>
-                </a:solidFill>
-                <a:latin typeface="맑은 고딕"/>
-              </a:rPr>
-              <a:t>임베딩(선택)</a:t>
-            </a:r>
-          </a:p>
-        </p:txBody>
-      </p:sp>
-      <p:sp>
-        <p:nvSpPr>
-          <p:cNvPr id="46" name="TextBox 45"/>
-          <p:cNvSpPr txBox="1"/>
-          <p:nvPr/>
-        </p:nvSpPr>
-        <p:spPr>
-          <a:xfrm>
-            <a:off x="6035040" y="3438143"/>
-            <a:ext cx="5486400" cy="201168"/>
-          </a:xfrm>
-          <a:prstGeom prst="rect">
-            <a:avLst/>
-          </a:prstGeom>
-          <a:noFill/>
-        </p:spPr>
-        <p:txBody>
-          <a:bodyPr wrap="square" anchor="t" lIns="0" rIns="0" tIns="9144" bIns="9144">
-            <a:spAutoFit/>
-          </a:bodyPr>
-          <a:lstStyle/>
-          <a:p>
-            <a:pPr algn="l">
-              <a:lnSpc>
-                <a:spcPct val="100000"/>
-              </a:lnSpc>
-              <a:spcBef>
-                <a:spcPts val="0"/>
-              </a:spcBef>
-              <a:spcAft>
-                <a:spcPts val="0"/>
-              </a:spcAft>
-            </a:pPr>
-            <a:r>
-              <a:rPr sz="800" b="0">
-                <a:solidFill>
-                  <a:srgbClr val="5B6470"/>
-                </a:solidFill>
-                <a:latin typeface="맑은 고딕"/>
-              </a:rPr>
-              <a:t>인용은 검색된 조항으로 제한 · 룰엔진=결정적 등급 권위 · LLM=보조</a:t>
-            </a:r>
-          </a:p>
-        </p:txBody>
-      </p:sp>
-      <p:sp>
-        <p:nvSpPr>
-          <p:cNvPr id="47" name="Down Arrow 46"/>
-          <p:cNvSpPr/>
-          <p:nvPr/>
-        </p:nvSpPr>
-        <p:spPr>
-          <a:xfrm>
-            <a:off x="6830568" y="4663440"/>
-            <a:ext cx="237744" cy="365760"/>
+            <a:off x="6867144" y="5029200"/>
+            <a:ext cx="256032" cy="310896"/>
           </a:xfrm>
           <a:prstGeom prst="downArrow">
             <a:avLst/>
@@ -5761,14 +5724,14 @@
       </p:sp>
       <p:sp>
         <p:nvSpPr>
-          <p:cNvPr id="48" name="TextBox 47"/>
+          <p:cNvPr id="44" name="TextBox 43"/>
           <p:cNvSpPr txBox="1"/>
           <p:nvPr/>
         </p:nvSpPr>
         <p:spPr>
           <a:xfrm>
-            <a:off x="7114032" y="4663440"/>
-            <a:ext cx="2286000" cy="365760"/>
+            <a:off x="7178040" y="5029200"/>
+            <a:ext cx="2286000" cy="310896"/>
           </a:xfrm>
           <a:prstGeom prst="rect">
             <a:avLst/>
@@ -5793,11 +5756,11 @@
               </a:spcAft>
             </a:pPr>
             <a:r>
-              <a:rPr sz="850" b="1">
+              <a:rPr sz="950" b="1">
                 <a:solidFill>
                   <a:srgbClr val="5B6470"/>
                 </a:solidFill>
-                <a:latin typeface="맑은 고딕"/>
+                <a:latin typeface="Malgun Gothic"/>
               </a:rPr>
               <a:t>조회·기록</a:t>
             </a:r>
@@ -5806,14 +5769,14 @@
       </p:sp>
       <p:sp>
         <p:nvSpPr>
-          <p:cNvPr id="49" name="Down Arrow 48"/>
+          <p:cNvPr id="45" name="Down Arrow 44"/>
           <p:cNvSpPr/>
           <p:nvPr/>
         </p:nvSpPr>
         <p:spPr>
           <a:xfrm>
-            <a:off x="10213848" y="4663440"/>
-            <a:ext cx="237744" cy="365760"/>
+            <a:off x="10250424" y="5029200"/>
+            <a:ext cx="256032" cy="310896"/>
           </a:xfrm>
           <a:prstGeom prst="downArrow">
             <a:avLst/>
@@ -5850,14 +5813,14 @@
       </p:sp>
       <p:sp>
         <p:nvSpPr>
-          <p:cNvPr id="50" name="TextBox 49"/>
+          <p:cNvPr id="46" name="TextBox 45"/>
           <p:cNvSpPr txBox="1"/>
           <p:nvPr/>
         </p:nvSpPr>
         <p:spPr>
           <a:xfrm>
-            <a:off x="10497312" y="4663440"/>
-            <a:ext cx="2286000" cy="365760"/>
+            <a:off x="10561320" y="5029200"/>
+            <a:ext cx="2286000" cy="310896"/>
           </a:xfrm>
           <a:prstGeom prst="rect">
             <a:avLst/>
@@ -5882,11 +5845,11 @@
               </a:spcAft>
             </a:pPr>
             <a:r>
-              <a:rPr sz="850" b="1">
+              <a:rPr sz="950" b="1">
                 <a:solidFill>
                   <a:srgbClr val="5B6470"/>
                 </a:solidFill>
-                <a:latin typeface="맑은 고딕"/>
+                <a:latin typeface="Malgun Gothic"/>
               </a:rPr>
               <a:t>연동</a:t>
             </a:r>
@@ -5895,14 +5858,14 @@
       </p:sp>
       <p:sp>
         <p:nvSpPr>
-          <p:cNvPr id="51" name="Can 50"/>
+          <p:cNvPr id="47" name="Can 46"/>
           <p:cNvSpPr/>
           <p:nvPr/>
         </p:nvSpPr>
         <p:spPr>
           <a:xfrm>
-            <a:off x="5806440" y="5120640"/>
-            <a:ext cx="1554480" cy="1188720"/>
+            <a:off x="5852160" y="5340096"/>
+            <a:ext cx="1600200" cy="1097280"/>
           </a:xfrm>
           <a:prstGeom prst="can">
             <a:avLst/>
@@ -5930,7 +5893,7 @@
           </a:fontRef>
         </p:style>
         <p:txBody>
-          <a:bodyPr rtlCol="0" anchor="ctr" wrap="square" lIns="64008" rIns="64008" tIns="9144" bIns="9144"/>
+          <a:bodyPr rtlCol="0" anchor="ctr" wrap="square" lIns="54864" rIns="54864" tIns="9144" bIns="9144"/>
           <a:lstStyle/>
           <a:p>
             <a:pPr algn="ctr">
@@ -5945,13 +5908,13 @@
               </a:spcAft>
             </a:pPr>
             <a:r>
-              <a:rPr sz="950" b="1">
+              <a:rPr sz="1050" b="1">
                 <a:solidFill>
                   <a:srgbClr val="FFFFFF"/>
                 </a:solidFill>
-                <a:latin typeface="맑은 고딕"/>
-              </a:rPr>
-              <a:t>🗄 SQLite</a:t>
+                <a:latin typeface="Malgun Gothic"/>
+              </a:rPr>
+              <a:t>SQLite</a:t>
             </a:r>
           </a:p>
           <a:p>
@@ -5967,11 +5930,11 @@
               </a:spcAft>
             </a:pPr>
             <a:r>
-              <a:rPr sz="750" b="0">
+              <a:rPr sz="850" b="0">
                 <a:solidFill>
                   <a:srgbClr val="DFE6F0"/>
                 </a:solidFill>
-                <a:latin typeface="맑은 고딕"/>
+                <a:latin typeface="Malgun Gothic"/>
               </a:rPr>
               <a:t>승인·감사로그</a:t>
             </a:r>
@@ -5989,27 +5952,27 @@
               </a:spcAft>
             </a:pPr>
             <a:r>
-              <a:rPr sz="750" b="0">
+              <a:rPr sz="850" b="0">
                 <a:solidFill>
                   <a:srgbClr val="DFE6F0"/>
                 </a:solidFill>
-                <a:latin typeface="맑은 고딕"/>
-              </a:rPr>
-              <a:t>내규·배포</a:t>
-            </a:r>
-          </a:p>
-        </p:txBody>
-      </p:sp>
-      <p:sp>
-        <p:nvSpPr>
-          <p:cNvPr id="52" name="Can 51"/>
+                <a:latin typeface="Malgun Gothic"/>
+              </a:rPr>
+              <a:t>내규·배포 로그</a:t>
+            </a:r>
+          </a:p>
+        </p:txBody>
+      </p:sp>
+      <p:sp>
+        <p:nvSpPr>
+          <p:cNvPr id="48" name="Can 47"/>
           <p:cNvSpPr/>
           <p:nvPr/>
         </p:nvSpPr>
         <p:spPr>
           <a:xfrm>
-            <a:off x="7498079" y="5120640"/>
-            <a:ext cx="1554480" cy="1188720"/>
+            <a:off x="7589520" y="5340096"/>
+            <a:ext cx="1600200" cy="1097280"/>
           </a:xfrm>
           <a:prstGeom prst="can">
             <a:avLst/>
@@ -6037,7 +6000,7 @@
           </a:fontRef>
         </p:style>
         <p:txBody>
-          <a:bodyPr rtlCol="0" anchor="ctr" wrap="square" lIns="64008" rIns="64008" tIns="9144" bIns="9144"/>
+          <a:bodyPr rtlCol="0" anchor="ctr" wrap="square" lIns="54864" rIns="54864" tIns="9144" bIns="9144"/>
           <a:lstStyle/>
           <a:p>
             <a:pPr algn="ctr">
@@ -6052,13 +6015,13 @@
               </a:spcAft>
             </a:pPr>
             <a:r>
-              <a:rPr sz="950" b="1">
+              <a:rPr sz="1050" b="1">
                 <a:solidFill>
                   <a:srgbClr val="FFFFFF"/>
                 </a:solidFill>
-                <a:latin typeface="맑은 고딕"/>
-              </a:rPr>
-              <a:t>📚 규제 KB</a:t>
+                <a:latin typeface="Malgun Gothic"/>
+              </a:rPr>
+              <a:t>규제 KB</a:t>
             </a:r>
           </a:p>
           <a:p>
@@ -6074,11 +6037,11 @@
               </a:spcAft>
             </a:pPr>
             <a:r>
-              <a:rPr sz="700" b="0">
+              <a:rPr sz="800" b="0">
                 <a:solidFill>
                   <a:srgbClr val="DFE6F0"/>
                 </a:solidFill>
-                <a:latin typeface="맑은 고딕"/>
+                <a:latin typeface="Malgun Gothic"/>
               </a:rPr>
               <a:t>regulations.json</a:t>
             </a:r>
@@ -6096,11 +6059,11 @@
               </a:spcAft>
             </a:pPr>
             <a:r>
-              <a:rPr sz="700" b="0">
+              <a:rPr sz="800" b="0">
                 <a:solidFill>
                   <a:srgbClr val="DFE6F0"/>
                 </a:solidFill>
-                <a:latin typeface="맑은 고딕"/>
+                <a:latin typeface="Malgun Gothic"/>
               </a:rPr>
               <a:t>rules.yaml</a:t>
             </a:r>
@@ -6109,14 +6072,14 @@
       </p:sp>
       <p:sp>
         <p:nvSpPr>
-          <p:cNvPr id="53" name="Cloud 52"/>
+          <p:cNvPr id="49" name="Cloud 48"/>
           <p:cNvSpPr/>
           <p:nvPr/>
         </p:nvSpPr>
         <p:spPr>
           <a:xfrm>
-            <a:off x="9189720" y="4983480"/>
-            <a:ext cx="2560320" cy="1508760"/>
+            <a:off x="9326880" y="5212080"/>
+            <a:ext cx="2450592" cy="1371600"/>
           </a:xfrm>
           <a:prstGeom prst="cloud">
             <a:avLst/>
@@ -6155,14 +6118,14 @@
       </p:sp>
       <p:sp>
         <p:nvSpPr>
-          <p:cNvPr id="54" name="TextBox 53"/>
+          <p:cNvPr id="50" name="TextBox 49"/>
           <p:cNvSpPr txBox="1"/>
           <p:nvPr/>
         </p:nvSpPr>
         <p:spPr>
           <a:xfrm>
-            <a:off x="9189720" y="5138928"/>
-            <a:ext cx="2560320" cy="219456"/>
+            <a:off x="9326880" y="5358384"/>
+            <a:ext cx="2450592" cy="237744"/>
           </a:xfrm>
           <a:prstGeom prst="rect">
             <a:avLst/>
@@ -6187,26 +6150,26 @@
               </a:spcAft>
             </a:pPr>
             <a:r>
-              <a:rPr sz="950" b="1">
+              <a:rPr sz="1000" b="1">
                 <a:solidFill>
                   <a:srgbClr val="8A6200"/>
                 </a:solidFill>
-                <a:latin typeface="맑은 고딕"/>
-              </a:rPr>
-              <a:t>☁ 외부 연동 (어댑터)</a:t>
-            </a:r>
-          </a:p>
-        </p:txBody>
-      </p:sp>
-      <p:sp>
-        <p:nvSpPr>
-          <p:cNvPr id="55" name="TextBox 54"/>
+                <a:latin typeface="Malgun Gothic"/>
+              </a:rPr>
+              <a:t>외부 연동 (어댑터)</a:t>
+            </a:r>
+          </a:p>
+        </p:txBody>
+      </p:sp>
+      <p:sp>
+        <p:nvSpPr>
+          <p:cNvPr id="51" name="TextBox 50"/>
           <p:cNvSpPr txBox="1"/>
           <p:nvPr/>
         </p:nvSpPr>
         <p:spPr>
           <a:xfrm>
-            <a:off x="9326880" y="5394960"/>
+            <a:off x="9418320" y="5614416"/>
             <a:ext cx="2286000" cy="237744"/>
           </a:xfrm>
           <a:prstGeom prst="rect">
@@ -6232,20 +6195,20 @@
               </a:spcAft>
             </a:pPr>
             <a:r>
-              <a:rPr sz="800" b="1">
+              <a:rPr sz="900" b="1">
                 <a:solidFill>
                   <a:srgbClr val="6B4E00"/>
                 </a:solidFill>
-                <a:latin typeface="맑은 고딕"/>
+                <a:latin typeface="Malgun Gothic"/>
               </a:rPr>
               <a:t>법제처 OpenAPI  </a:t>
             </a:r>
             <a:r>
-              <a:rPr sz="750" b="1">
+              <a:rPr sz="850" b="1">
                 <a:solidFill>
                   <a:srgbClr val="C78A06"/>
                 </a:solidFill>
-                <a:latin typeface="맑은 고딕"/>
+                <a:latin typeface="Malgun Gothic"/>
               </a:rPr>
               <a:t>F14</a:t>
             </a:r>
@@ -6254,13 +6217,13 @@
       </p:sp>
       <p:sp>
         <p:nvSpPr>
-          <p:cNvPr id="56" name="TextBox 55"/>
+          <p:cNvPr id="52" name="TextBox 51"/>
           <p:cNvSpPr txBox="1"/>
           <p:nvPr/>
         </p:nvSpPr>
         <p:spPr>
           <a:xfrm>
-            <a:off x="9326880" y="5669280"/>
+            <a:off x="9418320" y="5888736"/>
             <a:ext cx="2286000" cy="237744"/>
           </a:xfrm>
           <a:prstGeom prst="rect">
@@ -6286,20 +6249,20 @@
               </a:spcAft>
             </a:pPr>
             <a:r>
-              <a:rPr sz="800" b="1">
+              <a:rPr sz="900" b="1">
                 <a:solidFill>
                   <a:srgbClr val="6B4E00"/>
                 </a:solidFill>
-                <a:latin typeface="맑은 고딕"/>
+                <a:latin typeface="Malgun Gothic"/>
               </a:rPr>
               <a:t>FCM·SNS·알림톡  </a:t>
             </a:r>
             <a:r>
-              <a:rPr sz="750" b="1">
+              <a:rPr sz="850" b="1">
                 <a:solidFill>
                   <a:srgbClr val="C78A06"/>
                 </a:solidFill>
-                <a:latin typeface="맑은 고딕"/>
+                <a:latin typeface="Malgun Gothic"/>
               </a:rPr>
               <a:t>F15</a:t>
             </a:r>
@@ -6308,13 +6271,13 @@
       </p:sp>
       <p:sp>
         <p:nvSpPr>
-          <p:cNvPr id="57" name="TextBox 56"/>
+          <p:cNvPr id="53" name="TextBox 52"/>
           <p:cNvSpPr txBox="1"/>
           <p:nvPr/>
         </p:nvSpPr>
         <p:spPr>
           <a:xfrm>
-            <a:off x="9326880" y="5943600"/>
+            <a:off x="9418320" y="6163056"/>
             <a:ext cx="2286000" cy="237744"/>
           </a:xfrm>
           <a:prstGeom prst="rect">
@@ -6340,20 +6303,20 @@
               </a:spcAft>
             </a:pPr>
             <a:r>
-              <a:rPr sz="800" b="1">
+              <a:rPr sz="900" b="1">
                 <a:solidFill>
                   <a:srgbClr val="6B4E00"/>
                 </a:solidFill>
-                <a:latin typeface="맑은 고딕"/>
+                <a:latin typeface="Malgun Gothic"/>
               </a:rPr>
               <a:t>코어뱅킹 API  </a:t>
             </a:r>
             <a:r>
-              <a:rPr sz="750" b="1">
+              <a:rPr sz="850" b="1">
                 <a:solidFill>
                   <a:srgbClr val="C78A06"/>
                 </a:solidFill>
-                <a:latin typeface="맑은 고딕"/>
+                <a:latin typeface="Malgun Gothic"/>
               </a:rPr>
               <a:t>F16</a:t>
             </a:r>
@@ -6362,14 +6325,14 @@
       </p:sp>
       <p:sp>
         <p:nvSpPr>
-          <p:cNvPr id="58" name="TextBox 57"/>
+          <p:cNvPr id="54" name="TextBox 53"/>
           <p:cNvSpPr txBox="1"/>
           <p:nvPr/>
         </p:nvSpPr>
         <p:spPr>
           <a:xfrm>
-            <a:off x="411480" y="6492240"/>
-            <a:ext cx="11338560" cy="274320"/>
+            <a:off x="411480" y="6528816"/>
+            <a:ext cx="11338560" cy="256032"/>
           </a:xfrm>
           <a:prstGeom prst="rect">
             <a:avLst/>
@@ -6394,13 +6357,13 @@
               </a:spcAft>
             </a:pPr>
             <a:r>
-              <a:rPr sz="850" b="0">
+              <a:rPr sz="900" b="0">
                 <a:solidFill>
                   <a:srgbClr val="5B6470"/>
                 </a:solidFill>
-                <a:latin typeface="맑은 고딕"/>
-              </a:rPr>
-              <a:t>외부 연동은 어댑터로 분리 — 데모는 목/피드, 운영 시 법제처 OpenAPI·FCM/SNS/알림톡·코어뱅킹 API로 교체 · 전 과정 온프레미스</a:t>
+                <a:latin typeface="Malgun Gothic"/>
+              </a:rPr>
+              <a:t>외부 연동은 어댑터로 분리 - 데모는 목/피드, 운영 시 법제처 OpenAPI·FCM/SNS/알림톡·코어뱅킹 API로 교체 · 전 과정 온프레미스</a:t>
             </a:r>
           </a:p>
         </p:txBody>

</xml_diff>

<commit_message>
docs: architecture with model logos linked to stages + autopilot flowchart
- 모델을 무료 로고 이미지로 표기(Ollama 라마=SimpleIcons, BGE-m3=HuggingFace 로고)
  하고, 각 모델을 실제로 쓰는 단계와 연결선으로 연결(Ollama->(4)(5), BGE-m3->(2)).
- 준법 오토파일럿을 봇 아이콘 + 순서도로 표현: ①심의->②LLM 고쳐쓰기->③재심의->
  ④통과/에스컬레이션, ③->② 루프백(미통과 시 반복).
- 아이콘 PNG를 docs/assets/arch/에 포함(재현 가능). 엔진-단계 매핑을 시각 연결로 표현.

Co-Authored-By: Claude Opus 4.8 (1M context) <noreply@anthropic.com>
</commit_message>
<xml_diff>
--- a/docs/submission/JB준법코파일럿_시스템아키텍처.pptx
+++ b/docs/submission/JB준법코파일럿_시스템아키텍처.pptx
@@ -3096,7 +3096,7 @@
         </p:nvSpPr>
         <p:spPr>
           <a:xfrm>
-            <a:off x="411480" y="182880"/>
+            <a:off x="411480" y="164592"/>
             <a:ext cx="10058400" cy="457200"/>
           </a:xfrm>
           <a:prstGeom prst="rect">
@@ -3141,7 +3141,7 @@
         </p:nvSpPr>
         <p:spPr>
           <a:xfrm>
-            <a:off x="429768" y="694944"/>
+            <a:off x="429768" y="676656"/>
             <a:ext cx="11338560" cy="274320"/>
           </a:xfrm>
           <a:prstGeom prst="rect">
@@ -3173,7 +3173,7 @@
                 </a:solidFill>
                 <a:latin typeface="Malgun Gothic"/>
               </a:rPr>
-              <a:t>사용자 · 프론트엔드 · 백엔드 API · AI Agent/모델 · DB/외부연동 - 전 과정 온프레미스 · 휴먼인더루프</a:t>
+              <a:t>사용자 · 프론트엔드 · 백엔드(AI Agent/모델) · DB/외부연동 - 전 과정 온프레미스 · 휴먼인더루프</a:t>
             </a:r>
           </a:p>
         </p:txBody>
@@ -3186,7 +3186,7 @@
         </p:nvSpPr>
         <p:spPr>
           <a:xfrm>
-            <a:off x="411480" y="1024128"/>
+            <a:off x="411480" y="1005840"/>
             <a:ext cx="11365992" cy="31750"/>
           </a:xfrm>
           <a:prstGeom prst="rect">
@@ -3230,8 +3230,8 @@
         </p:nvSpPr>
         <p:spPr>
           <a:xfrm>
-            <a:off x="411480" y="1627632"/>
-            <a:ext cx="1920240" cy="2240280"/>
+            <a:off x="411480" y="1371600"/>
+            <a:ext cx="2286000" cy="1371600"/>
           </a:xfrm>
           <a:prstGeom prst="roundRect">
             <a:avLst/>
@@ -3276,8 +3276,8 @@
         </p:nvSpPr>
         <p:spPr>
           <a:xfrm>
-            <a:off x="411480" y="1737360"/>
-            <a:ext cx="1920240" cy="292608"/>
+            <a:off x="411480" y="1463040"/>
+            <a:ext cx="2286000" cy="274320"/>
           </a:xfrm>
           <a:prstGeom prst="rect">
             <a:avLst/>
@@ -3302,13 +3302,13 @@
               </a:spcAft>
             </a:pPr>
             <a:r>
-              <a:rPr sz="1400" b="1">
+              <a:rPr sz="1350" b="1">
                 <a:solidFill>
                   <a:srgbClr val="5B6470"/>
                 </a:solidFill>
                 <a:latin typeface="Malgun Gothic"/>
               </a:rPr>
-              <a:t>[사용자]</a:t>
+              <a:t>[ 사용자 ]</a:t>
             </a:r>
           </a:p>
         </p:txBody>
@@ -3321,8 +3321,8 @@
         </p:nvSpPr>
         <p:spPr>
           <a:xfrm>
-            <a:off x="557784" y="2139696"/>
-            <a:ext cx="1627632" cy="749808"/>
+            <a:off x="557784" y="1810512"/>
+            <a:ext cx="1993392" cy="411480"/>
           </a:xfrm>
           <a:prstGeom prst="roundRect">
             <a:avLst/>
@@ -3352,10 +3352,10 @@
           </a:fontRef>
         </p:style>
         <p:txBody>
-          <a:bodyPr rtlCol="0" anchor="ctr" wrap="square" lIns="73152" rIns="73152" tIns="9144" bIns="9144"/>
-          <a:lstStyle/>
-          <a:p>
-            <a:pPr algn="ctr">
+          <a:bodyPr rtlCol="0" anchor="ctr" wrap="square" tIns="9144" bIns="9144"/>
+          <a:lstStyle/>
+          <a:p>
+            <a:pPr algn="l">
               <a:lnSpc>
                 <a:spcPct val="100000"/>
               </a:lnSpc>
@@ -3367,7 +3367,7 @@
               </a:spcAft>
             </a:pPr>
             <a:r>
-              <a:rPr sz="1100" b="1">
+              <a:rPr sz="1050" b="1">
                 <a:solidFill>
                   <a:srgbClr val="1A1D21"/>
                 </a:solidFill>
@@ -3375,19 +3375,6 @@
               </a:rPr>
               <a:t>마케팅·지점 담당자</a:t>
             </a:r>
-          </a:p>
-          <a:p>
-            <a:pPr algn="ctr">
-              <a:lnSpc>
-                <a:spcPct val="100000"/>
-              </a:lnSpc>
-              <a:spcBef>
-                <a:spcPts val="0"/>
-              </a:spcBef>
-              <a:spcAft>
-                <a:spcPts val="0"/>
-              </a:spcAft>
-            </a:pPr>
             <a:r>
               <a:rPr sz="900" b="0">
                 <a:solidFill>
@@ -3395,29 +3382,7 @@
                 </a:solidFill>
                 <a:latin typeface="Malgun Gothic"/>
               </a:rPr>
-              <a:t>금융 콘텐츠 초안</a:t>
-            </a:r>
-          </a:p>
-          <a:p>
-            <a:pPr algn="ctr">
-              <a:lnSpc>
-                <a:spcPct val="100000"/>
-              </a:lnSpc>
-              <a:spcBef>
-                <a:spcPts val="0"/>
-              </a:spcBef>
-              <a:spcAft>
-                <a:spcPts val="0"/>
-              </a:spcAft>
-            </a:pPr>
-            <a:r>
-              <a:rPr sz="900" b="0">
-                <a:solidFill>
-                  <a:srgbClr val="5B6470"/>
-                </a:solidFill>
-                <a:latin typeface="Malgun Gothic"/>
-              </a:rPr>
-              <a:t>작성(실시간)</a:t>
+              <a:t>  콘텐츠 작성</a:t>
             </a:r>
           </a:p>
         </p:txBody>
@@ -3430,8 +3395,8 @@
         </p:nvSpPr>
         <p:spPr>
           <a:xfrm>
-            <a:off x="557784" y="2980944"/>
-            <a:ext cx="1627632" cy="749808"/>
+            <a:off x="557784" y="2267712"/>
+            <a:ext cx="1993392" cy="411480"/>
           </a:xfrm>
           <a:prstGeom prst="roundRect">
             <a:avLst/>
@@ -3461,10 +3426,10 @@
           </a:fontRef>
         </p:style>
         <p:txBody>
-          <a:bodyPr rtlCol="0" anchor="ctr" wrap="square" lIns="73152" rIns="73152" tIns="9144" bIns="9144"/>
-          <a:lstStyle/>
-          <a:p>
-            <a:pPr algn="ctr">
+          <a:bodyPr rtlCol="0" anchor="ctr" wrap="square" tIns="9144" bIns="9144"/>
+          <a:lstStyle/>
+          <a:p>
+            <a:pPr algn="l">
               <a:lnSpc>
                 <a:spcPct val="100000"/>
               </a:lnSpc>
@@ -3476,7 +3441,7 @@
               </a:spcAft>
             </a:pPr>
             <a:r>
-              <a:rPr sz="1100" b="1">
+              <a:rPr sz="1050" b="1">
                 <a:solidFill>
                   <a:srgbClr val="1A1D21"/>
                 </a:solidFill>
@@ -3484,19 +3449,6 @@
               </a:rPr>
               <a:t>준법관리자</a:t>
             </a:r>
-          </a:p>
-          <a:p>
-            <a:pPr algn="ctr">
-              <a:lnSpc>
-                <a:spcPct val="100000"/>
-              </a:lnSpc>
-              <a:spcBef>
-                <a:spcPts val="0"/>
-              </a:spcBef>
-              <a:spcAft>
-                <a:spcPts val="0"/>
-              </a:spcAft>
-            </a:pPr>
             <a:r>
               <a:rPr sz="900" b="0">
                 <a:solidFill>
@@ -3504,45 +3456,23 @@
                 </a:solidFill>
                 <a:latin typeface="Malgun Gothic"/>
               </a:rPr>
-              <a:t>준법감시부</a:t>
-            </a:r>
-          </a:p>
-          <a:p>
-            <a:pPr algn="ctr">
-              <a:lnSpc>
-                <a:spcPct val="100000"/>
-              </a:lnSpc>
-              <a:spcBef>
-                <a:spcPts val="0"/>
-              </a:spcBef>
-              <a:spcAft>
-                <a:spcPts val="0"/>
-              </a:spcAft>
-            </a:pPr>
-            <a:r>
-              <a:rPr sz="900" b="0">
-                <a:solidFill>
-                  <a:srgbClr val="5B6470"/>
-                </a:solidFill>
-                <a:latin typeface="Malgun Gothic"/>
-              </a:rPr>
-              <a:t>검토·승인(HITL)</a:t>
-            </a:r>
-          </a:p>
-        </p:txBody>
-      </p:sp>
-      <p:sp>
-        <p:nvSpPr>
-          <p:cNvPr id="9" name="Right Arrow 8"/>
+              <a:t>  검토·승인(HITL)</a:t>
+            </a:r>
+          </a:p>
+        </p:txBody>
+      </p:sp>
+      <p:sp>
+        <p:nvSpPr>
+          <p:cNvPr id="9" name="Down Arrow 8"/>
           <p:cNvSpPr/>
           <p:nvPr/>
         </p:nvSpPr>
         <p:spPr>
           <a:xfrm>
-            <a:off x="2432304" y="2560320"/>
-            <a:ext cx="420624" cy="384048"/>
-          </a:xfrm>
-          <a:prstGeom prst="rightArrow">
+            <a:off x="1426464" y="2788920"/>
+            <a:ext cx="256032" cy="292608"/>
+          </a:xfrm>
+          <a:prstGeom prst="downArrow">
             <a:avLst/>
           </a:prstGeom>
           <a:solidFill>
@@ -3583,8 +3513,8 @@
         </p:nvSpPr>
         <p:spPr>
           <a:xfrm>
-            <a:off x="2926080" y="1627632"/>
-            <a:ext cx="2377440" cy="2240280"/>
+            <a:off x="411480" y="3154680"/>
+            <a:ext cx="2286000" cy="2057400"/>
           </a:xfrm>
           <a:prstGeom prst="roundRect">
             <a:avLst/>
@@ -3629,8 +3559,8 @@
         </p:nvSpPr>
         <p:spPr>
           <a:xfrm>
-            <a:off x="2926080" y="1737360"/>
-            <a:ext cx="2377440" cy="292608"/>
+            <a:off x="411480" y="3246120"/>
+            <a:ext cx="2286000" cy="274320"/>
           </a:xfrm>
           <a:prstGeom prst="rect">
             <a:avLst/>
@@ -3655,13 +3585,13 @@
               </a:spcAft>
             </a:pPr>
             <a:r>
-              <a:rPr sz="1350" b="1">
+              <a:rPr sz="1250" b="1">
                 <a:solidFill>
                   <a:srgbClr val="0F9D58"/>
                 </a:solidFill>
                 <a:latin typeface="Malgun Gothic"/>
               </a:rPr>
-              <a:t>[프론트엔드 / UI]</a:t>
+              <a:t>[ 프론트엔드 / UI ]</a:t>
             </a:r>
           </a:p>
         </p:txBody>
@@ -3674,8 +3604,8 @@
         </p:nvSpPr>
         <p:spPr>
           <a:xfrm>
-            <a:off x="2926080" y="2048256"/>
-            <a:ext cx="2377440" cy="219456"/>
+            <a:off x="411480" y="3538728"/>
+            <a:ext cx="2286000" cy="219456"/>
           </a:xfrm>
           <a:prstGeom prst="rect">
             <a:avLst/>
@@ -3700,7 +3630,7 @@
               </a:spcAft>
             </a:pPr>
             <a:r>
-              <a:rPr sz="900" b="0">
+              <a:rPr sz="850" b="0">
                 <a:solidFill>
                   <a:srgbClr val="5B6470"/>
                 </a:solidFill>
@@ -3719,8 +3649,8 @@
         </p:nvSpPr>
         <p:spPr>
           <a:xfrm>
-            <a:off x="3072384" y="2322576"/>
-            <a:ext cx="2084832" cy="310896"/>
+            <a:off x="557784" y="3822191"/>
+            <a:ext cx="1993392" cy="292608"/>
           </a:xfrm>
           <a:prstGeom prst="roundRect">
             <a:avLst/>
@@ -3765,7 +3695,7 @@
               </a:spcAft>
             </a:pPr>
             <a:r>
-              <a:rPr sz="1050" b="0">
+              <a:rPr sz="1000" b="0">
                 <a:solidFill>
                   <a:srgbClr val="1A1D21"/>
                 </a:solidFill>
@@ -3784,8 +3714,8 @@
         </p:nvSpPr>
         <p:spPr>
           <a:xfrm>
-            <a:off x="3072384" y="2688336"/>
-            <a:ext cx="2084832" cy="310896"/>
+            <a:off x="557784" y="4160519"/>
+            <a:ext cx="1993392" cy="292608"/>
           </a:xfrm>
           <a:prstGeom prst="roundRect">
             <a:avLst/>
@@ -3830,7 +3760,7 @@
               </a:spcAft>
             </a:pPr>
             <a:r>
-              <a:rPr sz="1050" b="1">
+              <a:rPr sz="1000" b="1">
                 <a:solidFill>
                   <a:srgbClr val="1A1D21"/>
                 </a:solidFill>
@@ -3849,8 +3779,8 @@
         </p:nvSpPr>
         <p:spPr>
           <a:xfrm>
-            <a:off x="3072384" y="3054096"/>
-            <a:ext cx="2084832" cy="310896"/>
+            <a:off x="557784" y="4498847"/>
+            <a:ext cx="1993392" cy="292608"/>
           </a:xfrm>
           <a:prstGeom prst="roundRect">
             <a:avLst/>
@@ -3895,7 +3825,7 @@
               </a:spcAft>
             </a:pPr>
             <a:r>
-              <a:rPr sz="1050" b="0">
+              <a:rPr sz="1000" b="0">
                 <a:solidFill>
                   <a:srgbClr val="1A1D21"/>
                 </a:solidFill>
@@ -3914,8 +3844,8 @@
         </p:nvSpPr>
         <p:spPr>
           <a:xfrm>
-            <a:off x="3072384" y="3419856"/>
-            <a:ext cx="2084832" cy="310896"/>
+            <a:off x="557784" y="4837175"/>
+            <a:ext cx="1993392" cy="292608"/>
           </a:xfrm>
           <a:prstGeom prst="roundRect">
             <a:avLst/>
@@ -3960,7 +3890,7 @@
               </a:spcAft>
             </a:pPr>
             <a:r>
-              <a:rPr sz="1050" b="0">
+              <a:rPr sz="1000" b="0">
                 <a:solidFill>
                   <a:srgbClr val="1A1D21"/>
                 </a:solidFill>
@@ -3979,8 +3909,8 @@
         </p:nvSpPr>
         <p:spPr>
           <a:xfrm>
-            <a:off x="5394960" y="2560320"/>
-            <a:ext cx="420624" cy="384048"/>
+            <a:off x="2761488" y="3977639"/>
+            <a:ext cx="384048" cy="365760"/>
           </a:xfrm>
           <a:prstGeom prst="rightArrow">
             <a:avLst/>
@@ -4023,8 +3953,8 @@
         </p:nvSpPr>
         <p:spPr>
           <a:xfrm>
-            <a:off x="5074920" y="2267712"/>
-            <a:ext cx="1060704" cy="237744"/>
+            <a:off x="2441448" y="3685031"/>
+            <a:ext cx="1024128" cy="237744"/>
           </a:xfrm>
           <a:prstGeom prst="rect">
             <a:avLst/>
@@ -4068,8 +3998,8 @@
         </p:nvSpPr>
         <p:spPr>
           <a:xfrm>
-            <a:off x="5852160" y="1371600"/>
-            <a:ext cx="5925312" cy="3657600"/>
+            <a:off x="3291840" y="1371600"/>
+            <a:ext cx="8485632" cy="3931920"/>
           </a:xfrm>
           <a:prstGeom prst="roundRect">
             <a:avLst/>
@@ -4114,8 +4044,8 @@
         </p:nvSpPr>
         <p:spPr>
           <a:xfrm>
-            <a:off x="6016752" y="1490472"/>
-            <a:ext cx="5596128" cy="274320"/>
+            <a:off x="3474720" y="1481328"/>
+            <a:ext cx="8119872" cy="256032"/>
           </a:xfrm>
           <a:prstGeom prst="rect">
             <a:avLst/>
@@ -4146,7 +4076,7 @@
                 </a:solidFill>
                 <a:latin typeface="Malgun Gothic"/>
               </a:rPr>
-              <a:t>[백엔드 / Backend]  FastAPI (app/main.py) · 온프레미스</a:t>
+              <a:t>[ 백엔드 / Backend ]  FastAPI (app/main.py) · 온프레미스</a:t>
             </a:r>
           </a:p>
         </p:txBody>
@@ -4159,8 +4089,8 @@
         </p:nvSpPr>
         <p:spPr>
           <a:xfrm>
-            <a:off x="6016752" y="1828800"/>
-            <a:ext cx="5596128" cy="256032"/>
+            <a:off x="3474720" y="1792224"/>
+            <a:ext cx="8119872" cy="237744"/>
           </a:xfrm>
           <a:prstGeom prst="rect">
             <a:avLst/>
@@ -4204,8 +4134,8 @@
         </p:nvSpPr>
         <p:spPr>
           <a:xfrm>
-            <a:off x="6016752" y="2139696"/>
-            <a:ext cx="760258" cy="841248"/>
+            <a:off x="3474720" y="2084832"/>
+            <a:ext cx="1120793" cy="749808"/>
           </a:xfrm>
           <a:prstGeom prst="roundRect">
             <a:avLst/>
@@ -4250,7 +4180,7 @@
               </a:spcAft>
             </a:pPr>
             <a:r>
-              <a:rPr sz="1050" b="1">
+              <a:rPr sz="1000" b="1">
                 <a:solidFill>
                   <a:srgbClr val="1A1D21"/>
                 </a:solidFill>
@@ -4294,7 +4224,7 @@
               </a:spcAft>
             </a:pPr>
             <a:r>
-              <a:rPr sz="950" b="1">
+              <a:rPr sz="900" b="1">
                 <a:solidFill>
                   <a:srgbClr val="6B7480"/>
                 </a:solidFill>
@@ -4313,8 +4243,8 @@
         </p:nvSpPr>
         <p:spPr>
           <a:xfrm>
-            <a:off x="6758722" y="2139696"/>
-            <a:ext cx="91440" cy="841248"/>
+            <a:off x="4577225" y="2084832"/>
+            <a:ext cx="91440" cy="749808"/>
           </a:xfrm>
           <a:prstGeom prst="rect">
             <a:avLst/>
@@ -4358,8 +4288,8 @@
         </p:nvSpPr>
         <p:spPr>
           <a:xfrm>
-            <a:off x="6822730" y="2139696"/>
-            <a:ext cx="760258" cy="841248"/>
+            <a:off x="4641233" y="2084832"/>
+            <a:ext cx="1120793" cy="749808"/>
           </a:xfrm>
           <a:prstGeom prst="roundRect">
             <a:avLst/>
@@ -4404,7 +4334,7 @@
               </a:spcAft>
             </a:pPr>
             <a:r>
-              <a:rPr sz="1050" b="1">
+              <a:rPr sz="1000" b="1">
                 <a:solidFill>
                   <a:srgbClr val="1A1D21"/>
                 </a:solidFill>
@@ -4448,7 +4378,7 @@
               </a:spcAft>
             </a:pPr>
             <a:r>
-              <a:rPr sz="950" b="1">
+              <a:rPr sz="900" b="1">
                 <a:solidFill>
                   <a:srgbClr val="0F9D58"/>
                 </a:solidFill>
@@ -4467,8 +4397,8 @@
         </p:nvSpPr>
         <p:spPr>
           <a:xfrm>
-            <a:off x="7564700" y="2139696"/>
-            <a:ext cx="91440" cy="841248"/>
+            <a:off x="5743738" y="2084832"/>
+            <a:ext cx="91440" cy="749808"/>
           </a:xfrm>
           <a:prstGeom prst="rect">
             <a:avLst/>
@@ -4512,8 +4442,8 @@
         </p:nvSpPr>
         <p:spPr>
           <a:xfrm>
-            <a:off x="7628708" y="2139696"/>
-            <a:ext cx="760258" cy="841248"/>
+            <a:off x="5807746" y="2084832"/>
+            <a:ext cx="1120793" cy="749808"/>
           </a:xfrm>
           <a:prstGeom prst="roundRect">
             <a:avLst/>
@@ -4558,7 +4488,7 @@
               </a:spcAft>
             </a:pPr>
             <a:r>
-              <a:rPr sz="1050" b="1">
+              <a:rPr sz="1000" b="1">
                 <a:solidFill>
                   <a:srgbClr val="1A1D21"/>
                 </a:solidFill>
@@ -4602,7 +4532,7 @@
               </a:spcAft>
             </a:pPr>
             <a:r>
-              <a:rPr sz="950" b="1">
+              <a:rPr sz="900" b="1">
                 <a:solidFill>
                   <a:srgbClr val="6B7480"/>
                 </a:solidFill>
@@ -4621,8 +4551,8 @@
         </p:nvSpPr>
         <p:spPr>
           <a:xfrm>
-            <a:off x="8370678" y="2139696"/>
-            <a:ext cx="91440" cy="841248"/>
+            <a:off x="6910251" y="2084832"/>
+            <a:ext cx="91440" cy="749808"/>
           </a:xfrm>
           <a:prstGeom prst="rect">
             <a:avLst/>
@@ -4666,8 +4596,8 @@
         </p:nvSpPr>
         <p:spPr>
           <a:xfrm>
-            <a:off x="8434686" y="2139696"/>
-            <a:ext cx="760258" cy="841248"/>
+            <a:off x="6974259" y="2084832"/>
+            <a:ext cx="1120793" cy="749808"/>
           </a:xfrm>
           <a:prstGeom prst="roundRect">
             <a:avLst/>
@@ -4712,7 +4642,7 @@
               </a:spcAft>
             </a:pPr>
             <a:r>
-              <a:rPr sz="1050" b="1">
+              <a:rPr sz="1000" b="1">
                 <a:solidFill>
                   <a:srgbClr val="1A1D21"/>
                 </a:solidFill>
@@ -4756,7 +4686,7 @@
               </a:spcAft>
             </a:pPr>
             <a:r>
-              <a:rPr sz="950" b="1">
+              <a:rPr sz="900" b="1">
                 <a:solidFill>
                   <a:srgbClr val="5B3BBF"/>
                 </a:solidFill>
@@ -4775,8 +4705,8 @@
         </p:nvSpPr>
         <p:spPr>
           <a:xfrm>
-            <a:off x="9176656" y="2139696"/>
-            <a:ext cx="91440" cy="841248"/>
+            <a:off x="8076764" y="2084832"/>
+            <a:ext cx="91440" cy="749808"/>
           </a:xfrm>
           <a:prstGeom prst="rect">
             <a:avLst/>
@@ -4820,8 +4750,8 @@
         </p:nvSpPr>
         <p:spPr>
           <a:xfrm>
-            <a:off x="9240664" y="2139696"/>
-            <a:ext cx="760258" cy="841248"/>
+            <a:off x="8140772" y="2084832"/>
+            <a:ext cx="1120793" cy="749808"/>
           </a:xfrm>
           <a:prstGeom prst="roundRect">
             <a:avLst/>
@@ -4866,7 +4796,7 @@
               </a:spcAft>
             </a:pPr>
             <a:r>
-              <a:rPr sz="1050" b="1">
+              <a:rPr sz="1000" b="1">
                 <a:solidFill>
                   <a:srgbClr val="1A1D21"/>
                 </a:solidFill>
@@ -4910,7 +4840,7 @@
               </a:spcAft>
             </a:pPr>
             <a:r>
-              <a:rPr sz="950" b="1">
+              <a:rPr sz="900" b="1">
                 <a:solidFill>
                   <a:srgbClr val="5B3BBF"/>
                 </a:solidFill>
@@ -4929,8 +4859,8 @@
         </p:nvSpPr>
         <p:spPr>
           <a:xfrm>
-            <a:off x="9982634" y="2139696"/>
-            <a:ext cx="91440" cy="841248"/>
+            <a:off x="9243277" y="2084832"/>
+            <a:ext cx="91440" cy="749808"/>
           </a:xfrm>
           <a:prstGeom prst="rect">
             <a:avLst/>
@@ -4974,8 +4904,8 @@
         </p:nvSpPr>
         <p:spPr>
           <a:xfrm>
-            <a:off x="10046642" y="2139696"/>
-            <a:ext cx="760258" cy="841248"/>
+            <a:off x="9307285" y="2084832"/>
+            <a:ext cx="1120793" cy="749808"/>
           </a:xfrm>
           <a:prstGeom prst="roundRect">
             <a:avLst/>
@@ -5020,7 +4950,7 @@
               </a:spcAft>
             </a:pPr>
             <a:r>
-              <a:rPr sz="1050" b="1">
+              <a:rPr sz="1000" b="1">
                 <a:solidFill>
                   <a:srgbClr val="1A1D21"/>
                 </a:solidFill>
@@ -5064,7 +4994,7 @@
               </a:spcAft>
             </a:pPr>
             <a:r>
-              <a:rPr sz="950" b="1">
+              <a:rPr sz="900" b="1">
                 <a:solidFill>
                   <a:srgbClr val="6B7480"/>
                 </a:solidFill>
@@ -5083,8 +5013,8 @@
         </p:nvSpPr>
         <p:spPr>
           <a:xfrm>
-            <a:off x="10788612" y="2139696"/>
-            <a:ext cx="91440" cy="841248"/>
+            <a:off x="10409790" y="2084832"/>
+            <a:ext cx="91440" cy="749808"/>
           </a:xfrm>
           <a:prstGeom prst="rect">
             <a:avLst/>
@@ -5128,8 +5058,8 @@
         </p:nvSpPr>
         <p:spPr>
           <a:xfrm>
-            <a:off x="10852620" y="2139696"/>
-            <a:ext cx="760258" cy="841248"/>
+            <a:off x="10473798" y="2084832"/>
+            <a:ext cx="1120793" cy="749808"/>
           </a:xfrm>
           <a:prstGeom prst="roundRect">
             <a:avLst/>
@@ -5174,7 +5104,7 @@
               </a:spcAft>
             </a:pPr>
             <a:r>
-              <a:rPr sz="1050" b="1">
+              <a:rPr sz="1000" b="1">
                 <a:solidFill>
                   <a:srgbClr val="1A1D21"/>
                 </a:solidFill>
@@ -5218,7 +5148,7 @@
               </a:spcAft>
             </a:pPr>
             <a:r>
-              <a:rPr sz="950" b="1">
+              <a:rPr sz="900" b="1">
                 <a:solidFill>
                   <a:srgbClr val="6B7480"/>
                 </a:solidFill>
@@ -5237,8 +5167,577 @@
         </p:nvSpPr>
         <p:spPr>
           <a:xfrm>
-            <a:off x="6016752" y="3072384"/>
-            <a:ext cx="5596128" cy="438912"/>
+            <a:off x="4150069" y="3182112"/>
+            <a:ext cx="2103120" cy="603504"/>
+          </a:xfrm>
+          <a:prstGeom prst="roundRect">
+            <a:avLst/>
+          </a:prstGeom>
+          <a:solidFill>
+            <a:srgbClr val="E7F6EE"/>
+          </a:solidFill>
+          <a:ln w="15875">
+            <a:solidFill>
+              <a:srgbClr val="0F9D58"/>
+            </a:solidFill>
+          </a:ln>
+          <a:effectLst/>
+        </p:spPr>
+        <p:style>
+          <a:lnRef idx="1">
+            <a:schemeClr val="accent1"/>
+          </a:lnRef>
+          <a:fillRef idx="3">
+            <a:schemeClr val="accent1"/>
+          </a:fillRef>
+          <a:effectRef idx="2">
+            <a:schemeClr val="accent1"/>
+          </a:effectRef>
+          <a:fontRef idx="minor">
+            <a:schemeClr val="lt1"/>
+          </a:fontRef>
+        </p:style>
+        <p:txBody>
+          <a:bodyPr rtlCol="0" anchor="ctr"/>
+          <a:lstStyle/>
+          <a:p>
+            <a:pPr algn="ctr"/>
+          </a:p>
+        </p:txBody>
+      </p:sp>
+      <p:pic>
+        <p:nvPicPr>
+          <p:cNvPr id="36" name="Picture 35" descr="bge_hf.png"/>
+          <p:cNvPicPr>
+            <a:picLocks noChangeAspect="1"/>
+          </p:cNvPicPr>
+          <p:nvPr/>
+        </p:nvPicPr>
+        <p:blipFill>
+          <a:blip r:embed="rId2"/>
+          <a:stretch>
+            <a:fillRect/>
+          </a:stretch>
+        </p:blipFill>
+        <p:spPr>
+          <a:xfrm>
+            <a:off x="4259797" y="3300984"/>
+            <a:ext cx="365760" cy="365760"/>
+          </a:xfrm>
+          <a:prstGeom prst="rect">
+            <a:avLst/>
+          </a:prstGeom>
+        </p:spPr>
+      </p:pic>
+      <p:sp>
+        <p:nvSpPr>
+          <p:cNvPr id="37" name="TextBox 36"/>
+          <p:cNvSpPr txBox="1"/>
+          <p:nvPr/>
+        </p:nvSpPr>
+        <p:spPr>
+          <a:xfrm>
+            <a:off x="4698709" y="3182112"/>
+            <a:ext cx="1481328" cy="603504"/>
+          </a:xfrm>
+          <a:prstGeom prst="rect">
+            <a:avLst/>
+          </a:prstGeom>
+          <a:noFill/>
+        </p:spPr>
+        <p:txBody>
+          <a:bodyPr wrap="square" anchor="ctr" lIns="0" rIns="0" tIns="9144" bIns="9144">
+            <a:spAutoFit/>
+          </a:bodyPr>
+          <a:lstStyle/>
+          <a:p>
+            <a:pPr algn="l">
+              <a:lnSpc>
+                <a:spcPct val="100000"/>
+              </a:lnSpc>
+              <a:spcBef>
+                <a:spcPts val="0"/>
+              </a:spcBef>
+              <a:spcAft>
+                <a:spcPts val="0"/>
+              </a:spcAft>
+            </a:pPr>
+            <a:r>
+              <a:rPr sz="1050" b="1">
+                <a:solidFill>
+                  <a:srgbClr val="0F9D58"/>
+                </a:solidFill>
+                <a:latin typeface="Malgun Gothic"/>
+              </a:rPr>
+              <a:t>BGE-m3</a:t>
+            </a:r>
+          </a:p>
+          <a:p>
+            <a:pPr algn="l">
+              <a:lnSpc>
+                <a:spcPct val="100000"/>
+              </a:lnSpc>
+              <a:spcBef>
+                <a:spcPts val="0"/>
+              </a:spcBef>
+              <a:spcAft>
+                <a:spcPts val="0"/>
+              </a:spcAft>
+            </a:pPr>
+            <a:r>
+              <a:rPr sz="850" b="0">
+                <a:solidFill>
+                  <a:srgbClr val="5B6470"/>
+                </a:solidFill>
+                <a:latin typeface="Malgun Gothic"/>
+              </a:rPr>
+              <a:t>임베딩 (HuggingFace)</a:t>
+            </a:r>
+          </a:p>
+        </p:txBody>
+      </p:sp>
+      <p:cxnSp>
+        <p:nvCxnSpPr>
+          <p:cNvPr id="38" name="Connector 37"/>
+          <p:cNvCxnSpPr/>
+          <p:nvPr/>
+        </p:nvCxnSpPr>
+        <p:spPr>
+          <a:xfrm flipV="1">
+            <a:off x="5201629" y="2834640"/>
+            <a:ext cx="0" cy="347472"/>
+          </a:xfrm>
+          <a:prstGeom prst="line">
+            <a:avLst/>
+          </a:prstGeom>
+          <a:ln w="25400">
+            <a:solidFill>
+              <a:srgbClr val="0F9D58"/>
+            </a:solidFill>
+          </a:ln>
+          <a:effectLst/>
+        </p:spPr>
+        <p:style>
+          <a:lnRef idx="2">
+            <a:schemeClr val="accent1"/>
+          </a:lnRef>
+          <a:fillRef idx="0">
+            <a:schemeClr val="accent1"/>
+          </a:fillRef>
+          <a:effectRef idx="1">
+            <a:schemeClr val="accent1"/>
+          </a:effectRef>
+          <a:fontRef idx="minor">
+            <a:schemeClr val="tx1"/>
+          </a:fontRef>
+        </p:style>
+      </p:cxnSp>
+      <p:sp>
+        <p:nvSpPr>
+          <p:cNvPr id="39" name="Rounded Rectangle 38"/>
+          <p:cNvSpPr/>
+          <p:nvPr/>
+        </p:nvSpPr>
+        <p:spPr>
+          <a:xfrm>
+            <a:off x="6837751" y="3182112"/>
+            <a:ext cx="2560320" cy="603504"/>
+          </a:xfrm>
+          <a:prstGeom prst="roundRect">
+            <a:avLst/>
+          </a:prstGeom>
+          <a:solidFill>
+            <a:srgbClr val="EFEAFF"/>
+          </a:solidFill>
+          <a:ln w="15875">
+            <a:solidFill>
+              <a:srgbClr val="5B3BBF"/>
+            </a:solidFill>
+          </a:ln>
+          <a:effectLst/>
+        </p:spPr>
+        <p:style>
+          <a:lnRef idx="1">
+            <a:schemeClr val="accent1"/>
+          </a:lnRef>
+          <a:fillRef idx="3">
+            <a:schemeClr val="accent1"/>
+          </a:fillRef>
+          <a:effectRef idx="2">
+            <a:schemeClr val="accent1"/>
+          </a:effectRef>
+          <a:fontRef idx="minor">
+            <a:schemeClr val="lt1"/>
+          </a:fontRef>
+        </p:style>
+        <p:txBody>
+          <a:bodyPr rtlCol="0" anchor="ctr"/>
+          <a:lstStyle/>
+          <a:p>
+            <a:pPr algn="ctr"/>
+          </a:p>
+        </p:txBody>
+      </p:sp>
+      <p:pic>
+        <p:nvPicPr>
+          <p:cNvPr id="40" name="Picture 39" descr="ollama.png"/>
+          <p:cNvPicPr>
+            <a:picLocks noChangeAspect="1"/>
+          </p:cNvPicPr>
+          <p:nvPr/>
+        </p:nvPicPr>
+        <p:blipFill>
+          <a:blip r:embed="rId3"/>
+          <a:stretch>
+            <a:fillRect/>
+          </a:stretch>
+        </p:blipFill>
+        <p:spPr>
+          <a:xfrm>
+            <a:off x="6947479" y="3282696"/>
+            <a:ext cx="402336" cy="402336"/>
+          </a:xfrm>
+          <a:prstGeom prst="rect">
+            <a:avLst/>
+          </a:prstGeom>
+        </p:spPr>
+      </p:pic>
+      <p:sp>
+        <p:nvSpPr>
+          <p:cNvPr id="41" name="TextBox 40"/>
+          <p:cNvSpPr txBox="1"/>
+          <p:nvPr/>
+        </p:nvSpPr>
+        <p:spPr>
+          <a:xfrm>
+            <a:off x="7422967" y="3182112"/>
+            <a:ext cx="1901952" cy="603504"/>
+          </a:xfrm>
+          <a:prstGeom prst="rect">
+            <a:avLst/>
+          </a:prstGeom>
+          <a:noFill/>
+        </p:spPr>
+        <p:txBody>
+          <a:bodyPr wrap="square" anchor="ctr" lIns="0" rIns="0" tIns="9144" bIns="9144">
+            <a:spAutoFit/>
+          </a:bodyPr>
+          <a:lstStyle/>
+          <a:p>
+            <a:pPr algn="l">
+              <a:lnSpc>
+                <a:spcPct val="100000"/>
+              </a:lnSpc>
+              <a:spcBef>
+                <a:spcPts val="0"/>
+              </a:spcBef>
+              <a:spcAft>
+                <a:spcPts val="0"/>
+              </a:spcAft>
+            </a:pPr>
+            <a:r>
+              <a:rPr sz="1050" b="1">
+                <a:solidFill>
+                  <a:srgbClr val="5B3BBF"/>
+                </a:solidFill>
+                <a:latin typeface="Malgun Gothic"/>
+              </a:rPr>
+              <a:t>Ollama · Qwen2.5-7B</a:t>
+            </a:r>
+          </a:p>
+          <a:p>
+            <a:pPr algn="l">
+              <a:lnSpc>
+                <a:spcPct val="100000"/>
+              </a:lnSpc>
+              <a:spcBef>
+                <a:spcPts val="0"/>
+              </a:spcBef>
+              <a:spcAft>
+                <a:spcPts val="0"/>
+              </a:spcAft>
+            </a:pPr>
+            <a:r>
+              <a:rPr sz="850" b="0">
+                <a:solidFill>
+                  <a:srgbClr val="5B6470"/>
+                </a:solidFill>
+                <a:latin typeface="Malgun Gothic"/>
+              </a:rPr>
+              <a:t>LLM 추론 (온프레미스)</a:t>
+            </a:r>
+          </a:p>
+        </p:txBody>
+      </p:sp>
+      <p:cxnSp>
+        <p:nvCxnSpPr>
+          <p:cNvPr id="42" name="Connector 41"/>
+          <p:cNvCxnSpPr/>
+          <p:nvPr/>
+        </p:nvCxnSpPr>
+        <p:spPr>
+          <a:xfrm flipH="1" flipV="1">
+            <a:off x="7534655" y="2834640"/>
+            <a:ext cx="308936" cy="347472"/>
+          </a:xfrm>
+          <a:prstGeom prst="line">
+            <a:avLst/>
+          </a:prstGeom>
+          <a:ln w="25400">
+            <a:solidFill>
+              <a:srgbClr val="5B3BBF"/>
+            </a:solidFill>
+          </a:ln>
+          <a:effectLst/>
+        </p:spPr>
+        <p:style>
+          <a:lnRef idx="2">
+            <a:schemeClr val="accent1"/>
+          </a:lnRef>
+          <a:fillRef idx="0">
+            <a:schemeClr val="accent1"/>
+          </a:fillRef>
+          <a:effectRef idx="1">
+            <a:schemeClr val="accent1"/>
+          </a:effectRef>
+          <a:fontRef idx="minor">
+            <a:schemeClr val="tx1"/>
+          </a:fontRef>
+        </p:style>
+      </p:cxnSp>
+      <p:cxnSp>
+        <p:nvCxnSpPr>
+          <p:cNvPr id="43" name="Connector 42"/>
+          <p:cNvCxnSpPr/>
+          <p:nvPr/>
+        </p:nvCxnSpPr>
+        <p:spPr>
+          <a:xfrm flipV="1">
+            <a:off x="8392231" y="2834640"/>
+            <a:ext cx="308937" cy="347472"/>
+          </a:xfrm>
+          <a:prstGeom prst="line">
+            <a:avLst/>
+          </a:prstGeom>
+          <a:ln w="25400">
+            <a:solidFill>
+              <a:srgbClr val="5B3BBF"/>
+            </a:solidFill>
+          </a:ln>
+          <a:effectLst/>
+        </p:spPr>
+        <p:style>
+          <a:lnRef idx="2">
+            <a:schemeClr val="accent1"/>
+          </a:lnRef>
+          <a:fillRef idx="0">
+            <a:schemeClr val="accent1"/>
+          </a:fillRef>
+          <a:effectRef idx="1">
+            <a:schemeClr val="accent1"/>
+          </a:effectRef>
+          <a:fontRef idx="minor">
+            <a:schemeClr val="tx1"/>
+          </a:fontRef>
+        </p:style>
+      </p:cxnSp>
+      <p:pic>
+        <p:nvPicPr>
+          <p:cNvPr id="44" name="Picture 43" descr="autopilot.png"/>
+          <p:cNvPicPr>
+            <a:picLocks noChangeAspect="1"/>
+          </p:cNvPicPr>
+          <p:nvPr/>
+        </p:nvPicPr>
+        <p:blipFill>
+          <a:blip r:embed="rId4"/>
+          <a:stretch>
+            <a:fillRect/>
+          </a:stretch>
+        </p:blipFill>
+        <p:spPr>
+          <a:xfrm>
+            <a:off x="3474720" y="3950208"/>
+            <a:ext cx="384048" cy="384048"/>
+          </a:xfrm>
+          <a:prstGeom prst="rect">
+            <a:avLst/>
+          </a:prstGeom>
+        </p:spPr>
+      </p:pic>
+      <p:sp>
+        <p:nvSpPr>
+          <p:cNvPr id="45" name="TextBox 44"/>
+          <p:cNvSpPr txBox="1"/>
+          <p:nvPr/>
+        </p:nvSpPr>
+        <p:spPr>
+          <a:xfrm>
+            <a:off x="3931920" y="3968496"/>
+            <a:ext cx="7662672" cy="256032"/>
+          </a:xfrm>
+          <a:prstGeom prst="rect">
+            <a:avLst/>
+          </a:prstGeom>
+          <a:noFill/>
+        </p:spPr>
+        <p:txBody>
+          <a:bodyPr wrap="square" anchor="t" lIns="0" rIns="0" tIns="9144" bIns="9144">
+            <a:spAutoFit/>
+          </a:bodyPr>
+          <a:lstStyle/>
+          <a:p>
+            <a:pPr algn="l">
+              <a:lnSpc>
+                <a:spcPct val="100000"/>
+              </a:lnSpc>
+              <a:spcBef>
+                <a:spcPts val="0"/>
+              </a:spcBef>
+              <a:spcAft>
+                <a:spcPts val="0"/>
+              </a:spcAft>
+            </a:pPr>
+            <a:r>
+              <a:rPr sz="1200" b="1">
+                <a:solidFill>
+                  <a:srgbClr val="5B3BBF"/>
+                </a:solidFill>
+                <a:latin typeface="Malgun Gothic"/>
+              </a:rPr>
+              <a:t>준법 오토파일럿</a:t>
+            </a:r>
+            <a:r>
+              <a:rPr sz="950" b="0">
+                <a:solidFill>
+                  <a:srgbClr val="5B6470"/>
+                </a:solidFill>
+                <a:latin typeface="Malgun Gothic"/>
+              </a:rPr>
+              <a:t> - 위반 초안을 통과까지 자율 개선 (Ollama 기반)</a:t>
+            </a:r>
+          </a:p>
+        </p:txBody>
+      </p:sp>
+      <p:sp>
+        <p:nvSpPr>
+          <p:cNvPr id="46" name="Rounded Rectangle 45"/>
+          <p:cNvSpPr/>
+          <p:nvPr/>
+        </p:nvSpPr>
+        <p:spPr>
+          <a:xfrm>
+            <a:off x="3474720" y="4334256"/>
+            <a:ext cx="1714500" cy="548640"/>
+          </a:xfrm>
+          <a:prstGeom prst="roundRect">
+            <a:avLst/>
+          </a:prstGeom>
+          <a:solidFill>
+            <a:srgbClr val="EEF1F5"/>
+          </a:solidFill>
+          <a:ln w="9525">
+            <a:solidFill>
+              <a:srgbClr val="6B7480"/>
+            </a:solidFill>
+          </a:ln>
+          <a:effectLst/>
+        </p:spPr>
+        <p:style>
+          <a:lnRef idx="1">
+            <a:schemeClr val="accent1"/>
+          </a:lnRef>
+          <a:fillRef idx="3">
+            <a:schemeClr val="accent1"/>
+          </a:fillRef>
+          <a:effectRef idx="2">
+            <a:schemeClr val="accent1"/>
+          </a:effectRef>
+          <a:fontRef idx="minor">
+            <a:schemeClr val="lt1"/>
+          </a:fontRef>
+        </p:style>
+        <p:txBody>
+          <a:bodyPr rtlCol="0" anchor="ctr" wrap="square" lIns="36576" rIns="36576" tIns="9144" bIns="9144"/>
+          <a:lstStyle/>
+          <a:p>
+            <a:pPr algn="ctr">
+              <a:lnSpc>
+                <a:spcPct val="100000"/>
+              </a:lnSpc>
+              <a:spcBef>
+                <a:spcPts val="0"/>
+              </a:spcBef>
+              <a:spcAft>
+                <a:spcPts val="0"/>
+              </a:spcAft>
+            </a:pPr>
+            <a:r>
+              <a:rPr sz="1000" b="1">
+                <a:solidFill>
+                  <a:srgbClr val="1A1D21"/>
+                </a:solidFill>
+                <a:latin typeface="Malgun Gothic"/>
+              </a:rPr>
+              <a:t>① 심의·점수</a:t>
+            </a:r>
+          </a:p>
+        </p:txBody>
+      </p:sp>
+      <p:sp>
+        <p:nvSpPr>
+          <p:cNvPr id="47" name="Right Arrow 46"/>
+          <p:cNvSpPr/>
+          <p:nvPr/>
+        </p:nvSpPr>
+        <p:spPr>
+          <a:xfrm>
+            <a:off x="5244084" y="4480560"/>
+            <a:ext cx="274320" cy="256032"/>
+          </a:xfrm>
+          <a:prstGeom prst="rightArrow">
+            <a:avLst/>
+          </a:prstGeom>
+          <a:solidFill>
+            <a:srgbClr val="8AA0B5"/>
+          </a:solidFill>
+          <a:ln>
+            <a:noFill/>
+          </a:ln>
+          <a:effectLst/>
+        </p:spPr>
+        <p:style>
+          <a:lnRef idx="1">
+            <a:schemeClr val="accent1"/>
+          </a:lnRef>
+          <a:fillRef idx="3">
+            <a:schemeClr val="accent1"/>
+          </a:fillRef>
+          <a:effectRef idx="2">
+            <a:schemeClr val="accent1"/>
+          </a:effectRef>
+          <a:fontRef idx="minor">
+            <a:schemeClr val="lt1"/>
+          </a:fontRef>
+        </p:style>
+        <p:txBody>
+          <a:bodyPr rtlCol="0" anchor="ctr"/>
+          <a:lstStyle/>
+          <a:p>
+            <a:pPr algn="ctr"/>
+          </a:p>
+        </p:txBody>
+      </p:sp>
+      <p:sp>
+        <p:nvSpPr>
+          <p:cNvPr id="48" name="Rounded Rectangle 47"/>
+          <p:cNvSpPr/>
+          <p:nvPr/>
+        </p:nvSpPr>
+        <p:spPr>
+          <a:xfrm>
+            <a:off x="5609844" y="4334256"/>
+            <a:ext cx="1714500" cy="548640"/>
           </a:xfrm>
           <a:prstGeom prst="roundRect">
             <a:avLst/>
@@ -5268,10 +5767,10 @@
           </a:fontRef>
         </p:style>
         <p:txBody>
-          <a:bodyPr rtlCol="0" anchor="ctr" wrap="square" lIns="128016" rIns="128016" tIns="9144" bIns="9144"/>
-          <a:lstStyle/>
-          <a:p>
-            <a:pPr algn="l">
+          <a:bodyPr rtlCol="0" anchor="ctr" wrap="square" lIns="36576" rIns="36576" tIns="9144" bIns="9144"/>
+          <a:lstStyle/>
+          <a:p>
+            <a:pPr algn="ctr">
               <a:lnSpc>
                 <a:spcPct val="100000"/>
               </a:lnSpc>
@@ -5283,92 +5782,36 @@
               </a:spcAft>
             </a:pPr>
             <a:r>
-              <a:rPr sz="1150" b="1">
+              <a:rPr sz="1000" b="1">
                 <a:solidFill>
                   <a:srgbClr val="5B3BBF"/>
                 </a:solidFill>
                 <a:latin typeface="Malgun Gothic"/>
               </a:rPr>
-              <a:t>* 준법 오토파일럿</a:t>
-            </a:r>
-            <a:r>
-              <a:rPr sz="1000" b="0">
-                <a:solidFill>
-                  <a:srgbClr val="5B6470"/>
-                </a:solidFill>
-                <a:latin typeface="Malgun Gothic"/>
-              </a:rPr>
-              <a:t>  판단-&gt;고쳐쓰기-&gt;재심의 자율 개선 루프 (Ollama)</a:t>
-            </a:r>
-          </a:p>
-        </p:txBody>
-      </p:sp>
-      <p:sp>
-        <p:nvSpPr>
-          <p:cNvPr id="36" name="TextBox 35"/>
-          <p:cNvSpPr txBox="1"/>
-          <p:nvPr/>
-        </p:nvSpPr>
-        <p:spPr>
-          <a:xfrm>
-            <a:off x="6016752" y="3602736"/>
-            <a:ext cx="5596128" cy="237744"/>
-          </a:xfrm>
-          <a:prstGeom prst="rect">
-            <a:avLst/>
-          </a:prstGeom>
-          <a:noFill/>
-        </p:spPr>
-        <p:txBody>
-          <a:bodyPr wrap="square" anchor="t" lIns="0" rIns="0" tIns="9144" bIns="9144">
-            <a:spAutoFit/>
-          </a:bodyPr>
-          <a:lstStyle/>
-          <a:p>
-            <a:pPr algn="l">
-              <a:lnSpc>
-                <a:spcPct val="100000"/>
-              </a:lnSpc>
-              <a:spcBef>
-                <a:spcPts val="0"/>
-              </a:spcBef>
-              <a:spcAft>
-                <a:spcPts val="0"/>
-              </a:spcAft>
-            </a:pPr>
-            <a:r>
-              <a:rPr sz="1150" b="1">
-                <a:solidFill>
-                  <a:srgbClr val="003A6E"/>
-                </a:solidFill>
-                <a:latin typeface="Malgun Gothic"/>
-              </a:rPr>
-              <a:t>[엔진] 어느 모델이 어느 단계에 쓰이나</a:t>
-            </a:r>
-          </a:p>
-        </p:txBody>
-      </p:sp>
-      <p:sp>
-        <p:nvSpPr>
-          <p:cNvPr id="37" name="Rounded Rectangle 36"/>
+              <a:t>② LLM 고쳐쓰기</a:t>
+            </a:r>
+          </a:p>
+        </p:txBody>
+      </p:sp>
+      <p:sp>
+        <p:nvSpPr>
+          <p:cNvPr id="49" name="Right Arrow 48"/>
           <p:cNvSpPr/>
           <p:nvPr/>
         </p:nvSpPr>
         <p:spPr>
           <a:xfrm>
-            <a:off x="6016752" y="3877056"/>
-            <a:ext cx="2606040" cy="338328"/>
-          </a:xfrm>
-          <a:prstGeom prst="roundRect">
+            <a:off x="7379208" y="4480560"/>
+            <a:ext cx="274320" cy="256032"/>
+          </a:xfrm>
+          <a:prstGeom prst="rightArrow">
             <a:avLst/>
           </a:prstGeom>
           <a:solidFill>
-            <a:srgbClr val="EFEAFF"/>
+            <a:srgbClr val="8AA0B5"/>
           </a:solidFill>
-          <a:ln w="9525">
-            <a:solidFill>
-              <a:srgbClr val="5B3BBF"/>
-            </a:solidFill>
+          <a:ln>
+            <a:noFill/>
           </a:ln>
           <a:effectLst/>
         </p:spPr>
@@ -5387,197 +5830,23 @@
           </a:fontRef>
         </p:style>
         <p:txBody>
-          <a:bodyPr rtlCol="0" anchor="ctr" wrap="square" tIns="9144" bIns="9144"/>
-          <a:lstStyle/>
-          <a:p>
-            <a:pPr algn="l">
-              <a:lnSpc>
-                <a:spcPct val="100000"/>
-              </a:lnSpc>
-              <a:spcBef>
-                <a:spcPts val="0"/>
-              </a:spcBef>
-              <a:spcAft>
-                <a:spcPts val="0"/>
-              </a:spcAft>
-            </a:pPr>
-            <a:r>
-              <a:rPr sz="1000" b="1">
-                <a:solidFill>
-                  <a:srgbClr val="5B3BBF"/>
-                </a:solidFill>
-                <a:latin typeface="Malgun Gothic"/>
-              </a:rPr>
-              <a:t>Ollama · Qwen2.5-7B (LLM 추론)</a:t>
-            </a:r>
-          </a:p>
-        </p:txBody>
-      </p:sp>
-      <p:sp>
-        <p:nvSpPr>
-          <p:cNvPr id="38" name="TextBox 37"/>
-          <p:cNvSpPr txBox="1"/>
-          <p:nvPr/>
-        </p:nvSpPr>
-        <p:spPr>
-          <a:xfrm>
-            <a:off x="8741664" y="3877056"/>
-            <a:ext cx="2871216" cy="338328"/>
-          </a:xfrm>
-          <a:prstGeom prst="rect">
-            <a:avLst/>
-          </a:prstGeom>
-          <a:noFill/>
-        </p:spPr>
-        <p:txBody>
-          <a:bodyPr wrap="square" anchor="ctr" lIns="0" rIns="0" tIns="9144" bIns="9144">
-            <a:spAutoFit/>
-          </a:bodyPr>
-          <a:lstStyle/>
-          <a:p>
-            <a:pPr algn="l">
-              <a:lnSpc>
-                <a:spcPct val="100000"/>
-              </a:lnSpc>
-              <a:spcBef>
-                <a:spcPts val="0"/>
-              </a:spcBef>
-              <a:spcAft>
-                <a:spcPts val="0"/>
-              </a:spcAft>
-            </a:pPr>
-            <a:r>
-              <a:rPr sz="969" b="0">
-                <a:solidFill>
-                  <a:srgbClr val="1A1D21"/>
-                </a:solidFill>
-                <a:latin typeface="Malgun Gothic"/>
-              </a:rPr>
-              <a:t>-&gt; (4)LLM 심의 · (5)오인 시뮬레이터 · *오토파일럿 · 내규 변환 · 다국어 재심의</a:t>
-            </a:r>
-          </a:p>
-        </p:txBody>
-      </p:sp>
-      <p:sp>
-        <p:nvSpPr>
-          <p:cNvPr id="39" name="Rounded Rectangle 38"/>
+          <a:bodyPr rtlCol="0" anchor="ctr"/>
+          <a:lstStyle/>
+          <a:p>
+            <a:pPr algn="ctr"/>
+          </a:p>
+        </p:txBody>
+      </p:sp>
+      <p:sp>
+        <p:nvSpPr>
+          <p:cNvPr id="50" name="Rounded Rectangle 49"/>
           <p:cNvSpPr/>
           <p:nvPr/>
         </p:nvSpPr>
         <p:spPr>
           <a:xfrm>
-            <a:off x="6016752" y="4242816"/>
-            <a:ext cx="2606040" cy="338328"/>
-          </a:xfrm>
-          <a:prstGeom prst="roundRect">
-            <a:avLst/>
-          </a:prstGeom>
-          <a:solidFill>
-            <a:srgbClr val="E7F6EE"/>
-          </a:solidFill>
-          <a:ln w="9525">
-            <a:solidFill>
-              <a:srgbClr val="0F9D58"/>
-            </a:solidFill>
-          </a:ln>
-          <a:effectLst/>
-        </p:spPr>
-        <p:style>
-          <a:lnRef idx="1">
-            <a:schemeClr val="accent1"/>
-          </a:lnRef>
-          <a:fillRef idx="3">
-            <a:schemeClr val="accent1"/>
-          </a:fillRef>
-          <a:effectRef idx="2">
-            <a:schemeClr val="accent1"/>
-          </a:effectRef>
-          <a:fontRef idx="minor">
-            <a:schemeClr val="lt1"/>
-          </a:fontRef>
-        </p:style>
-        <p:txBody>
-          <a:bodyPr rtlCol="0" anchor="ctr" wrap="square" tIns="9144" bIns="9144"/>
-          <a:lstStyle/>
-          <a:p>
-            <a:pPr algn="l">
-              <a:lnSpc>
-                <a:spcPct val="100000"/>
-              </a:lnSpc>
-              <a:spcBef>
-                <a:spcPts val="0"/>
-              </a:spcBef>
-              <a:spcAft>
-                <a:spcPts val="0"/>
-              </a:spcAft>
-            </a:pPr>
-            <a:r>
-              <a:rPr sz="1000" b="1">
-                <a:solidFill>
-                  <a:srgbClr val="0F9D58"/>
-                </a:solidFill>
-                <a:latin typeface="Malgun Gothic"/>
-              </a:rPr>
-              <a:t>BGE-m3 (임베딩, 선택)</a:t>
-            </a:r>
-          </a:p>
-        </p:txBody>
-      </p:sp>
-      <p:sp>
-        <p:nvSpPr>
-          <p:cNvPr id="40" name="TextBox 39"/>
-          <p:cNvSpPr txBox="1"/>
-          <p:nvPr/>
-        </p:nvSpPr>
-        <p:spPr>
-          <a:xfrm>
-            <a:off x="8741664" y="4242816"/>
-            <a:ext cx="2871216" cy="338328"/>
-          </a:xfrm>
-          <a:prstGeom prst="rect">
-            <a:avLst/>
-          </a:prstGeom>
-          <a:noFill/>
-        </p:spPr>
-        <p:txBody>
-          <a:bodyPr wrap="square" anchor="ctr" lIns="0" rIns="0" tIns="9144" bIns="9144">
-            <a:spAutoFit/>
-          </a:bodyPr>
-          <a:lstStyle/>
-          <a:p>
-            <a:pPr algn="l">
-              <a:lnSpc>
-                <a:spcPct val="100000"/>
-              </a:lnSpc>
-              <a:spcBef>
-                <a:spcPts val="0"/>
-              </a:spcBef>
-              <a:spcAft>
-                <a:spcPts val="0"/>
-              </a:spcAft>
-            </a:pPr>
-            <a:r>
-              <a:rPr sz="969" b="0">
-                <a:solidFill>
-                  <a:srgbClr val="1A1D21"/>
-                </a:solidFill>
-                <a:latin typeface="Malgun Gothic"/>
-              </a:rPr>
-              <a:t>-&gt; (2) RAG 근거검색 - 미설치 시 어휘검색으로 자동 폴백</a:t>
-            </a:r>
-          </a:p>
-        </p:txBody>
-      </p:sp>
-      <p:sp>
-        <p:nvSpPr>
-          <p:cNvPr id="41" name="Rounded Rectangle 40"/>
-          <p:cNvSpPr/>
-          <p:nvPr/>
-        </p:nvSpPr>
-        <p:spPr>
-          <a:xfrm>
-            <a:off x="6016752" y="4608576"/>
-            <a:ext cx="2606040" cy="338328"/>
+            <a:off x="7744968" y="4334256"/>
+            <a:ext cx="1714500" cy="548640"/>
           </a:xfrm>
           <a:prstGeom prst="roundRect">
             <a:avLst/>
@@ -5607,10 +5876,10 @@
           </a:fontRef>
         </p:style>
         <p:txBody>
-          <a:bodyPr rtlCol="0" anchor="ctr" wrap="square" tIns="9144" bIns="9144"/>
-          <a:lstStyle/>
-          <a:p>
-            <a:pPr algn="l">
+          <a:bodyPr rtlCol="0" anchor="ctr" wrap="square" lIns="36576" rIns="36576" tIns="9144" bIns="9144"/>
+          <a:lstStyle/>
+          <a:p>
+            <a:pPr algn="ctr">
               <a:lnSpc>
                 <a:spcPct val="100000"/>
               </a:lnSpc>
@@ -5624,25 +5893,243 @@
             <a:r>
               <a:rPr sz="1000" b="1">
                 <a:solidFill>
-                  <a:srgbClr val="6B7480"/>
+                  <a:srgbClr val="1A1D21"/>
                 </a:solidFill>
                 <a:latin typeface="Malgun Gothic"/>
               </a:rPr>
-              <a:t>결정적 엔진 (모델 없음)</a:t>
-            </a:r>
-          </a:p>
-        </p:txBody>
-      </p:sp>
-      <p:sp>
-        <p:nvSpPr>
-          <p:cNvPr id="42" name="TextBox 41"/>
+              <a:t>③ 재심의</a:t>
+            </a:r>
+          </a:p>
+        </p:txBody>
+      </p:sp>
+      <p:sp>
+        <p:nvSpPr>
+          <p:cNvPr id="51" name="Right Arrow 50"/>
+          <p:cNvSpPr/>
+          <p:nvPr/>
+        </p:nvSpPr>
+        <p:spPr>
+          <a:xfrm>
+            <a:off x="9514332" y="4480560"/>
+            <a:ext cx="274320" cy="256032"/>
+          </a:xfrm>
+          <a:prstGeom prst="rightArrow">
+            <a:avLst/>
+          </a:prstGeom>
+          <a:solidFill>
+            <a:srgbClr val="8AA0B5"/>
+          </a:solidFill>
+          <a:ln>
+            <a:noFill/>
+          </a:ln>
+          <a:effectLst/>
+        </p:spPr>
+        <p:style>
+          <a:lnRef idx="1">
+            <a:schemeClr val="accent1"/>
+          </a:lnRef>
+          <a:fillRef idx="3">
+            <a:schemeClr val="accent1"/>
+          </a:fillRef>
+          <a:effectRef idx="2">
+            <a:schemeClr val="accent1"/>
+          </a:effectRef>
+          <a:fontRef idx="minor">
+            <a:schemeClr val="lt1"/>
+          </a:fontRef>
+        </p:style>
+        <p:txBody>
+          <a:bodyPr rtlCol="0" anchor="ctr"/>
+          <a:lstStyle/>
+          <a:p>
+            <a:pPr algn="ctr"/>
+          </a:p>
+        </p:txBody>
+      </p:sp>
+      <p:sp>
+        <p:nvSpPr>
+          <p:cNvPr id="52" name="Rounded Rectangle 51"/>
+          <p:cNvSpPr/>
+          <p:nvPr/>
+        </p:nvSpPr>
+        <p:spPr>
+          <a:xfrm>
+            <a:off x="9880092" y="4334256"/>
+            <a:ext cx="1714500" cy="548640"/>
+          </a:xfrm>
+          <a:prstGeom prst="roundRect">
+            <a:avLst/>
+          </a:prstGeom>
+          <a:solidFill>
+            <a:srgbClr val="E9EEF5"/>
+          </a:solidFill>
+          <a:ln w="9525">
+            <a:solidFill>
+              <a:srgbClr val="003A6E"/>
+            </a:solidFill>
+          </a:ln>
+          <a:effectLst/>
+        </p:spPr>
+        <p:style>
+          <a:lnRef idx="1">
+            <a:schemeClr val="accent1"/>
+          </a:lnRef>
+          <a:fillRef idx="3">
+            <a:schemeClr val="accent1"/>
+          </a:fillRef>
+          <a:effectRef idx="2">
+            <a:schemeClr val="accent1"/>
+          </a:effectRef>
+          <a:fontRef idx="minor">
+            <a:schemeClr val="lt1"/>
+          </a:fontRef>
+        </p:style>
+        <p:txBody>
+          <a:bodyPr rtlCol="0" anchor="ctr" wrap="square" lIns="36576" rIns="36576" tIns="9144" bIns="9144"/>
+          <a:lstStyle/>
+          <a:p>
+            <a:pPr algn="ctr">
+              <a:lnSpc>
+                <a:spcPct val="100000"/>
+              </a:lnSpc>
+              <a:spcBef>
+                <a:spcPts val="0"/>
+              </a:spcBef>
+              <a:spcAft>
+                <a:spcPts val="0"/>
+              </a:spcAft>
+            </a:pPr>
+            <a:r>
+              <a:rPr sz="1000" b="1">
+                <a:solidFill>
+                  <a:srgbClr val="003A6E"/>
+                </a:solidFill>
+                <a:latin typeface="Malgun Gothic"/>
+              </a:rPr>
+              <a:t>④ 통과 / 미수렴-&gt;사람</a:t>
+            </a:r>
+          </a:p>
+        </p:txBody>
+      </p:sp>
+      <p:cxnSp>
+        <p:nvCxnSpPr>
+          <p:cNvPr id="53" name="Connector 52"/>
+          <p:cNvCxnSpPr/>
+          <p:nvPr/>
+        </p:nvCxnSpPr>
+        <p:spPr>
+          <a:xfrm>
+            <a:off x="8602218" y="4882896"/>
+            <a:ext cx="0" cy="128016"/>
+          </a:xfrm>
+          <a:prstGeom prst="line">
+            <a:avLst/>
+          </a:prstGeom>
+          <a:ln w="22225">
+            <a:solidFill>
+              <a:srgbClr val="5B3BBF"/>
+            </a:solidFill>
+          </a:ln>
+          <a:effectLst/>
+        </p:spPr>
+        <p:style>
+          <a:lnRef idx="2">
+            <a:schemeClr val="accent1"/>
+          </a:lnRef>
+          <a:fillRef idx="0">
+            <a:schemeClr val="accent1"/>
+          </a:fillRef>
+          <a:effectRef idx="1">
+            <a:schemeClr val="accent1"/>
+          </a:effectRef>
+          <a:fontRef idx="minor">
+            <a:schemeClr val="tx1"/>
+          </a:fontRef>
+        </p:style>
+      </p:cxnSp>
+      <p:cxnSp>
+        <p:nvCxnSpPr>
+          <p:cNvPr id="54" name="Connector 53"/>
+          <p:cNvCxnSpPr/>
+          <p:nvPr/>
+        </p:nvCxnSpPr>
+        <p:spPr>
+          <a:xfrm flipH="1">
+            <a:off x="6467094" y="5010912"/>
+            <a:ext cx="2135124" cy="0"/>
+          </a:xfrm>
+          <a:prstGeom prst="line">
+            <a:avLst/>
+          </a:prstGeom>
+          <a:ln w="22225">
+            <a:solidFill>
+              <a:srgbClr val="5B3BBF"/>
+            </a:solidFill>
+          </a:ln>
+          <a:effectLst/>
+        </p:spPr>
+        <p:style>
+          <a:lnRef idx="2">
+            <a:schemeClr val="accent1"/>
+          </a:lnRef>
+          <a:fillRef idx="0">
+            <a:schemeClr val="accent1"/>
+          </a:fillRef>
+          <a:effectRef idx="1">
+            <a:schemeClr val="accent1"/>
+          </a:effectRef>
+          <a:fontRef idx="minor">
+            <a:schemeClr val="tx1"/>
+          </a:fontRef>
+        </p:style>
+      </p:cxnSp>
+      <p:cxnSp>
+        <p:nvCxnSpPr>
+          <p:cNvPr id="55" name="Connector 54"/>
+          <p:cNvCxnSpPr/>
+          <p:nvPr/>
+        </p:nvCxnSpPr>
+        <p:spPr>
+          <a:xfrm flipV="1">
+            <a:off x="6467094" y="4882896"/>
+            <a:ext cx="0" cy="128016"/>
+          </a:xfrm>
+          <a:prstGeom prst="line">
+            <a:avLst/>
+          </a:prstGeom>
+          <a:ln w="22225">
+            <a:solidFill>
+              <a:srgbClr val="5B3BBF"/>
+            </a:solidFill>
+            <a:tailEnd type="triangle" w="med" len="med"/>
+          </a:ln>
+          <a:effectLst/>
+        </p:spPr>
+        <p:style>
+          <a:lnRef idx="2">
+            <a:schemeClr val="accent1"/>
+          </a:lnRef>
+          <a:fillRef idx="0">
+            <a:schemeClr val="accent1"/>
+          </a:fillRef>
+          <a:effectRef idx="1">
+            <a:schemeClr val="accent1"/>
+          </a:effectRef>
+          <a:fontRef idx="minor">
+            <a:schemeClr val="tx1"/>
+          </a:fontRef>
+        </p:style>
+      </p:cxnSp>
+      <p:sp>
+        <p:nvSpPr>
+          <p:cNvPr id="56" name="TextBox 55"/>
           <p:cNvSpPr txBox="1"/>
           <p:nvPr/>
         </p:nvSpPr>
         <p:spPr>
           <a:xfrm>
-            <a:off x="8741664" y="4608576"/>
-            <a:ext cx="2871216" cy="338328"/>
+            <a:off x="6009894" y="4974336"/>
+            <a:ext cx="3049524" cy="219456"/>
           </a:xfrm>
           <a:prstGeom prst="rect">
             <a:avLst/>
@@ -5655,7 +6142,7 @@
           </a:bodyPr>
           <a:lstStyle/>
           <a:p>
-            <a:pPr algn="l">
+            <a:pPr algn="ctr">
               <a:lnSpc>
                 <a:spcPct val="100000"/>
               </a:lnSpc>
@@ -5667,27 +6154,27 @@
               </a:spcAft>
             </a:pPr>
             <a:r>
-              <a:rPr sz="969" b="0">
-                <a:solidFill>
-                  <a:srgbClr val="1A1D21"/>
+              <a:rPr sz="900" b="1">
+                <a:solidFill>
+                  <a:srgbClr val="5B3BBF"/>
                 </a:solidFill>
                 <a:latin typeface="Malgun Gothic"/>
               </a:rPr>
-              <a:t>-&gt; (1) 유형분류 · (3) 룰엔진 · (6) 리포트 · (7,8) 승인·감사 (규칙·집계)</a:t>
-            </a:r>
-          </a:p>
-        </p:txBody>
-      </p:sp>
-      <p:sp>
-        <p:nvSpPr>
-          <p:cNvPr id="43" name="Down Arrow 42"/>
+              <a:t>미통과 시 (2)~(3) 반복 (통과까지)</a:t>
+            </a:r>
+          </a:p>
+        </p:txBody>
+      </p:sp>
+      <p:sp>
+        <p:nvSpPr>
+          <p:cNvPr id="57" name="Down Arrow 56"/>
           <p:cNvSpPr/>
           <p:nvPr/>
         </p:nvSpPr>
         <p:spPr>
           <a:xfrm>
-            <a:off x="6867144" y="5029200"/>
-            <a:ext cx="256032" cy="310896"/>
+            <a:off x="5358384" y="5349240"/>
+            <a:ext cx="256032" cy="274320"/>
           </a:xfrm>
           <a:prstGeom prst="downArrow">
             <a:avLst/>
@@ -5724,14 +6211,14 @@
       </p:sp>
       <p:sp>
         <p:nvSpPr>
-          <p:cNvPr id="44" name="TextBox 43"/>
+          <p:cNvPr id="58" name="TextBox 57"/>
           <p:cNvSpPr txBox="1"/>
           <p:nvPr/>
         </p:nvSpPr>
         <p:spPr>
           <a:xfrm>
-            <a:off x="7178040" y="5029200"/>
-            <a:ext cx="2286000" cy="310896"/>
+            <a:off x="5669280" y="5349240"/>
+            <a:ext cx="2286000" cy="274320"/>
           </a:xfrm>
           <a:prstGeom prst="rect">
             <a:avLst/>
@@ -5769,14 +6256,14 @@
       </p:sp>
       <p:sp>
         <p:nvSpPr>
-          <p:cNvPr id="45" name="Down Arrow 44"/>
+          <p:cNvPr id="59" name="Down Arrow 58"/>
           <p:cNvSpPr/>
           <p:nvPr/>
         </p:nvSpPr>
         <p:spPr>
           <a:xfrm>
-            <a:off x="10250424" y="5029200"/>
-            <a:ext cx="256032" cy="310896"/>
+            <a:off x="10296144" y="5349240"/>
+            <a:ext cx="256032" cy="274320"/>
           </a:xfrm>
           <a:prstGeom prst="downArrow">
             <a:avLst/>
@@ -5813,14 +6300,14 @@
       </p:sp>
       <p:sp>
         <p:nvSpPr>
-          <p:cNvPr id="46" name="TextBox 45"/>
+          <p:cNvPr id="60" name="TextBox 59"/>
           <p:cNvSpPr txBox="1"/>
           <p:nvPr/>
         </p:nvSpPr>
         <p:spPr>
           <a:xfrm>
-            <a:off x="10561320" y="5029200"/>
-            <a:ext cx="2286000" cy="310896"/>
+            <a:off x="10607040" y="5349240"/>
+            <a:ext cx="2286000" cy="274320"/>
           </a:xfrm>
           <a:prstGeom prst="rect">
             <a:avLst/>
@@ -5858,14 +6345,14 @@
       </p:sp>
       <p:sp>
         <p:nvSpPr>
-          <p:cNvPr id="47" name="Can 46"/>
+          <p:cNvPr id="61" name="Can 60"/>
           <p:cNvSpPr/>
           <p:nvPr/>
         </p:nvSpPr>
         <p:spPr>
           <a:xfrm>
-            <a:off x="5852160" y="5340096"/>
-            <a:ext cx="1600200" cy="1097280"/>
+            <a:off x="4206240" y="5650992"/>
+            <a:ext cx="1645920" cy="1024128"/>
           </a:xfrm>
           <a:prstGeom prst="can">
             <a:avLst/>
@@ -5958,21 +6445,21 @@
                 </a:solidFill>
                 <a:latin typeface="Malgun Gothic"/>
               </a:rPr>
-              <a:t>내규·배포 로그</a:t>
-            </a:r>
-          </a:p>
-        </p:txBody>
-      </p:sp>
-      <p:sp>
-        <p:nvSpPr>
-          <p:cNvPr id="48" name="Can 47"/>
+              <a:t>내규·배포</a:t>
+            </a:r>
+          </a:p>
+        </p:txBody>
+      </p:sp>
+      <p:sp>
+        <p:nvSpPr>
+          <p:cNvPr id="62" name="Can 61"/>
           <p:cNvSpPr/>
           <p:nvPr/>
         </p:nvSpPr>
         <p:spPr>
           <a:xfrm>
-            <a:off x="7589520" y="5340096"/>
-            <a:ext cx="1600200" cy="1097280"/>
+            <a:off x="6035040" y="5650992"/>
+            <a:ext cx="1645920" cy="1024128"/>
           </a:xfrm>
           <a:prstGeom prst="can">
             <a:avLst/>
@@ -6072,14 +6559,14 @@
       </p:sp>
       <p:sp>
         <p:nvSpPr>
-          <p:cNvPr id="49" name="Cloud 48"/>
+          <p:cNvPr id="63" name="Cloud 62"/>
           <p:cNvSpPr/>
           <p:nvPr/>
         </p:nvSpPr>
         <p:spPr>
           <a:xfrm>
-            <a:off x="9326880" y="5212080"/>
-            <a:ext cx="2450592" cy="1371600"/>
+            <a:off x="9235440" y="5532120"/>
+            <a:ext cx="2542032" cy="1234440"/>
           </a:xfrm>
           <a:prstGeom prst="cloud">
             <a:avLst/>
@@ -6118,14 +6605,14 @@
       </p:sp>
       <p:sp>
         <p:nvSpPr>
-          <p:cNvPr id="50" name="TextBox 49"/>
+          <p:cNvPr id="64" name="TextBox 63"/>
           <p:cNvSpPr txBox="1"/>
           <p:nvPr/>
         </p:nvSpPr>
         <p:spPr>
           <a:xfrm>
-            <a:off x="9326880" y="5358384"/>
-            <a:ext cx="2450592" cy="237744"/>
+            <a:off x="9235440" y="5650992"/>
+            <a:ext cx="2542032" cy="219456"/>
           </a:xfrm>
           <a:prstGeom prst="rect">
             <a:avLst/>
@@ -6163,14 +6650,14 @@
       </p:sp>
       <p:sp>
         <p:nvSpPr>
-          <p:cNvPr id="51" name="TextBox 50"/>
+          <p:cNvPr id="65" name="TextBox 64"/>
           <p:cNvSpPr txBox="1"/>
           <p:nvPr/>
         </p:nvSpPr>
         <p:spPr>
           <a:xfrm>
-            <a:off x="9418320" y="5614416"/>
-            <a:ext cx="2286000" cy="237744"/>
+            <a:off x="9326880" y="5888736"/>
+            <a:ext cx="2377440" cy="219456"/>
           </a:xfrm>
           <a:prstGeom prst="rect">
             <a:avLst/>
@@ -6217,14 +6704,14 @@
       </p:sp>
       <p:sp>
         <p:nvSpPr>
-          <p:cNvPr id="52" name="TextBox 51"/>
+          <p:cNvPr id="66" name="TextBox 65"/>
           <p:cNvSpPr txBox="1"/>
           <p:nvPr/>
         </p:nvSpPr>
         <p:spPr>
           <a:xfrm>
-            <a:off x="9418320" y="5888736"/>
-            <a:ext cx="2286000" cy="237744"/>
+            <a:off x="9326880" y="6135624"/>
+            <a:ext cx="2377440" cy="219456"/>
           </a:xfrm>
           <a:prstGeom prst="rect">
             <a:avLst/>
@@ -6271,14 +6758,14 @@
       </p:sp>
       <p:sp>
         <p:nvSpPr>
-          <p:cNvPr id="53" name="TextBox 52"/>
+          <p:cNvPr id="67" name="TextBox 66"/>
           <p:cNvSpPr txBox="1"/>
           <p:nvPr/>
         </p:nvSpPr>
         <p:spPr>
           <a:xfrm>
-            <a:off x="9418320" y="6163056"/>
-            <a:ext cx="2286000" cy="237744"/>
+            <a:off x="9326880" y="6382512"/>
+            <a:ext cx="2377440" cy="219456"/>
           </a:xfrm>
           <a:prstGeom prst="rect">
             <a:avLst/>
@@ -6319,51 +6806,6 @@
                 <a:latin typeface="Malgun Gothic"/>
               </a:rPr>
               <a:t>F16</a:t>
-            </a:r>
-          </a:p>
-        </p:txBody>
-      </p:sp>
-      <p:sp>
-        <p:nvSpPr>
-          <p:cNvPr id="54" name="TextBox 53"/>
-          <p:cNvSpPr txBox="1"/>
-          <p:nvPr/>
-        </p:nvSpPr>
-        <p:spPr>
-          <a:xfrm>
-            <a:off x="411480" y="6528816"/>
-            <a:ext cx="11338560" cy="256032"/>
-          </a:xfrm>
-          <a:prstGeom prst="rect">
-            <a:avLst/>
-          </a:prstGeom>
-          <a:noFill/>
-        </p:spPr>
-        <p:txBody>
-          <a:bodyPr wrap="square" anchor="t" lIns="0" rIns="0" tIns="9144" bIns="9144">
-            <a:spAutoFit/>
-          </a:bodyPr>
-          <a:lstStyle/>
-          <a:p>
-            <a:pPr algn="l">
-              <a:lnSpc>
-                <a:spcPct val="100000"/>
-              </a:lnSpc>
-              <a:spcBef>
-                <a:spcPts val="0"/>
-              </a:spcBef>
-              <a:spcAft>
-                <a:spcPts val="0"/>
-              </a:spcAft>
-            </a:pPr>
-            <a:r>
-              <a:rPr sz="900" b="0">
-                <a:solidFill>
-                  <a:srgbClr val="5B6470"/>
-                </a:solidFill>
-                <a:latin typeface="Malgun Gothic"/>
-              </a:rPr>
-              <a:t>외부 연동은 어댑터로 분리 - 데모는 목/피드, 운영 시 법제처 OpenAPI·FCM/SNS/알림톡·코어뱅킹 API로 교체 · 전 과정 온프레미스</a:t>
             </a:r>
           </a:p>
         </p:txBody>

</xml_diff>